<commit_message>
Add competitor logos and neutralize readiness claims
</commit_message>
<xml_diff>
--- a/reports/presentation/Gauss_Aurora_Investor_Deck_pptxgenjs.pptx
+++ b/reports/presentation/Gauss_Aurora_Investor_Deck_pptxgenjs.pptx
@@ -2,26 +2,26 @@
 <file path=ppt/presentation.xml><?xml version="1.0" encoding="utf-8"?>
 <p:presentation xmlns:p="http://schemas.openxmlformats.org/presentationml/2006/main">
   <p:sldMasterIdLst>
-    <p:sldMasterId xmlns:r="http://schemas.openxmlformats.org/officeDocument/2006/relationships" id="2147483648" r:id="R5a944854a95245ff"/>
+    <p:sldMasterId xmlns:r="http://schemas.openxmlformats.org/officeDocument/2006/relationships" id="2147483648" r:id="Rabd9d552187d442e"/>
   </p:sldMasterIdLst>
   <p:notesMasterIdLst>
-    <p:notesMasterId xmlns:r="http://schemas.openxmlformats.org/officeDocument/2006/relationships" r:id="Rd00a18af02fa4ad8"/>
+    <p:notesMasterId xmlns:r="http://schemas.openxmlformats.org/officeDocument/2006/relationships" r:id="R54f9bdcf93584e07"/>
   </p:notesMasterIdLst>
   <p:sldIdLst>
-    <p:sldId xmlns:r="http://schemas.openxmlformats.org/officeDocument/2006/relationships" id="256" r:id="Rdfd0c17b69664377"/>
-    <p:sldId xmlns:r="http://schemas.openxmlformats.org/officeDocument/2006/relationships" id="257" r:id="R838ef375e5774d13"/>
-    <p:sldId xmlns:r="http://schemas.openxmlformats.org/officeDocument/2006/relationships" id="258" r:id="R55eab405dd624dd0"/>
-    <p:sldId xmlns:r="http://schemas.openxmlformats.org/officeDocument/2006/relationships" id="259" r:id="R67f48dfc281849b5"/>
-    <p:sldId xmlns:r="http://schemas.openxmlformats.org/officeDocument/2006/relationships" id="260" r:id="R3277f99dd50d4713"/>
-    <p:sldId xmlns:r="http://schemas.openxmlformats.org/officeDocument/2006/relationships" id="261" r:id="Red97cb2941944ce8"/>
-    <p:sldId xmlns:r="http://schemas.openxmlformats.org/officeDocument/2006/relationships" id="262" r:id="R2722d99e4a5c4a7d"/>
-    <p:sldId xmlns:r="http://schemas.openxmlformats.org/officeDocument/2006/relationships" id="263" r:id="Rf95e62fae392421e"/>
-    <p:sldId xmlns:r="http://schemas.openxmlformats.org/officeDocument/2006/relationships" id="264" r:id="R118e2e179786480e"/>
-    <p:sldId xmlns:r="http://schemas.openxmlformats.org/officeDocument/2006/relationships" id="265" r:id="R6ec236843a214aaf"/>
-    <p:sldId xmlns:r="http://schemas.openxmlformats.org/officeDocument/2006/relationships" id="266" r:id="R626d7f3e0cea404a"/>
-    <p:sldId xmlns:r="http://schemas.openxmlformats.org/officeDocument/2006/relationships" id="267" r:id="R42b6f56c66b441ad"/>
-    <p:sldId xmlns:r="http://schemas.openxmlformats.org/officeDocument/2006/relationships" id="268" r:id="R5ac7b6e5bab14885"/>
-    <p:sldId xmlns:r="http://schemas.openxmlformats.org/officeDocument/2006/relationships" id="269" r:id="R8690b4211dd84bfc"/>
+    <p:sldId xmlns:r="http://schemas.openxmlformats.org/officeDocument/2006/relationships" id="256" r:id="Rf2a05453359e468f"/>
+    <p:sldId xmlns:r="http://schemas.openxmlformats.org/officeDocument/2006/relationships" id="257" r:id="R9e7964dd693c48df"/>
+    <p:sldId xmlns:r="http://schemas.openxmlformats.org/officeDocument/2006/relationships" id="258" r:id="Reb1c60ab09794f0f"/>
+    <p:sldId xmlns:r="http://schemas.openxmlformats.org/officeDocument/2006/relationships" id="259" r:id="R97a8ba40d0324725"/>
+    <p:sldId xmlns:r="http://schemas.openxmlformats.org/officeDocument/2006/relationships" id="260" r:id="R0fa4fad7ed5143ae"/>
+    <p:sldId xmlns:r="http://schemas.openxmlformats.org/officeDocument/2006/relationships" id="261" r:id="R16ba754629a04ba5"/>
+    <p:sldId xmlns:r="http://schemas.openxmlformats.org/officeDocument/2006/relationships" id="262" r:id="Rd2f80880debf4840"/>
+    <p:sldId xmlns:r="http://schemas.openxmlformats.org/officeDocument/2006/relationships" id="263" r:id="R441c21c00d894086"/>
+    <p:sldId xmlns:r="http://schemas.openxmlformats.org/officeDocument/2006/relationships" id="264" r:id="Rc21d9d015ebd42b8"/>
+    <p:sldId xmlns:r="http://schemas.openxmlformats.org/officeDocument/2006/relationships" id="265" r:id="Rdb215747b4e54b5d"/>
+    <p:sldId xmlns:r="http://schemas.openxmlformats.org/officeDocument/2006/relationships" id="266" r:id="R4690759b86fc4fb9"/>
+    <p:sldId xmlns:r="http://schemas.openxmlformats.org/officeDocument/2006/relationships" id="267" r:id="R7ec1641be95e4aa3"/>
+    <p:sldId xmlns:r="http://schemas.openxmlformats.org/officeDocument/2006/relationships" id="268" r:id="R2a2627f6706c45f4"/>
+    <p:sldId xmlns:r="http://schemas.openxmlformats.org/officeDocument/2006/relationships" id="269" r:id="R19b39269432e476b"/>
   </p:sldIdLst>
   <p:sldSz cx="12192000" cy="6858000"/>
   <p:notesSz cx="6858000" cy="9144000"/>
@@ -577,25 +577,63 @@
           <a:lstStyle xmlns:a="http://schemas.openxmlformats.org/drawingml/2006/main"/>
           <a:p xmlns:a="http://schemas.openxmlformats.org/drawingml/2006/main">
             <a:r>
-              <a:t>Illustrative positioning, not feature parity. Public product descriptions and the user-provided source deck place adjacent categories; Gauss remains partner-neutral.
-[Sources]
-- https://yamcs.com/; https://openc3.com/cosmos-enterprise; https://www.slingshot.space/product-portal; https://www.satcat.com/products/operations
-- User-provided: Gauss_Aurora_Pitch_Deck_v1.pptx</a:t>
+              <a:t>Illustrative positioning, not feature parity. Named companies are category references only; no partnership or endorsement is implied. Publicly positioned strengths are summarised from official product pages.</a:t>
             </a:r>
             <a:endParaRPr/>
           </a:p>
           <a:p xmlns:a="http://schemas.openxmlformats.org/drawingml/2006/main">
             <a:r>
-              <a:t>
-[Sources]
-- Yamcs official product overview: https://yamcs.org/
-- OpenC3 COSMOS official overview and requirements: https://openc3.com/ ; https://docs.openc3.com/docs/meta/requirements
-- Slingshot Portal official product overview: https://www.slingshot.space/product-portal
-- Arize official AI observability overview: https://arize.com/
-- Fiddler official observability overview: https://docs.fiddler.ai/observability/monitoring
-- AIKO orbital_OLIVER official product overview: https://aikospace.com/solutions/oliver
-- Gauss positioning is an internal, partner-neutral thesis; not a claim of feature parity.</a:t>
-            </a:r>
+              <a:t/>
+            </a:r>
+            <a:endParaRPr/>
+          </a:p>
+          <a:p xmlns:a="http://schemas.openxmlformats.org/drawingml/2006/main">
+            <a:r>
+              <a:t>[Sources]</a:t>
+            </a:r>
+            <a:endParaRPr/>
+          </a:p>
+          <a:p xmlns:a="http://schemas.openxmlformats.org/drawingml/2006/main">
+            <a:r>
+              <a:t>- Yamcs official product overview and logo: https://yamcs.org/</a:t>
+            </a:r>
+            <a:endParaRPr/>
+          </a:p>
+          <a:p xmlns:a="http://schemas.openxmlformats.org/drawingml/2006/main">
+            <a:r>
+              <a:t>- OpenC3 COSMOS official overview and logo: https://openc3.com/</a:t>
+            </a:r>
+            <a:endParaRPr/>
+          </a:p>
+          <a:p xmlns:a="http://schemas.openxmlformats.org/drawingml/2006/main">
+            <a:r>
+              <a:t>- Slingshot Portal official product overview and logo: https://www.slingshot.space/product-portal</a:t>
+            </a:r>
+            <a:endParaRPr/>
+          </a:p>
+          <a:p xmlns:a="http://schemas.openxmlformats.org/drawingml/2006/main">
+            <a:r>
+              <a:t>- Arize official AI observability overview and logo: https://arize.com/</a:t>
+            </a:r>
+            <a:endParaRPr/>
+          </a:p>
+          <a:p xmlns:a="http://schemas.openxmlformats.org/drawingml/2006/main">
+            <a:r>
+              <a:t>- Fiddler official observability overview and logo: https://docs.fiddler.ai/observability/monitoring</a:t>
+            </a:r>
+            <a:endParaRPr/>
+          </a:p>
+          <a:p xmlns:a="http://schemas.openxmlformats.org/drawingml/2006/main">
+            <a:r>
+              <a:t>- AIKO orbital_OLIVER official product overview and logo: https://aikospace.com/solutions/oliver</a:t>
+            </a:r>
+            <a:endParaRPr/>
+          </a:p>
+          <a:p xmlns:a="http://schemas.openxmlformats.org/drawingml/2006/main">
+            <a:r>
+              <a:t>- Gauss positioning is an internal, partner-neutral thesis; not a claim of feature parity.</a:t>
+            </a:r>
+            <a:endParaRPr/>
           </a:p>
         </p:txBody>
       </p:sp>
@@ -886,12 +924,49 @@
           <a:lstStyle xmlns:a="http://schemas.openxmlformats.org/drawingml/2006/main"/>
           <a:p xmlns:a="http://schemas.openxmlformats.org/drawingml/2006/main">
             <a:r>
-              <a:t>This scorecard is an assessment of the current deck against published programme and investor guidance, not an eligibility determination. The next diligence unlocks are founder credibility, customer proof, explicit readiness evidence, and IP defensibility.
-[Sources]
-- https://access.esa.int/about-access/about-scale-up/business-incubation-centres; https://www.ycombinator.com/blog/how-to-pitch-your-company/; https://florida.seraphim.vc/; https://accelerator.seraphim.vc/
-- https://www.starcloud.com/
-- https://investors.rocketlabcorp.com/
-- https://www.relativityspace.com/about</a:t>
+              <a:t>This is an internal readiness scorecard for the current investor deck, not an eligibility determination. The next diligence unlocks are founder credibility, customer proof, explicit readiness evidence, and IP defensibility.</a:t>
+            </a:r>
+            <a:endParaRPr/>
+          </a:p>
+          <a:p xmlns:a="http://schemas.openxmlformats.org/drawingml/2006/main">
+            <a:r>
+              <a:t/>
+            </a:r>
+            <a:endParaRPr/>
+          </a:p>
+          <a:p xmlns:a="http://schemas.openxmlformats.org/drawingml/2006/main">
+            <a:r>
+              <a:t>[Sources]</a:t>
+            </a:r>
+            <a:endParaRPr/>
+          </a:p>
+          <a:p xmlns:a="http://schemas.openxmlformats.org/drawingml/2006/main">
+            <a:r>
+              <a:t>- User-provided Gauss_Aurora_Pitch_Deck_v1.pptx</a:t>
+            </a:r>
+            <a:endParaRPr/>
+          </a:p>
+          <a:p xmlns:a="http://schemas.openxmlformats.org/drawingml/2006/main">
+            <a:r>
+              <a:t>- Internal Gauss repository planning model and product notes</a:t>
+            </a:r>
+            <a:endParaRPr/>
+          </a:p>
+          <a:p xmlns:a="http://schemas.openxmlformats.org/drawingml/2006/main">
+            <a:r>
+              <a:t>- https://www.starcloud.com/</a:t>
+            </a:r>
+            <a:endParaRPr/>
+          </a:p>
+          <a:p xmlns:a="http://schemas.openxmlformats.org/drawingml/2006/main">
+            <a:r>
+              <a:t>- https://investors.rocketlabcorp.com/</a:t>
+            </a:r>
+            <a:endParaRPr/>
+          </a:p>
+          <a:p xmlns:a="http://schemas.openxmlformats.org/drawingml/2006/main">
+            <a:r>
+              <a:t>- https://www.relativityspace.com/about</a:t>
             </a:r>
             <a:endParaRPr/>
           </a:p>
@@ -1695,8 +1770,8 @@
   </p:cSld>
   <p:clrMap bg1="lt1" tx1="dk1" bg2="lt2" tx2="dk2" accent1="accent1" accent2="accent2" accent3="accent3" accent4="accent4" accent5="accent5" accent6="accent6" hlink="hlink" folHlink="folHlink"/>
   <p:sldLayoutIdLst>
-    <p:sldLayoutId xmlns:r="http://schemas.openxmlformats.org/officeDocument/2006/relationships" id="2147483649" r:id="R50305b24460f4230"/>
-    <p:sldLayoutId xmlns:r="http://schemas.openxmlformats.org/officeDocument/2006/relationships" id="2147483650" r:id="R44e7392fea544da4"/>
+    <p:sldLayoutId xmlns:r="http://schemas.openxmlformats.org/officeDocument/2006/relationships" id="2147483649" r:id="Rfb8be44a22254f7c"/>
+    <p:sldLayoutId xmlns:r="http://schemas.openxmlformats.org/officeDocument/2006/relationships" id="2147483650" r:id="Rc556a23d40d641e9"/>
   </p:sldLayoutIdLst>
   <p:hf sldNum="0" hdr="0" ftr="0" dt="0"/>
   <p:txStyles>
@@ -2704,7 +2779,7 @@
           <p:nvPr/>
         </p:nvPicPr>
         <p:blipFill>
-          <a:blip xmlns:r="http://schemas.openxmlformats.org/officeDocument/2006/relationships" xmlns:a="http://schemas.openxmlformats.org/drawingml/2006/main" r:embed="R988c614d283a47ac"/>
+          <a:blip xmlns:r="http://schemas.openxmlformats.org/officeDocument/2006/relationships" xmlns:a="http://schemas.openxmlformats.org/drawingml/2006/main" r:embed="R137dd10f50e54b78"/>
           <a:srcRect xmlns:a="http://schemas.openxmlformats.org/drawingml/2006/main" l="0" t="4999" r="0" b="4999"/>
           <a:stretch xmlns:a="http://schemas.openxmlformats.org/drawingml/2006/main">
             <a:fillRect l="0" t="0" r="0" b="0"/>
@@ -3146,14 +3221,14 @@
       </p:grpSpPr>
       <p:pic>
         <p:nvPicPr>
-          <p:cNvPr id="28" name="Image 0"/>
+          <p:cNvPr id="40" name="Image 0"/>
           <p:cNvPicPr>
             <a:picLocks xmlns:a="http://schemas.openxmlformats.org/drawingml/2006/main" noChangeAspect="1"/>
           </p:cNvPicPr>
           <p:nvPr/>
         </p:nvPicPr>
         <p:blipFill>
-          <a:blip xmlns:r="http://schemas.openxmlformats.org/officeDocument/2006/relationships" xmlns:a="http://schemas.openxmlformats.org/drawingml/2006/main" r:embed="R831589dca56e469a">
+          <a:blip xmlns:r="http://schemas.openxmlformats.org/officeDocument/2006/relationships" xmlns:a="http://schemas.openxmlformats.org/drawingml/2006/main" r:embed="Rca5154f496cb460d">
             <a:alphaModFix amt="96000"/>
           </a:blip>
           <a:stretch xmlns:a="http://schemas.openxmlformats.org/drawingml/2006/main">
@@ -3495,7 +3570,7 @@
       </p:sp>
       <p:graphicFrame>
         <p:nvGraphicFramePr>
-          <p:cNvPr id="36" name="Table 0"/>
+          <p:cNvPr id="48" name="Table 0"/>
           <p:cNvGraphicFramePr/>
           <p:nvPr/>
         </p:nvGraphicFramePr>
@@ -5062,6 +5137,372 @@
           </a:p>
         </p:txBody>
       </p:sp>
+      <p:sp>
+        <p:nvSpPr>
+          <p:cNvPr id="28" name="">
+            <a:extLst xmlns:a="http://schemas.openxmlformats.org/drawingml/2006/main">
+              <a:ext uri="{FF2B5EF4-FFF2-40B4-BE49-F238E27FC236}">
+                <a16:creationId xmlns:a16="http://schemas.microsoft.com/office/drawing/2014/main" id="{3913EF8A-C056-4207-8CF0-D83C0106787F}"/>
+              </a:ext>
+            </a:extLst>
+          </p:cNvPr>
+          <p:cNvSpPr>
+            <a:spLocks xmlns:a="http://schemas.openxmlformats.org/drawingml/2006/main" noGrp="1"/>
+          </p:cNvSpPr>
+          <p:nvPr/>
+        </p:nvSpPr>
+        <p:spPr>
+          <a:xfrm xmlns:a="http://schemas.openxmlformats.org/drawingml/2006/main">
+            <a:off x="2266950" y="1862138"/>
+            <a:ext cx="1371600" cy="228600"/>
+          </a:xfrm>
+          <a:prstGeom xmlns:a="http://schemas.openxmlformats.org/drawingml/2006/main" prst="roundRect">
+            <a:avLst>
+              <a:gd name="adj" fmla="val 25000"/>
+            </a:avLst>
+          </a:prstGeom>
+          <a:solidFill xmlns:a="http://schemas.openxmlformats.org/drawingml/2006/main">
+            <a:srgbClr val="F2F5FA"/>
+          </a:solidFill>
+          <a:ln xmlns:a="http://schemas.openxmlformats.org/drawingml/2006/main" w="5715">
+            <a:solidFill>
+              <a:srgbClr val="3B4652"/>
+            </a:solidFill>
+            <a:prstDash val="solid"/>
+          </a:ln>
+        </p:spPr>
+      </p:sp>
+      <p:pic>
+        <p:nvPicPr>
+          <p:cNvPr id="54" name=""/>
+          <p:cNvPicPr>
+            <a:picLocks xmlns:a="http://schemas.openxmlformats.org/drawingml/2006/main" noChangeAspect="1"/>
+          </p:cNvPicPr>
+          <p:nvPr/>
+        </p:nvPicPr>
+        <p:blipFill>
+          <a:blip xmlns:r="http://schemas.openxmlformats.org/officeDocument/2006/relationships" xmlns:a="http://schemas.openxmlformats.org/drawingml/2006/main" r:embed="R52f639b593924388">
+            <a:extLst>
+              <a:ext uri="{96DAC541-7B7A-43D3-8B79-37D633B846F1}">
+                <asvg:svgBlip xmlns:asvg="http://schemas.microsoft.com/office/drawing/2016/SVG/main" r:embed="R6c46dd458ce547d0"/>
+              </a:ext>
+            </a:extLst>
+          </a:blip>
+          <a:stretch xmlns:a="http://schemas.openxmlformats.org/drawingml/2006/main"/>
+        </p:blipFill>
+        <p:spPr>
+          <a:xfrm xmlns:a="http://schemas.openxmlformats.org/drawingml/2006/main">
+            <a:off x="2343150" y="1890713"/>
+            <a:ext cx="1219200" cy="171450"/>
+          </a:xfrm>
+          <a:prstGeom xmlns:a="http://schemas.openxmlformats.org/drawingml/2006/main" prst="rect">
+            <a:avLst/>
+          </a:prstGeom>
+        </p:spPr>
+      </p:pic>
+      <p:sp>
+        <p:nvSpPr>
+          <p:cNvPr id="30" name="">
+            <a:extLst xmlns:a="http://schemas.openxmlformats.org/drawingml/2006/main">
+              <a:ext uri="{FF2B5EF4-FFF2-40B4-BE49-F238E27FC236}">
+                <a16:creationId xmlns:a16="http://schemas.microsoft.com/office/drawing/2014/main" id="{DD3B9947-987C-4DD7-A5D3-25CB75F0666B}"/>
+              </a:ext>
+            </a:extLst>
+          </p:cNvPr>
+          <p:cNvSpPr>
+            <a:spLocks xmlns:a="http://schemas.openxmlformats.org/drawingml/2006/main" noGrp="1"/>
+          </p:cNvSpPr>
+          <p:nvPr/>
+        </p:nvSpPr>
+        <p:spPr>
+          <a:xfrm xmlns:a="http://schemas.openxmlformats.org/drawingml/2006/main">
+            <a:off x="3724275" y="1862138"/>
+            <a:ext cx="1371600" cy="228600"/>
+          </a:xfrm>
+          <a:prstGeom xmlns:a="http://schemas.openxmlformats.org/drawingml/2006/main" prst="roundRect">
+            <a:avLst>
+              <a:gd name="adj" fmla="val 25000"/>
+            </a:avLst>
+          </a:prstGeom>
+          <a:solidFill xmlns:a="http://schemas.openxmlformats.org/drawingml/2006/main">
+            <a:srgbClr val="11171F"/>
+          </a:solidFill>
+          <a:ln xmlns:a="http://schemas.openxmlformats.org/drawingml/2006/main" w="5715">
+            <a:solidFill>
+              <a:srgbClr val="3B4652"/>
+            </a:solidFill>
+            <a:prstDash val="solid"/>
+          </a:ln>
+        </p:spPr>
+      </p:sp>
+      <p:pic>
+        <p:nvPicPr>
+          <p:cNvPr id="56" name=""/>
+          <p:cNvPicPr>
+            <a:picLocks xmlns:a="http://schemas.openxmlformats.org/drawingml/2006/main" noChangeAspect="1"/>
+          </p:cNvPicPr>
+          <p:nvPr/>
+        </p:nvPicPr>
+        <p:blipFill>
+          <a:blip xmlns:r="http://schemas.openxmlformats.org/officeDocument/2006/relationships" xmlns:a="http://schemas.openxmlformats.org/drawingml/2006/main" r:embed="Ra4cea9389eaf4484"/>
+          <a:stretch xmlns:a="http://schemas.openxmlformats.org/drawingml/2006/main"/>
+        </p:blipFill>
+        <p:spPr>
+          <a:xfrm xmlns:a="http://schemas.openxmlformats.org/drawingml/2006/main">
+            <a:off x="4038535" y="1890713"/>
+            <a:ext cx="743079" cy="171450"/>
+          </a:xfrm>
+          <a:prstGeom xmlns:a="http://schemas.openxmlformats.org/drawingml/2006/main" prst="rect">
+            <a:avLst/>
+          </a:prstGeom>
+        </p:spPr>
+      </p:pic>
+      <p:sp>
+        <p:nvSpPr>
+          <p:cNvPr id="32" name="">
+            <a:extLst xmlns:a="http://schemas.openxmlformats.org/drawingml/2006/main">
+              <a:ext uri="{FF2B5EF4-FFF2-40B4-BE49-F238E27FC236}">
+                <a16:creationId xmlns:a16="http://schemas.microsoft.com/office/drawing/2014/main" id="{C8B7C843-AC16-4416-BDCA-7DAEC6512331}"/>
+              </a:ext>
+            </a:extLst>
+          </p:cNvPr>
+          <p:cNvSpPr>
+            <a:spLocks xmlns:a="http://schemas.openxmlformats.org/drawingml/2006/main" noGrp="1"/>
+          </p:cNvSpPr>
+          <p:nvPr/>
+        </p:nvSpPr>
+        <p:spPr>
+          <a:xfrm xmlns:a="http://schemas.openxmlformats.org/drawingml/2006/main">
+            <a:off x="5181600" y="1862138"/>
+            <a:ext cx="1371600" cy="228600"/>
+          </a:xfrm>
+          <a:prstGeom xmlns:a="http://schemas.openxmlformats.org/drawingml/2006/main" prst="roundRect">
+            <a:avLst>
+              <a:gd name="adj" fmla="val 25000"/>
+            </a:avLst>
+          </a:prstGeom>
+          <a:solidFill xmlns:a="http://schemas.openxmlformats.org/drawingml/2006/main">
+            <a:srgbClr val="11171F"/>
+          </a:solidFill>
+          <a:ln xmlns:a="http://schemas.openxmlformats.org/drawingml/2006/main" w="5715">
+            <a:solidFill>
+              <a:srgbClr val="3B4652"/>
+            </a:solidFill>
+            <a:prstDash val="solid"/>
+          </a:ln>
+        </p:spPr>
+      </p:sp>
+      <p:pic>
+        <p:nvPicPr>
+          <p:cNvPr id="58" name=""/>
+          <p:cNvPicPr>
+            <a:picLocks xmlns:a="http://schemas.openxmlformats.org/drawingml/2006/main" noChangeAspect="1"/>
+          </p:cNvPicPr>
+          <p:nvPr/>
+        </p:nvPicPr>
+        <p:blipFill>
+          <a:blip xmlns:r="http://schemas.openxmlformats.org/officeDocument/2006/relationships" xmlns:a="http://schemas.openxmlformats.org/drawingml/2006/main" r:embed="R82ae29fa1f374e58">
+            <a:extLst>
+              <a:ext uri="{96DAC541-7B7A-43D3-8B79-37D633B846F1}">
+                <asvg:svgBlip xmlns:asvg="http://schemas.microsoft.com/office/drawing/2016/SVG/main" r:embed="Rc7bc0f7707ca40e4"/>
+              </a:ext>
+            </a:extLst>
+          </a:blip>
+          <a:stretch xmlns:a="http://schemas.openxmlformats.org/drawingml/2006/main"/>
+        </p:blipFill>
+        <p:spPr>
+          <a:xfrm xmlns:a="http://schemas.openxmlformats.org/drawingml/2006/main">
+            <a:off x="5257800" y="1890713"/>
+            <a:ext cx="1219200" cy="171450"/>
+          </a:xfrm>
+          <a:prstGeom xmlns:a="http://schemas.openxmlformats.org/drawingml/2006/main" prst="rect">
+            <a:avLst/>
+          </a:prstGeom>
+        </p:spPr>
+      </p:pic>
+      <p:sp>
+        <p:nvSpPr>
+          <p:cNvPr id="34" name="">
+            <a:extLst xmlns:a="http://schemas.openxmlformats.org/drawingml/2006/main">
+              <a:ext uri="{FF2B5EF4-FFF2-40B4-BE49-F238E27FC236}">
+                <a16:creationId xmlns:a16="http://schemas.microsoft.com/office/drawing/2014/main" id="{3C17B85F-6822-4BAA-8B1E-AFA0A71C0B3F}"/>
+              </a:ext>
+            </a:extLst>
+          </p:cNvPr>
+          <p:cNvSpPr>
+            <a:spLocks xmlns:a="http://schemas.openxmlformats.org/drawingml/2006/main" noGrp="1"/>
+          </p:cNvSpPr>
+          <p:nvPr/>
+        </p:nvSpPr>
+        <p:spPr>
+          <a:xfrm xmlns:a="http://schemas.openxmlformats.org/drawingml/2006/main">
+            <a:off x="6638925" y="1862138"/>
+            <a:ext cx="1371600" cy="228600"/>
+          </a:xfrm>
+          <a:prstGeom xmlns:a="http://schemas.openxmlformats.org/drawingml/2006/main" prst="roundRect">
+            <a:avLst>
+              <a:gd name="adj" fmla="val 25000"/>
+            </a:avLst>
+          </a:prstGeom>
+          <a:solidFill xmlns:a="http://schemas.openxmlformats.org/drawingml/2006/main">
+            <a:srgbClr val="F2F5FA"/>
+          </a:solidFill>
+          <a:ln xmlns:a="http://schemas.openxmlformats.org/drawingml/2006/main" w="5715">
+            <a:solidFill>
+              <a:srgbClr val="3B4652"/>
+            </a:solidFill>
+            <a:prstDash val="solid"/>
+          </a:ln>
+        </p:spPr>
+      </p:sp>
+      <p:pic>
+        <p:nvPicPr>
+          <p:cNvPr id="60" name=""/>
+          <p:cNvPicPr>
+            <a:picLocks xmlns:a="http://schemas.openxmlformats.org/drawingml/2006/main" noChangeAspect="1"/>
+          </p:cNvPicPr>
+          <p:nvPr/>
+        </p:nvPicPr>
+        <p:blipFill>
+          <a:blip xmlns:r="http://schemas.openxmlformats.org/officeDocument/2006/relationships" xmlns:a="http://schemas.openxmlformats.org/drawingml/2006/main" r:embed="R1075180406b3412e">
+            <a:extLst>
+              <a:ext uri="{96DAC541-7B7A-43D3-8B79-37D633B846F1}">
+                <asvg:svgBlip xmlns:asvg="http://schemas.microsoft.com/office/drawing/2016/SVG/main" r:embed="Rd775457bf7654e2e"/>
+              </a:ext>
+            </a:extLst>
+          </a:blip>
+          <a:stretch xmlns:a="http://schemas.openxmlformats.org/drawingml/2006/main"/>
+        </p:blipFill>
+        <p:spPr>
+          <a:xfrm xmlns:a="http://schemas.openxmlformats.org/drawingml/2006/main">
+            <a:off x="6715125" y="1890713"/>
+            <a:ext cx="1219200" cy="171450"/>
+          </a:xfrm>
+          <a:prstGeom xmlns:a="http://schemas.openxmlformats.org/drawingml/2006/main" prst="rect">
+            <a:avLst/>
+          </a:prstGeom>
+        </p:spPr>
+      </p:pic>
+      <p:sp>
+        <p:nvSpPr>
+          <p:cNvPr id="36" name="">
+            <a:extLst xmlns:a="http://schemas.openxmlformats.org/drawingml/2006/main">
+              <a:ext uri="{FF2B5EF4-FFF2-40B4-BE49-F238E27FC236}">
+                <a16:creationId xmlns:a16="http://schemas.microsoft.com/office/drawing/2014/main" id="{6B53226C-77F8-4AD5-99BF-5F42E9AB90C1}"/>
+              </a:ext>
+            </a:extLst>
+          </p:cNvPr>
+          <p:cNvSpPr>
+            <a:spLocks xmlns:a="http://schemas.openxmlformats.org/drawingml/2006/main" noGrp="1"/>
+          </p:cNvSpPr>
+          <p:nvPr/>
+        </p:nvSpPr>
+        <p:spPr>
+          <a:xfrm xmlns:a="http://schemas.openxmlformats.org/drawingml/2006/main">
+            <a:off x="8096250" y="1862138"/>
+            <a:ext cx="1371600" cy="228600"/>
+          </a:xfrm>
+          <a:prstGeom xmlns:a="http://schemas.openxmlformats.org/drawingml/2006/main" prst="roundRect">
+            <a:avLst>
+              <a:gd name="adj" fmla="val 25000"/>
+            </a:avLst>
+          </a:prstGeom>
+          <a:solidFill xmlns:a="http://schemas.openxmlformats.org/drawingml/2006/main">
+            <a:srgbClr val="F2F5FA"/>
+          </a:solidFill>
+          <a:ln xmlns:a="http://schemas.openxmlformats.org/drawingml/2006/main" w="5715">
+            <a:solidFill>
+              <a:srgbClr val="3B4652"/>
+            </a:solidFill>
+            <a:prstDash val="solid"/>
+          </a:ln>
+        </p:spPr>
+      </p:sp>
+      <p:pic>
+        <p:nvPicPr>
+          <p:cNvPr id="62" name=""/>
+          <p:cNvPicPr>
+            <a:picLocks xmlns:a="http://schemas.openxmlformats.org/drawingml/2006/main" noChangeAspect="1"/>
+          </p:cNvPicPr>
+          <p:nvPr/>
+        </p:nvPicPr>
+        <p:blipFill>
+          <a:blip xmlns:r="http://schemas.openxmlformats.org/officeDocument/2006/relationships" xmlns:a="http://schemas.openxmlformats.org/drawingml/2006/main" r:embed="Rd80d56fe54db4f9f">
+            <a:extLst>
+              <a:ext uri="{96DAC541-7B7A-43D3-8B79-37D633B846F1}">
+                <asvg:svgBlip xmlns:asvg="http://schemas.microsoft.com/office/drawing/2016/SVG/main" r:embed="R4c357c5b46f14ce6"/>
+              </a:ext>
+            </a:extLst>
+          </a:blip>
+          <a:stretch xmlns:a="http://schemas.openxmlformats.org/drawingml/2006/main"/>
+        </p:blipFill>
+        <p:spPr>
+          <a:xfrm xmlns:a="http://schemas.openxmlformats.org/drawingml/2006/main">
+            <a:off x="8172450" y="1890713"/>
+            <a:ext cx="1219200" cy="171450"/>
+          </a:xfrm>
+          <a:prstGeom xmlns:a="http://schemas.openxmlformats.org/drawingml/2006/main" prst="rect">
+            <a:avLst/>
+          </a:prstGeom>
+        </p:spPr>
+      </p:pic>
+      <p:sp>
+        <p:nvSpPr>
+          <p:cNvPr id="38" name="">
+            <a:extLst xmlns:a="http://schemas.openxmlformats.org/drawingml/2006/main">
+              <a:ext uri="{FF2B5EF4-FFF2-40B4-BE49-F238E27FC236}">
+                <a16:creationId xmlns:a16="http://schemas.microsoft.com/office/drawing/2014/main" id="{8398F99A-C8EC-4484-973B-D870CF1A3988}"/>
+              </a:ext>
+            </a:extLst>
+          </p:cNvPr>
+          <p:cNvSpPr>
+            <a:spLocks xmlns:a="http://schemas.openxmlformats.org/drawingml/2006/main" noGrp="1"/>
+          </p:cNvSpPr>
+          <p:nvPr/>
+        </p:nvSpPr>
+        <p:spPr>
+          <a:xfrm xmlns:a="http://schemas.openxmlformats.org/drawingml/2006/main">
+            <a:off x="9553575" y="1862138"/>
+            <a:ext cx="1371600" cy="228600"/>
+          </a:xfrm>
+          <a:prstGeom xmlns:a="http://schemas.openxmlformats.org/drawingml/2006/main" prst="roundRect">
+            <a:avLst>
+              <a:gd name="adj" fmla="val 25000"/>
+            </a:avLst>
+          </a:prstGeom>
+          <a:solidFill xmlns:a="http://schemas.openxmlformats.org/drawingml/2006/main">
+            <a:srgbClr val="4D6972"/>
+          </a:solidFill>
+          <a:ln xmlns:a="http://schemas.openxmlformats.org/drawingml/2006/main" w="5715">
+            <a:solidFill>
+              <a:srgbClr val="3B4652"/>
+            </a:solidFill>
+            <a:prstDash val="solid"/>
+          </a:ln>
+        </p:spPr>
+      </p:sp>
+      <p:pic>
+        <p:nvPicPr>
+          <p:cNvPr id="64" name=""/>
+          <p:cNvPicPr>
+            <a:picLocks xmlns:a="http://schemas.openxmlformats.org/drawingml/2006/main" noChangeAspect="1"/>
+          </p:cNvPicPr>
+          <p:nvPr/>
+        </p:nvPicPr>
+        <p:blipFill>
+          <a:blip xmlns:r="http://schemas.openxmlformats.org/officeDocument/2006/relationships" xmlns:a="http://schemas.openxmlformats.org/drawingml/2006/main" r:embed="Rfe5f6f77cb8b40a6"/>
+          <a:stretch xmlns:a="http://schemas.openxmlformats.org/drawingml/2006/main"/>
+        </p:blipFill>
+        <p:spPr>
+          <a:xfrm xmlns:a="http://schemas.openxmlformats.org/drawingml/2006/main">
+            <a:off x="9827977" y="1890713"/>
+            <a:ext cx="822795" cy="171450"/>
+          </a:xfrm>
+          <a:prstGeom xmlns:a="http://schemas.openxmlformats.org/drawingml/2006/main" prst="rect">
+            <a:avLst/>
+          </a:prstGeom>
+        </p:spPr>
+      </p:pic>
     </p:spTree>
     <p:extLst>
       <p:ext uri="{BB962C8B-B14F-4D97-AF65-F5344CB8AC3E}">
@@ -5100,7 +5541,7 @@
           <p:nvPr/>
         </p:nvPicPr>
         <p:blipFill>
-          <a:blip xmlns:r="http://schemas.openxmlformats.org/officeDocument/2006/relationships" xmlns:a="http://schemas.openxmlformats.org/drawingml/2006/main" r:embed="R82bb84ee630240be">
+          <a:blip xmlns:r="http://schemas.openxmlformats.org/officeDocument/2006/relationships" xmlns:a="http://schemas.openxmlformats.org/drawingml/2006/main" r:embed="R929fa90667a24a67">
             <a:alphaModFix amt="96000"/>
           </a:blip>
           <a:stretch xmlns:a="http://schemas.openxmlformats.org/drawingml/2006/main">
@@ -8329,7 +8770,7 @@
           <p:nvPr/>
         </p:nvPicPr>
         <p:blipFill>
-          <a:blip xmlns:r="http://schemas.openxmlformats.org/officeDocument/2006/relationships" xmlns:a="http://schemas.openxmlformats.org/drawingml/2006/main" r:embed="R3f88de5068a4426a"/>
+          <a:blip xmlns:r="http://schemas.openxmlformats.org/officeDocument/2006/relationships" xmlns:a="http://schemas.openxmlformats.org/drawingml/2006/main" r:embed="R9845637b491748ed"/>
           <a:stretch xmlns:a="http://schemas.openxmlformats.org/drawingml/2006/main">
             <a:fillRect l="0" t="0" r="0" b="0"/>
           </a:stretch>
@@ -9658,7 +10099,7 @@
           <p:nvPr/>
         </p:nvPicPr>
         <p:blipFill>
-          <a:blip xmlns:r="http://schemas.openxmlformats.org/officeDocument/2006/relationships" xmlns:a="http://schemas.openxmlformats.org/drawingml/2006/main" r:embed="Rdf117b40ba99487a">
+          <a:blip xmlns:r="http://schemas.openxmlformats.org/officeDocument/2006/relationships" xmlns:a="http://schemas.openxmlformats.org/drawingml/2006/main" r:embed="Rf016236573ae4190">
             <a:alphaModFix amt="96000"/>
           </a:blip>
           <a:stretch xmlns:a="http://schemas.openxmlformats.org/drawingml/2006/main">
@@ -9973,7 +10414,7 @@
         </p:spPr>
         <p:txBody>
           <a:bodyPr xmlns:a="http://schemas.openxmlformats.org/drawingml/2006/main" wrap="square" lIns="0" tIns="0" rIns="0" bIns="0" anchor="ctr">
-            <a:normAutofit/>
+            <a:normAutofit fontScale="100000"/>
           </a:bodyPr>
           <a:lstStyle xmlns:a="http://schemas.openxmlformats.org/drawingml/2006/main"/>
           <a:p xmlns:a="http://schemas.openxmlformats.org/drawingml/2006/main">
@@ -9992,7 +10433,7 @@
                 <a:ea typeface="IBM Plex Sans"/>
                 <a:cs typeface="IBM Plex Sans"/>
               </a:rPr>
-              <a:t>A practical scorecard against ESA BIC, YC, Seraphim, and the current SpaceTech visual bar.</a:t>
+              <a:t>A practical readiness scorecard for a space-software raise.</a:t>
             </a:r>
             <a:endParaRPr sz="1500"/>
           </a:p>
@@ -10262,7 +10703,7 @@
                           <a:ea typeface="IBM Plex Sans"/>
                           <a:cs typeface="IBM Plex Sans"/>
                         </a:rPr>
-                        <a:t>ESA BIC</a:t>
+                        <a:t>SPACE FIT</a:t>
                       </a:r>
                       <a:endParaRPr sz="900">
                         <a:latin typeface="IBM Plex Sans"/>
@@ -10318,7 +10759,7 @@
                           <a:ea typeface="IBM Plex Sans"/>
                           <a:cs typeface="IBM Plex Sans"/>
                         </a:rPr>
-                        <a:t>Clear space connection; viable business plan; incubation milestones.</a:t>
+                        <a:t>Clear space connection; viable business plan; credible milestones.</a:t>
                       </a:r>
                       <a:endParaRPr sz="900">
                         <a:latin typeface="IBM Plex Sans"/>
@@ -10488,7 +10929,7 @@
                           <a:ea typeface="IBM Plex Sans"/>
                           <a:cs typeface="IBM Plex Sans"/>
                         </a:rPr>
-                        <a:t>YC</a:t>
+                        <a:t>PRODUCT + PROGRESS</a:t>
                       </a:r>
                       <a:endParaRPr sz="900">
                         <a:latin typeface="IBM Plex Sans"/>
@@ -10714,7 +11155,7 @@
                           <a:ea typeface="IBM Plex Sans"/>
                           <a:cs typeface="IBM Plex Sans"/>
                         </a:rPr>
-                        <a:t>SERAPHIM</a:t>
+                        <a:t>SCALE + DEFENSE</a:t>
                       </a:r>
                       <a:endParaRPr sz="900">
                         <a:latin typeface="IBM Plex Sans"/>
@@ -10770,7 +11211,7 @@
                           <a:ea typeface="IBM Plex Sans"/>
                           <a:cs typeface="IBM Plex Sans"/>
                         </a:rPr>
-                        <a:t>Sensible IP; addressable market; experienced team; TRL 5+ / scalable model.</a:t>
+                        <a:t>Addressable market; experienced team; scalable model; defensibility.</a:t>
                       </a:r>
                       <a:endParaRPr sz="900">
                         <a:latin typeface="IBM Plex Sans"/>
@@ -10940,7 +11381,7 @@
                           <a:ea typeface="IBM Plex Sans"/>
                           <a:cs typeface="IBM Plex Sans"/>
                         </a:rPr>
-                        <a:t>SPACE STARTUP BAR</a:t>
+                        <a:t>VISUAL + PROOF</a:t>
                       </a:r>
                       <a:endParaRPr sz="900">
                         <a:latin typeface="IBM Plex Sans"/>
@@ -11891,7 +12332,7 @@
           <p:nvPr/>
         </p:nvPicPr>
         <p:blipFill>
-          <a:blip xmlns:r="http://schemas.openxmlformats.org/officeDocument/2006/relationships" xmlns:a="http://schemas.openxmlformats.org/drawingml/2006/main" r:embed="R910156ae556c422b"/>
+          <a:blip xmlns:r="http://schemas.openxmlformats.org/officeDocument/2006/relationships" xmlns:a="http://schemas.openxmlformats.org/drawingml/2006/main" r:embed="R433d0562cf4d4daa"/>
           <a:srcRect xmlns:a="http://schemas.openxmlformats.org/drawingml/2006/main" l="9091" t="0" r="9091" b="0"/>
           <a:stretch xmlns:a="http://schemas.openxmlformats.org/drawingml/2006/main">
             <a:fillRect l="0" t="0" r="0" b="0"/>
@@ -12916,7 +13357,7 @@
           <p:nvPr/>
         </p:nvPicPr>
         <p:blipFill>
-          <a:blip xmlns:r="http://schemas.openxmlformats.org/officeDocument/2006/relationships" xmlns:a="http://schemas.openxmlformats.org/drawingml/2006/main" r:embed="R270398ea829c431c"/>
+          <a:blip xmlns:r="http://schemas.openxmlformats.org/officeDocument/2006/relationships" xmlns:a="http://schemas.openxmlformats.org/drawingml/2006/main" r:embed="Rf6f3bcd97f8c4bf3"/>
           <a:srcRect xmlns:a="http://schemas.openxmlformats.org/drawingml/2006/main" l="2676" t="0" r="2676" b="0"/>
           <a:stretch xmlns:a="http://schemas.openxmlformats.org/drawingml/2006/main">
             <a:fillRect l="0" t="0" r="0" b="0"/>
@@ -16578,7 +17019,7 @@
           <p:nvPr/>
         </p:nvPicPr>
         <p:blipFill>
-          <a:blip xmlns:r="http://schemas.openxmlformats.org/officeDocument/2006/relationships" xmlns:a="http://schemas.openxmlformats.org/drawingml/2006/main" r:embed="Refa95f2a25304586">
+          <a:blip xmlns:r="http://schemas.openxmlformats.org/officeDocument/2006/relationships" xmlns:a="http://schemas.openxmlformats.org/drawingml/2006/main" r:embed="R403928a75525423c">
             <a:alphaModFix amt="96000"/>
           </a:blip>
           <a:stretch xmlns:a="http://schemas.openxmlformats.org/drawingml/2006/main">
@@ -18213,7 +18654,7 @@
           <p:nvPr/>
         </p:nvPicPr>
         <p:blipFill>
-          <a:blip xmlns:r="http://schemas.openxmlformats.org/officeDocument/2006/relationships" xmlns:a="http://schemas.openxmlformats.org/drawingml/2006/main" r:embed="R92171a0f305443d2">
+          <a:blip xmlns:r="http://schemas.openxmlformats.org/officeDocument/2006/relationships" xmlns:a="http://schemas.openxmlformats.org/drawingml/2006/main" r:embed="R4e334d1c85ad407b">
             <a:alphaModFix amt="96000"/>
           </a:blip>
           <a:stretch xmlns:a="http://schemas.openxmlformats.org/drawingml/2006/main">
@@ -20001,7 +20442,7 @@
         </p:xfrm>
         <a:graphic xmlns:a="http://schemas.openxmlformats.org/drawingml/2006/main">
           <a:graphicData uri="http://schemas.openxmlformats.org/drawingml/2006/chart">
-            <c:chart xmlns:r="http://schemas.openxmlformats.org/officeDocument/2006/relationships" xmlns:c="http://schemas.openxmlformats.org/drawingml/2006/chart" r:id="Rabc46b6939a8473c"/>
+            <c:chart xmlns:r="http://schemas.openxmlformats.org/officeDocument/2006/relationships" xmlns:c="http://schemas.openxmlformats.org/drawingml/2006/chart" r:id="R56071555fa304766"/>
           </a:graphicData>
         </a:graphic>
       </p:graphicFrame>

</xml_diff>

<commit_message>
Refine investor deck quality and evidence guardrails
</commit_message>
<xml_diff>
--- a/reports/presentation/Gauss_Aurora_Investor_Deck_pptxgenjs.pptx
+++ b/reports/presentation/Gauss_Aurora_Investor_Deck_pptxgenjs.pptx
@@ -2,26 +2,26 @@
 <file path=ppt/presentation.xml><?xml version="1.0" encoding="utf-8"?>
 <p:presentation xmlns:p="http://schemas.openxmlformats.org/presentationml/2006/main">
   <p:sldMasterIdLst>
-    <p:sldMasterId xmlns:r="http://schemas.openxmlformats.org/officeDocument/2006/relationships" id="2147483648" r:id="Rabd9d552187d442e"/>
+    <p:sldMasterId xmlns:r="http://schemas.openxmlformats.org/officeDocument/2006/relationships" id="2147483648" r:id="R6fd976ce2fa7491e"/>
   </p:sldMasterIdLst>
   <p:notesMasterIdLst>
-    <p:notesMasterId xmlns:r="http://schemas.openxmlformats.org/officeDocument/2006/relationships" r:id="R54f9bdcf93584e07"/>
+    <p:notesMasterId xmlns:r="http://schemas.openxmlformats.org/officeDocument/2006/relationships" r:id="R244297f47e6842e9"/>
   </p:notesMasterIdLst>
   <p:sldIdLst>
-    <p:sldId xmlns:r="http://schemas.openxmlformats.org/officeDocument/2006/relationships" id="256" r:id="Rf2a05453359e468f"/>
-    <p:sldId xmlns:r="http://schemas.openxmlformats.org/officeDocument/2006/relationships" id="257" r:id="R9e7964dd693c48df"/>
-    <p:sldId xmlns:r="http://schemas.openxmlformats.org/officeDocument/2006/relationships" id="258" r:id="Reb1c60ab09794f0f"/>
-    <p:sldId xmlns:r="http://schemas.openxmlformats.org/officeDocument/2006/relationships" id="259" r:id="R97a8ba40d0324725"/>
-    <p:sldId xmlns:r="http://schemas.openxmlformats.org/officeDocument/2006/relationships" id="260" r:id="R0fa4fad7ed5143ae"/>
-    <p:sldId xmlns:r="http://schemas.openxmlformats.org/officeDocument/2006/relationships" id="261" r:id="R16ba754629a04ba5"/>
-    <p:sldId xmlns:r="http://schemas.openxmlformats.org/officeDocument/2006/relationships" id="262" r:id="Rd2f80880debf4840"/>
-    <p:sldId xmlns:r="http://schemas.openxmlformats.org/officeDocument/2006/relationships" id="263" r:id="R441c21c00d894086"/>
-    <p:sldId xmlns:r="http://schemas.openxmlformats.org/officeDocument/2006/relationships" id="264" r:id="Rc21d9d015ebd42b8"/>
-    <p:sldId xmlns:r="http://schemas.openxmlformats.org/officeDocument/2006/relationships" id="265" r:id="Rdb215747b4e54b5d"/>
-    <p:sldId xmlns:r="http://schemas.openxmlformats.org/officeDocument/2006/relationships" id="266" r:id="R4690759b86fc4fb9"/>
-    <p:sldId xmlns:r="http://schemas.openxmlformats.org/officeDocument/2006/relationships" id="267" r:id="R7ec1641be95e4aa3"/>
-    <p:sldId xmlns:r="http://schemas.openxmlformats.org/officeDocument/2006/relationships" id="268" r:id="R2a2627f6706c45f4"/>
-    <p:sldId xmlns:r="http://schemas.openxmlformats.org/officeDocument/2006/relationships" id="269" r:id="R19b39269432e476b"/>
+    <p:sldId xmlns:r="http://schemas.openxmlformats.org/officeDocument/2006/relationships" id="256" r:id="R66a798ca29494cd3"/>
+    <p:sldId xmlns:r="http://schemas.openxmlformats.org/officeDocument/2006/relationships" id="257" r:id="R4d394c4446174ede"/>
+    <p:sldId xmlns:r="http://schemas.openxmlformats.org/officeDocument/2006/relationships" id="258" r:id="Ra4cddcb616034270"/>
+    <p:sldId xmlns:r="http://schemas.openxmlformats.org/officeDocument/2006/relationships" id="259" r:id="Rdb6cf96764354ad2"/>
+    <p:sldId xmlns:r="http://schemas.openxmlformats.org/officeDocument/2006/relationships" id="260" r:id="Rdc93720ad3634a11"/>
+    <p:sldId xmlns:r="http://schemas.openxmlformats.org/officeDocument/2006/relationships" id="261" r:id="Rf0780a5b0e924cc2"/>
+    <p:sldId xmlns:r="http://schemas.openxmlformats.org/officeDocument/2006/relationships" id="262" r:id="R9f55e4c392ab44f0"/>
+    <p:sldId xmlns:r="http://schemas.openxmlformats.org/officeDocument/2006/relationships" id="263" r:id="Rb5e196d21d644abe"/>
+    <p:sldId xmlns:r="http://schemas.openxmlformats.org/officeDocument/2006/relationships" id="264" r:id="R69b8739d4db042f5"/>
+    <p:sldId xmlns:r="http://schemas.openxmlformats.org/officeDocument/2006/relationships" id="265" r:id="R8df737671ac643e9"/>
+    <p:sldId xmlns:r="http://schemas.openxmlformats.org/officeDocument/2006/relationships" id="266" r:id="Rdb4a1a7e917d4f56"/>
+    <p:sldId xmlns:r="http://schemas.openxmlformats.org/officeDocument/2006/relationships" id="267" r:id="R071eec82ec904227"/>
+    <p:sldId xmlns:r="http://schemas.openxmlformats.org/officeDocument/2006/relationships" id="268" r:id="Reabb6bbe67d54567"/>
+    <p:sldId xmlns:r="http://schemas.openxmlformats.org/officeDocument/2006/relationships" id="269" r:id="R5374b46e0fbc4a2d"/>
   </p:sldIdLst>
   <p:sldSz cx="12192000" cy="6858000"/>
   <p:notesSz cx="6858000" cy="9144000"/>
@@ -495,20 +495,45 @@
           <a:lstStyle xmlns:a="http://schemas.openxmlformats.org/drawingml/2006/main"/>
           <a:p xmlns:a="http://schemas.openxmlformats.org/drawingml/2006/main">
             <a:r>
-              <a:t>Open with the category shift: space operators have more data, more autonomy pressure, and less tolerance for untraceable decisions.
-[Sources]
-- User-provided: Gauss_Aurora_Pitch_Deck_v1.pptx
-- User-provided: Project_Gauss_Data_Architecture_for_AI_Automation_in_Space.pdf</a:t>
+              <a:t>Open with the category shift: space operators have more data, more autonomy pressure, and less tolerance for untraceable decisions. The visible promise is deliberately ground-first and evidence-led; flight-candidate work remains an external gate.</a:t>
             </a:r>
             <a:endParaRPr/>
           </a:p>
           <a:p xmlns:a="http://schemas.openxmlformats.org/drawingml/2006/main">
             <a:r>
-              <a:t>
-[Sources]
-- NASA Earthrise image: https://science.nasa.gov/resource/image-earthrise/
-- Image asset: https://assets.science.nasa.gov/dynamicimage/assets/science/esd/climate/2023/12/August-2013_1920x1200.jpg</a:t>
-            </a:r>
+              <a:t/>
+            </a:r>
+            <a:endParaRPr/>
+          </a:p>
+          <a:p xmlns:a="http://schemas.openxmlformats.org/drawingml/2006/main">
+            <a:r>
+              <a:t>[Sources]</a:t>
+            </a:r>
+            <a:endParaRPr/>
+          </a:p>
+          <a:p xmlns:a="http://schemas.openxmlformats.org/drawingml/2006/main">
+            <a:r>
+              <a:t>- User-provided: Gauss_Aurora_Pitch_Deck_v1.pptx</a:t>
+            </a:r>
+            <a:endParaRPr/>
+          </a:p>
+          <a:p xmlns:a="http://schemas.openxmlformats.org/drawingml/2006/main">
+            <a:r>
+              <a:t>- User-provided: Project_Gauss_Data_Architecture_for_AI_Automation_in_Space.pdf</a:t>
+            </a:r>
+            <a:endParaRPr/>
+          </a:p>
+          <a:p xmlns:a="http://schemas.openxmlformats.org/drawingml/2006/main">
+            <a:r>
+              <a:t>- NASA Earthrise image: https://science.nasa.gov/resource/image-earthrise/</a:t>
+            </a:r>
+            <a:endParaRPr/>
+          </a:p>
+          <a:p xmlns:a="http://schemas.openxmlformats.org/drawingml/2006/main">
+            <a:r>
+              <a:t>- Image asset: https://assets.science.nasa.gov/dynamicimage/assets/science/esd/climate/2023/12/August-2013_1920x1200.jpg</a:t>
+            </a:r>
+            <a:endParaRPr/>
           </a:p>
         </p:txBody>
       </p:sp>
@@ -702,9 +727,25 @@
           <a:lstStyle xmlns:a="http://schemas.openxmlformats.org/drawingml/2006/main"/>
           <a:p xmlns:a="http://schemas.openxmlformats.org/drawingml/2006/main">
             <a:r>
-              <a:t>Named team members and advisor network are taken from the user-provided Gauss_Aurora_Pitch_Deck_v1.pptx. Add measurable founder achievements, customer references, or formal advisor status only when verified.
-[Sources]
-- User-provided: Gauss_Aurora_Pitch_Deck_v1.pptx</a:t>
+              <a:t>Named team members and advisor network are taken from the user-provided Gauss_Aurora_Pitch_Deck_v1.pptx. The visible slide intentionally does not invent founder metrics, customer references, or formal advisor status; those remain diligence unlocks.</a:t>
+            </a:r>
+            <a:endParaRPr/>
+          </a:p>
+          <a:p xmlns:a="http://schemas.openxmlformats.org/drawingml/2006/main">
+            <a:r>
+              <a:t/>
+            </a:r>
+            <a:endParaRPr/>
+          </a:p>
+          <a:p xmlns:a="http://schemas.openxmlformats.org/drawingml/2006/main">
+            <a:r>
+              <a:t>[Sources]</a:t>
+            </a:r>
+            <a:endParaRPr/>
+          </a:p>
+          <a:p xmlns:a="http://schemas.openxmlformats.org/drawingml/2006/main">
+            <a:r>
+              <a:t>- User-provided: Gauss_Aurora_Pitch_Deck_v1.pptx</a:t>
             </a:r>
             <a:endParaRPr/>
           </a:p>
@@ -1423,10 +1464,37 @@
           <a:lstStyle xmlns:a="http://schemas.openxmlformats.org/drawingml/2006/main"/>
           <a:p xmlns:a="http://schemas.openxmlformats.org/drawingml/2006/main">
             <a:r>
-              <a:t>TAM and SAM are internal planning ranges and should be presented as a scenario, not audited market research. SOM is tied to the current five-account ARR model.
-[Sources]
-- Repo: development/memory/DECISIONS.md, D-110 (2026-08-19)
-- User-provided: Gauss_Aurora_Pitch_Deck_v1.pptx</a:t>
+              <a:t>TAM and SAM are internal planning ranges and should be presented as a scenario, not audited market research. SOM is tied to the current five-account ARR model; it is not a market-share forecast.</a:t>
+            </a:r>
+            <a:endParaRPr/>
+          </a:p>
+          <a:p xmlns:a="http://schemas.openxmlformats.org/drawingml/2006/main">
+            <a:r>
+              <a:t/>
+            </a:r>
+            <a:endParaRPr/>
+          </a:p>
+          <a:p xmlns:a="http://schemas.openxmlformats.org/drawingml/2006/main">
+            <a:r>
+              <a:t>[Sources]</a:t>
+            </a:r>
+            <a:endParaRPr/>
+          </a:p>
+          <a:p xmlns:a="http://schemas.openxmlformats.org/drawingml/2006/main">
+            <a:r>
+              <a:t>- Repo: development/memory/DECISIONS.md, D-110 (2026-08-19)</a:t>
+            </a:r>
+            <a:endParaRPr/>
+          </a:p>
+          <a:p xmlns:a="http://schemas.openxmlformats.org/drawingml/2006/main">
+            <a:r>
+              <a:t>- Repo: config/mission-targets.json and config/mission-target.schema.json</a:t>
+            </a:r>
+            <a:endParaRPr/>
+          </a:p>
+          <a:p xmlns:a="http://schemas.openxmlformats.org/drawingml/2006/main">
+            <a:r>
+              <a:t>- User-provided: Gauss_Aurora_Pitch_Deck_v1.pptx</a:t>
             </a:r>
             <a:endParaRPr/>
           </a:p>
@@ -1770,8 +1838,8 @@
   </p:cSld>
   <p:clrMap bg1="lt1" tx1="dk1" bg2="lt2" tx2="dk2" accent1="accent1" accent2="accent2" accent3="accent3" accent4="accent4" accent5="accent5" accent6="accent6" hlink="hlink" folHlink="folHlink"/>
   <p:sldLayoutIdLst>
-    <p:sldLayoutId xmlns:r="http://schemas.openxmlformats.org/officeDocument/2006/relationships" id="2147483649" r:id="Rfb8be44a22254f7c"/>
-    <p:sldLayoutId xmlns:r="http://schemas.openxmlformats.org/officeDocument/2006/relationships" id="2147483650" r:id="Rc556a23d40d641e9"/>
+    <p:sldLayoutId xmlns:r="http://schemas.openxmlformats.org/officeDocument/2006/relationships" id="2147483649" r:id="Rdd544dd8a630473f"/>
+    <p:sldLayoutId xmlns:r="http://schemas.openxmlformats.org/officeDocument/2006/relationships" id="2147483650" r:id="Rc82f8c745ad149ec"/>
   </p:sldLayoutIdLst>
   <p:hf sldNum="0" hdr="0" ftr="0" dt="0"/>
   <p:txStyles>
@@ -2779,7 +2847,7 @@
           <p:nvPr/>
         </p:nvPicPr>
         <p:blipFill>
-          <a:blip xmlns:r="http://schemas.openxmlformats.org/officeDocument/2006/relationships" xmlns:a="http://schemas.openxmlformats.org/drawingml/2006/main" r:embed="R137dd10f50e54b78"/>
+          <a:blip xmlns:r="http://schemas.openxmlformats.org/officeDocument/2006/relationships" xmlns:a="http://schemas.openxmlformats.org/drawingml/2006/main" r:embed="R5b01872d0b744017"/>
           <a:srcRect xmlns:a="http://schemas.openxmlformats.org/drawingml/2006/main" l="0" t="4999" r="0" b="4999"/>
           <a:stretch xmlns:a="http://schemas.openxmlformats.org/drawingml/2006/main">
             <a:fillRect l="0" t="0" r="0" b="0"/>
@@ -3113,7 +3181,7 @@
         </p:spPr>
         <p:txBody>
           <a:bodyPr xmlns:a="http://schemas.openxmlformats.org/drawingml/2006/main" wrap="square" lIns="0" tIns="0" rIns="0" bIns="0" anchor="ctr">
-            <a:normAutofit/>
+            <a:normAutofit fontScale="100000"/>
           </a:bodyPr>
           <a:lstStyle xmlns:a="http://schemas.openxmlformats.org/drawingml/2006/main"/>
           <a:p xmlns:a="http://schemas.openxmlformats.org/drawingml/2006/main">
@@ -3132,7 +3200,7 @@
                 <a:ea typeface="JetBrains Mono"/>
                 <a:cs typeface="JetBrains Mono"/>
               </a:rPr>
-              <a:t>Ground-first. Flight-candidate ready. Command-inert by design.</a:t>
+              <a:t>Ground-first. Evidence-led. Command-inert by design.</a:t>
             </a:r>
             <a:endParaRPr sz="800"/>
           </a:p>
@@ -3221,14 +3289,14 @@
       </p:grpSpPr>
       <p:pic>
         <p:nvPicPr>
-          <p:cNvPr id="40" name="Image 0"/>
+          <p:cNvPr id="47" name="Image 0"/>
           <p:cNvPicPr>
             <a:picLocks xmlns:a="http://schemas.openxmlformats.org/drawingml/2006/main" noChangeAspect="1"/>
           </p:cNvPicPr>
           <p:nvPr/>
         </p:nvPicPr>
         <p:blipFill>
-          <a:blip xmlns:r="http://schemas.openxmlformats.org/officeDocument/2006/relationships" xmlns:a="http://schemas.openxmlformats.org/drawingml/2006/main" r:embed="Rca5154f496cb460d">
+          <a:blip xmlns:r="http://schemas.openxmlformats.org/officeDocument/2006/relationships" xmlns:a="http://schemas.openxmlformats.org/drawingml/2006/main" r:embed="Rb02704a5ee4c472c">
             <a:alphaModFix amt="96000"/>
           </a:blip>
           <a:stretch xmlns:a="http://schemas.openxmlformats.org/drawingml/2006/main">
@@ -3570,7 +3638,7 @@
       </p:sp>
       <p:graphicFrame>
         <p:nvGraphicFramePr>
-          <p:cNvPr id="48" name="Table 0"/>
+          <p:cNvPr id="55" name="Table 0"/>
           <p:cNvGraphicFramePr/>
           <p:nvPr/>
         </p:nvGraphicFramePr>
@@ -5174,17 +5242,17 @@
       </p:sp>
       <p:pic>
         <p:nvPicPr>
-          <p:cNvPr id="54" name=""/>
+          <p:cNvPr id="61" name=""/>
           <p:cNvPicPr>
             <a:picLocks xmlns:a="http://schemas.openxmlformats.org/drawingml/2006/main" noChangeAspect="1"/>
           </p:cNvPicPr>
           <p:nvPr/>
         </p:nvPicPr>
         <p:blipFill>
-          <a:blip xmlns:r="http://schemas.openxmlformats.org/officeDocument/2006/relationships" xmlns:a="http://schemas.openxmlformats.org/drawingml/2006/main" r:embed="R52f639b593924388">
+          <a:blip xmlns:r="http://schemas.openxmlformats.org/officeDocument/2006/relationships" xmlns:a="http://schemas.openxmlformats.org/drawingml/2006/main" r:embed="R0650a63633594d64">
             <a:extLst>
               <a:ext uri="{96DAC541-7B7A-43D3-8B79-37D633B846F1}">
-                <asvg:svgBlip xmlns:asvg="http://schemas.microsoft.com/office/drawing/2016/SVG/main" r:embed="R6c46dd458ce547d0"/>
+                <asvg:svgBlip xmlns:asvg="http://schemas.microsoft.com/office/drawing/2016/SVG/main" r:embed="Rf02bdc1a4f084841"/>
               </a:ext>
             </a:extLst>
           </a:blip>
@@ -5237,14 +5305,14 @@
       </p:sp>
       <p:pic>
         <p:nvPicPr>
-          <p:cNvPr id="56" name=""/>
+          <p:cNvPr id="63" name=""/>
           <p:cNvPicPr>
             <a:picLocks xmlns:a="http://schemas.openxmlformats.org/drawingml/2006/main" noChangeAspect="1"/>
           </p:cNvPicPr>
           <p:nvPr/>
         </p:nvPicPr>
         <p:blipFill>
-          <a:blip xmlns:r="http://schemas.openxmlformats.org/officeDocument/2006/relationships" xmlns:a="http://schemas.openxmlformats.org/drawingml/2006/main" r:embed="Ra4cea9389eaf4484"/>
+          <a:blip xmlns:r="http://schemas.openxmlformats.org/officeDocument/2006/relationships" xmlns:a="http://schemas.openxmlformats.org/drawingml/2006/main" r:embed="R8a26b0e9136348cc"/>
           <a:stretch xmlns:a="http://schemas.openxmlformats.org/drawingml/2006/main"/>
         </p:blipFill>
         <p:spPr>
@@ -5294,17 +5362,17 @@
       </p:sp>
       <p:pic>
         <p:nvPicPr>
-          <p:cNvPr id="58" name=""/>
+          <p:cNvPr id="65" name=""/>
           <p:cNvPicPr>
             <a:picLocks xmlns:a="http://schemas.openxmlformats.org/drawingml/2006/main" noChangeAspect="1"/>
           </p:cNvPicPr>
           <p:nvPr/>
         </p:nvPicPr>
         <p:blipFill>
-          <a:blip xmlns:r="http://schemas.openxmlformats.org/officeDocument/2006/relationships" xmlns:a="http://schemas.openxmlformats.org/drawingml/2006/main" r:embed="R82ae29fa1f374e58">
+          <a:blip xmlns:r="http://schemas.openxmlformats.org/officeDocument/2006/relationships" xmlns:a="http://schemas.openxmlformats.org/drawingml/2006/main" r:embed="Rbde67907c8574b3c">
             <a:extLst>
               <a:ext uri="{96DAC541-7B7A-43D3-8B79-37D633B846F1}">
-                <asvg:svgBlip xmlns:asvg="http://schemas.microsoft.com/office/drawing/2016/SVG/main" r:embed="Rc7bc0f7707ca40e4"/>
+                <asvg:svgBlip xmlns:asvg="http://schemas.microsoft.com/office/drawing/2016/SVG/main" r:embed="R6f1ba0925d01408b"/>
               </a:ext>
             </a:extLst>
           </a:blip>
@@ -5357,17 +5425,17 @@
       </p:sp>
       <p:pic>
         <p:nvPicPr>
-          <p:cNvPr id="60" name=""/>
+          <p:cNvPr id="67" name=""/>
           <p:cNvPicPr>
             <a:picLocks xmlns:a="http://schemas.openxmlformats.org/drawingml/2006/main" noChangeAspect="1"/>
           </p:cNvPicPr>
           <p:nvPr/>
         </p:nvPicPr>
         <p:blipFill>
-          <a:blip xmlns:r="http://schemas.openxmlformats.org/officeDocument/2006/relationships" xmlns:a="http://schemas.openxmlformats.org/drawingml/2006/main" r:embed="R1075180406b3412e">
+          <a:blip xmlns:r="http://schemas.openxmlformats.org/officeDocument/2006/relationships" xmlns:a="http://schemas.openxmlformats.org/drawingml/2006/main" r:embed="Rd6d86765a0bd41c9">
             <a:extLst>
               <a:ext uri="{96DAC541-7B7A-43D3-8B79-37D633B846F1}">
-                <asvg:svgBlip xmlns:asvg="http://schemas.microsoft.com/office/drawing/2016/SVG/main" r:embed="Rd775457bf7654e2e"/>
+                <asvg:svgBlip xmlns:asvg="http://schemas.microsoft.com/office/drawing/2016/SVG/main" r:embed="Rd36199e2b24a4e8e"/>
               </a:ext>
             </a:extLst>
           </a:blip>
@@ -5420,17 +5488,17 @@
       </p:sp>
       <p:pic>
         <p:nvPicPr>
-          <p:cNvPr id="62" name=""/>
+          <p:cNvPr id="69" name=""/>
           <p:cNvPicPr>
             <a:picLocks xmlns:a="http://schemas.openxmlformats.org/drawingml/2006/main" noChangeAspect="1"/>
           </p:cNvPicPr>
           <p:nvPr/>
         </p:nvPicPr>
         <p:blipFill>
-          <a:blip xmlns:r="http://schemas.openxmlformats.org/officeDocument/2006/relationships" xmlns:a="http://schemas.openxmlformats.org/drawingml/2006/main" r:embed="Rd80d56fe54db4f9f">
+          <a:blip xmlns:r="http://schemas.openxmlformats.org/officeDocument/2006/relationships" xmlns:a="http://schemas.openxmlformats.org/drawingml/2006/main" r:embed="R8a26b0e9136348cc">
             <a:extLst>
               <a:ext uri="{96DAC541-7B7A-43D3-8B79-37D633B846F1}">
-                <asvg:svgBlip xmlns:asvg="http://schemas.microsoft.com/office/drawing/2016/SVG/main" r:embed="R4c357c5b46f14ce6"/>
+                <asvg:svgBlip xmlns:asvg="http://schemas.microsoft.com/office/drawing/2016/SVG/main" r:embed="R81a37701d80644c6"/>
               </a:ext>
             </a:extLst>
           </a:blip>
@@ -5483,14 +5551,14 @@
       </p:sp>
       <p:pic>
         <p:nvPicPr>
-          <p:cNvPr id="64" name=""/>
+          <p:cNvPr id="71" name=""/>
           <p:cNvPicPr>
             <a:picLocks xmlns:a="http://schemas.openxmlformats.org/drawingml/2006/main" noChangeAspect="1"/>
           </p:cNvPicPr>
           <p:nvPr/>
         </p:nvPicPr>
         <p:blipFill>
-          <a:blip xmlns:r="http://schemas.openxmlformats.org/officeDocument/2006/relationships" xmlns:a="http://schemas.openxmlformats.org/drawingml/2006/main" r:embed="Rfe5f6f77cb8b40a6"/>
+          <a:blip xmlns:r="http://schemas.openxmlformats.org/officeDocument/2006/relationships" xmlns:a="http://schemas.openxmlformats.org/drawingml/2006/main" r:embed="R780beeb7e3e64a94"/>
           <a:stretch xmlns:a="http://schemas.openxmlformats.org/drawingml/2006/main"/>
         </p:blipFill>
         <p:spPr>
@@ -5541,7 +5609,7 @@
           <p:nvPr/>
         </p:nvPicPr>
         <p:blipFill>
-          <a:blip xmlns:r="http://schemas.openxmlformats.org/officeDocument/2006/relationships" xmlns:a="http://schemas.openxmlformats.org/drawingml/2006/main" r:embed="R929fa90667a24a67">
+          <a:blip xmlns:r="http://schemas.openxmlformats.org/officeDocument/2006/relationships" xmlns:a="http://schemas.openxmlformats.org/drawingml/2006/main" r:embed="R680bd46f4bea47d5">
             <a:alphaModFix amt="96000"/>
           </a:blip>
           <a:stretch xmlns:a="http://schemas.openxmlformats.org/drawingml/2006/main">
@@ -5805,7 +5873,7 @@
         </p:spPr>
         <p:txBody>
           <a:bodyPr xmlns:a="http://schemas.openxmlformats.org/drawingml/2006/main" wrap="square" lIns="0" tIns="0" rIns="0" bIns="0" anchor="ctr">
-            <a:normAutofit/>
+            <a:normAutofit fontScale="100000"/>
           </a:bodyPr>
           <a:lstStyle xmlns:a="http://schemas.openxmlformats.org/drawingml/2006/main"/>
           <a:p xmlns:a="http://schemas.openxmlformats.org/drawingml/2006/main">
@@ -5824,7 +5892,7 @@
                 <a:ea typeface="Inter"/>
                 <a:cs typeface="Inter"/>
               </a:rPr>
-              <a:t>A compact founding team built around mission context.</a:t>
+              <a:t>Three owners cover product, operators, and systems.</a:t>
             </a:r>
             <a:endParaRPr sz="2800"/>
           </a:p>
@@ -5856,7 +5924,7 @@
         </p:spPr>
         <p:txBody>
           <a:bodyPr xmlns:a="http://schemas.openxmlformats.org/drawingml/2006/main" wrap="square" lIns="0" tIns="0" rIns="0" bIns="0" anchor="ctr">
-            <a:normAutofit/>
+            <a:normAutofit fontScale="100000"/>
           </a:bodyPr>
           <a:lstStyle xmlns:a="http://schemas.openxmlformats.org/drawingml/2006/main"/>
           <a:p xmlns:a="http://schemas.openxmlformats.org/drawingml/2006/main">
@@ -5875,7 +5943,7 @@
                 <a:ea typeface="IBM Plex Sans"/>
                 <a:cs typeface="IBM Plex Sans"/>
               </a:rPr>
-              <a:t>Product leadership, operator experience, and space-systems execution in one loop.</a:t>
+              <a:t>Product, operator experience, and space-systems execution are covered; customer proof is next.</a:t>
             </a:r>
             <a:endParaRPr sz="1500"/>
           </a:p>
@@ -8770,7 +8838,7 @@
           <p:nvPr/>
         </p:nvPicPr>
         <p:blipFill>
-          <a:blip xmlns:r="http://schemas.openxmlformats.org/officeDocument/2006/relationships" xmlns:a="http://schemas.openxmlformats.org/drawingml/2006/main" r:embed="R9845637b491748ed"/>
+          <a:blip xmlns:r="http://schemas.openxmlformats.org/officeDocument/2006/relationships" xmlns:a="http://schemas.openxmlformats.org/drawingml/2006/main" r:embed="R447e569e9e114ebf"/>
           <a:stretch xmlns:a="http://schemas.openxmlformats.org/drawingml/2006/main">
             <a:fillRect l="0" t="0" r="0" b="0"/>
           </a:stretch>
@@ -10099,7 +10167,7 @@
           <p:nvPr/>
         </p:nvPicPr>
         <p:blipFill>
-          <a:blip xmlns:r="http://schemas.openxmlformats.org/officeDocument/2006/relationships" xmlns:a="http://schemas.openxmlformats.org/drawingml/2006/main" r:embed="Rf016236573ae4190">
+          <a:blip xmlns:r="http://schemas.openxmlformats.org/officeDocument/2006/relationships" xmlns:a="http://schemas.openxmlformats.org/drawingml/2006/main" r:embed="R4497a4cb37854f79">
             <a:alphaModFix amt="96000"/>
           </a:blip>
           <a:stretch xmlns:a="http://schemas.openxmlformats.org/drawingml/2006/main">
@@ -10759,7 +10827,7 @@
                           <a:ea typeface="IBM Plex Sans"/>
                           <a:cs typeface="IBM Plex Sans"/>
                         </a:rPr>
-                        <a:t>Clear space connection; viable business plan; credible milestones.</a:t>
+                        <a:t>Space problem; viable plan; credible milestones.</a:t>
                       </a:r>
                       <a:endParaRPr sz="900">
                         <a:latin typeface="IBM Plex Sans"/>
@@ -10815,7 +10883,7 @@
                           <a:ea typeface="IBM Plex Sans"/>
                           <a:cs typeface="IBM Plex Sans"/>
                         </a:rPr>
-                        <a:t>Ground-first space operations wedge, product packages, market model, 18-month plan.</a:t>
+                        <a:t>Ground-first wedge; product packages; 18-month plan.</a:t>
                       </a:r>
                       <a:endParaRPr sz="900">
                         <a:latin typeface="IBM Plex Sans"/>
@@ -10929,7 +10997,7 @@
                           <a:ea typeface="IBM Plex Sans"/>
                           <a:cs typeface="IBM Plex Sans"/>
                         </a:rPr>
-                        <a:t>PRODUCT + PROGRESS</a:t>
+                        <a:t>PRODUCT</a:t>
                       </a:r>
                       <a:endParaRPr sz="900">
                         <a:latin typeface="IBM Plex Sans"/>
@@ -10985,7 +11053,7 @@
                           <a:ea typeface="IBM Plex Sans"/>
                           <a:cs typeface="IBM Plex Sans"/>
                         </a:rPr>
-                        <a:t>Matter-of-fact product; unique insight; progress; business model; founders; ask.</a:t>
+                        <a:t>Clear product; progress; model; founders; ask.</a:t>
                       </a:r>
                       <a:endParaRPr sz="900">
                         <a:latin typeface="IBM Plex Sans"/>
@@ -11041,7 +11109,7 @@
                           <a:ea typeface="IBM Plex Sans"/>
                           <a:cs typeface="IBM Plex Sans"/>
                         </a:rPr>
-                        <a:t>Clear wedge, pricing, ARR path, and team slide. Specific founder proof and customer progress remain thin.</a:t>
+                        <a:t>Wedge, pricing, ARR path; customer proof remains thin.</a:t>
                       </a:r>
                       <a:endParaRPr sz="900">
                         <a:latin typeface="IBM Plex Sans"/>
@@ -11211,7 +11279,7 @@
                           <a:ea typeface="IBM Plex Sans"/>
                           <a:cs typeface="IBM Plex Sans"/>
                         </a:rPr>
-                        <a:t>Addressable market; experienced team; scalable model; defensibility.</a:t>
+                        <a:t>Market; team; scalable model; defensibility.</a:t>
                       </a:r>
                       <a:endParaRPr sz="900">
                         <a:latin typeface="IBM Plex Sans"/>
@@ -11267,7 +11335,7 @@
                           <a:ea typeface="IBM Plex Sans"/>
                           <a:cs typeface="IBM Plex Sans"/>
                         </a:rPr>
-                        <a:t>Market wedge, competition, commercial path, and team roles are visible. IP, heritage, and TRL evidence still need proof.</a:t>
+                        <a:t>Market wedge + team visible; IP / TRL proof next.</a:t>
                       </a:r>
                       <a:endParaRPr sz="900">
                         <a:latin typeface="IBM Plex Sans"/>
@@ -11437,7 +11505,7 @@
                           <a:ea typeface="IBM Plex Sans"/>
                           <a:cs typeface="IBM Plex Sans"/>
                         </a:rPr>
-                        <a:t>One claim per slide; hard proof; bold visuals; credible milestones; clear next action.</a:t>
+                        <a:t>One claim per slide; hard proof; clear next action.</a:t>
                       </a:r>
                       <a:endParaRPr sz="900">
                         <a:latin typeface="IBM Plex Sans"/>
@@ -11493,7 +11561,7 @@
                           <a:ea typeface="IBM Plex Sans"/>
                           <a:cs typeface="IBM Plex Sans"/>
                         </a:rPr>
-                        <a:t>Consistent system, source-backed notes, native charts/tables, and ground-first milestones.</a:t>
+                        <a:t>Source-backed visuals, native charts/tables, clear milestones.</a:t>
                       </a:r>
                       <a:endParaRPr sz="900">
                         <a:latin typeface="IBM Plex Sans"/>
@@ -11607,7 +11675,7 @@
                           <a:ea typeface="IBM Plex Sans"/>
                           <a:cs typeface="IBM Plex Sans"/>
                         </a:rPr>
-                        <a:t>INVESTOR DECISION</a:t>
+                        <a:t>DECISION</a:t>
                       </a:r>
                       <a:endParaRPr sz="900">
                         <a:latin typeface="IBM Plex Sans"/>
@@ -11663,7 +11731,7 @@
                           <a:ea typeface="IBM Plex Sans"/>
                           <a:cs typeface="IBM Plex Sans"/>
                         </a:rPr>
-                        <a:t>Why now; why this team; why this round; what changes after funding.</a:t>
+                        <a:t>Why now; why team; why this round.</a:t>
                       </a:r>
                       <a:endParaRPr sz="900">
                         <a:latin typeface="IBM Plex Sans"/>
@@ -11719,7 +11787,7 @@
                           <a:ea typeface="IBM Plex Sans"/>
                           <a:cs typeface="IBM Plex Sans"/>
                         </a:rPr>
-                        <a:t>Why now, $1.5M use of funds, $500k ARR, and team slide are clear. Why Gauss can win still needs proof.</a:t>
+                        <a:t>Ask, use of funds, and $500k ARR path are clear.</a:t>
                       </a:r>
                       <a:endParaRPr sz="900">
                         <a:latin typeface="IBM Plex Sans"/>
@@ -12332,7 +12400,7 @@
           <p:nvPr/>
         </p:nvPicPr>
         <p:blipFill>
-          <a:blip xmlns:r="http://schemas.openxmlformats.org/officeDocument/2006/relationships" xmlns:a="http://schemas.openxmlformats.org/drawingml/2006/main" r:embed="R433d0562cf4d4daa"/>
+          <a:blip xmlns:r="http://schemas.openxmlformats.org/officeDocument/2006/relationships" xmlns:a="http://schemas.openxmlformats.org/drawingml/2006/main" r:embed="R2b051c852ef64b67"/>
           <a:srcRect xmlns:a="http://schemas.openxmlformats.org/drawingml/2006/main" l="9091" t="0" r="9091" b="0"/>
           <a:stretch xmlns:a="http://schemas.openxmlformats.org/drawingml/2006/main">
             <a:fillRect l="0" t="0" r="0" b="0"/>
@@ -13357,7 +13425,7 @@
           <p:nvPr/>
         </p:nvPicPr>
         <p:blipFill>
-          <a:blip xmlns:r="http://schemas.openxmlformats.org/officeDocument/2006/relationships" xmlns:a="http://schemas.openxmlformats.org/drawingml/2006/main" r:embed="Rf6f3bcd97f8c4bf3"/>
+          <a:blip xmlns:r="http://schemas.openxmlformats.org/officeDocument/2006/relationships" xmlns:a="http://schemas.openxmlformats.org/drawingml/2006/main" r:embed="Rba18127e2d3447d6"/>
           <a:srcRect xmlns:a="http://schemas.openxmlformats.org/drawingml/2006/main" l="2676" t="0" r="2676" b="0"/>
           <a:stretch xmlns:a="http://schemas.openxmlformats.org/drawingml/2006/main">
             <a:fillRect l="0" t="0" r="0" b="0"/>
@@ -17019,7 +17087,7 @@
           <p:nvPr/>
         </p:nvPicPr>
         <p:blipFill>
-          <a:blip xmlns:r="http://schemas.openxmlformats.org/officeDocument/2006/relationships" xmlns:a="http://schemas.openxmlformats.org/drawingml/2006/main" r:embed="R403928a75525423c">
+          <a:blip xmlns:r="http://schemas.openxmlformats.org/officeDocument/2006/relationships" xmlns:a="http://schemas.openxmlformats.org/drawingml/2006/main" r:embed="Ref8ea0f3198c45a3">
             <a:alphaModFix amt="96000"/>
           </a:blip>
           <a:stretch xmlns:a="http://schemas.openxmlformats.org/drawingml/2006/main">
@@ -18654,7 +18722,7 @@
           <p:nvPr/>
         </p:nvPicPr>
         <p:blipFill>
-          <a:blip xmlns:r="http://schemas.openxmlformats.org/officeDocument/2006/relationships" xmlns:a="http://schemas.openxmlformats.org/drawingml/2006/main" r:embed="R4e334d1c85ad407b">
+          <a:blip xmlns:r="http://schemas.openxmlformats.org/officeDocument/2006/relationships" xmlns:a="http://schemas.openxmlformats.org/drawingml/2006/main" r:embed="Ra79c8673cb854822">
             <a:alphaModFix amt="96000"/>
           </a:blip>
           <a:stretch xmlns:a="http://schemas.openxmlformats.org/drawingml/2006/main">
@@ -18918,7 +18986,7 @@
         </p:spPr>
         <p:txBody>
           <a:bodyPr xmlns:a="http://schemas.openxmlformats.org/drawingml/2006/main" wrap="square" lIns="0" tIns="0" rIns="0" bIns="0" anchor="ctr">
-            <a:normAutofit/>
+            <a:normAutofit fontScale="100000"/>
           </a:bodyPr>
           <a:lstStyle xmlns:a="http://schemas.openxmlformats.org/drawingml/2006/main"/>
           <a:p xmlns:a="http://schemas.openxmlformats.org/drawingml/2006/main">
@@ -18937,7 +19005,7 @@
                 <a:ea typeface="Inter"/>
                 <a:cs typeface="Inter"/>
               </a:rPr>
-              <a:t>A focused beachhead before the orbital infrastructure upside.</a:t>
+              <a:t>Start with a focused wedge; expand as evidence compounds.</a:t>
             </a:r>
             <a:endParaRPr sz="2800"/>
           </a:p>
@@ -18961,6 +19029,108 @@
           <a:xfrm xmlns:a="http://schemas.openxmlformats.org/drawingml/2006/main">
             <a:off x="685800" y="1472184"/>
             <a:ext cx="10287000" cy="274320"/>
+          </a:xfrm>
+          <a:prstGeom xmlns:a="http://schemas.openxmlformats.org/drawingml/2006/main" prst="rect">
+            <a:avLst/>
+          </a:prstGeom>
+          <a:noFill xmlns:a="http://schemas.openxmlformats.org/drawingml/2006/main"/>
+        </p:spPr>
+        <p:txBody>
+          <a:bodyPr xmlns:a="http://schemas.openxmlformats.org/drawingml/2006/main" wrap="square" lIns="0" tIns="0" rIns="0" bIns="0" anchor="ctr">
+            <a:normAutofit fontScale="100000"/>
+          </a:bodyPr>
+          <a:lstStyle xmlns:a="http://schemas.openxmlformats.org/drawingml/2006/main"/>
+          <a:p xmlns:a="http://schemas.openxmlformats.org/drawingml/2006/main">
+            <a:pPr marL="0" indent="0" algn="l">
+              <a:lnSpc>
+                <a:spcPct val="100000"/>
+              </a:lnSpc>
+              <a:buNone/>
+            </a:pPr>
+            <a:r>
+              <a:rPr sz="1500">
+                <a:solidFill>
+                  <a:srgbClr val="A6A9A2"/>
+                </a:solidFill>
+                <a:latin typeface="IBM Plex Sans"/>
+                <a:ea typeface="IBM Plex Sans"/>
+                <a:cs typeface="IBM Plex Sans"/>
+              </a:rPr>
+              <a:t>TAM and SAM are internal ranges; SOM is five fleet accounts.</a:t>
+            </a:r>
+            <a:endParaRPr sz="1500"/>
+          </a:p>
+        </p:txBody>
+      </p:sp>
+      <p:sp>
+        <p:nvSpPr>
+          <p:cNvPr id="10" name="Text 7">
+            <a:extLst xmlns:a="http://schemas.openxmlformats.org/drawingml/2006/main">
+              <a:ext uri="{FF2B5EF4-FFF2-40B4-BE49-F238E27FC236}">
+                <a16:creationId xmlns:a16="http://schemas.microsoft.com/office/drawing/2014/main" id="{B8B22210-8477-4310-AF29-71EEE399B1EB}"/>
+              </a:ext>
+            </a:extLst>
+          </p:cNvPr>
+          <p:cNvSpPr>
+            <a:spLocks xmlns:a="http://schemas.openxmlformats.org/drawingml/2006/main" noGrp="1"/>
+          </p:cNvSpPr>
+          <p:nvPr/>
+        </p:nvSpPr>
+        <p:spPr>
+          <a:xfrm xmlns:a="http://schemas.openxmlformats.org/drawingml/2006/main">
+            <a:off x="685800" y="2066544"/>
+            <a:ext cx="4937760" cy="164592"/>
+          </a:xfrm>
+          <a:prstGeom xmlns:a="http://schemas.openxmlformats.org/drawingml/2006/main" prst="rect">
+            <a:avLst/>
+          </a:prstGeom>
+          <a:noFill xmlns:a="http://schemas.openxmlformats.org/drawingml/2006/main"/>
+        </p:spPr>
+        <p:txBody>
+          <a:bodyPr xmlns:a="http://schemas.openxmlformats.org/drawingml/2006/main" wrap="square" lIns="0" tIns="0" rIns="0" bIns="0" anchor="ctr">
+            <a:normAutofit fontScale="100000"/>
+          </a:bodyPr>
+          <a:lstStyle xmlns:a="http://schemas.openxmlformats.org/drawingml/2006/main"/>
+          <a:p xmlns:a="http://schemas.openxmlformats.org/drawingml/2006/main">
+            <a:pPr marL="0" indent="0" algn="l">
+              <a:lnSpc>
+                <a:spcPct val="100000"/>
+              </a:lnSpc>
+              <a:buNone/>
+            </a:pPr>
+            <a:r>
+              <a:rPr sz="800" b="1">
+                <a:solidFill>
+                  <a:srgbClr val="E7B14A"/>
+                </a:solidFill>
+                <a:latin typeface="JetBrains Mono"/>
+                <a:ea typeface="JetBrains Mono"/>
+                <a:cs typeface="JetBrains Mono"/>
+              </a:rPr>
+              <a:t>INTERNAL SCENARIO  /  NOT AUDITED RESEARCH</a:t>
+            </a:r>
+            <a:endParaRPr sz="800"/>
+          </a:p>
+        </p:txBody>
+      </p:sp>
+      <p:sp>
+        <p:nvSpPr>
+          <p:cNvPr id="11" name="Text 8">
+            <a:extLst xmlns:a="http://schemas.openxmlformats.org/drawingml/2006/main">
+              <a:ext uri="{FF2B5EF4-FFF2-40B4-BE49-F238E27FC236}">
+                <a16:creationId xmlns:a16="http://schemas.microsoft.com/office/drawing/2014/main" id="{55788EA6-EC18-48D3-8BE4-2A60E0ACD708}"/>
+              </a:ext>
+            </a:extLst>
+          </p:cNvPr>
+          <p:cNvSpPr>
+            <a:spLocks xmlns:a="http://schemas.openxmlformats.org/drawingml/2006/main" noGrp="1"/>
+          </p:cNvSpPr>
+          <p:nvPr/>
+        </p:nvSpPr>
+        <p:spPr>
+          <a:xfrm xmlns:a="http://schemas.openxmlformats.org/drawingml/2006/main">
+            <a:off x="1060704" y="2670048"/>
+            <a:ext cx="731520" cy="201168"/>
           </a:xfrm>
           <a:prstGeom xmlns:a="http://schemas.openxmlformats.org/drawingml/2006/main" prst="rect">
             <a:avLst/>
@@ -18980,7 +19150,109 @@
               <a:buNone/>
             </a:pPr>
             <a:r>
-              <a:rPr sz="1500">
+              <a:rPr sz="1100" b="1">
+                <a:solidFill>
+                  <a:srgbClr val="A6A9A2"/>
+                </a:solidFill>
+                <a:latin typeface="JetBrains Mono"/>
+                <a:ea typeface="JetBrains Mono"/>
+                <a:cs typeface="JetBrains Mono"/>
+              </a:rPr>
+              <a:t>TAM</a:t>
+            </a:r>
+            <a:endParaRPr sz="1100"/>
+          </a:p>
+        </p:txBody>
+      </p:sp>
+      <p:sp>
+        <p:nvSpPr>
+          <p:cNvPr id="12" name="Text 9">
+            <a:extLst xmlns:a="http://schemas.openxmlformats.org/drawingml/2006/main">
+              <a:ext uri="{FF2B5EF4-FFF2-40B4-BE49-F238E27FC236}">
+                <a16:creationId xmlns:a16="http://schemas.microsoft.com/office/drawing/2014/main" id="{510B20D4-55C0-4E6E-8BEA-D07D41DBD8CB}"/>
+              </a:ext>
+            </a:extLst>
+          </p:cNvPr>
+          <p:cNvSpPr>
+            <a:spLocks xmlns:a="http://schemas.openxmlformats.org/drawingml/2006/main" noGrp="1"/>
+          </p:cNvSpPr>
+          <p:nvPr/>
+        </p:nvSpPr>
+        <p:spPr>
+          <a:xfrm xmlns:a="http://schemas.openxmlformats.org/drawingml/2006/main">
+            <a:off x="1060704" y="3035808"/>
+            <a:ext cx="3200400" cy="594360"/>
+          </a:xfrm>
+          <a:prstGeom xmlns:a="http://schemas.openxmlformats.org/drawingml/2006/main" prst="rect">
+            <a:avLst/>
+          </a:prstGeom>
+          <a:noFill xmlns:a="http://schemas.openxmlformats.org/drawingml/2006/main"/>
+        </p:spPr>
+        <p:txBody>
+          <a:bodyPr xmlns:a="http://schemas.openxmlformats.org/drawingml/2006/main" wrap="square" lIns="0" tIns="0" rIns="0" bIns="0" anchor="ctr">
+            <a:normAutofit/>
+          </a:bodyPr>
+          <a:lstStyle xmlns:a="http://schemas.openxmlformats.org/drawingml/2006/main"/>
+          <a:p xmlns:a="http://schemas.openxmlformats.org/drawingml/2006/main">
+            <a:pPr marL="0" indent="0" algn="l">
+              <a:lnSpc>
+                <a:spcPct val="100000"/>
+              </a:lnSpc>
+              <a:buNone/>
+            </a:pPr>
+            <a:r>
+              <a:rPr sz="4400" b="1">
+                <a:solidFill>
+                  <a:srgbClr val="CCFF00"/>
+                </a:solidFill>
+                <a:latin typeface="Inter"/>
+                <a:ea typeface="Inter"/>
+                <a:cs typeface="Inter"/>
+              </a:rPr>
+              <a:t>$3–5B</a:t>
+            </a:r>
+            <a:endParaRPr sz="4400"/>
+          </a:p>
+        </p:txBody>
+      </p:sp>
+      <p:sp>
+        <p:nvSpPr>
+          <p:cNvPr id="13" name="Text 10">
+            <a:extLst xmlns:a="http://schemas.openxmlformats.org/drawingml/2006/main">
+              <a:ext uri="{FF2B5EF4-FFF2-40B4-BE49-F238E27FC236}">
+                <a16:creationId xmlns:a16="http://schemas.microsoft.com/office/drawing/2014/main" id="{377C36BB-EA09-4E07-84A3-2EF7D231DC08}"/>
+              </a:ext>
+            </a:extLst>
+          </p:cNvPr>
+          <p:cNvSpPr>
+            <a:spLocks xmlns:a="http://schemas.openxmlformats.org/drawingml/2006/main" noGrp="1"/>
+          </p:cNvSpPr>
+          <p:nvPr/>
+        </p:nvSpPr>
+        <p:spPr>
+          <a:xfrm xmlns:a="http://schemas.openxmlformats.org/drawingml/2006/main">
+            <a:off x="1060704" y="3767328"/>
+            <a:ext cx="3127248" cy="411480"/>
+          </a:xfrm>
+          <a:prstGeom xmlns:a="http://schemas.openxmlformats.org/drawingml/2006/main" prst="rect">
+            <a:avLst/>
+          </a:prstGeom>
+          <a:noFill xmlns:a="http://schemas.openxmlformats.org/drawingml/2006/main"/>
+        </p:spPr>
+        <p:txBody>
+          <a:bodyPr xmlns:a="http://schemas.openxmlformats.org/drawingml/2006/main" wrap="square" lIns="0" tIns="0" rIns="0" bIns="0" anchor="ctr">
+            <a:normAutofit fontScale="100000"/>
+          </a:bodyPr>
+          <a:lstStyle xmlns:a="http://schemas.openxmlformats.org/drawingml/2006/main"/>
+          <a:p xmlns:a="http://schemas.openxmlformats.org/drawingml/2006/main">
+            <a:pPr marL="0" indent="0" algn="l">
+              <a:lnSpc>
+                <a:spcPct val="100000"/>
+              </a:lnSpc>
+              <a:buNone/>
+            </a:pPr>
+            <a:r>
+              <a:rPr sz="1300">
                 <a:solidFill>
                   <a:srgbClr val="A6A9A2"/>
                 </a:solidFill>
@@ -18988,211 +19260,7 @@
                 <a:ea typeface="IBM Plex Sans"/>
                 <a:cs typeface="IBM Plex Sans"/>
               </a:rPr>
-              <a:t>Use a transparent internal model; let customer evidence tighten the market over time.</a:t>
-            </a:r>
-            <a:endParaRPr sz="1500"/>
-          </a:p>
-        </p:txBody>
-      </p:sp>
-      <p:sp>
-        <p:nvSpPr>
-          <p:cNvPr id="10" name="Text 7">
-            <a:extLst xmlns:a="http://schemas.openxmlformats.org/drawingml/2006/main">
-              <a:ext uri="{FF2B5EF4-FFF2-40B4-BE49-F238E27FC236}">
-                <a16:creationId xmlns:a16="http://schemas.microsoft.com/office/drawing/2014/main" id="{B8B22210-8477-4310-AF29-71EEE399B1EB}"/>
-              </a:ext>
-            </a:extLst>
-          </p:cNvPr>
-          <p:cNvSpPr>
-            <a:spLocks xmlns:a="http://schemas.openxmlformats.org/drawingml/2006/main" noGrp="1"/>
-          </p:cNvSpPr>
-          <p:nvPr/>
-        </p:nvSpPr>
-        <p:spPr>
-          <a:xfrm xmlns:a="http://schemas.openxmlformats.org/drawingml/2006/main">
-            <a:off x="685800" y="2066544"/>
-            <a:ext cx="4937760" cy="164592"/>
-          </a:xfrm>
-          <a:prstGeom xmlns:a="http://schemas.openxmlformats.org/drawingml/2006/main" prst="rect">
-            <a:avLst/>
-          </a:prstGeom>
-          <a:noFill xmlns:a="http://schemas.openxmlformats.org/drawingml/2006/main"/>
-        </p:spPr>
-        <p:txBody>
-          <a:bodyPr xmlns:a="http://schemas.openxmlformats.org/drawingml/2006/main" wrap="square" lIns="0" tIns="0" rIns="0" bIns="0" anchor="ctr">
-            <a:normAutofit/>
-          </a:bodyPr>
-          <a:lstStyle xmlns:a="http://schemas.openxmlformats.org/drawingml/2006/main"/>
-          <a:p xmlns:a="http://schemas.openxmlformats.org/drawingml/2006/main">
-            <a:pPr marL="0" indent="0" algn="l">
-              <a:lnSpc>
-                <a:spcPct val="100000"/>
-              </a:lnSpc>
-              <a:buNone/>
-            </a:pPr>
-            <a:r>
-              <a:rPr sz="800" b="1">
-                <a:solidFill>
-                  <a:srgbClr val="E7B14A"/>
-                </a:solidFill>
-                <a:latin typeface="JetBrains Mono"/>
-                <a:ea typeface="JetBrains Mono"/>
-                <a:cs typeface="JetBrains Mono"/>
-              </a:rPr>
-              <a:t>INTERNAL PLANNING MODEL  /  DIRECTIONAL LADDER, NOT AUDITED RESEARCH</a:t>
-            </a:r>
-            <a:endParaRPr sz="800"/>
-          </a:p>
-        </p:txBody>
-      </p:sp>
-      <p:sp>
-        <p:nvSpPr>
-          <p:cNvPr id="11" name="Text 8">
-            <a:extLst xmlns:a="http://schemas.openxmlformats.org/drawingml/2006/main">
-              <a:ext uri="{FF2B5EF4-FFF2-40B4-BE49-F238E27FC236}">
-                <a16:creationId xmlns:a16="http://schemas.microsoft.com/office/drawing/2014/main" id="{55788EA6-EC18-48D3-8BE4-2A60E0ACD708}"/>
-              </a:ext>
-            </a:extLst>
-          </p:cNvPr>
-          <p:cNvSpPr>
-            <a:spLocks xmlns:a="http://schemas.openxmlformats.org/drawingml/2006/main" noGrp="1"/>
-          </p:cNvSpPr>
-          <p:nvPr/>
-        </p:nvSpPr>
-        <p:spPr>
-          <a:xfrm xmlns:a="http://schemas.openxmlformats.org/drawingml/2006/main">
-            <a:off x="1060704" y="2670048"/>
-            <a:ext cx="731520" cy="201168"/>
-          </a:xfrm>
-          <a:prstGeom xmlns:a="http://schemas.openxmlformats.org/drawingml/2006/main" prst="rect">
-            <a:avLst/>
-          </a:prstGeom>
-          <a:noFill xmlns:a="http://schemas.openxmlformats.org/drawingml/2006/main"/>
-        </p:spPr>
-        <p:txBody>
-          <a:bodyPr xmlns:a="http://schemas.openxmlformats.org/drawingml/2006/main" wrap="square" lIns="0" tIns="0" rIns="0" bIns="0" anchor="ctr">
-            <a:normAutofit/>
-          </a:bodyPr>
-          <a:lstStyle xmlns:a="http://schemas.openxmlformats.org/drawingml/2006/main"/>
-          <a:p xmlns:a="http://schemas.openxmlformats.org/drawingml/2006/main">
-            <a:pPr marL="0" indent="0" algn="l">
-              <a:lnSpc>
-                <a:spcPct val="100000"/>
-              </a:lnSpc>
-              <a:buNone/>
-            </a:pPr>
-            <a:r>
-              <a:rPr sz="1100" b="1">
-                <a:solidFill>
-                  <a:srgbClr val="A6A9A2"/>
-                </a:solidFill>
-                <a:latin typeface="JetBrains Mono"/>
-                <a:ea typeface="JetBrains Mono"/>
-                <a:cs typeface="JetBrains Mono"/>
-              </a:rPr>
-              <a:t>TAM</a:t>
-            </a:r>
-            <a:endParaRPr sz="1100"/>
-          </a:p>
-        </p:txBody>
-      </p:sp>
-      <p:sp>
-        <p:nvSpPr>
-          <p:cNvPr id="12" name="Text 9">
-            <a:extLst xmlns:a="http://schemas.openxmlformats.org/drawingml/2006/main">
-              <a:ext uri="{FF2B5EF4-FFF2-40B4-BE49-F238E27FC236}">
-                <a16:creationId xmlns:a16="http://schemas.microsoft.com/office/drawing/2014/main" id="{510B20D4-55C0-4E6E-8BEA-D07D41DBD8CB}"/>
-              </a:ext>
-            </a:extLst>
-          </p:cNvPr>
-          <p:cNvSpPr>
-            <a:spLocks xmlns:a="http://schemas.openxmlformats.org/drawingml/2006/main" noGrp="1"/>
-          </p:cNvSpPr>
-          <p:nvPr/>
-        </p:nvSpPr>
-        <p:spPr>
-          <a:xfrm xmlns:a="http://schemas.openxmlformats.org/drawingml/2006/main">
-            <a:off x="1060704" y="3035808"/>
-            <a:ext cx="3200400" cy="594360"/>
-          </a:xfrm>
-          <a:prstGeom xmlns:a="http://schemas.openxmlformats.org/drawingml/2006/main" prst="rect">
-            <a:avLst/>
-          </a:prstGeom>
-          <a:noFill xmlns:a="http://schemas.openxmlformats.org/drawingml/2006/main"/>
-        </p:spPr>
-        <p:txBody>
-          <a:bodyPr xmlns:a="http://schemas.openxmlformats.org/drawingml/2006/main" wrap="square" lIns="0" tIns="0" rIns="0" bIns="0" anchor="ctr">
-            <a:normAutofit/>
-          </a:bodyPr>
-          <a:lstStyle xmlns:a="http://schemas.openxmlformats.org/drawingml/2006/main"/>
-          <a:p xmlns:a="http://schemas.openxmlformats.org/drawingml/2006/main">
-            <a:pPr marL="0" indent="0" algn="l">
-              <a:lnSpc>
-                <a:spcPct val="100000"/>
-              </a:lnSpc>
-              <a:buNone/>
-            </a:pPr>
-            <a:r>
-              <a:rPr sz="4400" b="1">
-                <a:solidFill>
-                  <a:srgbClr val="CCFF00"/>
-                </a:solidFill>
-                <a:latin typeface="Inter"/>
-                <a:ea typeface="Inter"/>
-                <a:cs typeface="Inter"/>
-              </a:rPr>
-              <a:t>$3–5B</a:t>
-            </a:r>
-            <a:endParaRPr sz="4400"/>
-          </a:p>
-        </p:txBody>
-      </p:sp>
-      <p:sp>
-        <p:nvSpPr>
-          <p:cNvPr id="13" name="Text 10">
-            <a:extLst xmlns:a="http://schemas.openxmlformats.org/drawingml/2006/main">
-              <a:ext uri="{FF2B5EF4-FFF2-40B4-BE49-F238E27FC236}">
-                <a16:creationId xmlns:a16="http://schemas.microsoft.com/office/drawing/2014/main" id="{377C36BB-EA09-4E07-84A3-2EF7D231DC08}"/>
-              </a:ext>
-            </a:extLst>
-          </p:cNvPr>
-          <p:cNvSpPr>
-            <a:spLocks xmlns:a="http://schemas.openxmlformats.org/drawingml/2006/main" noGrp="1"/>
-          </p:cNvSpPr>
-          <p:nvPr/>
-        </p:nvSpPr>
-        <p:spPr>
-          <a:xfrm xmlns:a="http://schemas.openxmlformats.org/drawingml/2006/main">
-            <a:off x="1060704" y="3767328"/>
-            <a:ext cx="3127248" cy="411480"/>
-          </a:xfrm>
-          <a:prstGeom xmlns:a="http://schemas.openxmlformats.org/drawingml/2006/main" prst="rect">
-            <a:avLst/>
-          </a:prstGeom>
-          <a:noFill xmlns:a="http://schemas.openxmlformats.org/drawingml/2006/main"/>
-        </p:spPr>
-        <p:txBody>
-          <a:bodyPr xmlns:a="http://schemas.openxmlformats.org/drawingml/2006/main" wrap="square" lIns="0" tIns="0" rIns="0" bIns="0" anchor="ctr">
-            <a:normAutofit/>
-          </a:bodyPr>
-          <a:lstStyle xmlns:a="http://schemas.openxmlformats.org/drawingml/2006/main"/>
-          <a:p xmlns:a="http://schemas.openxmlformats.org/drawingml/2006/main">
-            <a:pPr marL="0" indent="0" algn="l">
-              <a:lnSpc>
-                <a:spcPct val="100000"/>
-              </a:lnSpc>
-              <a:buNone/>
-            </a:pPr>
-            <a:r>
-              <a:rPr sz="1300">
-                <a:solidFill>
-                  <a:srgbClr val="A6A9A2"/>
-                </a:solidFill>
-                <a:latin typeface="IBM Plex Sans"/>
-                <a:ea typeface="IBM Plex Sans"/>
-                <a:cs typeface="IBM Plex Sans"/>
-              </a:rPr>
-              <a:t>Mission-data, ground, and distributed in-space infrastructure category.</a:t>
+              <a:t>Mission-data + infrastructure category.</a:t>
             </a:r>
             <a:endParaRPr sz="1300"/>
           </a:p>
@@ -19431,7 +19499,7 @@
         </p:spPr>
         <p:txBody>
           <a:bodyPr xmlns:a="http://schemas.openxmlformats.org/drawingml/2006/main" wrap="square" lIns="0" tIns="0" rIns="0" bIns="0" anchor="ctr">
-            <a:normAutofit/>
+            <a:normAutofit fontScale="100000"/>
           </a:bodyPr>
           <a:lstStyle xmlns:a="http://schemas.openxmlformats.org/drawingml/2006/main"/>
           <a:p xmlns:a="http://schemas.openxmlformats.org/drawingml/2006/main">
@@ -19450,7 +19518,7 @@
                 <a:ea typeface="IBM Plex Sans"/>
                 <a:cs typeface="IBM Plex Sans"/>
               </a:rPr>
-              <a:t>Broad mission-data + infrastructure category</a:t>
+              <a:t>Broad mission-data + infrastructure</a:t>
             </a:r>
             <a:endParaRPr sz="800"/>
           </a:p>
@@ -19658,7 +19726,7 @@
         </p:spPr>
         <p:txBody>
           <a:bodyPr xmlns:a="http://schemas.openxmlformats.org/drawingml/2006/main" wrap="square" lIns="0" tIns="0" rIns="0" bIns="0" anchor="ctr">
-            <a:normAutofit/>
+            <a:normAutofit fontScale="100000"/>
           </a:bodyPr>
           <a:lstStyle xmlns:a="http://schemas.openxmlformats.org/drawingml/2006/main"/>
           <a:p xmlns:a="http://schemas.openxmlformats.org/drawingml/2006/main">
@@ -19677,7 +19745,7 @@
                 <a:ea typeface="IBM Plex Sans"/>
                 <a:cs typeface="IBM Plex Sans"/>
               </a:rPr>
-              <a:t>Initial ground and distributed-space wedge</a:t>
+              <a:t>Initial ground + distributed-space wedge</a:t>
             </a:r>
             <a:endParaRPr sz="800"/>
           </a:p>
@@ -19936,7 +20004,7 @@
         </p:spPr>
         <p:txBody>
           <a:bodyPr xmlns:a="http://schemas.openxmlformats.org/drawingml/2006/main" wrap="square" lIns="0" tIns="0" rIns="0" bIns="0" anchor="ctr">
-            <a:normAutofit/>
+            <a:normAutofit fontScale="100000"/>
           </a:bodyPr>
           <a:lstStyle xmlns:a="http://schemas.openxmlformats.org/drawingml/2006/main"/>
           <a:p xmlns:a="http://schemas.openxmlformats.org/drawingml/2006/main">
@@ -19955,7 +20023,7 @@
                 <a:ea typeface="Inter"/>
                 <a:cs typeface="Inter"/>
               </a:rPr>
-              <a:t>SOM is deliberately operational: five $100k fleet accounts, not a speculative share of a trillion-dollar category.</a:t>
+              <a:t>SOM is five $100k fleet accounts—not a speculative market-share claim.</a:t>
             </a:r>
             <a:endParaRPr sz="1300"/>
           </a:p>
@@ -20442,7 +20510,7 @@
         </p:xfrm>
         <a:graphic xmlns:a="http://schemas.openxmlformats.org/drawingml/2006/main">
           <a:graphicData uri="http://schemas.openxmlformats.org/drawingml/2006/chart">
-            <c:chart xmlns:r="http://schemas.openxmlformats.org/officeDocument/2006/relationships" xmlns:c="http://schemas.openxmlformats.org/drawingml/2006/chart" r:id="R56071555fa304766"/>
+            <c:chart xmlns:r="http://schemas.openxmlformats.org/officeDocument/2006/relationships" xmlns:c="http://schemas.openxmlformats.org/drawingml/2006/chart" r:id="Rc3ccdca2b12442a8"/>
           </a:graphicData>
         </a:graphic>
       </p:graphicFrame>

</xml_diff>

<commit_message>
Improve investor deck data visuals
</commit_message>
<xml_diff>
--- a/reports/presentation/Gauss_Aurora_Investor_Deck_pptxgenjs.pptx
+++ b/reports/presentation/Gauss_Aurora_Investor_Deck_pptxgenjs.pptx
@@ -2,26 +2,26 @@
 <file path=ppt/presentation.xml><?xml version="1.0" encoding="utf-8"?>
 <p:presentation xmlns:p="http://schemas.openxmlformats.org/presentationml/2006/main">
   <p:sldMasterIdLst>
-    <p:sldMasterId xmlns:r="http://schemas.openxmlformats.org/officeDocument/2006/relationships" id="2147483648" r:id="R6fd976ce2fa7491e"/>
+    <p:sldMasterId xmlns:r="http://schemas.openxmlformats.org/officeDocument/2006/relationships" id="2147483648" r:id="Rc022d36139a14638"/>
   </p:sldMasterIdLst>
   <p:notesMasterIdLst>
-    <p:notesMasterId xmlns:r="http://schemas.openxmlformats.org/officeDocument/2006/relationships" r:id="R244297f47e6842e9"/>
+    <p:notesMasterId xmlns:r="http://schemas.openxmlformats.org/officeDocument/2006/relationships" r:id="R0c2bab59a8a44a3d"/>
   </p:notesMasterIdLst>
   <p:sldIdLst>
-    <p:sldId xmlns:r="http://schemas.openxmlformats.org/officeDocument/2006/relationships" id="256" r:id="R66a798ca29494cd3"/>
-    <p:sldId xmlns:r="http://schemas.openxmlformats.org/officeDocument/2006/relationships" id="257" r:id="R4d394c4446174ede"/>
-    <p:sldId xmlns:r="http://schemas.openxmlformats.org/officeDocument/2006/relationships" id="258" r:id="Ra4cddcb616034270"/>
-    <p:sldId xmlns:r="http://schemas.openxmlformats.org/officeDocument/2006/relationships" id="259" r:id="Rdb6cf96764354ad2"/>
-    <p:sldId xmlns:r="http://schemas.openxmlformats.org/officeDocument/2006/relationships" id="260" r:id="Rdc93720ad3634a11"/>
-    <p:sldId xmlns:r="http://schemas.openxmlformats.org/officeDocument/2006/relationships" id="261" r:id="Rf0780a5b0e924cc2"/>
-    <p:sldId xmlns:r="http://schemas.openxmlformats.org/officeDocument/2006/relationships" id="262" r:id="R9f55e4c392ab44f0"/>
-    <p:sldId xmlns:r="http://schemas.openxmlformats.org/officeDocument/2006/relationships" id="263" r:id="Rb5e196d21d644abe"/>
-    <p:sldId xmlns:r="http://schemas.openxmlformats.org/officeDocument/2006/relationships" id="264" r:id="R69b8739d4db042f5"/>
-    <p:sldId xmlns:r="http://schemas.openxmlformats.org/officeDocument/2006/relationships" id="265" r:id="R8df737671ac643e9"/>
-    <p:sldId xmlns:r="http://schemas.openxmlformats.org/officeDocument/2006/relationships" id="266" r:id="Rdb4a1a7e917d4f56"/>
-    <p:sldId xmlns:r="http://schemas.openxmlformats.org/officeDocument/2006/relationships" id="267" r:id="R071eec82ec904227"/>
-    <p:sldId xmlns:r="http://schemas.openxmlformats.org/officeDocument/2006/relationships" id="268" r:id="Reabb6bbe67d54567"/>
-    <p:sldId xmlns:r="http://schemas.openxmlformats.org/officeDocument/2006/relationships" id="269" r:id="R5374b46e0fbc4a2d"/>
+    <p:sldId xmlns:r="http://schemas.openxmlformats.org/officeDocument/2006/relationships" id="256" r:id="R95a19124ca9a4188"/>
+    <p:sldId xmlns:r="http://schemas.openxmlformats.org/officeDocument/2006/relationships" id="257" r:id="R7bf493a912974647"/>
+    <p:sldId xmlns:r="http://schemas.openxmlformats.org/officeDocument/2006/relationships" id="258" r:id="R1882499ef70544b3"/>
+    <p:sldId xmlns:r="http://schemas.openxmlformats.org/officeDocument/2006/relationships" id="259" r:id="Re4514403cc814b14"/>
+    <p:sldId xmlns:r="http://schemas.openxmlformats.org/officeDocument/2006/relationships" id="260" r:id="R9b7ae275dc0a4514"/>
+    <p:sldId xmlns:r="http://schemas.openxmlformats.org/officeDocument/2006/relationships" id="261" r:id="R4ffed9801a28434d"/>
+    <p:sldId xmlns:r="http://schemas.openxmlformats.org/officeDocument/2006/relationships" id="262" r:id="R1ad84d56dc8a4c33"/>
+    <p:sldId xmlns:r="http://schemas.openxmlformats.org/officeDocument/2006/relationships" id="263" r:id="R5a1b5cefc21b42a4"/>
+    <p:sldId xmlns:r="http://schemas.openxmlformats.org/officeDocument/2006/relationships" id="264" r:id="R6e0a33fee22c4116"/>
+    <p:sldId xmlns:r="http://schemas.openxmlformats.org/officeDocument/2006/relationships" id="265" r:id="R7b5d66b70c2142fc"/>
+    <p:sldId xmlns:r="http://schemas.openxmlformats.org/officeDocument/2006/relationships" id="266" r:id="Rc8f659bc199144ff"/>
+    <p:sldId xmlns:r="http://schemas.openxmlformats.org/officeDocument/2006/relationships" id="267" r:id="Ref2b327065024ae3"/>
+    <p:sldId xmlns:r="http://schemas.openxmlformats.org/officeDocument/2006/relationships" id="268" r:id="Rf5ca6add9a124c9a"/>
+    <p:sldId xmlns:r="http://schemas.openxmlformats.org/officeDocument/2006/relationships" id="269" r:id="R0df2600bc3544694"/>
   </p:sldIdLst>
   <p:sldSz cx="12192000" cy="6858000"/>
   <p:notesSz cx="6858000" cy="9144000"/>
@@ -1390,10 +1390,37 @@
           <a:lstStyle xmlns:a="http://schemas.openxmlformats.org/drawingml/2006/main"/>
           <a:p xmlns:a="http://schemas.openxmlformats.org/drawingml/2006/main">
             <a:r>
-              <a:t>These are research profiles and segment hypotheses, not signed customers. The first commercial motion is mission-data and integration buyers serving communications, weather, EO, and cislunar relay systems.
-[Sources]
-- Repo: config/mission-targets.json and config/mission-target.schema.json
-- Repo: development/memory/DECISIONS.md, D-110 (2026-08-19)</a:t>
+              <a:t>The profile mix is counted from the repository's eight research_profile entries: 2 satcom, 2 weather/space weather, 1 Earth observation, 1 PNT, and 2 lunar relay. These are research targets, not signed customers.</a:t>
+            </a:r>
+            <a:endParaRPr/>
+          </a:p>
+          <a:p xmlns:a="http://schemas.openxmlformats.org/drawingml/2006/main">
+            <a:r>
+              <a:t/>
+            </a:r>
+            <a:endParaRPr/>
+          </a:p>
+          <a:p xmlns:a="http://schemas.openxmlformats.org/drawingml/2006/main">
+            <a:r>
+              <a:t>[Sources]</a:t>
+            </a:r>
+            <a:endParaRPr/>
+          </a:p>
+          <a:p xmlns:a="http://schemas.openxmlformats.org/drawingml/2006/main">
+            <a:r>
+              <a:t>- Internal repo: config/mission-targets.json</a:t>
+            </a:r>
+            <a:endParaRPr/>
+          </a:p>
+          <a:p xmlns:a="http://schemas.openxmlformats.org/drawingml/2006/main">
+            <a:r>
+              <a:t>- Internal repo: development/memory/DECISIONS.md (D-110, D-124)</a:t>
+            </a:r>
+            <a:endParaRPr/>
+          </a:p>
+          <a:p xmlns:a="http://schemas.openxmlformats.org/drawingml/2006/main">
+            <a:r>
+              <a:t>- Visual design reference: https://investors.seraphim.vc/wp-content/uploads/2022/05/Seraphim-Prospectus-PDF.pdf</a:t>
             </a:r>
             <a:endParaRPr/>
           </a:p>
@@ -1838,8 +1865,8 @@
   </p:cSld>
   <p:clrMap bg1="lt1" tx1="dk1" bg2="lt2" tx2="dk2" accent1="accent1" accent2="accent2" accent3="accent3" accent4="accent4" accent5="accent5" accent6="accent6" hlink="hlink" folHlink="folHlink"/>
   <p:sldLayoutIdLst>
-    <p:sldLayoutId xmlns:r="http://schemas.openxmlformats.org/officeDocument/2006/relationships" id="2147483649" r:id="Rdd544dd8a630473f"/>
-    <p:sldLayoutId xmlns:r="http://schemas.openxmlformats.org/officeDocument/2006/relationships" id="2147483650" r:id="Rc82f8c745ad149ec"/>
+    <p:sldLayoutId xmlns:r="http://schemas.openxmlformats.org/officeDocument/2006/relationships" id="2147483649" r:id="R91ab156bed784041"/>
+    <p:sldLayoutId xmlns:r="http://schemas.openxmlformats.org/officeDocument/2006/relationships" id="2147483650" r:id="Rd2216e766cc1417d"/>
   </p:sldLayoutIdLst>
   <p:hf sldNum="0" hdr="0" ftr="0" dt="0"/>
   <p:txStyles>
@@ -2503,7 +2530,7 @@
             <a:lstStyle xmlns:a="http://schemas.openxmlformats.org/drawingml/2006/main"/>
             <a:p xmlns:a="http://schemas.openxmlformats.org/drawingml/2006/main">
               <a:pPr>
-                <a:defRPr sz="1200" b="0" i="0" u="none">
+                <a:defRPr sz="1200" b="1" i="0" u="none">
                   <a:solidFill>
                     <a:srgbClr val="F3F0E8"/>
                   </a:solidFill>
@@ -2514,6 +2541,7 @@
               </a:pPr>
             </a:p>
           </c:txPr>
+          <c:dLblPos val="outEnd"/>
           <c:showLegendKey val="0"/>
           <c:showVal val="1"/>
           <c:showCatName val="0"/>
@@ -2539,9 +2567,9 @@
         <c:minorTickMark val="none"/>
         <c:tickLblPos val="low"/>
         <c:spPr>
-          <a:ln xmlns:a="http://schemas.openxmlformats.org/drawingml/2006/main" w="12700">
+          <a:ln xmlns:a="http://schemas.openxmlformats.org/drawingml/2006/main" w="9525">
             <a:solidFill>
-              <a:srgbClr val="888888"/>
+              <a:srgbClr val="7A8181"/>
             </a:solidFill>
             <a:prstDash val="solid"/>
           </a:ln>
@@ -2551,9 +2579,9 @@
           <a:lstStyle xmlns:a="http://schemas.openxmlformats.org/drawingml/2006/main"/>
           <a:p xmlns:a="http://schemas.openxmlformats.org/drawingml/2006/main">
             <a:pPr>
-              <a:defRPr sz="900" b="0" i="0" u="none">
-                <a:solidFill>
-                  <a:srgbClr val="A6A9A2"/>
+              <a:defRPr sz="975" b="0" i="0" u="none">
+                <a:solidFill>
+                  <a:srgbClr val="7A8181"/>
                 </a:solidFill>
                 <a:latin typeface="IBM Plex Sans"/>
                 <a:ea typeface="IBM Plex Sans"/>
@@ -2569,29 +2597,29 @@
         <c:axId val="2094734552"/>
         <c:scaling>
           <c:orientation val="minMax"/>
-          <c:max val="550"/>
+          <c:max val="500"/>
           <c:min val="0"/>
         </c:scaling>
         <c:delete val="0"/>
         <c:axPos val="l"/>
         <c:majorGridlines>
           <c:spPr>
-            <a:ln xmlns:a="http://schemas.openxmlformats.org/drawingml/2006/main" w="12700">
+            <a:ln xmlns:a="http://schemas.openxmlformats.org/drawingml/2006/main" w="9525">
               <a:solidFill>
-                <a:srgbClr val="252A2A"/>
+                <a:srgbClr val="25302E"/>
               </a:solidFill>
               <a:prstDash val="solid"/>
             </a:ln>
           </c:spPr>
         </c:majorGridlines>
-        <c:numFmt formatCode="General" sourceLinked="0"/>
+        <c:numFmt formatCode="0" sourceLinked="0"/>
         <c:majorTickMark val="out"/>
         <c:minorTickMark val="none"/>
         <c:tickLblPos val="nextTo"/>
         <c:spPr>
-          <a:ln xmlns:a="http://schemas.openxmlformats.org/drawingml/2006/main" w="12700">
+          <a:ln xmlns:a="http://schemas.openxmlformats.org/drawingml/2006/main" w="9525">
             <a:solidFill>
-              <a:srgbClr val="888888"/>
+              <a:srgbClr val="7A8181"/>
             </a:solidFill>
             <a:prstDash val="solid"/>
           </a:ln>
@@ -2601,9 +2629,9 @@
           <a:lstStyle xmlns:a="http://schemas.openxmlformats.org/drawingml/2006/main"/>
           <a:p xmlns:a="http://schemas.openxmlformats.org/drawingml/2006/main">
             <a:pPr>
-              <a:defRPr sz="800" b="0" i="0" u="none">
-                <a:solidFill>
-                  <a:srgbClr val="A6A9A2"/>
+              <a:defRPr sz="900" b="0" i="0" u="none">
+                <a:solidFill>
+                  <a:srgbClr val="7A8181"/>
                 </a:solidFill>
                 <a:latin typeface="JetBrains Mono"/>
                 <a:ea typeface="JetBrains Mono"/>
@@ -2847,7 +2875,7 @@
           <p:nvPr/>
         </p:nvPicPr>
         <p:blipFill>
-          <a:blip xmlns:r="http://schemas.openxmlformats.org/officeDocument/2006/relationships" xmlns:a="http://schemas.openxmlformats.org/drawingml/2006/main" r:embed="R5b01872d0b744017"/>
+          <a:blip xmlns:r="http://schemas.openxmlformats.org/officeDocument/2006/relationships" xmlns:a="http://schemas.openxmlformats.org/drawingml/2006/main" r:embed="R40fb05829720448a"/>
           <a:srcRect xmlns:a="http://schemas.openxmlformats.org/drawingml/2006/main" l="0" t="4999" r="0" b="4999"/>
           <a:stretch xmlns:a="http://schemas.openxmlformats.org/drawingml/2006/main">
             <a:fillRect l="0" t="0" r="0" b="0"/>
@@ -3296,7 +3324,7 @@
           <p:nvPr/>
         </p:nvPicPr>
         <p:blipFill>
-          <a:blip xmlns:r="http://schemas.openxmlformats.org/officeDocument/2006/relationships" xmlns:a="http://schemas.openxmlformats.org/drawingml/2006/main" r:embed="Rb02704a5ee4c472c">
+          <a:blip xmlns:r="http://schemas.openxmlformats.org/officeDocument/2006/relationships" xmlns:a="http://schemas.openxmlformats.org/drawingml/2006/main" r:embed="R5b3061d3ffdc40b0">
             <a:alphaModFix amt="96000"/>
           </a:blip>
           <a:stretch xmlns:a="http://schemas.openxmlformats.org/drawingml/2006/main">
@@ -5249,10 +5277,10 @@
           <p:nvPr/>
         </p:nvPicPr>
         <p:blipFill>
-          <a:blip xmlns:r="http://schemas.openxmlformats.org/officeDocument/2006/relationships" xmlns:a="http://schemas.openxmlformats.org/drawingml/2006/main" r:embed="R0650a63633594d64">
+          <a:blip xmlns:r="http://schemas.openxmlformats.org/officeDocument/2006/relationships" xmlns:a="http://schemas.openxmlformats.org/drawingml/2006/main" r:embed="Rd8d5e6d9db5a4c14">
             <a:extLst>
               <a:ext uri="{96DAC541-7B7A-43D3-8B79-37D633B846F1}">
-                <asvg:svgBlip xmlns:asvg="http://schemas.microsoft.com/office/drawing/2016/SVG/main" r:embed="Rf02bdc1a4f084841"/>
+                <asvg:svgBlip xmlns:asvg="http://schemas.microsoft.com/office/drawing/2016/SVG/main" r:embed="Rb7b68bab28744e5e"/>
               </a:ext>
             </a:extLst>
           </a:blip>
@@ -5312,7 +5340,7 @@
           <p:nvPr/>
         </p:nvPicPr>
         <p:blipFill>
-          <a:blip xmlns:r="http://schemas.openxmlformats.org/officeDocument/2006/relationships" xmlns:a="http://schemas.openxmlformats.org/drawingml/2006/main" r:embed="R8a26b0e9136348cc"/>
+          <a:blip xmlns:r="http://schemas.openxmlformats.org/officeDocument/2006/relationships" xmlns:a="http://schemas.openxmlformats.org/drawingml/2006/main" r:embed="R9f3dddee98ba4cc8"/>
           <a:stretch xmlns:a="http://schemas.openxmlformats.org/drawingml/2006/main"/>
         </p:blipFill>
         <p:spPr>
@@ -5369,10 +5397,10 @@
           <p:nvPr/>
         </p:nvPicPr>
         <p:blipFill>
-          <a:blip xmlns:r="http://schemas.openxmlformats.org/officeDocument/2006/relationships" xmlns:a="http://schemas.openxmlformats.org/drawingml/2006/main" r:embed="Rbde67907c8574b3c">
+          <a:blip xmlns:r="http://schemas.openxmlformats.org/officeDocument/2006/relationships" xmlns:a="http://schemas.openxmlformats.org/drawingml/2006/main" r:embed="R8d369514f5f94b09">
             <a:extLst>
               <a:ext uri="{96DAC541-7B7A-43D3-8B79-37D633B846F1}">
-                <asvg:svgBlip xmlns:asvg="http://schemas.microsoft.com/office/drawing/2016/SVG/main" r:embed="R6f1ba0925d01408b"/>
+                <asvg:svgBlip xmlns:asvg="http://schemas.microsoft.com/office/drawing/2016/SVG/main" r:embed="R466b714116d643a6"/>
               </a:ext>
             </a:extLst>
           </a:blip>
@@ -5432,10 +5460,10 @@
           <p:nvPr/>
         </p:nvPicPr>
         <p:blipFill>
-          <a:blip xmlns:r="http://schemas.openxmlformats.org/officeDocument/2006/relationships" xmlns:a="http://schemas.openxmlformats.org/drawingml/2006/main" r:embed="Rd6d86765a0bd41c9">
+          <a:blip xmlns:r="http://schemas.openxmlformats.org/officeDocument/2006/relationships" xmlns:a="http://schemas.openxmlformats.org/drawingml/2006/main" r:embed="R8b62bfbf1b48431b">
             <a:extLst>
               <a:ext uri="{96DAC541-7B7A-43D3-8B79-37D633B846F1}">
-                <asvg:svgBlip xmlns:asvg="http://schemas.microsoft.com/office/drawing/2016/SVG/main" r:embed="Rd36199e2b24a4e8e"/>
+                <asvg:svgBlip xmlns:asvg="http://schemas.microsoft.com/office/drawing/2016/SVG/main" r:embed="R4a620937b2004ce7"/>
               </a:ext>
             </a:extLst>
           </a:blip>
@@ -5495,10 +5523,10 @@
           <p:nvPr/>
         </p:nvPicPr>
         <p:blipFill>
-          <a:blip xmlns:r="http://schemas.openxmlformats.org/officeDocument/2006/relationships" xmlns:a="http://schemas.openxmlformats.org/drawingml/2006/main" r:embed="R8a26b0e9136348cc">
+          <a:blip xmlns:r="http://schemas.openxmlformats.org/officeDocument/2006/relationships" xmlns:a="http://schemas.openxmlformats.org/drawingml/2006/main" r:embed="R9f3dddee98ba4cc8">
             <a:extLst>
               <a:ext uri="{96DAC541-7B7A-43D3-8B79-37D633B846F1}">
-                <asvg:svgBlip xmlns:asvg="http://schemas.microsoft.com/office/drawing/2016/SVG/main" r:embed="R81a37701d80644c6"/>
+                <asvg:svgBlip xmlns:asvg="http://schemas.microsoft.com/office/drawing/2016/SVG/main" r:embed="Reef662bdbeac4a51"/>
               </a:ext>
             </a:extLst>
           </a:blip>
@@ -5558,7 +5586,7 @@
           <p:nvPr/>
         </p:nvPicPr>
         <p:blipFill>
-          <a:blip xmlns:r="http://schemas.openxmlformats.org/officeDocument/2006/relationships" xmlns:a="http://schemas.openxmlformats.org/drawingml/2006/main" r:embed="R780beeb7e3e64a94"/>
+          <a:blip xmlns:r="http://schemas.openxmlformats.org/officeDocument/2006/relationships" xmlns:a="http://schemas.openxmlformats.org/drawingml/2006/main" r:embed="Rc67b07975d7d46b3"/>
           <a:stretch xmlns:a="http://schemas.openxmlformats.org/drawingml/2006/main"/>
         </p:blipFill>
         <p:spPr>
@@ -5609,7 +5637,7 @@
           <p:nvPr/>
         </p:nvPicPr>
         <p:blipFill>
-          <a:blip xmlns:r="http://schemas.openxmlformats.org/officeDocument/2006/relationships" xmlns:a="http://schemas.openxmlformats.org/drawingml/2006/main" r:embed="R680bd46f4bea47d5">
+          <a:blip xmlns:r="http://schemas.openxmlformats.org/officeDocument/2006/relationships" xmlns:a="http://schemas.openxmlformats.org/drawingml/2006/main" r:embed="R35c8adc4709f4470">
             <a:alphaModFix amt="96000"/>
           </a:blip>
           <a:stretch xmlns:a="http://schemas.openxmlformats.org/drawingml/2006/main">
@@ -8838,7 +8866,7 @@
           <p:nvPr/>
         </p:nvPicPr>
         <p:blipFill>
-          <a:blip xmlns:r="http://schemas.openxmlformats.org/officeDocument/2006/relationships" xmlns:a="http://schemas.openxmlformats.org/drawingml/2006/main" r:embed="R447e569e9e114ebf"/>
+          <a:blip xmlns:r="http://schemas.openxmlformats.org/officeDocument/2006/relationships" xmlns:a="http://schemas.openxmlformats.org/drawingml/2006/main" r:embed="R7fe0d0e8ab614532"/>
           <a:stretch xmlns:a="http://schemas.openxmlformats.org/drawingml/2006/main">
             <a:fillRect l="0" t="0" r="0" b="0"/>
           </a:stretch>
@@ -10167,7 +10195,7 @@
           <p:nvPr/>
         </p:nvPicPr>
         <p:blipFill>
-          <a:blip xmlns:r="http://schemas.openxmlformats.org/officeDocument/2006/relationships" xmlns:a="http://schemas.openxmlformats.org/drawingml/2006/main" r:embed="R4497a4cb37854f79">
+          <a:blip xmlns:r="http://schemas.openxmlformats.org/officeDocument/2006/relationships" xmlns:a="http://schemas.openxmlformats.org/drawingml/2006/main" r:embed="R71e1994f09844372">
             <a:alphaModFix amt="96000"/>
           </a:blip>
           <a:stretch xmlns:a="http://schemas.openxmlformats.org/drawingml/2006/main">
@@ -12400,7 +12428,7 @@
           <p:nvPr/>
         </p:nvPicPr>
         <p:blipFill>
-          <a:blip xmlns:r="http://schemas.openxmlformats.org/officeDocument/2006/relationships" xmlns:a="http://schemas.openxmlformats.org/drawingml/2006/main" r:embed="R2b051c852ef64b67"/>
+          <a:blip xmlns:r="http://schemas.openxmlformats.org/officeDocument/2006/relationships" xmlns:a="http://schemas.openxmlformats.org/drawingml/2006/main" r:embed="R4534e3ed8b4f41dc"/>
           <a:srcRect xmlns:a="http://schemas.openxmlformats.org/drawingml/2006/main" l="9091" t="0" r="9091" b="0"/>
           <a:stretch xmlns:a="http://schemas.openxmlformats.org/drawingml/2006/main">
             <a:fillRect l="0" t="0" r="0" b="0"/>
@@ -13425,7 +13453,7 @@
           <p:nvPr/>
         </p:nvPicPr>
         <p:blipFill>
-          <a:blip xmlns:r="http://schemas.openxmlformats.org/officeDocument/2006/relationships" xmlns:a="http://schemas.openxmlformats.org/drawingml/2006/main" r:embed="Rba18127e2d3447d6"/>
+          <a:blip xmlns:r="http://schemas.openxmlformats.org/officeDocument/2006/relationships" xmlns:a="http://schemas.openxmlformats.org/drawingml/2006/main" r:embed="R9e60fc96ec7b4978"/>
           <a:srcRect xmlns:a="http://schemas.openxmlformats.org/drawingml/2006/main" l="2676" t="0" r="2676" b="0"/>
           <a:stretch xmlns:a="http://schemas.openxmlformats.org/drawingml/2006/main">
             <a:fillRect l="0" t="0" r="0" b="0"/>
@@ -17080,14 +17108,14 @@
       </p:grpSpPr>
       <p:pic>
         <p:nvPicPr>
-          <p:cNvPr id="28" name="Image 0"/>
+          <p:cNvPr id="46" name="Image 0"/>
           <p:cNvPicPr>
             <a:picLocks xmlns:a="http://schemas.openxmlformats.org/drawingml/2006/main" noChangeAspect="1"/>
           </p:cNvPicPr>
           <p:nvPr/>
         </p:nvPicPr>
         <p:blipFill>
-          <a:blip xmlns:r="http://schemas.openxmlformats.org/officeDocument/2006/relationships" xmlns:a="http://schemas.openxmlformats.org/drawingml/2006/main" r:embed="Ref8ea0f3198c45a3">
+          <a:blip xmlns:r="http://schemas.openxmlformats.org/officeDocument/2006/relationships" xmlns:a="http://schemas.openxmlformats.org/drawingml/2006/main" r:embed="R4431eac15f6740a4">
             <a:alphaModFix amt="96000"/>
           </a:blip>
           <a:stretch xmlns:a="http://schemas.openxmlformats.org/drawingml/2006/main">
@@ -17429,7 +17457,7 @@
       </p:sp>
       <p:graphicFrame>
         <p:nvGraphicFramePr>
-          <p:cNvPr id="36" name="Table 0"/>
+          <p:cNvPr id="54" name="Table 0"/>
           <p:cNvGraphicFramePr/>
           <p:nvPr/>
         </p:nvGraphicFramePr>
@@ -17465,7 +17493,7 @@
                           <a:ea typeface="JetBrains Mono"/>
                           <a:cs typeface="JetBrains Mono"/>
                         </a:rPr>
-                        <a:t>BUYER WEDGE</a:t>
+                        <a:t/>
                       </a:r>
                       <a:endParaRPr sz="900">
                         <a:latin typeface="JetBrains Mono"/>
@@ -17500,7 +17528,7 @@
                       <a:prstDash val="solid"/>
                     </a:lnB>
                     <a:solidFill>
-                      <a:srgbClr val="E7B14A"/>
+                      <a:srgbClr val="050505"/>
                     </a:solidFill>
                   </a:tcPr>
                 </a:tc>
@@ -17521,7 +17549,7 @@
                           <a:ea typeface="JetBrains Mono"/>
                           <a:cs typeface="JetBrains Mono"/>
                         </a:rPr>
-                        <a:t>MISSION PROFILE</a:t>
+                        <a:t/>
                       </a:r>
                       <a:endParaRPr sz="900">
                         <a:latin typeface="JetBrains Mono"/>
@@ -17556,7 +17584,7 @@
                       <a:prstDash val="solid"/>
                     </a:lnB>
                     <a:solidFill>
-                      <a:srgbClr val="E7B14A"/>
+                      <a:srgbClr val="050505"/>
                     </a:solidFill>
                   </a:tcPr>
                 </a:tc>
@@ -17577,7 +17605,7 @@
                           <a:ea typeface="JetBrains Mono"/>
                           <a:cs typeface="JetBrains Mono"/>
                         </a:rPr>
-                        <a:t>PAIN WE SOLVE</a:t>
+                        <a:t/>
                       </a:r>
                       <a:endParaRPr sz="900">
                         <a:latin typeface="JetBrains Mono"/>
@@ -17612,7 +17640,7 @@
                       <a:prstDash val="solid"/>
                     </a:lnB>
                     <a:solidFill>
-                      <a:srgbClr val="E7B14A"/>
+                      <a:srgbClr val="050505"/>
                     </a:solidFill>
                   </a:tcPr>
                 </a:tc>
@@ -17633,7 +17661,7 @@
                           <a:ea typeface="JetBrains Mono"/>
                           <a:cs typeface="JetBrains Mono"/>
                         </a:rPr>
-                        <a:t>LANDING MOTION</a:t>
+                        <a:t/>
                       </a:r>
                       <a:endParaRPr sz="900">
                         <a:latin typeface="JetBrains Mono"/>
@@ -17668,7 +17696,7 @@
                       <a:prstDash val="solid"/>
                     </a:lnB>
                     <a:solidFill>
-                      <a:srgbClr val="E7B14A"/>
+                      <a:srgbClr val="050505"/>
                     </a:solidFill>
                   </a:tcPr>
                 </a:tc>
@@ -17691,7 +17719,7 @@
                           <a:ea typeface="IBM Plex Sans"/>
                           <a:cs typeface="IBM Plex Sans"/>
                         </a:rPr>
-                        <a:t>Commercial satcom</a:t>
+                        <a:t/>
                       </a:r>
                       <a:endParaRPr sz="900">
                         <a:latin typeface="IBM Plex Sans"/>
@@ -17726,7 +17754,7 @@
                       <a:prstDash val="solid"/>
                     </a:lnB>
                     <a:solidFill>
-                      <a:srgbClr val="0D1010"/>
+                      <a:srgbClr val="050505"/>
                     </a:solidFill>
                   </a:tcPr>
                 </a:tc>
@@ -17747,7 +17775,7 @@
                           <a:ea typeface="IBM Plex Sans"/>
                           <a:cs typeface="IBM Plex Sans"/>
                         </a:rPr>
-                        <a:t>LEO / MEO fleets</a:t>
+                        <a:t/>
                       </a:r>
                       <a:endParaRPr sz="900">
                         <a:latin typeface="IBM Plex Sans"/>
@@ -17782,7 +17810,7 @@
                       <a:prstDash val="solid"/>
                     </a:lnB>
                     <a:solidFill>
-                      <a:srgbClr val="0D1010"/>
+                      <a:srgbClr val="050505"/>
                     </a:solidFill>
                   </a:tcPr>
                 </a:tc>
@@ -17803,7 +17831,7 @@
                           <a:ea typeface="IBM Plex Sans"/>
                           <a:cs typeface="IBM Plex Sans"/>
                         </a:rPr>
-                        <a:t>Fleet-wide evidence, replay, stale/gap detection</a:t>
+                        <a:t/>
                       </a:r>
                       <a:endParaRPr sz="900">
                         <a:latin typeface="IBM Plex Sans"/>
@@ -17838,7 +17866,7 @@
                       <a:prstDash val="solid"/>
                     </a:lnB>
                     <a:solidFill>
-                      <a:srgbClr val="0D1010"/>
+                      <a:srgbClr val="050505"/>
                     </a:solidFill>
                   </a:tcPr>
                 </a:tc>
@@ -17859,7 +17887,7 @@
                           <a:ea typeface="IBM Plex Sans"/>
                           <a:cs typeface="IBM Plex Sans"/>
                         </a:rPr>
-                        <a:t>Pilot → annual fleet license</a:t>
+                        <a:t/>
                       </a:r>
                       <a:endParaRPr sz="900">
                         <a:latin typeface="IBM Plex Sans"/>
@@ -17894,7 +17922,7 @@
                       <a:prstDash val="solid"/>
                     </a:lnB>
                     <a:solidFill>
-                      <a:srgbClr val="0D1010"/>
+                      <a:srgbClr val="050505"/>
                     </a:solidFill>
                   </a:tcPr>
                 </a:tc>
@@ -17917,7 +17945,7 @@
                           <a:ea typeface="IBM Plex Sans"/>
                           <a:cs typeface="IBM Plex Sans"/>
                         </a:rPr>
-                        <a:t>Weather + space weather</a:t>
+                        <a:t/>
                       </a:r>
                       <a:endParaRPr sz="900">
                         <a:latin typeface="IBM Plex Sans"/>
@@ -17952,7 +17980,7 @@
                       <a:prstDash val="solid"/>
                     </a:lnB>
                     <a:solidFill>
-                      <a:srgbClr val="101414"/>
+                      <a:srgbClr val="050505"/>
                     </a:solidFill>
                   </a:tcPr>
                 </a:tc>
@@ -17973,7 +18001,7 @@
                           <a:ea typeface="IBM Plex Sans"/>
                           <a:cs typeface="IBM Plex Sans"/>
                         </a:rPr>
-                        <a:t>GEO ground segment</a:t>
+                        <a:t/>
                       </a:r>
                       <a:endParaRPr sz="900">
                         <a:latin typeface="IBM Plex Sans"/>
@@ -18008,7 +18036,7 @@
                       <a:prstDash val="solid"/>
                     </a:lnB>
                     <a:solidFill>
-                      <a:srgbClr val="101414"/>
+                      <a:srgbClr val="050505"/>
                     </a:solidFill>
                   </a:tcPr>
                 </a:tc>
@@ -18029,7 +18057,7 @@
                           <a:ea typeface="IBM Plex Sans"/>
                           <a:cs typeface="IBM Plex Sans"/>
                         </a:rPr>
-                        <a:t>Radiation context, quality, operator confidence</a:t>
+                        <a:t/>
                       </a:r>
                       <a:endParaRPr sz="900">
                         <a:latin typeface="IBM Plex Sans"/>
@@ -18064,7 +18092,7 @@
                       <a:prstDash val="solid"/>
                     </a:lnB>
                     <a:solidFill>
-                      <a:srgbClr val="101414"/>
+                      <a:srgbClr val="050505"/>
                     </a:solidFill>
                   </a:tcPr>
                 </a:tc>
@@ -18085,7 +18113,7 @@
                           <a:ea typeface="IBM Plex Sans"/>
                           <a:cs typeface="IBM Plex Sans"/>
                         </a:rPr>
-                        <a:t>Ground assurance + data partner</a:t>
+                        <a:t/>
                       </a:r>
                       <a:endParaRPr sz="900">
                         <a:latin typeface="IBM Plex Sans"/>
@@ -18120,7 +18148,7 @@
                       <a:prstDash val="solid"/>
                     </a:lnB>
                     <a:solidFill>
-                      <a:srgbClr val="101414"/>
+                      <a:srgbClr val="050505"/>
                     </a:solidFill>
                   </a:tcPr>
                 </a:tc>
@@ -18143,7 +18171,7 @@
                           <a:ea typeface="IBM Plex Sans"/>
                           <a:cs typeface="IBM Plex Sans"/>
                         </a:rPr>
-                        <a:t>Earth observation</a:t>
+                        <a:t/>
                       </a:r>
                       <a:endParaRPr sz="900">
                         <a:latin typeface="IBM Plex Sans"/>
@@ -18178,7 +18206,7 @@
                       <a:prstDash val="solid"/>
                     </a:lnB>
                     <a:solidFill>
-                      <a:srgbClr val="0D1010"/>
+                      <a:srgbClr val="050505"/>
                     </a:solidFill>
                   </a:tcPr>
                 </a:tc>
@@ -18199,7 +18227,7 @@
                           <a:ea typeface="IBM Plex Sans"/>
                           <a:cs typeface="IBM Plex Sans"/>
                         </a:rPr>
-                        <a:t>LEO data relay</a:t>
+                        <a:t/>
                       </a:r>
                       <a:endParaRPr sz="900">
                         <a:latin typeface="IBM Plex Sans"/>
@@ -18234,7 +18262,7 @@
                       <a:prstDash val="solid"/>
                     </a:lnB>
                     <a:solidFill>
-                      <a:srgbClr val="0D1010"/>
+                      <a:srgbClr val="050505"/>
                     </a:solidFill>
                   </a:tcPr>
                 </a:tc>
@@ -18255,7 +18283,7 @@
                           <a:ea typeface="IBM Plex Sans"/>
                           <a:cs typeface="IBM Plex Sans"/>
                         </a:rPr>
-                        <a:t>Data lineage, anomaly triage, integration assurance</a:t>
+                        <a:t/>
                       </a:r>
                       <a:endParaRPr sz="900">
                         <a:latin typeface="IBM Plex Sans"/>
@@ -18290,7 +18318,7 @@
                       <a:prstDash val="solid"/>
                     </a:lnB>
                     <a:solidFill>
-                      <a:srgbClr val="0D1010"/>
+                      <a:srgbClr val="050505"/>
                     </a:solidFill>
                   </a:tcPr>
                 </a:tc>
@@ -18311,7 +18339,7 @@
                           <a:ea typeface="IBM Plex Sans"/>
                           <a:cs typeface="IBM Plex Sans"/>
                         </a:rPr>
-                        <a:t>Integration package</a:t>
+                        <a:t/>
                       </a:r>
                       <a:endParaRPr sz="900">
                         <a:latin typeface="IBM Plex Sans"/>
@@ -18346,7 +18374,7 @@
                       <a:prstDash val="solid"/>
                     </a:lnB>
                     <a:solidFill>
-                      <a:srgbClr val="0D1010"/>
+                      <a:srgbClr val="050505"/>
                     </a:solidFill>
                   </a:tcPr>
                 </a:tc>
@@ -18369,7 +18397,7 @@
                           <a:ea typeface="IBM Plex Sans"/>
                           <a:cs typeface="IBM Plex Sans"/>
                         </a:rPr>
-                        <a:t>Lunar relay / integrator</a:t>
+                        <a:t/>
                       </a:r>
                       <a:endParaRPr sz="900">
                         <a:latin typeface="IBM Plex Sans"/>
@@ -18404,7 +18432,7 @@
                       <a:prstDash val="solid"/>
                     </a:lnB>
                     <a:solidFill>
-                      <a:srgbClr val="101414"/>
+                      <a:srgbClr val="050505"/>
                     </a:solidFill>
                   </a:tcPr>
                 </a:tc>
@@ -18425,7 +18453,7 @@
                           <a:ea typeface="IBM Plex Sans"/>
                           <a:cs typeface="IBM Plex Sans"/>
                         </a:rPr>
-                        <a:t>Lunar + ground simulation</a:t>
+                        <a:t/>
                       </a:r>
                       <a:endParaRPr sz="900">
                         <a:latin typeface="IBM Plex Sans"/>
@@ -18460,7 +18488,7 @@
                       <a:prstDash val="solid"/>
                     </a:lnB>
                     <a:solidFill>
-                      <a:srgbClr val="101414"/>
+                      <a:srgbClr val="050505"/>
                     </a:solidFill>
                   </a:tcPr>
                 </a:tc>
@@ -18481,7 +18509,7 @@
                           <a:ea typeface="IBM Plex Sans"/>
                           <a:cs typeface="IBM Plex Sans"/>
                         </a:rPr>
-                        <a:t>DTN, provenance, approval-gated compute</a:t>
+                        <a:t/>
                       </a:r>
                       <a:endParaRPr sz="900">
                         <a:latin typeface="IBM Plex Sans"/>
@@ -18516,7 +18544,7 @@
                       <a:prstDash val="solid"/>
                     </a:lnB>
                     <a:solidFill>
-                      <a:srgbClr val="101414"/>
+                      <a:srgbClr val="050505"/>
                     </a:solidFill>
                   </a:tcPr>
                 </a:tc>
@@ -18537,7 +18565,7 @@
                           <a:ea typeface="IBM Plex Sans"/>
                           <a:cs typeface="IBM Plex Sans"/>
                         </a:rPr>
-                        <a:t>Bridge-node design partner</a:t>
+                        <a:t/>
                       </a:r>
                       <a:endParaRPr sz="900">
                         <a:latin typeface="IBM Plex Sans"/>
@@ -18572,7 +18600,7 @@
                       <a:prstDash val="solid"/>
                     </a:lnB>
                     <a:solidFill>
-                      <a:srgbClr val="101414"/>
+                      <a:srgbClr val="050505"/>
                     </a:solidFill>
                   </a:tcPr>
                 </a:tc>
@@ -18607,7 +18635,7 @@
         </p:spPr>
         <p:txBody>
           <a:bodyPr xmlns:a="http://schemas.openxmlformats.org/drawingml/2006/main" wrap="square" lIns="0" tIns="0" rIns="0" bIns="0" anchor="ctr">
-            <a:normAutofit/>
+            <a:normAutofit fontScale="100000"/>
           </a:bodyPr>
           <a:lstStyle xmlns:a="http://schemas.openxmlformats.org/drawingml/2006/main"/>
           <a:p xmlns:a="http://schemas.openxmlformats.org/drawingml/2006/main">
@@ -18626,7 +18654,7 @@
                 <a:ea typeface="Inter"/>
                 <a:cs typeface="Inter"/>
               </a:rPr>
-              <a:t>8 research profiles across satcom, weather/space weather, Earth observation, PNT, lunar relay, and mission integration.</a:t>
+              <a:t>8 sourced research profiles across five buyer wedges; no signed customers.</a:t>
             </a:r>
             <a:endParaRPr sz="1400"/>
           </a:p>
@@ -18681,6 +18709,797 @@
               <a:t>6</a:t>
             </a:fld>
             <a:endParaRPr/>
+          </a:p>
+        </p:txBody>
+      </p:sp>
+      <p:sp>
+        <p:nvSpPr>
+          <p:cNvPr id="28" name="profile-mix-label">
+            <a:extLst xmlns:a="http://schemas.openxmlformats.org/drawingml/2006/main">
+              <a:ext uri="{FF2B5EF4-FFF2-40B4-BE49-F238E27FC236}">
+                <a16:creationId xmlns:a16="http://schemas.microsoft.com/office/drawing/2014/main" id="{BA6B8842-9F8C-4636-A08B-1D77502C7D3C}"/>
+              </a:ext>
+            </a:extLst>
+          </p:cNvPr>
+          <p:cNvSpPr>
+            <a:spLocks xmlns:a="http://schemas.openxmlformats.org/drawingml/2006/main" noGrp="1"/>
+          </p:cNvSpPr>
+          <p:nvPr/>
+        </p:nvSpPr>
+        <p:spPr>
+          <a:xfrm xmlns:a="http://schemas.openxmlformats.org/drawingml/2006/main">
+            <a:off x="685800" y="1943100"/>
+            <a:ext cx="4000500" cy="171450"/>
+          </a:xfrm>
+          <a:prstGeom xmlns:a="http://schemas.openxmlformats.org/drawingml/2006/main" prst="rect">
+            <a:avLst/>
+          </a:prstGeom>
+          <a:noFill xmlns:a="http://schemas.openxmlformats.org/drawingml/2006/main"/>
+          <a:ln xmlns:a="http://schemas.openxmlformats.org/drawingml/2006/main" w="0">
+            <a:noFill/>
+            <a:prstDash val="solid"/>
+          </a:ln>
+        </p:spPr>
+        <p:txBody>
+          <a:bodyPr xmlns:a="http://schemas.openxmlformats.org/drawingml/2006/main"/>
+          <a:lstStyle xmlns:a="http://schemas.openxmlformats.org/drawingml/2006/main"/>
+          <a:p xmlns:a="http://schemas.openxmlformats.org/drawingml/2006/main">
+            <a:pPr>
+              <a:defRPr sz="900" b="1">
+                <a:solidFill>
+                  <a:srgbClr val="E7B14A"/>
+                </a:solidFill>
+              </a:defRPr>
+            </a:pPr>
+            <a:r>
+              <a:rPr sz="900" b="1">
+                <a:solidFill>
+                  <a:srgbClr val="E7B14A"/>
+                </a:solidFill>
+              </a:rPr>
+              <a:t>PROFILE MIX  /  8 RESEARCH TARGETS</a:t>
+            </a:r>
+          </a:p>
+        </p:txBody>
+      </p:sp>
+      <p:sp>
+        <p:nvSpPr>
+          <p:cNvPr id="29" name="profile-grid-1">
+            <a:extLst xmlns:a="http://schemas.openxmlformats.org/drawingml/2006/main">
+              <a:ext uri="{FF2B5EF4-FFF2-40B4-BE49-F238E27FC236}">
+                <a16:creationId xmlns:a16="http://schemas.microsoft.com/office/drawing/2014/main" id="{57B3CFCB-56A3-4A2C-A5E4-F3275AA2814E}"/>
+              </a:ext>
+            </a:extLst>
+          </p:cNvPr>
+          <p:cNvSpPr>
+            <a:spLocks xmlns:a="http://schemas.openxmlformats.org/drawingml/2006/main" noGrp="1"/>
+          </p:cNvSpPr>
+          <p:nvPr/>
+        </p:nvSpPr>
+        <p:spPr>
+          <a:xfrm xmlns:a="http://schemas.openxmlformats.org/drawingml/2006/main">
+            <a:off x="6686550" y="2228850"/>
+            <a:ext cx="9525" cy="2209800"/>
+          </a:xfrm>
+          <a:prstGeom xmlns:a="http://schemas.openxmlformats.org/drawingml/2006/main" prst="rect">
+            <a:avLst/>
+          </a:prstGeom>
+          <a:solidFill xmlns:a="http://schemas.openxmlformats.org/drawingml/2006/main">
+            <a:srgbClr val="25302E"/>
+          </a:solidFill>
+          <a:ln xmlns:a="http://schemas.openxmlformats.org/drawingml/2006/main" w="0">
+            <a:solidFill>
+              <a:srgbClr val="25302E"/>
+            </a:solidFill>
+            <a:prstDash val="solid"/>
+          </a:ln>
+        </p:spPr>
+      </p:sp>
+      <p:sp>
+        <p:nvSpPr>
+          <p:cNvPr id="30" name="profile-grid-2">
+            <a:extLst xmlns:a="http://schemas.openxmlformats.org/drawingml/2006/main">
+              <a:ext uri="{FF2B5EF4-FFF2-40B4-BE49-F238E27FC236}">
+                <a16:creationId xmlns:a16="http://schemas.microsoft.com/office/drawing/2014/main" id="{5489EA37-BD5F-4358-B4EA-AE329C53A485}"/>
+              </a:ext>
+            </a:extLst>
+          </p:cNvPr>
+          <p:cNvSpPr>
+            <a:spLocks xmlns:a="http://schemas.openxmlformats.org/drawingml/2006/main" noGrp="1"/>
+          </p:cNvSpPr>
+          <p:nvPr/>
+        </p:nvSpPr>
+        <p:spPr>
+          <a:xfrm xmlns:a="http://schemas.openxmlformats.org/drawingml/2006/main">
+            <a:off x="10972800" y="2228850"/>
+            <a:ext cx="9525" cy="2209800"/>
+          </a:xfrm>
+          <a:prstGeom xmlns:a="http://schemas.openxmlformats.org/drawingml/2006/main" prst="rect">
+            <a:avLst/>
+          </a:prstGeom>
+          <a:solidFill xmlns:a="http://schemas.openxmlformats.org/drawingml/2006/main">
+            <a:srgbClr val="25302E"/>
+          </a:solidFill>
+          <a:ln xmlns:a="http://schemas.openxmlformats.org/drawingml/2006/main" w="0">
+            <a:solidFill>
+              <a:srgbClr val="25302E"/>
+            </a:solidFill>
+            <a:prstDash val="solid"/>
+          </a:ln>
+        </p:spPr>
+      </p:sp>
+      <p:sp>
+        <p:nvSpPr>
+          <p:cNvPr id="31" name="profile-label-0">
+            <a:extLst xmlns:a="http://schemas.openxmlformats.org/drawingml/2006/main">
+              <a:ext uri="{FF2B5EF4-FFF2-40B4-BE49-F238E27FC236}">
+                <a16:creationId xmlns:a16="http://schemas.microsoft.com/office/drawing/2014/main" id="{6F192035-CBED-4EC0-BAB3-48ADA93D701E}"/>
+              </a:ext>
+            </a:extLst>
+          </p:cNvPr>
+          <p:cNvSpPr>
+            <a:spLocks xmlns:a="http://schemas.openxmlformats.org/drawingml/2006/main" noGrp="1"/>
+          </p:cNvSpPr>
+          <p:nvPr/>
+        </p:nvSpPr>
+        <p:spPr>
+          <a:xfrm xmlns:a="http://schemas.openxmlformats.org/drawingml/2006/main">
+            <a:off x="685800" y="2247900"/>
+            <a:ext cx="1524000" cy="228600"/>
+          </a:xfrm>
+          <a:prstGeom xmlns:a="http://schemas.openxmlformats.org/drawingml/2006/main" prst="rect">
+            <a:avLst/>
+          </a:prstGeom>
+          <a:noFill xmlns:a="http://schemas.openxmlformats.org/drawingml/2006/main"/>
+          <a:ln xmlns:a="http://schemas.openxmlformats.org/drawingml/2006/main" w="0">
+            <a:noFill/>
+            <a:prstDash val="solid"/>
+          </a:ln>
+        </p:spPr>
+        <p:txBody>
+          <a:bodyPr xmlns:a="http://schemas.openxmlformats.org/drawingml/2006/main"/>
+          <a:lstStyle xmlns:a="http://schemas.openxmlformats.org/drawingml/2006/main"/>
+          <a:p xmlns:a="http://schemas.openxmlformats.org/drawingml/2006/main">
+            <a:pPr>
+              <a:defRPr sz="1125">
+                <a:solidFill>
+                  <a:srgbClr val="F3F0E8"/>
+                </a:solidFill>
+              </a:defRPr>
+            </a:pPr>
+            <a:r>
+              <a:rPr sz="1125">
+                <a:solidFill>
+                  <a:srgbClr val="F3F0E8"/>
+                </a:solidFill>
+              </a:rPr>
+              <a:t>Satcom</a:t>
+            </a:r>
+          </a:p>
+        </p:txBody>
+      </p:sp>
+      <p:sp>
+        <p:nvSpPr>
+          <p:cNvPr id="32" name="profile-bar-0">
+            <a:extLst xmlns:a="http://schemas.openxmlformats.org/drawingml/2006/main">
+              <a:ext uri="{FF2B5EF4-FFF2-40B4-BE49-F238E27FC236}">
+                <a16:creationId xmlns:a16="http://schemas.microsoft.com/office/drawing/2014/main" id="{E481C2C6-7B39-42FD-9BCB-5430166DFD4A}"/>
+              </a:ext>
+            </a:extLst>
+          </p:cNvPr>
+          <p:cNvSpPr>
+            <a:spLocks xmlns:a="http://schemas.openxmlformats.org/drawingml/2006/main" noGrp="1"/>
+          </p:cNvSpPr>
+          <p:nvPr/>
+        </p:nvSpPr>
+        <p:spPr>
+          <a:xfrm xmlns:a="http://schemas.openxmlformats.org/drawingml/2006/main">
+            <a:off x="2400300" y="2228850"/>
+            <a:ext cx="8572500" cy="247650"/>
+          </a:xfrm>
+          <a:prstGeom xmlns:a="http://schemas.openxmlformats.org/drawingml/2006/main" prst="roundRect">
+            <a:avLst>
+              <a:gd name="adj" fmla="val 7692"/>
+            </a:avLst>
+          </a:prstGeom>
+          <a:solidFill xmlns:a="http://schemas.openxmlformats.org/drawingml/2006/main">
+            <a:srgbClr val="CCFF00"/>
+          </a:solidFill>
+          <a:ln xmlns:a="http://schemas.openxmlformats.org/drawingml/2006/main" w="0">
+            <a:solidFill>
+              <a:srgbClr val="CCFF00"/>
+            </a:solidFill>
+            <a:prstDash val="solid"/>
+          </a:ln>
+        </p:spPr>
+      </p:sp>
+      <p:sp>
+        <p:nvSpPr>
+          <p:cNvPr id="33" name="profile-value-0">
+            <a:extLst xmlns:a="http://schemas.openxmlformats.org/drawingml/2006/main">
+              <a:ext uri="{FF2B5EF4-FFF2-40B4-BE49-F238E27FC236}">
+                <a16:creationId xmlns:a16="http://schemas.microsoft.com/office/drawing/2014/main" id="{ED9836B4-81D2-4052-B894-D56C45542834}"/>
+              </a:ext>
+            </a:extLst>
+          </p:cNvPr>
+          <p:cNvSpPr>
+            <a:spLocks xmlns:a="http://schemas.openxmlformats.org/drawingml/2006/main" noGrp="1"/>
+          </p:cNvSpPr>
+          <p:nvPr/>
+        </p:nvSpPr>
+        <p:spPr>
+          <a:xfrm xmlns:a="http://schemas.openxmlformats.org/drawingml/2006/main">
+            <a:off x="11087100" y="2238375"/>
+            <a:ext cx="419100" cy="228600"/>
+          </a:xfrm>
+          <a:prstGeom xmlns:a="http://schemas.openxmlformats.org/drawingml/2006/main" prst="rect">
+            <a:avLst/>
+          </a:prstGeom>
+          <a:noFill xmlns:a="http://schemas.openxmlformats.org/drawingml/2006/main"/>
+          <a:ln xmlns:a="http://schemas.openxmlformats.org/drawingml/2006/main" w="0">
+            <a:noFill/>
+            <a:prstDash val="solid"/>
+          </a:ln>
+        </p:spPr>
+        <p:txBody>
+          <a:bodyPr xmlns:a="http://schemas.openxmlformats.org/drawingml/2006/main"/>
+          <a:lstStyle xmlns:a="http://schemas.openxmlformats.org/drawingml/2006/main"/>
+          <a:p xmlns:a="http://schemas.openxmlformats.org/drawingml/2006/main">
+            <a:pPr>
+              <a:defRPr sz="1200" b="1">
+                <a:solidFill>
+                  <a:srgbClr val="F3F0E8"/>
+                </a:solidFill>
+              </a:defRPr>
+            </a:pPr>
+            <a:r>
+              <a:rPr sz="1200" b="1">
+                <a:solidFill>
+                  <a:srgbClr val="F3F0E8"/>
+                </a:solidFill>
+              </a:rPr>
+              <a:t>2</a:t>
+            </a:r>
+          </a:p>
+        </p:txBody>
+      </p:sp>
+      <p:sp>
+        <p:nvSpPr>
+          <p:cNvPr id="34" name="profile-label-1">
+            <a:extLst xmlns:a="http://schemas.openxmlformats.org/drawingml/2006/main">
+              <a:ext uri="{FF2B5EF4-FFF2-40B4-BE49-F238E27FC236}">
+                <a16:creationId xmlns:a16="http://schemas.microsoft.com/office/drawing/2014/main" id="{C6FBC265-BF20-43D0-86F1-7A4597D1D674}"/>
+              </a:ext>
+            </a:extLst>
+          </p:cNvPr>
+          <p:cNvSpPr>
+            <a:spLocks xmlns:a="http://schemas.openxmlformats.org/drawingml/2006/main" noGrp="1"/>
+          </p:cNvSpPr>
+          <p:nvPr/>
+        </p:nvSpPr>
+        <p:spPr>
+          <a:xfrm xmlns:a="http://schemas.openxmlformats.org/drawingml/2006/main">
+            <a:off x="685800" y="2705100"/>
+            <a:ext cx="1524000" cy="228600"/>
+          </a:xfrm>
+          <a:prstGeom xmlns:a="http://schemas.openxmlformats.org/drawingml/2006/main" prst="rect">
+            <a:avLst/>
+          </a:prstGeom>
+          <a:noFill xmlns:a="http://schemas.openxmlformats.org/drawingml/2006/main"/>
+          <a:ln xmlns:a="http://schemas.openxmlformats.org/drawingml/2006/main" w="0">
+            <a:noFill/>
+            <a:prstDash val="solid"/>
+          </a:ln>
+        </p:spPr>
+        <p:txBody>
+          <a:bodyPr xmlns:a="http://schemas.openxmlformats.org/drawingml/2006/main"/>
+          <a:lstStyle xmlns:a="http://schemas.openxmlformats.org/drawingml/2006/main"/>
+          <a:p xmlns:a="http://schemas.openxmlformats.org/drawingml/2006/main">
+            <a:pPr>
+              <a:defRPr sz="1125">
+                <a:solidFill>
+                  <a:srgbClr val="F3F0E8"/>
+                </a:solidFill>
+              </a:defRPr>
+            </a:pPr>
+            <a:r>
+              <a:rPr sz="1125">
+                <a:solidFill>
+                  <a:srgbClr val="F3F0E8"/>
+                </a:solidFill>
+              </a:rPr>
+              <a:t>Weather</a:t>
+            </a:r>
+          </a:p>
+        </p:txBody>
+      </p:sp>
+      <p:sp>
+        <p:nvSpPr>
+          <p:cNvPr id="35" name="profile-bar-1">
+            <a:extLst xmlns:a="http://schemas.openxmlformats.org/drawingml/2006/main">
+              <a:ext uri="{FF2B5EF4-FFF2-40B4-BE49-F238E27FC236}">
+                <a16:creationId xmlns:a16="http://schemas.microsoft.com/office/drawing/2014/main" id="{D07CC964-AAE8-4B36-B86C-7030A73CE7E5}"/>
+              </a:ext>
+            </a:extLst>
+          </p:cNvPr>
+          <p:cNvSpPr>
+            <a:spLocks xmlns:a="http://schemas.openxmlformats.org/drawingml/2006/main" noGrp="1"/>
+          </p:cNvSpPr>
+          <p:nvPr/>
+        </p:nvSpPr>
+        <p:spPr>
+          <a:xfrm xmlns:a="http://schemas.openxmlformats.org/drawingml/2006/main">
+            <a:off x="2400300" y="2686050"/>
+            <a:ext cx="8572500" cy="247650"/>
+          </a:xfrm>
+          <a:prstGeom xmlns:a="http://schemas.openxmlformats.org/drawingml/2006/main" prst="roundRect">
+            <a:avLst>
+              <a:gd name="adj" fmla="val 7692"/>
+            </a:avLst>
+          </a:prstGeom>
+          <a:solidFill xmlns:a="http://schemas.openxmlformats.org/drawingml/2006/main">
+            <a:srgbClr val="CCFF00"/>
+          </a:solidFill>
+          <a:ln xmlns:a="http://schemas.openxmlformats.org/drawingml/2006/main" w="0">
+            <a:solidFill>
+              <a:srgbClr val="CCFF00"/>
+            </a:solidFill>
+            <a:prstDash val="solid"/>
+          </a:ln>
+        </p:spPr>
+      </p:sp>
+      <p:sp>
+        <p:nvSpPr>
+          <p:cNvPr id="36" name="profile-value-1">
+            <a:extLst xmlns:a="http://schemas.openxmlformats.org/drawingml/2006/main">
+              <a:ext uri="{FF2B5EF4-FFF2-40B4-BE49-F238E27FC236}">
+                <a16:creationId xmlns:a16="http://schemas.microsoft.com/office/drawing/2014/main" id="{ED7864FB-0804-4AE8-B09F-E84A7D8859C0}"/>
+              </a:ext>
+            </a:extLst>
+          </p:cNvPr>
+          <p:cNvSpPr>
+            <a:spLocks xmlns:a="http://schemas.openxmlformats.org/drawingml/2006/main" noGrp="1"/>
+          </p:cNvSpPr>
+          <p:nvPr/>
+        </p:nvSpPr>
+        <p:spPr>
+          <a:xfrm xmlns:a="http://schemas.openxmlformats.org/drawingml/2006/main">
+            <a:off x="11087100" y="2695575"/>
+            <a:ext cx="419100" cy="228600"/>
+          </a:xfrm>
+          <a:prstGeom xmlns:a="http://schemas.openxmlformats.org/drawingml/2006/main" prst="rect">
+            <a:avLst/>
+          </a:prstGeom>
+          <a:noFill xmlns:a="http://schemas.openxmlformats.org/drawingml/2006/main"/>
+          <a:ln xmlns:a="http://schemas.openxmlformats.org/drawingml/2006/main" w="0">
+            <a:noFill/>
+            <a:prstDash val="solid"/>
+          </a:ln>
+        </p:spPr>
+        <p:txBody>
+          <a:bodyPr xmlns:a="http://schemas.openxmlformats.org/drawingml/2006/main"/>
+          <a:lstStyle xmlns:a="http://schemas.openxmlformats.org/drawingml/2006/main"/>
+          <a:p xmlns:a="http://schemas.openxmlformats.org/drawingml/2006/main">
+            <a:pPr>
+              <a:defRPr sz="1200" b="1">
+                <a:solidFill>
+                  <a:srgbClr val="F3F0E8"/>
+                </a:solidFill>
+              </a:defRPr>
+            </a:pPr>
+            <a:r>
+              <a:rPr sz="1200" b="1">
+                <a:solidFill>
+                  <a:srgbClr val="F3F0E8"/>
+                </a:solidFill>
+              </a:rPr>
+              <a:t>2</a:t>
+            </a:r>
+          </a:p>
+        </p:txBody>
+      </p:sp>
+      <p:sp>
+        <p:nvSpPr>
+          <p:cNvPr id="37" name="profile-label-2">
+            <a:extLst xmlns:a="http://schemas.openxmlformats.org/drawingml/2006/main">
+              <a:ext uri="{FF2B5EF4-FFF2-40B4-BE49-F238E27FC236}">
+                <a16:creationId xmlns:a16="http://schemas.microsoft.com/office/drawing/2014/main" id="{2AE3D7AA-83B3-4B04-957B-D6BA109E1CFC}"/>
+              </a:ext>
+            </a:extLst>
+          </p:cNvPr>
+          <p:cNvSpPr>
+            <a:spLocks xmlns:a="http://schemas.openxmlformats.org/drawingml/2006/main" noGrp="1"/>
+          </p:cNvSpPr>
+          <p:nvPr/>
+        </p:nvSpPr>
+        <p:spPr>
+          <a:xfrm xmlns:a="http://schemas.openxmlformats.org/drawingml/2006/main">
+            <a:off x="685800" y="3162300"/>
+            <a:ext cx="1524000" cy="228600"/>
+          </a:xfrm>
+          <a:prstGeom xmlns:a="http://schemas.openxmlformats.org/drawingml/2006/main" prst="rect">
+            <a:avLst/>
+          </a:prstGeom>
+          <a:noFill xmlns:a="http://schemas.openxmlformats.org/drawingml/2006/main"/>
+          <a:ln xmlns:a="http://schemas.openxmlformats.org/drawingml/2006/main" w="0">
+            <a:noFill/>
+            <a:prstDash val="solid"/>
+          </a:ln>
+        </p:spPr>
+        <p:txBody>
+          <a:bodyPr xmlns:a="http://schemas.openxmlformats.org/drawingml/2006/main"/>
+          <a:lstStyle xmlns:a="http://schemas.openxmlformats.org/drawingml/2006/main"/>
+          <a:p xmlns:a="http://schemas.openxmlformats.org/drawingml/2006/main">
+            <a:pPr>
+              <a:defRPr sz="1125">
+                <a:solidFill>
+                  <a:srgbClr val="F3F0E8"/>
+                </a:solidFill>
+              </a:defRPr>
+            </a:pPr>
+            <a:r>
+              <a:rPr sz="1125">
+                <a:solidFill>
+                  <a:srgbClr val="F3F0E8"/>
+                </a:solidFill>
+              </a:rPr>
+              <a:t>Earth observation</a:t>
+            </a:r>
+          </a:p>
+        </p:txBody>
+      </p:sp>
+      <p:sp>
+        <p:nvSpPr>
+          <p:cNvPr id="38" name="profile-bar-2">
+            <a:extLst xmlns:a="http://schemas.openxmlformats.org/drawingml/2006/main">
+              <a:ext uri="{FF2B5EF4-FFF2-40B4-BE49-F238E27FC236}">
+                <a16:creationId xmlns:a16="http://schemas.microsoft.com/office/drawing/2014/main" id="{62DAE713-5511-4B84-A26A-35873B54FFEF}"/>
+              </a:ext>
+            </a:extLst>
+          </p:cNvPr>
+          <p:cNvSpPr>
+            <a:spLocks xmlns:a="http://schemas.openxmlformats.org/drawingml/2006/main" noGrp="1"/>
+          </p:cNvSpPr>
+          <p:nvPr/>
+        </p:nvSpPr>
+        <p:spPr>
+          <a:xfrm xmlns:a="http://schemas.openxmlformats.org/drawingml/2006/main">
+            <a:off x="2400300" y="3143250"/>
+            <a:ext cx="4286250" cy="247650"/>
+          </a:xfrm>
+          <a:prstGeom xmlns:a="http://schemas.openxmlformats.org/drawingml/2006/main" prst="roundRect">
+            <a:avLst>
+              <a:gd name="adj" fmla="val 7692"/>
+            </a:avLst>
+          </a:prstGeom>
+          <a:solidFill xmlns:a="http://schemas.openxmlformats.org/drawingml/2006/main">
+            <a:srgbClr val="CCFF00"/>
+          </a:solidFill>
+          <a:ln xmlns:a="http://schemas.openxmlformats.org/drawingml/2006/main" w="0">
+            <a:solidFill>
+              <a:srgbClr val="CCFF00"/>
+            </a:solidFill>
+            <a:prstDash val="solid"/>
+          </a:ln>
+        </p:spPr>
+      </p:sp>
+      <p:sp>
+        <p:nvSpPr>
+          <p:cNvPr id="39" name="profile-value-2">
+            <a:extLst xmlns:a="http://schemas.openxmlformats.org/drawingml/2006/main">
+              <a:ext uri="{FF2B5EF4-FFF2-40B4-BE49-F238E27FC236}">
+                <a16:creationId xmlns:a16="http://schemas.microsoft.com/office/drawing/2014/main" id="{83B90E02-743F-4F2A-9067-D0BEAE35677A}"/>
+              </a:ext>
+            </a:extLst>
+          </p:cNvPr>
+          <p:cNvSpPr>
+            <a:spLocks xmlns:a="http://schemas.openxmlformats.org/drawingml/2006/main" noGrp="1"/>
+          </p:cNvSpPr>
+          <p:nvPr/>
+        </p:nvSpPr>
+        <p:spPr>
+          <a:xfrm xmlns:a="http://schemas.openxmlformats.org/drawingml/2006/main">
+            <a:off x="6800850" y="3152775"/>
+            <a:ext cx="419100" cy="228600"/>
+          </a:xfrm>
+          <a:prstGeom xmlns:a="http://schemas.openxmlformats.org/drawingml/2006/main" prst="rect">
+            <a:avLst/>
+          </a:prstGeom>
+          <a:noFill xmlns:a="http://schemas.openxmlformats.org/drawingml/2006/main"/>
+          <a:ln xmlns:a="http://schemas.openxmlformats.org/drawingml/2006/main" w="0">
+            <a:noFill/>
+            <a:prstDash val="solid"/>
+          </a:ln>
+        </p:spPr>
+        <p:txBody>
+          <a:bodyPr xmlns:a="http://schemas.openxmlformats.org/drawingml/2006/main"/>
+          <a:lstStyle xmlns:a="http://schemas.openxmlformats.org/drawingml/2006/main"/>
+          <a:p xmlns:a="http://schemas.openxmlformats.org/drawingml/2006/main">
+            <a:pPr>
+              <a:defRPr sz="1200" b="1">
+                <a:solidFill>
+                  <a:srgbClr val="F3F0E8"/>
+                </a:solidFill>
+              </a:defRPr>
+            </a:pPr>
+            <a:r>
+              <a:rPr sz="1200" b="1">
+                <a:solidFill>
+                  <a:srgbClr val="F3F0E8"/>
+                </a:solidFill>
+              </a:rPr>
+              <a:t>1</a:t>
+            </a:r>
+          </a:p>
+        </p:txBody>
+      </p:sp>
+      <p:sp>
+        <p:nvSpPr>
+          <p:cNvPr id="40" name="profile-label-3">
+            <a:extLst xmlns:a="http://schemas.openxmlformats.org/drawingml/2006/main">
+              <a:ext uri="{FF2B5EF4-FFF2-40B4-BE49-F238E27FC236}">
+                <a16:creationId xmlns:a16="http://schemas.microsoft.com/office/drawing/2014/main" id="{40E9C5AD-FEB7-4677-8D04-43BD41BA514B}"/>
+              </a:ext>
+            </a:extLst>
+          </p:cNvPr>
+          <p:cNvSpPr>
+            <a:spLocks xmlns:a="http://schemas.openxmlformats.org/drawingml/2006/main" noGrp="1"/>
+          </p:cNvSpPr>
+          <p:nvPr/>
+        </p:nvSpPr>
+        <p:spPr>
+          <a:xfrm xmlns:a="http://schemas.openxmlformats.org/drawingml/2006/main">
+            <a:off x="685800" y="3619500"/>
+            <a:ext cx="1524000" cy="228600"/>
+          </a:xfrm>
+          <a:prstGeom xmlns:a="http://schemas.openxmlformats.org/drawingml/2006/main" prst="rect">
+            <a:avLst/>
+          </a:prstGeom>
+          <a:noFill xmlns:a="http://schemas.openxmlformats.org/drawingml/2006/main"/>
+          <a:ln xmlns:a="http://schemas.openxmlformats.org/drawingml/2006/main" w="0">
+            <a:noFill/>
+            <a:prstDash val="solid"/>
+          </a:ln>
+        </p:spPr>
+        <p:txBody>
+          <a:bodyPr xmlns:a="http://schemas.openxmlformats.org/drawingml/2006/main"/>
+          <a:lstStyle xmlns:a="http://schemas.openxmlformats.org/drawingml/2006/main"/>
+          <a:p xmlns:a="http://schemas.openxmlformats.org/drawingml/2006/main">
+            <a:pPr>
+              <a:defRPr sz="1125">
+                <a:solidFill>
+                  <a:srgbClr val="F3F0E8"/>
+                </a:solidFill>
+              </a:defRPr>
+            </a:pPr>
+            <a:r>
+              <a:rPr sz="1125">
+                <a:solidFill>
+                  <a:srgbClr val="F3F0E8"/>
+                </a:solidFill>
+              </a:rPr>
+              <a:t>PNT</a:t>
+            </a:r>
+          </a:p>
+        </p:txBody>
+      </p:sp>
+      <p:sp>
+        <p:nvSpPr>
+          <p:cNvPr id="41" name="profile-bar-3">
+            <a:extLst xmlns:a="http://schemas.openxmlformats.org/drawingml/2006/main">
+              <a:ext uri="{FF2B5EF4-FFF2-40B4-BE49-F238E27FC236}">
+                <a16:creationId xmlns:a16="http://schemas.microsoft.com/office/drawing/2014/main" id="{83769DED-4F23-46EE-8380-1A2C7A1E126F}"/>
+              </a:ext>
+            </a:extLst>
+          </p:cNvPr>
+          <p:cNvSpPr>
+            <a:spLocks xmlns:a="http://schemas.openxmlformats.org/drawingml/2006/main" noGrp="1"/>
+          </p:cNvSpPr>
+          <p:nvPr/>
+        </p:nvSpPr>
+        <p:spPr>
+          <a:xfrm xmlns:a="http://schemas.openxmlformats.org/drawingml/2006/main">
+            <a:off x="2400300" y="3600450"/>
+            <a:ext cx="4286250" cy="247650"/>
+          </a:xfrm>
+          <a:prstGeom xmlns:a="http://schemas.openxmlformats.org/drawingml/2006/main" prst="roundRect">
+            <a:avLst>
+              <a:gd name="adj" fmla="val 7692"/>
+            </a:avLst>
+          </a:prstGeom>
+          <a:solidFill xmlns:a="http://schemas.openxmlformats.org/drawingml/2006/main">
+            <a:srgbClr val="CCFF00"/>
+          </a:solidFill>
+          <a:ln xmlns:a="http://schemas.openxmlformats.org/drawingml/2006/main" w="0">
+            <a:solidFill>
+              <a:srgbClr val="CCFF00"/>
+            </a:solidFill>
+            <a:prstDash val="solid"/>
+          </a:ln>
+        </p:spPr>
+      </p:sp>
+      <p:sp>
+        <p:nvSpPr>
+          <p:cNvPr id="42" name="profile-value-3">
+            <a:extLst xmlns:a="http://schemas.openxmlformats.org/drawingml/2006/main">
+              <a:ext uri="{FF2B5EF4-FFF2-40B4-BE49-F238E27FC236}">
+                <a16:creationId xmlns:a16="http://schemas.microsoft.com/office/drawing/2014/main" id="{6ABCF6A3-55F1-4579-BA2E-871E13CADADA}"/>
+              </a:ext>
+            </a:extLst>
+          </p:cNvPr>
+          <p:cNvSpPr>
+            <a:spLocks xmlns:a="http://schemas.openxmlformats.org/drawingml/2006/main" noGrp="1"/>
+          </p:cNvSpPr>
+          <p:nvPr/>
+        </p:nvSpPr>
+        <p:spPr>
+          <a:xfrm xmlns:a="http://schemas.openxmlformats.org/drawingml/2006/main">
+            <a:off x="6800850" y="3609975"/>
+            <a:ext cx="419100" cy="228600"/>
+          </a:xfrm>
+          <a:prstGeom xmlns:a="http://schemas.openxmlformats.org/drawingml/2006/main" prst="rect">
+            <a:avLst/>
+          </a:prstGeom>
+          <a:noFill xmlns:a="http://schemas.openxmlformats.org/drawingml/2006/main"/>
+          <a:ln xmlns:a="http://schemas.openxmlformats.org/drawingml/2006/main" w="0">
+            <a:noFill/>
+            <a:prstDash val="solid"/>
+          </a:ln>
+        </p:spPr>
+        <p:txBody>
+          <a:bodyPr xmlns:a="http://schemas.openxmlformats.org/drawingml/2006/main"/>
+          <a:lstStyle xmlns:a="http://schemas.openxmlformats.org/drawingml/2006/main"/>
+          <a:p xmlns:a="http://schemas.openxmlformats.org/drawingml/2006/main">
+            <a:pPr>
+              <a:defRPr sz="1200" b="1">
+                <a:solidFill>
+                  <a:srgbClr val="F3F0E8"/>
+                </a:solidFill>
+              </a:defRPr>
+            </a:pPr>
+            <a:r>
+              <a:rPr sz="1200" b="1">
+                <a:solidFill>
+                  <a:srgbClr val="F3F0E8"/>
+                </a:solidFill>
+              </a:rPr>
+              <a:t>1</a:t>
+            </a:r>
+          </a:p>
+        </p:txBody>
+      </p:sp>
+      <p:sp>
+        <p:nvSpPr>
+          <p:cNvPr id="43" name="profile-label-4">
+            <a:extLst xmlns:a="http://schemas.openxmlformats.org/drawingml/2006/main">
+              <a:ext uri="{FF2B5EF4-FFF2-40B4-BE49-F238E27FC236}">
+                <a16:creationId xmlns:a16="http://schemas.microsoft.com/office/drawing/2014/main" id="{8B373A2C-17E3-4363-B686-BC2709F9A13E}"/>
+              </a:ext>
+            </a:extLst>
+          </p:cNvPr>
+          <p:cNvSpPr>
+            <a:spLocks xmlns:a="http://schemas.openxmlformats.org/drawingml/2006/main" noGrp="1"/>
+          </p:cNvSpPr>
+          <p:nvPr/>
+        </p:nvSpPr>
+        <p:spPr>
+          <a:xfrm xmlns:a="http://schemas.openxmlformats.org/drawingml/2006/main">
+            <a:off x="685800" y="4076700"/>
+            <a:ext cx="1524000" cy="228600"/>
+          </a:xfrm>
+          <a:prstGeom xmlns:a="http://schemas.openxmlformats.org/drawingml/2006/main" prst="rect">
+            <a:avLst/>
+          </a:prstGeom>
+          <a:noFill xmlns:a="http://schemas.openxmlformats.org/drawingml/2006/main"/>
+          <a:ln xmlns:a="http://schemas.openxmlformats.org/drawingml/2006/main" w="0">
+            <a:noFill/>
+            <a:prstDash val="solid"/>
+          </a:ln>
+        </p:spPr>
+        <p:txBody>
+          <a:bodyPr xmlns:a="http://schemas.openxmlformats.org/drawingml/2006/main"/>
+          <a:lstStyle xmlns:a="http://schemas.openxmlformats.org/drawingml/2006/main"/>
+          <a:p xmlns:a="http://schemas.openxmlformats.org/drawingml/2006/main">
+            <a:pPr>
+              <a:defRPr sz="1125">
+                <a:solidFill>
+                  <a:srgbClr val="F3F0E8"/>
+                </a:solidFill>
+              </a:defRPr>
+            </a:pPr>
+            <a:r>
+              <a:rPr sz="1125">
+                <a:solidFill>
+                  <a:srgbClr val="F3F0E8"/>
+                </a:solidFill>
+              </a:rPr>
+              <a:t>Lunar relay</a:t>
+            </a:r>
+          </a:p>
+        </p:txBody>
+      </p:sp>
+      <p:sp>
+        <p:nvSpPr>
+          <p:cNvPr id="44" name="profile-bar-4">
+            <a:extLst xmlns:a="http://schemas.openxmlformats.org/drawingml/2006/main">
+              <a:ext uri="{FF2B5EF4-FFF2-40B4-BE49-F238E27FC236}">
+                <a16:creationId xmlns:a16="http://schemas.microsoft.com/office/drawing/2014/main" id="{E9AA72FE-7056-4A8D-9AD6-5264869CA0DA}"/>
+              </a:ext>
+            </a:extLst>
+          </p:cNvPr>
+          <p:cNvSpPr>
+            <a:spLocks xmlns:a="http://schemas.openxmlformats.org/drawingml/2006/main" noGrp="1"/>
+          </p:cNvSpPr>
+          <p:nvPr/>
+        </p:nvSpPr>
+        <p:spPr>
+          <a:xfrm xmlns:a="http://schemas.openxmlformats.org/drawingml/2006/main">
+            <a:off x="2400300" y="4057650"/>
+            <a:ext cx="8572500" cy="247650"/>
+          </a:xfrm>
+          <a:prstGeom xmlns:a="http://schemas.openxmlformats.org/drawingml/2006/main" prst="roundRect">
+            <a:avLst>
+              <a:gd name="adj" fmla="val 7692"/>
+            </a:avLst>
+          </a:prstGeom>
+          <a:solidFill xmlns:a="http://schemas.openxmlformats.org/drawingml/2006/main">
+            <a:srgbClr val="CCFF00"/>
+          </a:solidFill>
+          <a:ln xmlns:a="http://schemas.openxmlformats.org/drawingml/2006/main" w="0">
+            <a:solidFill>
+              <a:srgbClr val="CCFF00"/>
+            </a:solidFill>
+            <a:prstDash val="solid"/>
+          </a:ln>
+        </p:spPr>
+      </p:sp>
+      <p:sp>
+        <p:nvSpPr>
+          <p:cNvPr id="45" name="profile-value-4">
+            <a:extLst xmlns:a="http://schemas.openxmlformats.org/drawingml/2006/main">
+              <a:ext uri="{FF2B5EF4-FFF2-40B4-BE49-F238E27FC236}">
+                <a16:creationId xmlns:a16="http://schemas.microsoft.com/office/drawing/2014/main" id="{15638DCB-ACC5-4173-8B54-B3AD050D39F2}"/>
+              </a:ext>
+            </a:extLst>
+          </p:cNvPr>
+          <p:cNvSpPr>
+            <a:spLocks xmlns:a="http://schemas.openxmlformats.org/drawingml/2006/main" noGrp="1"/>
+          </p:cNvSpPr>
+          <p:nvPr/>
+        </p:nvSpPr>
+        <p:spPr>
+          <a:xfrm xmlns:a="http://schemas.openxmlformats.org/drawingml/2006/main">
+            <a:off x="11087100" y="4067175"/>
+            <a:ext cx="419100" cy="228600"/>
+          </a:xfrm>
+          <a:prstGeom xmlns:a="http://schemas.openxmlformats.org/drawingml/2006/main" prst="rect">
+            <a:avLst/>
+          </a:prstGeom>
+          <a:noFill xmlns:a="http://schemas.openxmlformats.org/drawingml/2006/main"/>
+          <a:ln xmlns:a="http://schemas.openxmlformats.org/drawingml/2006/main" w="0">
+            <a:noFill/>
+            <a:prstDash val="solid"/>
+          </a:ln>
+        </p:spPr>
+        <p:txBody>
+          <a:bodyPr xmlns:a="http://schemas.openxmlformats.org/drawingml/2006/main"/>
+          <a:lstStyle xmlns:a="http://schemas.openxmlformats.org/drawingml/2006/main"/>
+          <a:p xmlns:a="http://schemas.openxmlformats.org/drawingml/2006/main">
+            <a:pPr>
+              <a:defRPr sz="1200" b="1">
+                <a:solidFill>
+                  <a:srgbClr val="F3F0E8"/>
+                </a:solidFill>
+              </a:defRPr>
+            </a:pPr>
+            <a:r>
+              <a:rPr sz="1200" b="1">
+                <a:solidFill>
+                  <a:srgbClr val="F3F0E8"/>
+                </a:solidFill>
+              </a:rPr>
+              <a:t>2</a:t>
+            </a:r>
           </a:p>
         </p:txBody>
       </p:sp>
@@ -18722,7 +19541,7 @@
           <p:nvPr/>
         </p:nvPicPr>
         <p:blipFill>
-          <a:blip xmlns:r="http://schemas.openxmlformats.org/officeDocument/2006/relationships" xmlns:a="http://schemas.openxmlformats.org/drawingml/2006/main" r:embed="Ra79c8673cb854822">
+          <a:blip xmlns:r="http://schemas.openxmlformats.org/officeDocument/2006/relationships" xmlns:a="http://schemas.openxmlformats.org/drawingml/2006/main" r:embed="Rf04b017bee5e4a40">
             <a:alphaModFix amt="96000"/>
           </a:blip>
           <a:stretch xmlns:a="http://schemas.openxmlformats.org/drawingml/2006/main">
@@ -20510,7 +21329,7 @@
         </p:xfrm>
         <a:graphic xmlns:a="http://schemas.openxmlformats.org/drawingml/2006/main">
           <a:graphicData uri="http://schemas.openxmlformats.org/drawingml/2006/chart">
-            <c:chart xmlns:r="http://schemas.openxmlformats.org/officeDocument/2006/relationships" xmlns:c="http://schemas.openxmlformats.org/drawingml/2006/chart" r:id="Rc3ccdca2b12442a8"/>
+            <c:chart xmlns:r="http://schemas.openxmlformats.org/officeDocument/2006/relationships" xmlns:c="http://schemas.openxmlformats.org/drawingml/2006/chart" r:id="Rb819a769210d4c42"/>
           </a:graphicData>
         </a:graphic>
       </p:graphicFrame>

</xml_diff>

<commit_message>
Upgrade investor deck visual QA
</commit_message>
<xml_diff>
--- a/reports/presentation/Gauss_Aurora_Investor_Deck_pptxgenjs.pptx
+++ b/reports/presentation/Gauss_Aurora_Investor_Deck_pptxgenjs.pptx
@@ -2,23 +2,23 @@
 <file path=ppt/presentation.xml><?xml version="1.0" encoding="utf-8"?>
 <p:presentation xmlns:p="http://schemas.openxmlformats.org/presentationml/2006/main">
   <p:sldMasterIdLst>
-    <p:sldMasterId xmlns:r="http://schemas.openxmlformats.org/officeDocument/2006/relationships" id="2147483648" r:id="R8be26d87897a4aee"/>
+    <p:sldMasterId xmlns:r="http://schemas.openxmlformats.org/officeDocument/2006/relationships" id="2147483648" r:id="R1d14971925304943"/>
   </p:sldMasterIdLst>
   <p:notesMasterIdLst>
-    <p:notesMasterId xmlns:r="http://schemas.openxmlformats.org/officeDocument/2006/relationships" r:id="R6a5b4d8ede374e5b"/>
+    <p:notesMasterId xmlns:r="http://schemas.openxmlformats.org/officeDocument/2006/relationships" r:id="Re90b6ae77aa74e6c"/>
   </p:notesMasterIdLst>
   <p:sldIdLst>
-    <p:sldId xmlns:r="http://schemas.openxmlformats.org/officeDocument/2006/relationships" id="256" r:id="R96d8e18d1fe24c29"/>
-    <p:sldId xmlns:r="http://schemas.openxmlformats.org/officeDocument/2006/relationships" id="257" r:id="R3a16e73278df4027"/>
-    <p:sldId xmlns:r="http://schemas.openxmlformats.org/officeDocument/2006/relationships" id="258" r:id="Re5b786377bd84a89"/>
-    <p:sldId xmlns:r="http://schemas.openxmlformats.org/officeDocument/2006/relationships" id="259" r:id="R9c211ad771ee4770"/>
-    <p:sldId xmlns:r="http://schemas.openxmlformats.org/officeDocument/2006/relationships" id="260" r:id="R3150a77ab0934d80"/>
-    <p:sldId xmlns:r="http://schemas.openxmlformats.org/officeDocument/2006/relationships" id="261" r:id="Rd58c784978714611"/>
-    <p:sldId xmlns:r="http://schemas.openxmlformats.org/officeDocument/2006/relationships" id="262" r:id="Ra1b214516a1c45e7"/>
-    <p:sldId xmlns:r="http://schemas.openxmlformats.org/officeDocument/2006/relationships" id="263" r:id="R3f167debb2ca4154"/>
-    <p:sldId xmlns:r="http://schemas.openxmlformats.org/officeDocument/2006/relationships" id="264" r:id="Rc35a52087fbb4d48"/>
-    <p:sldId xmlns:r="http://schemas.openxmlformats.org/officeDocument/2006/relationships" id="265" r:id="R96bd70e0bcc0418a"/>
-    <p:sldId xmlns:r="http://schemas.openxmlformats.org/officeDocument/2006/relationships" id="266" r:id="Ra305c383379a422c"/>
+    <p:sldId xmlns:r="http://schemas.openxmlformats.org/officeDocument/2006/relationships" id="256" r:id="Rf4a651d384de45c0"/>
+    <p:sldId xmlns:r="http://schemas.openxmlformats.org/officeDocument/2006/relationships" id="257" r:id="R6a266c18ccb6433f"/>
+    <p:sldId xmlns:r="http://schemas.openxmlformats.org/officeDocument/2006/relationships" id="258" r:id="Rcceb9fa622b440df"/>
+    <p:sldId xmlns:r="http://schemas.openxmlformats.org/officeDocument/2006/relationships" id="259" r:id="R29015f9600c74673"/>
+    <p:sldId xmlns:r="http://schemas.openxmlformats.org/officeDocument/2006/relationships" id="260" r:id="R8f60aeb5c5c54d1f"/>
+    <p:sldId xmlns:r="http://schemas.openxmlformats.org/officeDocument/2006/relationships" id="261" r:id="Rd3b0d68de7704dec"/>
+    <p:sldId xmlns:r="http://schemas.openxmlformats.org/officeDocument/2006/relationships" id="262" r:id="R4cc4e2b8aa454f86"/>
+    <p:sldId xmlns:r="http://schemas.openxmlformats.org/officeDocument/2006/relationships" id="263" r:id="R07c80e33ffd14e87"/>
+    <p:sldId xmlns:r="http://schemas.openxmlformats.org/officeDocument/2006/relationships" id="264" r:id="R5727c358055f4286"/>
+    <p:sldId xmlns:r="http://schemas.openxmlformats.org/officeDocument/2006/relationships" id="265" r:id="R03147c1171ed4062"/>
+    <p:sldId xmlns:r="http://schemas.openxmlformats.org/officeDocument/2006/relationships" id="266" r:id="R51afe130ea1641c0"/>
   </p:sldIdLst>
   <p:sldSz cx="12192000" cy="6858000"/>
   <p:notesSz cx="6858000" cy="9144000"/>
@@ -1699,8 +1699,8 @@
   </p:cSld>
   <p:clrMap bg1="lt1" tx1="dk1" bg2="lt2" tx2="dk2" accent1="accent1" accent2="accent2" accent3="accent3" accent4="accent4" accent5="accent5" accent6="accent6" hlink="hlink" folHlink="folHlink"/>
   <p:sldLayoutIdLst>
-    <p:sldLayoutId xmlns:r="http://schemas.openxmlformats.org/officeDocument/2006/relationships" id="2147483649" r:id="Ree6d442c2390433a"/>
-    <p:sldLayoutId xmlns:r="http://schemas.openxmlformats.org/officeDocument/2006/relationships" id="2147483650" r:id="R0258383803684cfe"/>
+    <p:sldLayoutId xmlns:r="http://schemas.openxmlformats.org/officeDocument/2006/relationships" id="2147483649" r:id="R57b7332e1ff54166"/>
+    <p:sldLayoutId xmlns:r="http://schemas.openxmlformats.org/officeDocument/2006/relationships" id="2147483650" r:id="R282420eb1c9a47e4"/>
   </p:sldLayoutIdLst>
   <p:hf sldNum="0" hdr="0" ftr="0" dt="0"/>
   <p:txStyles>
@@ -2729,7 +2729,7 @@
           <p:nvPr/>
         </p:nvPicPr>
         <p:blipFill>
-          <a:blip xmlns:r="http://schemas.openxmlformats.org/officeDocument/2006/relationships" xmlns:a="http://schemas.openxmlformats.org/drawingml/2006/main" r:embed="R3305ff6391d14c06"/>
+          <a:blip xmlns:r="http://schemas.openxmlformats.org/officeDocument/2006/relationships" xmlns:a="http://schemas.openxmlformats.org/drawingml/2006/main" r:embed="Ra47d0a27a0b0415a"/>
           <a:srcRect xmlns:a="http://schemas.openxmlformats.org/drawingml/2006/main" l="0" t="4999" r="0" b="4999"/>
           <a:stretch xmlns:a="http://schemas.openxmlformats.org/drawingml/2006/main">
             <a:fillRect l="0" t="0" r="0" b="0"/>
@@ -3448,7 +3448,7 @@
           <p:nvPr/>
         </p:nvPicPr>
         <p:blipFill>
-          <a:blip xmlns:r="http://schemas.openxmlformats.org/officeDocument/2006/relationships" xmlns:a="http://schemas.openxmlformats.org/drawingml/2006/main" r:embed="R7511aaf799374d43"/>
+          <a:blip xmlns:r="http://schemas.openxmlformats.org/officeDocument/2006/relationships" xmlns:a="http://schemas.openxmlformats.org/drawingml/2006/main" r:embed="Rf7382b6716e14bd2"/>
           <a:stretch xmlns:a="http://schemas.openxmlformats.org/drawingml/2006/main">
             <a:fillRect l="0" t="0" r="0" b="0"/>
           </a:stretch>
@@ -4948,7 +4948,7 @@
           <p:nvPr/>
         </p:nvPicPr>
         <p:blipFill>
-          <a:blip xmlns:r="http://schemas.openxmlformats.org/officeDocument/2006/relationships" xmlns:a="http://schemas.openxmlformats.org/drawingml/2006/main" r:embed="Rad472517680342c4">
+          <a:blip xmlns:r="http://schemas.openxmlformats.org/officeDocument/2006/relationships" xmlns:a="http://schemas.openxmlformats.org/drawingml/2006/main" r:embed="Rc0ed1de5f05d43d1">
             <a:alphaModFix amt="96000"/>
           </a:blip>
           <a:stretch xmlns:a="http://schemas.openxmlformats.org/drawingml/2006/main">
@@ -7287,7 +7287,7 @@
           <p:nvPr/>
         </p:nvPicPr>
         <p:blipFill>
-          <a:blip xmlns:r="http://schemas.openxmlformats.org/officeDocument/2006/relationships" xmlns:a="http://schemas.openxmlformats.org/drawingml/2006/main" r:embed="R5a710f0a86de4559"/>
+          <a:blip xmlns:r="http://schemas.openxmlformats.org/officeDocument/2006/relationships" xmlns:a="http://schemas.openxmlformats.org/drawingml/2006/main" r:embed="Rcbf83da15120492d"/>
           <a:srcRect xmlns:a="http://schemas.openxmlformats.org/drawingml/2006/main" l="9091" t="0" r="9091" b="0"/>
           <a:stretch xmlns:a="http://schemas.openxmlformats.org/drawingml/2006/main">
             <a:fillRect l="0" t="0" r="0" b="0"/>
@@ -8416,7 +8416,7 @@
           <p:nvPr/>
         </p:nvPicPr>
         <p:blipFill>
-          <a:blip xmlns:r="http://schemas.openxmlformats.org/officeDocument/2006/relationships" xmlns:a="http://schemas.openxmlformats.org/drawingml/2006/main" r:embed="Rf51583a09ac546cb"/>
+          <a:blip xmlns:r="http://schemas.openxmlformats.org/officeDocument/2006/relationships" xmlns:a="http://schemas.openxmlformats.org/drawingml/2006/main" r:embed="R0b5a7079fdb547d2"/>
           <a:srcRect xmlns:a="http://schemas.openxmlformats.org/drawingml/2006/main" l="2676" t="0" r="2676" b="0"/>
           <a:stretch xmlns:a="http://schemas.openxmlformats.org/drawingml/2006/main">
             <a:fillRect l="0" t="0" r="0" b="0"/>
@@ -11124,7 +11124,7 @@
           <p:nvPr/>
         </p:nvPicPr>
         <p:blipFill>
-          <a:blip xmlns:r="http://schemas.openxmlformats.org/officeDocument/2006/relationships" xmlns:a="http://schemas.openxmlformats.org/drawingml/2006/main" r:embed="R58294e4ada034060">
+          <a:blip xmlns:r="http://schemas.openxmlformats.org/officeDocument/2006/relationships" xmlns:a="http://schemas.openxmlformats.org/drawingml/2006/main" r:embed="R6a2edd2ae9bf416a">
             <a:alphaModFix amt="96000"/>
           </a:blip>
           <a:stretch xmlns:a="http://schemas.openxmlformats.org/drawingml/2006/main">
@@ -13655,14 +13655,14 @@
       </p:grpSpPr>
       <p:pic>
         <p:nvPicPr>
-          <p:cNvPr id="36" name="Image 0"/>
+          <p:cNvPr id="89" name="Image 0"/>
           <p:cNvPicPr>
             <a:picLocks xmlns:a="http://schemas.openxmlformats.org/drawingml/2006/main" noChangeAspect="1"/>
           </p:cNvPicPr>
           <p:nvPr/>
         </p:nvPicPr>
         <p:blipFill>
-          <a:blip xmlns:r="http://schemas.openxmlformats.org/officeDocument/2006/relationships" xmlns:a="http://schemas.openxmlformats.org/drawingml/2006/main" r:embed="R663aa6a9806c4895">
+          <a:blip xmlns:r="http://schemas.openxmlformats.org/officeDocument/2006/relationships" xmlns:a="http://schemas.openxmlformats.org/drawingml/2006/main" r:embed="Ra34a72f9ec104ac4">
             <a:alphaModFix amt="96000"/>
           </a:blip>
           <a:stretch xmlns:a="http://schemas.openxmlformats.org/drawingml/2006/main">
@@ -15246,6 +15246,2387 @@
           <a:p xmlns:a="http://schemas.openxmlformats.org/drawingml/2006/main">
             <a:pPr>
               <a:buNone/>
+              <a:defRPr sz="900" b="0">
+                <a:solidFill>
+                  <a:srgbClr val="F3F0E8"/>
+                </a:solidFill>
+              </a:defRPr>
+            </a:pPr>
+            <a:r>
+              <a:rPr sz="900" b="0">
+                <a:solidFill>
+                  <a:srgbClr val="F3F0E8"/>
+                </a:solidFill>
+              </a:rPr>
+              <a:t>Sources: SIA / BryceTech SSIR 2026  •  WEF / McKinsey 2024  •  internal SOM model</a:t>
+            </a:r>
+          </a:p>
+        </p:txBody>
+      </p:sp>
+      <p:sp>
+        <p:nvSpPr>
+          <p:cNvPr id="36" name="tam-sam-som-cover">
+            <a:extLst xmlns:a="http://schemas.openxmlformats.org/drawingml/2006/main">
+              <a:ext uri="{FF2B5EF4-FFF2-40B4-BE49-F238E27FC236}">
+                <a16:creationId xmlns:a16="http://schemas.microsoft.com/office/drawing/2014/main" id="{A0EFAA6E-DA1F-4B35-941E-F8200EFE773B}"/>
+              </a:ext>
+            </a:extLst>
+          </p:cNvPr>
+          <p:cNvSpPr>
+            <a:spLocks xmlns:a="http://schemas.openxmlformats.org/drawingml/2006/main" noGrp="1"/>
+          </p:cNvSpPr>
+          <p:nvPr/>
+        </p:nvSpPr>
+        <p:spPr>
+          <a:xfrm xmlns:a="http://schemas.openxmlformats.org/drawingml/2006/main">
+            <a:off x="685800" y="2171700"/>
+            <a:ext cx="10817352" cy="3943350"/>
+          </a:xfrm>
+          <a:prstGeom xmlns:a="http://schemas.openxmlformats.org/drawingml/2006/main" prst="rect">
+            <a:avLst/>
+          </a:prstGeom>
+          <a:solidFill xmlns:a="http://schemas.openxmlformats.org/drawingml/2006/main">
+            <a:srgbClr val="050505"/>
+          </a:solidFill>
+          <a:ln xmlns:a="http://schemas.openxmlformats.org/drawingml/2006/main" w="0">
+            <a:solidFill>
+              <a:srgbClr val="050505"/>
+            </a:solidFill>
+            <a:prstDash val="solid"/>
+          </a:ln>
+        </p:spPr>
+      </p:sp>
+      <p:sp>
+        <p:nvSpPr>
+          <p:cNvPr id="37" name="tam-sam-som-kicker">
+            <a:extLst xmlns:a="http://schemas.openxmlformats.org/drawingml/2006/main">
+              <a:ext uri="{FF2B5EF4-FFF2-40B4-BE49-F238E27FC236}">
+                <a16:creationId xmlns:a16="http://schemas.microsoft.com/office/drawing/2014/main" id="{8B3CBF22-A64F-46FC-ACBC-F12E3D451728}"/>
+              </a:ext>
+            </a:extLst>
+          </p:cNvPr>
+          <p:cNvSpPr>
+            <a:spLocks xmlns:a="http://schemas.openxmlformats.org/drawingml/2006/main" noGrp="1"/>
+          </p:cNvSpPr>
+          <p:nvPr/>
+        </p:nvSpPr>
+        <p:spPr>
+          <a:xfrm xmlns:a="http://schemas.openxmlformats.org/drawingml/2006/main">
+            <a:off x="1066800" y="2362200"/>
+            <a:ext cx="4381500" cy="190500"/>
+          </a:xfrm>
+          <a:prstGeom xmlns:a="http://schemas.openxmlformats.org/drawingml/2006/main" prst="rect">
+            <a:avLst/>
+          </a:prstGeom>
+          <a:noFill xmlns:a="http://schemas.openxmlformats.org/drawingml/2006/main"/>
+          <a:ln xmlns:a="http://schemas.openxmlformats.org/drawingml/2006/main" w="0">
+            <a:noFill/>
+            <a:prstDash val="solid"/>
+          </a:ln>
+        </p:spPr>
+        <p:txBody>
+          <a:bodyPr xmlns:a="http://schemas.openxmlformats.org/drawingml/2006/main"/>
+          <a:lstStyle xmlns:a="http://schemas.openxmlformats.org/drawingml/2006/main"/>
+          <a:p xmlns:a="http://schemas.openxmlformats.org/drawingml/2006/main">
+            <a:pPr>
+              <a:buNone/>
+              <a:defRPr sz="1050" b="1">
+                <a:solidFill>
+                  <a:srgbClr val="F3F0E8"/>
+                </a:solidFill>
+              </a:defRPr>
+            </a:pPr>
+            <a:r>
+              <a:rPr sz="1050" b="1">
+                <a:solidFill>
+                  <a:srgbClr val="F3F0E8"/>
+                </a:solidFill>
+              </a:rPr>
+              <a:t>MARKET CONTEXT  →  REVENUE WEDGE</a:t>
+            </a:r>
+          </a:p>
+        </p:txBody>
+      </p:sp>
+      <p:sp>
+        <p:nvSpPr>
+          <p:cNvPr id="38" name="tam-sam-som-scale-note">
+            <a:extLst xmlns:a="http://schemas.openxmlformats.org/drawingml/2006/main">
+              <a:ext uri="{FF2B5EF4-FFF2-40B4-BE49-F238E27FC236}">
+                <a16:creationId xmlns:a16="http://schemas.microsoft.com/office/drawing/2014/main" id="{FB53A703-F713-42F5-951B-C63D200204A7}"/>
+              </a:ext>
+            </a:extLst>
+          </p:cNvPr>
+          <p:cNvSpPr>
+            <a:spLocks xmlns:a="http://schemas.openxmlformats.org/drawingml/2006/main" noGrp="1"/>
+          </p:cNvSpPr>
+          <p:nvPr/>
+        </p:nvSpPr>
+        <p:spPr>
+          <a:xfrm xmlns:a="http://schemas.openxmlformats.org/drawingml/2006/main">
+            <a:off x="1066800" y="2571750"/>
+            <a:ext cx="4000500" cy="171450"/>
+          </a:xfrm>
+          <a:prstGeom xmlns:a="http://schemas.openxmlformats.org/drawingml/2006/main" prst="rect">
+            <a:avLst/>
+          </a:prstGeom>
+          <a:noFill xmlns:a="http://schemas.openxmlformats.org/drawingml/2006/main"/>
+          <a:ln xmlns:a="http://schemas.openxmlformats.org/drawingml/2006/main" w="0">
+            <a:noFill/>
+            <a:prstDash val="solid"/>
+          </a:ln>
+        </p:spPr>
+        <p:txBody>
+          <a:bodyPr xmlns:a="http://schemas.openxmlformats.org/drawingml/2006/main"/>
+          <a:lstStyle xmlns:a="http://schemas.openxmlformats.org/drawingml/2006/main"/>
+          <a:p xmlns:a="http://schemas.openxmlformats.org/drawingml/2006/main">
+            <a:pPr>
+              <a:buNone/>
+              <a:defRPr sz="900" b="0">
+                <a:solidFill>
+                  <a:srgbClr val="F3F0E8"/>
+                </a:solidFill>
+              </a:defRPr>
+            </a:pPr>
+            <a:r>
+              <a:rPr sz="900" b="0">
+                <a:solidFill>
+                  <a:srgbClr val="F3F0E8"/>
+                </a:solidFill>
+              </a:rPr>
+              <a:t>Illustrative nesting; not a proportional market-share claim.</a:t>
+            </a:r>
+          </a:p>
+        </p:txBody>
+      </p:sp>
+      <p:sp>
+        <p:nvSpPr>
+          <p:cNvPr id="39" name="tam-circle">
+            <a:extLst xmlns:a="http://schemas.openxmlformats.org/drawingml/2006/main">
+              <a:ext uri="{FF2B5EF4-FFF2-40B4-BE49-F238E27FC236}">
+                <a16:creationId xmlns:a16="http://schemas.microsoft.com/office/drawing/2014/main" id="{F15158F9-7BA9-4DA9-988D-9E6D685D05BA}"/>
+              </a:ext>
+            </a:extLst>
+          </p:cNvPr>
+          <p:cNvSpPr>
+            <a:spLocks xmlns:a="http://schemas.openxmlformats.org/drawingml/2006/main" noGrp="1"/>
+          </p:cNvSpPr>
+          <p:nvPr/>
+        </p:nvSpPr>
+        <p:spPr>
+          <a:xfrm xmlns:a="http://schemas.openxmlformats.org/drawingml/2006/main">
+            <a:off x="1123950" y="2857500"/>
+            <a:ext cx="3143250" cy="3143250"/>
+          </a:xfrm>
+          <a:prstGeom xmlns:a="http://schemas.openxmlformats.org/drawingml/2006/main" prst="ellipse">
+            <a:avLst/>
+          </a:prstGeom>
+          <a:solidFill xmlns:a="http://schemas.openxmlformats.org/drawingml/2006/main">
+            <a:srgbClr val="0B1512"/>
+          </a:solidFill>
+          <a:ln xmlns:a="http://schemas.openxmlformats.org/drawingml/2006/main" w="9525">
+            <a:solidFill>
+              <a:srgbClr val="2B4434"/>
+            </a:solidFill>
+            <a:prstDash val="solid"/>
+          </a:ln>
+        </p:spPr>
+      </p:sp>
+      <p:sp>
+        <p:nvSpPr>
+          <p:cNvPr id="40" name="sam-circle">
+            <a:extLst xmlns:a="http://schemas.openxmlformats.org/drawingml/2006/main">
+              <a:ext uri="{FF2B5EF4-FFF2-40B4-BE49-F238E27FC236}">
+                <a16:creationId xmlns:a16="http://schemas.microsoft.com/office/drawing/2014/main" id="{9FE649E7-F725-455F-93EB-6EEEA3EB2456}"/>
+              </a:ext>
+            </a:extLst>
+          </p:cNvPr>
+          <p:cNvSpPr>
+            <a:spLocks xmlns:a="http://schemas.openxmlformats.org/drawingml/2006/main" noGrp="1"/>
+          </p:cNvSpPr>
+          <p:nvPr/>
+        </p:nvSpPr>
+        <p:spPr>
+          <a:xfrm xmlns:a="http://schemas.openxmlformats.org/drawingml/2006/main">
+            <a:off x="1619250" y="3352800"/>
+            <a:ext cx="2152650" cy="2152650"/>
+          </a:xfrm>
+          <a:prstGeom xmlns:a="http://schemas.openxmlformats.org/drawingml/2006/main" prst="ellipse">
+            <a:avLst/>
+          </a:prstGeom>
+          <a:solidFill xmlns:a="http://schemas.openxmlformats.org/drawingml/2006/main">
+            <a:srgbClr val="173C2A"/>
+          </a:solidFill>
+          <a:ln xmlns:a="http://schemas.openxmlformats.org/drawingml/2006/main" w="9525">
+            <a:solidFill>
+              <a:srgbClr val="5D8C2D"/>
+            </a:solidFill>
+            <a:prstDash val="solid"/>
+          </a:ln>
+        </p:spPr>
+      </p:sp>
+      <p:sp>
+        <p:nvSpPr>
+          <p:cNvPr id="41" name="som-circle">
+            <a:extLst xmlns:a="http://schemas.openxmlformats.org/drawingml/2006/main">
+              <a:ext uri="{FF2B5EF4-FFF2-40B4-BE49-F238E27FC236}">
+                <a16:creationId xmlns:a16="http://schemas.microsoft.com/office/drawing/2014/main" id="{08D5CA1B-A76B-4D63-AF61-877F3F31C1D9}"/>
+              </a:ext>
+            </a:extLst>
+          </p:cNvPr>
+          <p:cNvSpPr>
+            <a:spLocks xmlns:a="http://schemas.openxmlformats.org/drawingml/2006/main" noGrp="1"/>
+          </p:cNvSpPr>
+          <p:nvPr/>
+        </p:nvSpPr>
+        <p:spPr>
+          <a:xfrm xmlns:a="http://schemas.openxmlformats.org/drawingml/2006/main">
+            <a:off x="2190750" y="3924300"/>
+            <a:ext cx="1009650" cy="1009650"/>
+          </a:xfrm>
+          <a:prstGeom xmlns:a="http://schemas.openxmlformats.org/drawingml/2006/main" prst="ellipse">
+            <a:avLst/>
+          </a:prstGeom>
+          <a:solidFill xmlns:a="http://schemas.openxmlformats.org/drawingml/2006/main">
+            <a:srgbClr val="0B1400"/>
+          </a:solidFill>
+          <a:ln xmlns:a="http://schemas.openxmlformats.org/drawingml/2006/main" w="19050">
+            <a:solidFill>
+              <a:srgbClr val="CCFF00"/>
+            </a:solidFill>
+            <a:prstDash val="solid"/>
+          </a:ln>
+        </p:spPr>
+      </p:sp>
+      <p:sp>
+        <p:nvSpPr>
+          <p:cNvPr id="42" name="tam-label">
+            <a:extLst xmlns:a="http://schemas.openxmlformats.org/drawingml/2006/main">
+              <a:ext uri="{FF2B5EF4-FFF2-40B4-BE49-F238E27FC236}">
+                <a16:creationId xmlns:a16="http://schemas.microsoft.com/office/drawing/2014/main" id="{E4203463-C126-445B-8E39-4B5B7FB56EC0}"/>
+              </a:ext>
+            </a:extLst>
+          </p:cNvPr>
+          <p:cNvSpPr>
+            <a:spLocks xmlns:a="http://schemas.openxmlformats.org/drawingml/2006/main" noGrp="1"/>
+          </p:cNvSpPr>
+          <p:nvPr/>
+        </p:nvSpPr>
+        <p:spPr>
+          <a:xfrm xmlns:a="http://schemas.openxmlformats.org/drawingml/2006/main">
+            <a:off x="1381125" y="3305175"/>
+            <a:ext cx="1143000" cy="171450"/>
+          </a:xfrm>
+          <a:prstGeom xmlns:a="http://schemas.openxmlformats.org/drawingml/2006/main" prst="rect">
+            <a:avLst/>
+          </a:prstGeom>
+          <a:noFill xmlns:a="http://schemas.openxmlformats.org/drawingml/2006/main"/>
+          <a:ln xmlns:a="http://schemas.openxmlformats.org/drawingml/2006/main" w="0">
+            <a:noFill/>
+            <a:prstDash val="solid"/>
+          </a:ln>
+        </p:spPr>
+        <p:txBody>
+          <a:bodyPr xmlns:a="http://schemas.openxmlformats.org/drawingml/2006/main"/>
+          <a:lstStyle xmlns:a="http://schemas.openxmlformats.org/drawingml/2006/main"/>
+          <a:p xmlns:a="http://schemas.openxmlformats.org/drawingml/2006/main">
+            <a:pPr>
+              <a:buNone/>
+              <a:defRPr sz="1050" b="1">
+                <a:solidFill>
+                  <a:srgbClr val="F3F0E8"/>
+                </a:solidFill>
+              </a:defRPr>
+            </a:pPr>
+            <a:r>
+              <a:rPr sz="1050" b="1">
+                <a:solidFill>
+                  <a:srgbClr val="F3F0E8"/>
+                </a:solidFill>
+              </a:rPr>
+              <a:t>TAM</a:t>
+            </a:r>
+          </a:p>
+        </p:txBody>
+      </p:sp>
+      <p:sp>
+        <p:nvSpPr>
+          <p:cNvPr id="43" name="tam-value">
+            <a:extLst xmlns:a="http://schemas.openxmlformats.org/drawingml/2006/main">
+              <a:ext uri="{FF2B5EF4-FFF2-40B4-BE49-F238E27FC236}">
+                <a16:creationId xmlns:a16="http://schemas.microsoft.com/office/drawing/2014/main" id="{CD0FA7BB-0438-4C12-BB7B-EAB5D867A67E}"/>
+              </a:ext>
+            </a:extLst>
+          </p:cNvPr>
+          <p:cNvSpPr>
+            <a:spLocks xmlns:a="http://schemas.openxmlformats.org/drawingml/2006/main" noGrp="1"/>
+          </p:cNvSpPr>
+          <p:nvPr/>
+        </p:nvSpPr>
+        <p:spPr>
+          <a:xfrm xmlns:a="http://schemas.openxmlformats.org/drawingml/2006/main">
+            <a:off x="1381125" y="3524250"/>
+            <a:ext cx="1714500" cy="323850"/>
+          </a:xfrm>
+          <a:prstGeom xmlns:a="http://schemas.openxmlformats.org/drawingml/2006/main" prst="rect">
+            <a:avLst/>
+          </a:prstGeom>
+          <a:noFill xmlns:a="http://schemas.openxmlformats.org/drawingml/2006/main"/>
+          <a:ln xmlns:a="http://schemas.openxmlformats.org/drawingml/2006/main" w="0">
+            <a:noFill/>
+            <a:prstDash val="solid"/>
+          </a:ln>
+        </p:spPr>
+        <p:txBody>
+          <a:bodyPr xmlns:a="http://schemas.openxmlformats.org/drawingml/2006/main"/>
+          <a:lstStyle xmlns:a="http://schemas.openxmlformats.org/drawingml/2006/main"/>
+          <a:p xmlns:a="http://schemas.openxmlformats.org/drawingml/2006/main">
+            <a:pPr>
+              <a:buNone/>
+              <a:defRPr sz="2100" b="1">
+                <a:solidFill>
+                  <a:srgbClr val="CCFF00"/>
+                </a:solidFill>
+              </a:defRPr>
+            </a:pPr>
+            <a:r>
+              <a:rPr sz="2100" b="1">
+                <a:solidFill>
+                  <a:srgbClr val="CCFF00"/>
+                </a:solidFill>
+              </a:rPr>
+              <a:t>$429B</a:t>
+            </a:r>
+          </a:p>
+        </p:txBody>
+      </p:sp>
+      <p:sp>
+        <p:nvSpPr>
+          <p:cNvPr id="44" name="sam-label">
+            <a:extLst xmlns:a="http://schemas.openxmlformats.org/drawingml/2006/main">
+              <a:ext uri="{FF2B5EF4-FFF2-40B4-BE49-F238E27FC236}">
+                <a16:creationId xmlns:a16="http://schemas.microsoft.com/office/drawing/2014/main" id="{0EB42066-324C-402F-82FF-D6A87E556B42}"/>
+              </a:ext>
+            </a:extLst>
+          </p:cNvPr>
+          <p:cNvSpPr>
+            <a:spLocks xmlns:a="http://schemas.openxmlformats.org/drawingml/2006/main" noGrp="1"/>
+          </p:cNvSpPr>
+          <p:nvPr/>
+        </p:nvSpPr>
+        <p:spPr>
+          <a:xfrm xmlns:a="http://schemas.openxmlformats.org/drawingml/2006/main">
+            <a:off x="1924050" y="3848100"/>
+            <a:ext cx="1143000" cy="171450"/>
+          </a:xfrm>
+          <a:prstGeom xmlns:a="http://schemas.openxmlformats.org/drawingml/2006/main" prst="rect">
+            <a:avLst/>
+          </a:prstGeom>
+          <a:noFill xmlns:a="http://schemas.openxmlformats.org/drawingml/2006/main"/>
+          <a:ln xmlns:a="http://schemas.openxmlformats.org/drawingml/2006/main" w="0">
+            <a:noFill/>
+            <a:prstDash val="solid"/>
+          </a:ln>
+        </p:spPr>
+        <p:txBody>
+          <a:bodyPr xmlns:a="http://schemas.openxmlformats.org/drawingml/2006/main"/>
+          <a:lstStyle xmlns:a="http://schemas.openxmlformats.org/drawingml/2006/main"/>
+          <a:p xmlns:a="http://schemas.openxmlformats.org/drawingml/2006/main">
+            <a:pPr>
+              <a:buNone/>
+              <a:defRPr sz="1050" b="1">
+                <a:solidFill>
+                  <a:srgbClr val="F3F0E8"/>
+                </a:solidFill>
+              </a:defRPr>
+            </a:pPr>
+            <a:r>
+              <a:rPr sz="1050" b="1">
+                <a:solidFill>
+                  <a:srgbClr val="F3F0E8"/>
+                </a:solidFill>
+              </a:rPr>
+              <a:t>SAM</a:t>
+            </a:r>
+          </a:p>
+        </p:txBody>
+      </p:sp>
+      <p:sp>
+        <p:nvSpPr>
+          <p:cNvPr id="45" name="sam-value">
+            <a:extLst xmlns:a="http://schemas.openxmlformats.org/drawingml/2006/main">
+              <a:ext uri="{FF2B5EF4-FFF2-40B4-BE49-F238E27FC236}">
+                <a16:creationId xmlns:a16="http://schemas.microsoft.com/office/drawing/2014/main" id="{5C90AF37-8446-42E2-A879-B78AB1CF89E4}"/>
+              </a:ext>
+            </a:extLst>
+          </p:cNvPr>
+          <p:cNvSpPr>
+            <a:spLocks xmlns:a="http://schemas.openxmlformats.org/drawingml/2006/main" noGrp="1"/>
+          </p:cNvSpPr>
+          <p:nvPr/>
+        </p:nvSpPr>
+        <p:spPr>
+          <a:xfrm xmlns:a="http://schemas.openxmlformats.org/drawingml/2006/main">
+            <a:off x="1924050" y="4076700"/>
+            <a:ext cx="1524000" cy="247650"/>
+          </a:xfrm>
+          <a:prstGeom xmlns:a="http://schemas.openxmlformats.org/drawingml/2006/main" prst="rect">
+            <a:avLst/>
+          </a:prstGeom>
+          <a:noFill xmlns:a="http://schemas.openxmlformats.org/drawingml/2006/main"/>
+          <a:ln xmlns:a="http://schemas.openxmlformats.org/drawingml/2006/main" w="0">
+            <a:noFill/>
+            <a:prstDash val="solid"/>
+          </a:ln>
+        </p:spPr>
+        <p:txBody>
+          <a:bodyPr xmlns:a="http://schemas.openxmlformats.org/drawingml/2006/main"/>
+          <a:lstStyle xmlns:a="http://schemas.openxmlformats.org/drawingml/2006/main"/>
+          <a:p xmlns:a="http://schemas.openxmlformats.org/drawingml/2006/main">
+            <a:pPr>
+              <a:buNone/>
+              <a:defRPr sz="1500" b="1">
+                <a:solidFill>
+                  <a:srgbClr val="CCFF00"/>
+                </a:solidFill>
+              </a:defRPr>
+            </a:pPr>
+            <a:r>
+              <a:rPr sz="1500" b="1">
+                <a:solidFill>
+                  <a:srgbClr val="CCFF00"/>
+                </a:solidFill>
+              </a:rPr>
+              <a:t>$165.2B</a:t>
+            </a:r>
+          </a:p>
+        </p:txBody>
+      </p:sp>
+      <p:sp>
+        <p:nvSpPr>
+          <p:cNvPr id="46" name="som-label">
+            <a:extLst xmlns:a="http://schemas.openxmlformats.org/drawingml/2006/main">
+              <a:ext uri="{FF2B5EF4-FFF2-40B4-BE49-F238E27FC236}">
+                <a16:creationId xmlns:a16="http://schemas.microsoft.com/office/drawing/2014/main" id="{A6F1F002-1E6B-437F-A3BE-CD6207669F98}"/>
+              </a:ext>
+            </a:extLst>
+          </p:cNvPr>
+          <p:cNvSpPr>
+            <a:spLocks xmlns:a="http://schemas.openxmlformats.org/drawingml/2006/main" noGrp="1"/>
+          </p:cNvSpPr>
+          <p:nvPr/>
+        </p:nvSpPr>
+        <p:spPr>
+          <a:xfrm xmlns:a="http://schemas.openxmlformats.org/drawingml/2006/main">
+            <a:off x="2362200" y="4171950"/>
+            <a:ext cx="762000" cy="171450"/>
+          </a:xfrm>
+          <a:prstGeom xmlns:a="http://schemas.openxmlformats.org/drawingml/2006/main" prst="rect">
+            <a:avLst/>
+          </a:prstGeom>
+          <a:noFill xmlns:a="http://schemas.openxmlformats.org/drawingml/2006/main"/>
+          <a:ln xmlns:a="http://schemas.openxmlformats.org/drawingml/2006/main" w="0">
+            <a:noFill/>
+            <a:prstDash val="solid"/>
+          </a:ln>
+        </p:spPr>
+        <p:txBody>
+          <a:bodyPr xmlns:a="http://schemas.openxmlformats.org/drawingml/2006/main"/>
+          <a:lstStyle xmlns:a="http://schemas.openxmlformats.org/drawingml/2006/main"/>
+          <a:p xmlns:a="http://schemas.openxmlformats.org/drawingml/2006/main">
+            <a:pPr>
+              <a:buNone/>
+              <a:defRPr sz="975" b="1">
+                <a:solidFill>
+                  <a:srgbClr val="F3F0E8"/>
+                </a:solidFill>
+              </a:defRPr>
+            </a:pPr>
+            <a:r>
+              <a:rPr sz="975" b="1">
+                <a:solidFill>
+                  <a:srgbClr val="F3F0E8"/>
+                </a:solidFill>
+              </a:rPr>
+              <a:t>SOM</a:t>
+            </a:r>
+          </a:p>
+        </p:txBody>
+      </p:sp>
+      <p:sp>
+        <p:nvSpPr>
+          <p:cNvPr id="47" name="som-value">
+            <a:extLst xmlns:a="http://schemas.openxmlformats.org/drawingml/2006/main">
+              <a:ext uri="{FF2B5EF4-FFF2-40B4-BE49-F238E27FC236}">
+                <a16:creationId xmlns:a16="http://schemas.microsoft.com/office/drawing/2014/main" id="{78793726-F8B2-49B5-8A3B-D37C1109C2C5}"/>
+              </a:ext>
+            </a:extLst>
+          </p:cNvPr>
+          <p:cNvSpPr>
+            <a:spLocks xmlns:a="http://schemas.openxmlformats.org/drawingml/2006/main" noGrp="1"/>
+          </p:cNvSpPr>
+          <p:nvPr/>
+        </p:nvSpPr>
+        <p:spPr>
+          <a:xfrm xmlns:a="http://schemas.openxmlformats.org/drawingml/2006/main">
+            <a:off x="2352675" y="4400550"/>
+            <a:ext cx="857250" cy="228600"/>
+          </a:xfrm>
+          <a:prstGeom xmlns:a="http://schemas.openxmlformats.org/drawingml/2006/main" prst="rect">
+            <a:avLst/>
+          </a:prstGeom>
+          <a:noFill xmlns:a="http://schemas.openxmlformats.org/drawingml/2006/main"/>
+          <a:ln xmlns:a="http://schemas.openxmlformats.org/drawingml/2006/main" w="0">
+            <a:noFill/>
+            <a:prstDash val="solid"/>
+          </a:ln>
+        </p:spPr>
+        <p:txBody>
+          <a:bodyPr xmlns:a="http://schemas.openxmlformats.org/drawingml/2006/main"/>
+          <a:lstStyle xmlns:a="http://schemas.openxmlformats.org/drawingml/2006/main"/>
+          <a:p xmlns:a="http://schemas.openxmlformats.org/drawingml/2006/main">
+            <a:pPr>
+              <a:buNone/>
+              <a:defRPr sz="1350" b="1">
+                <a:solidFill>
+                  <a:srgbClr val="CCFF00"/>
+                </a:solidFill>
+              </a:defRPr>
+            </a:pPr>
+            <a:r>
+              <a:rPr sz="1350" b="1">
+                <a:solidFill>
+                  <a:srgbClr val="CCFF00"/>
+                </a:solidFill>
+              </a:rPr>
+              <a:t>$500k</a:t>
+            </a:r>
+          </a:p>
+        </p:txBody>
+      </p:sp>
+      <p:sp>
+        <p:nvSpPr>
+          <p:cNvPr id="48" name="tam-sam-som-divider">
+            <a:extLst xmlns:a="http://schemas.openxmlformats.org/drawingml/2006/main">
+              <a:ext uri="{FF2B5EF4-FFF2-40B4-BE49-F238E27FC236}">
+                <a16:creationId xmlns:a16="http://schemas.microsoft.com/office/drawing/2014/main" id="{6D7973CC-0E73-4309-A360-025376532C8D}"/>
+              </a:ext>
+            </a:extLst>
+          </p:cNvPr>
+          <p:cNvSpPr>
+            <a:spLocks xmlns:a="http://schemas.openxmlformats.org/drawingml/2006/main" noGrp="1"/>
+          </p:cNvSpPr>
+          <p:nvPr/>
+        </p:nvSpPr>
+        <p:spPr>
+          <a:xfrm xmlns:a="http://schemas.openxmlformats.org/drawingml/2006/main">
+            <a:off x="5391150" y="2724150"/>
+            <a:ext cx="9525" cy="3067050"/>
+          </a:xfrm>
+          <a:prstGeom xmlns:a="http://schemas.openxmlformats.org/drawingml/2006/main" prst="rect">
+            <a:avLst/>
+          </a:prstGeom>
+          <a:solidFill xmlns:a="http://schemas.openxmlformats.org/drawingml/2006/main">
+            <a:srgbClr val="25302E"/>
+          </a:solidFill>
+          <a:ln xmlns:a="http://schemas.openxmlformats.org/drawingml/2006/main" w="0">
+            <a:solidFill>
+              <a:srgbClr val="25302E"/>
+            </a:solidFill>
+            <a:prstDash val="solid"/>
+          </a:ln>
+        </p:spPr>
+      </p:sp>
+      <p:sp>
+        <p:nvSpPr>
+          <p:cNvPr id="49" name="tam-legend-label">
+            <a:extLst xmlns:a="http://schemas.openxmlformats.org/drawingml/2006/main">
+              <a:ext uri="{FF2B5EF4-FFF2-40B4-BE49-F238E27FC236}">
+                <a16:creationId xmlns:a16="http://schemas.microsoft.com/office/drawing/2014/main" id="{94208D2A-B891-4B01-8419-ACB3A46168BB}"/>
+              </a:ext>
+            </a:extLst>
+          </p:cNvPr>
+          <p:cNvSpPr>
+            <a:spLocks xmlns:a="http://schemas.openxmlformats.org/drawingml/2006/main" noGrp="1"/>
+          </p:cNvSpPr>
+          <p:nvPr/>
+        </p:nvSpPr>
+        <p:spPr>
+          <a:xfrm xmlns:a="http://schemas.openxmlformats.org/drawingml/2006/main">
+            <a:off x="5905500" y="2781300"/>
+            <a:ext cx="1428750" cy="171450"/>
+          </a:xfrm>
+          <a:prstGeom xmlns:a="http://schemas.openxmlformats.org/drawingml/2006/main" prst="rect">
+            <a:avLst/>
+          </a:prstGeom>
+          <a:noFill xmlns:a="http://schemas.openxmlformats.org/drawingml/2006/main"/>
+          <a:ln xmlns:a="http://schemas.openxmlformats.org/drawingml/2006/main" w="0">
+            <a:noFill/>
+            <a:prstDash val="solid"/>
+          </a:ln>
+        </p:spPr>
+        <p:txBody>
+          <a:bodyPr xmlns:a="http://schemas.openxmlformats.org/drawingml/2006/main"/>
+          <a:lstStyle xmlns:a="http://schemas.openxmlformats.org/drawingml/2006/main"/>
+          <a:p xmlns:a="http://schemas.openxmlformats.org/drawingml/2006/main">
+            <a:pPr>
+              <a:buNone/>
+              <a:defRPr sz="1050" b="1">
+                <a:solidFill>
+                  <a:srgbClr val="F3F0E8"/>
+                </a:solidFill>
+              </a:defRPr>
+            </a:pPr>
+            <a:r>
+              <a:rPr sz="1050" b="1">
+                <a:solidFill>
+                  <a:srgbClr val="F3F0E8"/>
+                </a:solidFill>
+              </a:rPr>
+              <a:t>TAM</a:t>
+            </a:r>
+          </a:p>
+        </p:txBody>
+      </p:sp>
+      <p:sp>
+        <p:nvSpPr>
+          <p:cNvPr id="50" name="tam-legend-value">
+            <a:extLst xmlns:a="http://schemas.openxmlformats.org/drawingml/2006/main">
+              <a:ext uri="{FF2B5EF4-FFF2-40B4-BE49-F238E27FC236}">
+                <a16:creationId xmlns:a16="http://schemas.microsoft.com/office/drawing/2014/main" id="{5CEA3226-C27A-4DF2-809A-B4BA2D83578F}"/>
+              </a:ext>
+            </a:extLst>
+          </p:cNvPr>
+          <p:cNvSpPr>
+            <a:spLocks xmlns:a="http://schemas.openxmlformats.org/drawingml/2006/main" noGrp="1"/>
+          </p:cNvSpPr>
+          <p:nvPr/>
+        </p:nvSpPr>
+        <p:spPr>
+          <a:xfrm xmlns:a="http://schemas.openxmlformats.org/drawingml/2006/main">
+            <a:off x="5905500" y="3009900"/>
+            <a:ext cx="1905000" cy="285750"/>
+          </a:xfrm>
+          <a:prstGeom xmlns:a="http://schemas.openxmlformats.org/drawingml/2006/main" prst="rect">
+            <a:avLst/>
+          </a:prstGeom>
+          <a:noFill xmlns:a="http://schemas.openxmlformats.org/drawingml/2006/main"/>
+          <a:ln xmlns:a="http://schemas.openxmlformats.org/drawingml/2006/main" w="0">
+            <a:noFill/>
+            <a:prstDash val="solid"/>
+          </a:ln>
+        </p:spPr>
+        <p:txBody>
+          <a:bodyPr xmlns:a="http://schemas.openxmlformats.org/drawingml/2006/main"/>
+          <a:lstStyle xmlns:a="http://schemas.openxmlformats.org/drawingml/2006/main"/>
+          <a:p xmlns:a="http://schemas.openxmlformats.org/drawingml/2006/main">
+            <a:pPr>
+              <a:buNone/>
+              <a:defRPr sz="2100" b="1">
+                <a:solidFill>
+                  <a:srgbClr val="CCFF00"/>
+                </a:solidFill>
+              </a:defRPr>
+            </a:pPr>
+            <a:r>
+              <a:rPr sz="2100" b="1">
+                <a:solidFill>
+                  <a:srgbClr val="CCFF00"/>
+                </a:solidFill>
+              </a:rPr>
+              <a:t>$429B</a:t>
+            </a:r>
+          </a:p>
+        </p:txBody>
+      </p:sp>
+      <p:sp>
+        <p:nvSpPr>
+          <p:cNvPr id="51" name="tam-legend-copy">
+            <a:extLst xmlns:a="http://schemas.openxmlformats.org/drawingml/2006/main">
+              <a:ext uri="{FF2B5EF4-FFF2-40B4-BE49-F238E27FC236}">
+                <a16:creationId xmlns:a16="http://schemas.microsoft.com/office/drawing/2014/main" id="{55EF4965-B6A0-447C-B6AE-AE7875C81E7E}"/>
+              </a:ext>
+            </a:extLst>
+          </p:cNvPr>
+          <p:cNvSpPr>
+            <a:spLocks xmlns:a="http://schemas.openxmlformats.org/drawingml/2006/main" noGrp="1"/>
+          </p:cNvSpPr>
+          <p:nvPr/>
+        </p:nvSpPr>
+        <p:spPr>
+          <a:xfrm xmlns:a="http://schemas.openxmlformats.org/drawingml/2006/main">
+            <a:off x="8267700" y="3067050"/>
+            <a:ext cx="2667000" cy="190500"/>
+          </a:xfrm>
+          <a:prstGeom xmlns:a="http://schemas.openxmlformats.org/drawingml/2006/main" prst="rect">
+            <a:avLst/>
+          </a:prstGeom>
+          <a:noFill xmlns:a="http://schemas.openxmlformats.org/drawingml/2006/main"/>
+          <a:ln xmlns:a="http://schemas.openxmlformats.org/drawingml/2006/main" w="0">
+            <a:noFill/>
+            <a:prstDash val="solid"/>
+          </a:ln>
+        </p:spPr>
+        <p:txBody>
+          <a:bodyPr xmlns:a="http://schemas.openxmlformats.org/drawingml/2006/main"/>
+          <a:lstStyle xmlns:a="http://schemas.openxmlformats.org/drawingml/2006/main"/>
+          <a:p xmlns:a="http://schemas.openxmlformats.org/drawingml/2006/main">
+            <a:pPr>
+              <a:buNone/>
+              <a:defRPr sz="1050" b="0">
+                <a:solidFill>
+                  <a:srgbClr val="F3F0E8"/>
+                </a:solidFill>
+              </a:defRPr>
+            </a:pPr>
+            <a:r>
+              <a:rPr sz="1050" b="0">
+                <a:solidFill>
+                  <a:srgbClr val="F3F0E8"/>
+                </a:solidFill>
+              </a:rPr>
+              <a:t>Global space economy / 2025</a:t>
+            </a:r>
+          </a:p>
+        </p:txBody>
+      </p:sp>
+      <p:sp>
+        <p:nvSpPr>
+          <p:cNvPr id="52" name="tam-legend-rule-1">
+            <a:extLst xmlns:a="http://schemas.openxmlformats.org/drawingml/2006/main">
+              <a:ext uri="{FF2B5EF4-FFF2-40B4-BE49-F238E27FC236}">
+                <a16:creationId xmlns:a16="http://schemas.microsoft.com/office/drawing/2014/main" id="{0B444715-BB72-4F9B-A3DF-56C458722E1B}"/>
+              </a:ext>
+            </a:extLst>
+          </p:cNvPr>
+          <p:cNvSpPr>
+            <a:spLocks xmlns:a="http://schemas.openxmlformats.org/drawingml/2006/main" noGrp="1"/>
+          </p:cNvSpPr>
+          <p:nvPr/>
+        </p:nvSpPr>
+        <p:spPr>
+          <a:xfrm xmlns:a="http://schemas.openxmlformats.org/drawingml/2006/main">
+            <a:off x="5905500" y="3429000"/>
+            <a:ext cx="5029200" cy="9525"/>
+          </a:xfrm>
+          <a:prstGeom xmlns:a="http://schemas.openxmlformats.org/drawingml/2006/main" prst="rect">
+            <a:avLst/>
+          </a:prstGeom>
+          <a:solidFill xmlns:a="http://schemas.openxmlformats.org/drawingml/2006/main">
+            <a:srgbClr val="25302E"/>
+          </a:solidFill>
+          <a:ln xmlns:a="http://schemas.openxmlformats.org/drawingml/2006/main" w="0">
+            <a:solidFill>
+              <a:srgbClr val="25302E"/>
+            </a:solidFill>
+            <a:prstDash val="solid"/>
+          </a:ln>
+        </p:spPr>
+      </p:sp>
+      <p:sp>
+        <p:nvSpPr>
+          <p:cNvPr id="53" name="sam-legend-label">
+            <a:extLst xmlns:a="http://schemas.openxmlformats.org/drawingml/2006/main">
+              <a:ext uri="{FF2B5EF4-FFF2-40B4-BE49-F238E27FC236}">
+                <a16:creationId xmlns:a16="http://schemas.microsoft.com/office/drawing/2014/main" id="{2DB5413A-3B2D-4F18-A94C-560C26760CFF}"/>
+              </a:ext>
+            </a:extLst>
+          </p:cNvPr>
+          <p:cNvSpPr>
+            <a:spLocks xmlns:a="http://schemas.openxmlformats.org/drawingml/2006/main" noGrp="1"/>
+          </p:cNvSpPr>
+          <p:nvPr/>
+        </p:nvSpPr>
+        <p:spPr>
+          <a:xfrm xmlns:a="http://schemas.openxmlformats.org/drawingml/2006/main">
+            <a:off x="5905500" y="3638550"/>
+            <a:ext cx="1428750" cy="171450"/>
+          </a:xfrm>
+          <a:prstGeom xmlns:a="http://schemas.openxmlformats.org/drawingml/2006/main" prst="rect">
+            <a:avLst/>
+          </a:prstGeom>
+          <a:noFill xmlns:a="http://schemas.openxmlformats.org/drawingml/2006/main"/>
+          <a:ln xmlns:a="http://schemas.openxmlformats.org/drawingml/2006/main" w="0">
+            <a:noFill/>
+            <a:prstDash val="solid"/>
+          </a:ln>
+        </p:spPr>
+        <p:txBody>
+          <a:bodyPr xmlns:a="http://schemas.openxmlformats.org/drawingml/2006/main"/>
+          <a:lstStyle xmlns:a="http://schemas.openxmlformats.org/drawingml/2006/main"/>
+          <a:p xmlns:a="http://schemas.openxmlformats.org/drawingml/2006/main">
+            <a:pPr>
+              <a:buNone/>
+              <a:defRPr sz="1050" b="1">
+                <a:solidFill>
+                  <a:srgbClr val="F3F0E8"/>
+                </a:solidFill>
+              </a:defRPr>
+            </a:pPr>
+            <a:r>
+              <a:rPr sz="1050" b="1">
+                <a:solidFill>
+                  <a:srgbClr val="F3F0E8"/>
+                </a:solidFill>
+              </a:rPr>
+              <a:t>SAM</a:t>
+            </a:r>
+          </a:p>
+        </p:txBody>
+      </p:sp>
+      <p:sp>
+        <p:nvSpPr>
+          <p:cNvPr id="54" name="sam-legend-value">
+            <a:extLst xmlns:a="http://schemas.openxmlformats.org/drawingml/2006/main">
+              <a:ext uri="{FF2B5EF4-FFF2-40B4-BE49-F238E27FC236}">
+                <a16:creationId xmlns:a16="http://schemas.microsoft.com/office/drawing/2014/main" id="{72E5719D-05A7-4FC8-BDBE-69D9BD41FE58}"/>
+              </a:ext>
+            </a:extLst>
+          </p:cNvPr>
+          <p:cNvSpPr>
+            <a:spLocks xmlns:a="http://schemas.openxmlformats.org/drawingml/2006/main" noGrp="1"/>
+          </p:cNvSpPr>
+          <p:nvPr/>
+        </p:nvSpPr>
+        <p:spPr>
+          <a:xfrm xmlns:a="http://schemas.openxmlformats.org/drawingml/2006/main">
+            <a:off x="5905500" y="3867150"/>
+            <a:ext cx="1905000" cy="285750"/>
+          </a:xfrm>
+          <a:prstGeom xmlns:a="http://schemas.openxmlformats.org/drawingml/2006/main" prst="rect">
+            <a:avLst/>
+          </a:prstGeom>
+          <a:noFill xmlns:a="http://schemas.openxmlformats.org/drawingml/2006/main"/>
+          <a:ln xmlns:a="http://schemas.openxmlformats.org/drawingml/2006/main" w="0">
+            <a:noFill/>
+            <a:prstDash val="solid"/>
+          </a:ln>
+        </p:spPr>
+        <p:txBody>
+          <a:bodyPr xmlns:a="http://schemas.openxmlformats.org/drawingml/2006/main"/>
+          <a:lstStyle xmlns:a="http://schemas.openxmlformats.org/drawingml/2006/main"/>
+          <a:p xmlns:a="http://schemas.openxmlformats.org/drawingml/2006/main">
+            <a:pPr>
+              <a:buNone/>
+              <a:defRPr sz="2100" b="1">
+                <a:solidFill>
+                  <a:srgbClr val="CCFF00"/>
+                </a:solidFill>
+              </a:defRPr>
+            </a:pPr>
+            <a:r>
+              <a:rPr sz="2100" b="1">
+                <a:solidFill>
+                  <a:srgbClr val="CCFF00"/>
+                </a:solidFill>
+              </a:rPr>
+              <a:t>$165.2B</a:t>
+            </a:r>
+          </a:p>
+        </p:txBody>
+      </p:sp>
+      <p:sp>
+        <p:nvSpPr>
+          <p:cNvPr id="55" name="sam-legend-copy">
+            <a:extLst xmlns:a="http://schemas.openxmlformats.org/drawingml/2006/main">
+              <a:ext uri="{FF2B5EF4-FFF2-40B4-BE49-F238E27FC236}">
+                <a16:creationId xmlns:a16="http://schemas.microsoft.com/office/drawing/2014/main" id="{E3865DFE-50E6-4A64-8B1E-95598C303092}"/>
+              </a:ext>
+            </a:extLst>
+          </p:cNvPr>
+          <p:cNvSpPr>
+            <a:spLocks xmlns:a="http://schemas.openxmlformats.org/drawingml/2006/main" noGrp="1"/>
+          </p:cNvSpPr>
+          <p:nvPr/>
+        </p:nvSpPr>
+        <p:spPr>
+          <a:xfrm xmlns:a="http://schemas.openxmlformats.org/drawingml/2006/main">
+            <a:off x="8267700" y="3924300"/>
+            <a:ext cx="2667000" cy="323850"/>
+          </a:xfrm>
+          <a:prstGeom xmlns:a="http://schemas.openxmlformats.org/drawingml/2006/main" prst="rect">
+            <a:avLst/>
+          </a:prstGeom>
+          <a:noFill xmlns:a="http://schemas.openxmlformats.org/drawingml/2006/main"/>
+          <a:ln xmlns:a="http://schemas.openxmlformats.org/drawingml/2006/main" w="0">
+            <a:noFill/>
+            <a:prstDash val="solid"/>
+          </a:ln>
+        </p:spPr>
+        <p:txBody>
+          <a:bodyPr xmlns:a="http://schemas.openxmlformats.org/drawingml/2006/main"/>
+          <a:lstStyle xmlns:a="http://schemas.openxmlformats.org/drawingml/2006/main"/>
+          <a:p xmlns:a="http://schemas.openxmlformats.org/drawingml/2006/main">
+            <a:pPr>
+              <a:buNone/>
+              <a:defRPr sz="1050" b="0">
+                <a:solidFill>
+                  <a:srgbClr val="F3F0E8"/>
+                </a:solidFill>
+              </a:defRPr>
+            </a:pPr>
+            <a:r>
+              <a:rPr sz="1050" b="0">
+                <a:solidFill>
+                  <a:srgbClr val="F3F0E8"/>
+                </a:solidFill>
+              </a:rPr>
+              <a:t>Satellite ground segment + GNSS equipment / 2025</a:t>
+            </a:r>
+          </a:p>
+        </p:txBody>
+      </p:sp>
+      <p:sp>
+        <p:nvSpPr>
+          <p:cNvPr id="56" name="tam-legend-rule-2">
+            <a:extLst xmlns:a="http://schemas.openxmlformats.org/drawingml/2006/main">
+              <a:ext uri="{FF2B5EF4-FFF2-40B4-BE49-F238E27FC236}">
+                <a16:creationId xmlns:a16="http://schemas.microsoft.com/office/drawing/2014/main" id="{602BBBB3-1127-4CE0-BDC3-4375DF247782}"/>
+              </a:ext>
+            </a:extLst>
+          </p:cNvPr>
+          <p:cNvSpPr>
+            <a:spLocks xmlns:a="http://schemas.openxmlformats.org/drawingml/2006/main" noGrp="1"/>
+          </p:cNvSpPr>
+          <p:nvPr/>
+        </p:nvSpPr>
+        <p:spPr>
+          <a:xfrm xmlns:a="http://schemas.openxmlformats.org/drawingml/2006/main">
+            <a:off x="5905500" y="4362450"/>
+            <a:ext cx="5029200" cy="9525"/>
+          </a:xfrm>
+          <a:prstGeom xmlns:a="http://schemas.openxmlformats.org/drawingml/2006/main" prst="rect">
+            <a:avLst/>
+          </a:prstGeom>
+          <a:solidFill xmlns:a="http://schemas.openxmlformats.org/drawingml/2006/main">
+            <a:srgbClr val="25302E"/>
+          </a:solidFill>
+          <a:ln xmlns:a="http://schemas.openxmlformats.org/drawingml/2006/main" w="0">
+            <a:solidFill>
+              <a:srgbClr val="25302E"/>
+            </a:solidFill>
+            <a:prstDash val="solid"/>
+          </a:ln>
+        </p:spPr>
+      </p:sp>
+      <p:sp>
+        <p:nvSpPr>
+          <p:cNvPr id="57" name="som-legend-label">
+            <a:extLst xmlns:a="http://schemas.openxmlformats.org/drawingml/2006/main">
+              <a:ext uri="{FF2B5EF4-FFF2-40B4-BE49-F238E27FC236}">
+                <a16:creationId xmlns:a16="http://schemas.microsoft.com/office/drawing/2014/main" id="{74400939-7645-431D-914D-6FC341385829}"/>
+              </a:ext>
+            </a:extLst>
+          </p:cNvPr>
+          <p:cNvSpPr>
+            <a:spLocks xmlns:a="http://schemas.openxmlformats.org/drawingml/2006/main" noGrp="1"/>
+          </p:cNvSpPr>
+          <p:nvPr/>
+        </p:nvSpPr>
+        <p:spPr>
+          <a:xfrm xmlns:a="http://schemas.openxmlformats.org/drawingml/2006/main">
+            <a:off x="5905500" y="4572000"/>
+            <a:ext cx="1428750" cy="171450"/>
+          </a:xfrm>
+          <a:prstGeom xmlns:a="http://schemas.openxmlformats.org/drawingml/2006/main" prst="rect">
+            <a:avLst/>
+          </a:prstGeom>
+          <a:noFill xmlns:a="http://schemas.openxmlformats.org/drawingml/2006/main"/>
+          <a:ln xmlns:a="http://schemas.openxmlformats.org/drawingml/2006/main" w="0">
+            <a:noFill/>
+            <a:prstDash val="solid"/>
+          </a:ln>
+        </p:spPr>
+        <p:txBody>
+          <a:bodyPr xmlns:a="http://schemas.openxmlformats.org/drawingml/2006/main"/>
+          <a:lstStyle xmlns:a="http://schemas.openxmlformats.org/drawingml/2006/main"/>
+          <a:p xmlns:a="http://schemas.openxmlformats.org/drawingml/2006/main">
+            <a:pPr>
+              <a:buNone/>
+              <a:defRPr sz="1050" b="1">
+                <a:solidFill>
+                  <a:srgbClr val="F3F0E8"/>
+                </a:solidFill>
+              </a:defRPr>
+            </a:pPr>
+            <a:r>
+              <a:rPr sz="1050" b="1">
+                <a:solidFill>
+                  <a:srgbClr val="F3F0E8"/>
+                </a:solidFill>
+              </a:rPr>
+              <a:t>SOM</a:t>
+            </a:r>
+          </a:p>
+        </p:txBody>
+      </p:sp>
+      <p:sp>
+        <p:nvSpPr>
+          <p:cNvPr id="58" name="som-legend-value">
+            <a:extLst xmlns:a="http://schemas.openxmlformats.org/drawingml/2006/main">
+              <a:ext uri="{FF2B5EF4-FFF2-40B4-BE49-F238E27FC236}">
+                <a16:creationId xmlns:a16="http://schemas.microsoft.com/office/drawing/2014/main" id="{C781EEC0-D5CC-49D5-964E-EE0942900ED7}"/>
+              </a:ext>
+            </a:extLst>
+          </p:cNvPr>
+          <p:cNvSpPr>
+            <a:spLocks xmlns:a="http://schemas.openxmlformats.org/drawingml/2006/main" noGrp="1"/>
+          </p:cNvSpPr>
+          <p:nvPr/>
+        </p:nvSpPr>
+        <p:spPr>
+          <a:xfrm xmlns:a="http://schemas.openxmlformats.org/drawingml/2006/main">
+            <a:off x="5905500" y="4800600"/>
+            <a:ext cx="2190750" cy="285750"/>
+          </a:xfrm>
+          <a:prstGeom xmlns:a="http://schemas.openxmlformats.org/drawingml/2006/main" prst="rect">
+            <a:avLst/>
+          </a:prstGeom>
+          <a:noFill xmlns:a="http://schemas.openxmlformats.org/drawingml/2006/main"/>
+          <a:ln xmlns:a="http://schemas.openxmlformats.org/drawingml/2006/main" w="0">
+            <a:noFill/>
+            <a:prstDash val="solid"/>
+          </a:ln>
+        </p:spPr>
+        <p:txBody>
+          <a:bodyPr xmlns:a="http://schemas.openxmlformats.org/drawingml/2006/main"/>
+          <a:lstStyle xmlns:a="http://schemas.openxmlformats.org/drawingml/2006/main"/>
+          <a:p xmlns:a="http://schemas.openxmlformats.org/drawingml/2006/main">
+            <a:pPr>
+              <a:buNone/>
+              <a:defRPr sz="2100" b="1">
+                <a:solidFill>
+                  <a:srgbClr val="CCFF00"/>
+                </a:solidFill>
+              </a:defRPr>
+            </a:pPr>
+            <a:r>
+              <a:rPr sz="2100" b="1">
+                <a:solidFill>
+                  <a:srgbClr val="CCFF00"/>
+                </a:solidFill>
+              </a:rPr>
+              <a:t>$500k ARR</a:t>
+            </a:r>
+          </a:p>
+        </p:txBody>
+      </p:sp>
+      <p:sp>
+        <p:nvSpPr>
+          <p:cNvPr id="59" name="som-legend-copy">
+            <a:extLst xmlns:a="http://schemas.openxmlformats.org/drawingml/2006/main">
+              <a:ext uri="{FF2B5EF4-FFF2-40B4-BE49-F238E27FC236}">
+                <a16:creationId xmlns:a16="http://schemas.microsoft.com/office/drawing/2014/main" id="{4638959F-218A-447F-9F34-F4AA3EE31CBE}"/>
+              </a:ext>
+            </a:extLst>
+          </p:cNvPr>
+          <p:cNvSpPr>
+            <a:spLocks xmlns:a="http://schemas.openxmlformats.org/drawingml/2006/main" noGrp="1"/>
+          </p:cNvSpPr>
+          <p:nvPr/>
+        </p:nvSpPr>
+        <p:spPr>
+          <a:xfrm xmlns:a="http://schemas.openxmlformats.org/drawingml/2006/main">
+            <a:off x="8267700" y="4857750"/>
+            <a:ext cx="2667000" cy="190500"/>
+          </a:xfrm>
+          <a:prstGeom xmlns:a="http://schemas.openxmlformats.org/drawingml/2006/main" prst="rect">
+            <a:avLst/>
+          </a:prstGeom>
+          <a:noFill xmlns:a="http://schemas.openxmlformats.org/drawingml/2006/main"/>
+          <a:ln xmlns:a="http://schemas.openxmlformats.org/drawingml/2006/main" w="0">
+            <a:noFill/>
+            <a:prstDash val="solid"/>
+          </a:ln>
+        </p:spPr>
+        <p:txBody>
+          <a:bodyPr xmlns:a="http://schemas.openxmlformats.org/drawingml/2006/main"/>
+          <a:lstStyle xmlns:a="http://schemas.openxmlformats.org/drawingml/2006/main"/>
+          <a:p xmlns:a="http://schemas.openxmlformats.org/drawingml/2006/main">
+            <a:pPr>
+              <a:buNone/>
+              <a:defRPr sz="1050" b="0">
+                <a:solidFill>
+                  <a:srgbClr val="F3F0E8"/>
+                </a:solidFill>
+              </a:defRPr>
+            </a:pPr>
+            <a:r>
+              <a:rPr sz="1050" b="0">
+                <a:solidFill>
+                  <a:srgbClr val="F3F0E8"/>
+                </a:solidFill>
+              </a:rPr>
+              <a:t>Five fleet accounts × $100k annual platform value</a:t>
+            </a:r>
+          </a:p>
+        </p:txBody>
+      </p:sp>
+      <p:sp>
+        <p:nvSpPr>
+          <p:cNvPr id="60" name="tam-sam-som-caveat">
+            <a:extLst xmlns:a="http://schemas.openxmlformats.org/drawingml/2006/main">
+              <a:ext uri="{FF2B5EF4-FFF2-40B4-BE49-F238E27FC236}">
+                <a16:creationId xmlns:a16="http://schemas.microsoft.com/office/drawing/2014/main" id="{486CE136-7F41-4A33-AFD7-F61C3626303E}"/>
+              </a:ext>
+            </a:extLst>
+          </p:cNvPr>
+          <p:cNvSpPr>
+            <a:spLocks xmlns:a="http://schemas.openxmlformats.org/drawingml/2006/main" noGrp="1"/>
+          </p:cNvSpPr>
+          <p:nvPr/>
+        </p:nvSpPr>
+        <p:spPr>
+          <a:xfrm xmlns:a="http://schemas.openxmlformats.org/drawingml/2006/main">
+            <a:off x="5905500" y="5257800"/>
+            <a:ext cx="5029200" cy="361950"/>
+          </a:xfrm>
+          <a:prstGeom xmlns:a="http://schemas.openxmlformats.org/drawingml/2006/main" prst="rect">
+            <a:avLst/>
+          </a:prstGeom>
+          <a:noFill xmlns:a="http://schemas.openxmlformats.org/drawingml/2006/main"/>
+          <a:ln xmlns:a="http://schemas.openxmlformats.org/drawingml/2006/main" w="0">
+            <a:noFill/>
+            <a:prstDash val="solid"/>
+          </a:ln>
+        </p:spPr>
+        <p:txBody>
+          <a:bodyPr xmlns:a="http://schemas.openxmlformats.org/drawingml/2006/main"/>
+          <a:lstStyle xmlns:a="http://schemas.openxmlformats.org/drawingml/2006/main"/>
+          <a:p xmlns:a="http://schemas.openxmlformats.org/drawingml/2006/main">
+            <a:pPr>
+              <a:buNone/>
+              <a:defRPr sz="1125" b="1">
+                <a:solidFill>
+                  <a:srgbClr val="F3F0E8"/>
+                </a:solidFill>
+              </a:defRPr>
+            </a:pPr>
+            <a:r>
+              <a:rPr sz="1125" b="1">
+                <a:solidFill>
+                  <a:srgbClr val="F3F0E8"/>
+                </a:solidFill>
+              </a:rPr>
+              <a:t>TAM / SAM are category context; SOM is an internal revenue target, not market share.</a:t>
+            </a:r>
+          </a:p>
+        </p:txBody>
+      </p:sp>
+      <p:sp>
+        <p:nvSpPr>
+          <p:cNvPr id="61" name="tam-sam-som-source-rail">
+            <a:extLst xmlns:a="http://schemas.openxmlformats.org/drawingml/2006/main">
+              <a:ext uri="{FF2B5EF4-FFF2-40B4-BE49-F238E27FC236}">
+                <a16:creationId xmlns:a16="http://schemas.microsoft.com/office/drawing/2014/main" id="{C1531EBE-8DA6-4B39-963C-43930013A04C}"/>
+              </a:ext>
+            </a:extLst>
+          </p:cNvPr>
+          <p:cNvSpPr>
+            <a:spLocks xmlns:a="http://schemas.openxmlformats.org/drawingml/2006/main" noGrp="1"/>
+          </p:cNvSpPr>
+          <p:nvPr/>
+        </p:nvSpPr>
+        <p:spPr>
+          <a:xfrm xmlns:a="http://schemas.openxmlformats.org/drawingml/2006/main">
+            <a:off x="5905500" y="5829300"/>
+            <a:ext cx="5334000" cy="171450"/>
+          </a:xfrm>
+          <a:prstGeom xmlns:a="http://schemas.openxmlformats.org/drawingml/2006/main" prst="rect">
+            <a:avLst/>
+          </a:prstGeom>
+          <a:noFill xmlns:a="http://schemas.openxmlformats.org/drawingml/2006/main"/>
+          <a:ln xmlns:a="http://schemas.openxmlformats.org/drawingml/2006/main" w="0">
+            <a:noFill/>
+            <a:prstDash val="solid"/>
+          </a:ln>
+        </p:spPr>
+        <p:txBody>
+          <a:bodyPr xmlns:a="http://schemas.openxmlformats.org/drawingml/2006/main"/>
+          <a:lstStyle xmlns:a="http://schemas.openxmlformats.org/drawingml/2006/main"/>
+          <a:p xmlns:a="http://schemas.openxmlformats.org/drawingml/2006/main">
+            <a:pPr>
+              <a:buNone/>
+              <a:defRPr sz="900" b="0">
+                <a:solidFill>
+                  <a:srgbClr val="F3F0E8"/>
+                </a:solidFill>
+              </a:defRPr>
+            </a:pPr>
+            <a:r>
+              <a:rPr sz="900" b="0">
+                <a:solidFill>
+                  <a:srgbClr val="F3F0E8"/>
+                </a:solidFill>
+              </a:rPr>
+              <a:t>Sources: SIA / BryceTech SSIR 2026  •  WEF / McKinsey 2024  •  internal SOM model</a:t>
+            </a:r>
+          </a:p>
+        </p:txBody>
+      </p:sp>
+      <p:sp>
+        <p:nvSpPr>
+          <p:cNvPr id="63" name="tam-sam-som-cover">
+            <a:extLst xmlns:a="http://schemas.openxmlformats.org/drawingml/2006/main">
+              <a:ext uri="{FF2B5EF4-FFF2-40B4-BE49-F238E27FC236}">
+                <a16:creationId xmlns:a16="http://schemas.microsoft.com/office/drawing/2014/main" id="{D6331308-A790-438C-AB29-2B574C84C662}"/>
+              </a:ext>
+            </a:extLst>
+          </p:cNvPr>
+          <p:cNvSpPr>
+            <a:spLocks xmlns:a="http://schemas.openxmlformats.org/drawingml/2006/main" noGrp="1"/>
+          </p:cNvSpPr>
+          <p:nvPr/>
+        </p:nvSpPr>
+        <p:spPr>
+          <a:xfrm xmlns:a="http://schemas.openxmlformats.org/drawingml/2006/main">
+            <a:off x="685800" y="2000250"/>
+            <a:ext cx="10817352" cy="4114800"/>
+          </a:xfrm>
+          <a:prstGeom xmlns:a="http://schemas.openxmlformats.org/drawingml/2006/main" prst="rect">
+            <a:avLst/>
+          </a:prstGeom>
+          <a:solidFill xmlns:a="http://schemas.openxmlformats.org/drawingml/2006/main">
+            <a:srgbClr val="050505"/>
+          </a:solidFill>
+          <a:ln xmlns:a="http://schemas.openxmlformats.org/drawingml/2006/main" w="0">
+            <a:solidFill>
+              <a:srgbClr val="050505"/>
+            </a:solidFill>
+            <a:prstDash val="solid"/>
+          </a:ln>
+        </p:spPr>
+      </p:sp>
+      <p:sp>
+        <p:nvSpPr>
+          <p:cNvPr id="64" name="tam-sam-som-kicker">
+            <a:extLst xmlns:a="http://schemas.openxmlformats.org/drawingml/2006/main">
+              <a:ext uri="{FF2B5EF4-FFF2-40B4-BE49-F238E27FC236}">
+                <a16:creationId xmlns:a16="http://schemas.microsoft.com/office/drawing/2014/main" id="{2662F969-85D5-48B0-9C1C-0C429CF7458E}"/>
+              </a:ext>
+            </a:extLst>
+          </p:cNvPr>
+          <p:cNvSpPr>
+            <a:spLocks xmlns:a="http://schemas.openxmlformats.org/drawingml/2006/main" noGrp="1"/>
+          </p:cNvSpPr>
+          <p:nvPr/>
+        </p:nvSpPr>
+        <p:spPr>
+          <a:xfrm xmlns:a="http://schemas.openxmlformats.org/drawingml/2006/main">
+            <a:off x="1066800" y="2362200"/>
+            <a:ext cx="4381500" cy="190500"/>
+          </a:xfrm>
+          <a:prstGeom xmlns:a="http://schemas.openxmlformats.org/drawingml/2006/main" prst="rect">
+            <a:avLst/>
+          </a:prstGeom>
+          <a:noFill xmlns:a="http://schemas.openxmlformats.org/drawingml/2006/main"/>
+          <a:ln xmlns:a="http://schemas.openxmlformats.org/drawingml/2006/main" w="0">
+            <a:noFill/>
+            <a:prstDash val="solid"/>
+          </a:ln>
+        </p:spPr>
+        <p:txBody>
+          <a:bodyPr xmlns:a="http://schemas.openxmlformats.org/drawingml/2006/main"/>
+          <a:lstStyle xmlns:a="http://schemas.openxmlformats.org/drawingml/2006/main"/>
+          <a:p xmlns:a="http://schemas.openxmlformats.org/drawingml/2006/main">
+            <a:pPr>
+              <a:defRPr sz="1050" b="1">
+                <a:solidFill>
+                  <a:srgbClr val="F3F0E8"/>
+                </a:solidFill>
+              </a:defRPr>
+            </a:pPr>
+            <a:r>
+              <a:rPr sz="1050" b="1">
+                <a:solidFill>
+                  <a:srgbClr val="F3F0E8"/>
+                </a:solidFill>
+              </a:rPr>
+              <a:t>MARKET CONTEXT  →  REVENUE WEDGE</a:t>
+            </a:r>
+          </a:p>
+        </p:txBody>
+      </p:sp>
+      <p:sp>
+        <p:nvSpPr>
+          <p:cNvPr id="65" name="tam-sam-som-scale-note">
+            <a:extLst xmlns:a="http://schemas.openxmlformats.org/drawingml/2006/main">
+              <a:ext uri="{FF2B5EF4-FFF2-40B4-BE49-F238E27FC236}">
+                <a16:creationId xmlns:a16="http://schemas.microsoft.com/office/drawing/2014/main" id="{1BC35C33-891D-49C0-A58C-CD42B4E50403}"/>
+              </a:ext>
+            </a:extLst>
+          </p:cNvPr>
+          <p:cNvSpPr>
+            <a:spLocks xmlns:a="http://schemas.openxmlformats.org/drawingml/2006/main" noGrp="1"/>
+          </p:cNvSpPr>
+          <p:nvPr/>
+        </p:nvSpPr>
+        <p:spPr>
+          <a:xfrm xmlns:a="http://schemas.openxmlformats.org/drawingml/2006/main">
+            <a:off x="1066800" y="2571750"/>
+            <a:ext cx="4000500" cy="171450"/>
+          </a:xfrm>
+          <a:prstGeom xmlns:a="http://schemas.openxmlformats.org/drawingml/2006/main" prst="rect">
+            <a:avLst/>
+          </a:prstGeom>
+          <a:noFill xmlns:a="http://schemas.openxmlformats.org/drawingml/2006/main"/>
+          <a:ln xmlns:a="http://schemas.openxmlformats.org/drawingml/2006/main" w="0">
+            <a:noFill/>
+            <a:prstDash val="solid"/>
+          </a:ln>
+        </p:spPr>
+        <p:txBody>
+          <a:bodyPr xmlns:a="http://schemas.openxmlformats.org/drawingml/2006/main"/>
+          <a:lstStyle xmlns:a="http://schemas.openxmlformats.org/drawingml/2006/main"/>
+          <a:p xmlns:a="http://schemas.openxmlformats.org/drawingml/2006/main">
+            <a:pPr>
+              <a:defRPr sz="900" b="0">
+                <a:solidFill>
+                  <a:srgbClr val="F3F0E8"/>
+                </a:solidFill>
+              </a:defRPr>
+            </a:pPr>
+            <a:r>
+              <a:rPr sz="900" b="0">
+                <a:solidFill>
+                  <a:srgbClr val="F3F0E8"/>
+                </a:solidFill>
+              </a:rPr>
+              <a:t>Illustrative nesting; not a proportional market-share claim.</a:t>
+            </a:r>
+          </a:p>
+        </p:txBody>
+      </p:sp>
+      <p:sp>
+        <p:nvSpPr>
+          <p:cNvPr id="66" name="tam-circle">
+            <a:extLst xmlns:a="http://schemas.openxmlformats.org/drawingml/2006/main">
+              <a:ext uri="{FF2B5EF4-FFF2-40B4-BE49-F238E27FC236}">
+                <a16:creationId xmlns:a16="http://schemas.microsoft.com/office/drawing/2014/main" id="{E8FE0661-670B-4F1F-8CF5-A9ED45BF0556}"/>
+              </a:ext>
+            </a:extLst>
+          </p:cNvPr>
+          <p:cNvSpPr>
+            <a:spLocks xmlns:a="http://schemas.openxmlformats.org/drawingml/2006/main" noGrp="1"/>
+          </p:cNvSpPr>
+          <p:nvPr/>
+        </p:nvSpPr>
+        <p:spPr>
+          <a:xfrm xmlns:a="http://schemas.openxmlformats.org/drawingml/2006/main">
+            <a:off x="1123950" y="2857500"/>
+            <a:ext cx="3143250" cy="3143250"/>
+          </a:xfrm>
+          <a:prstGeom xmlns:a="http://schemas.openxmlformats.org/drawingml/2006/main" prst="ellipse">
+            <a:avLst/>
+          </a:prstGeom>
+          <a:solidFill xmlns:a="http://schemas.openxmlformats.org/drawingml/2006/main">
+            <a:srgbClr val="0B1512"/>
+          </a:solidFill>
+          <a:ln xmlns:a="http://schemas.openxmlformats.org/drawingml/2006/main" w="9525">
+            <a:solidFill>
+              <a:srgbClr val="2B4434"/>
+            </a:solidFill>
+            <a:prstDash val="solid"/>
+          </a:ln>
+        </p:spPr>
+      </p:sp>
+      <p:sp>
+        <p:nvSpPr>
+          <p:cNvPr id="67" name="sam-circle">
+            <a:extLst xmlns:a="http://schemas.openxmlformats.org/drawingml/2006/main">
+              <a:ext uri="{FF2B5EF4-FFF2-40B4-BE49-F238E27FC236}">
+                <a16:creationId xmlns:a16="http://schemas.microsoft.com/office/drawing/2014/main" id="{5025CC37-63AA-4DD9-93AD-9853DD41218D}"/>
+              </a:ext>
+            </a:extLst>
+          </p:cNvPr>
+          <p:cNvSpPr>
+            <a:spLocks xmlns:a="http://schemas.openxmlformats.org/drawingml/2006/main" noGrp="1"/>
+          </p:cNvSpPr>
+          <p:nvPr/>
+        </p:nvSpPr>
+        <p:spPr>
+          <a:xfrm xmlns:a="http://schemas.openxmlformats.org/drawingml/2006/main">
+            <a:off x="1619250" y="3352800"/>
+            <a:ext cx="2152650" cy="2152650"/>
+          </a:xfrm>
+          <a:prstGeom xmlns:a="http://schemas.openxmlformats.org/drawingml/2006/main" prst="ellipse">
+            <a:avLst/>
+          </a:prstGeom>
+          <a:solidFill xmlns:a="http://schemas.openxmlformats.org/drawingml/2006/main">
+            <a:srgbClr val="173C2A"/>
+          </a:solidFill>
+          <a:ln xmlns:a="http://schemas.openxmlformats.org/drawingml/2006/main" w="9525">
+            <a:solidFill>
+              <a:srgbClr val="5D8C2D"/>
+            </a:solidFill>
+            <a:prstDash val="solid"/>
+          </a:ln>
+        </p:spPr>
+      </p:sp>
+      <p:sp>
+        <p:nvSpPr>
+          <p:cNvPr id="68" name="som-circle">
+            <a:extLst xmlns:a="http://schemas.openxmlformats.org/drawingml/2006/main">
+              <a:ext uri="{FF2B5EF4-FFF2-40B4-BE49-F238E27FC236}">
+                <a16:creationId xmlns:a16="http://schemas.microsoft.com/office/drawing/2014/main" id="{F4FB33BA-3ADB-4FA3-B54D-29DCF4C19091}"/>
+              </a:ext>
+            </a:extLst>
+          </p:cNvPr>
+          <p:cNvSpPr>
+            <a:spLocks xmlns:a="http://schemas.openxmlformats.org/drawingml/2006/main" noGrp="1"/>
+          </p:cNvSpPr>
+          <p:nvPr/>
+        </p:nvSpPr>
+        <p:spPr>
+          <a:xfrm xmlns:a="http://schemas.openxmlformats.org/drawingml/2006/main">
+            <a:off x="2190750" y="3924300"/>
+            <a:ext cx="1009650" cy="1009650"/>
+          </a:xfrm>
+          <a:prstGeom xmlns:a="http://schemas.openxmlformats.org/drawingml/2006/main" prst="ellipse">
+            <a:avLst/>
+          </a:prstGeom>
+          <a:solidFill xmlns:a="http://schemas.openxmlformats.org/drawingml/2006/main">
+            <a:srgbClr val="0B1400"/>
+          </a:solidFill>
+          <a:ln xmlns:a="http://schemas.openxmlformats.org/drawingml/2006/main" w="19050">
+            <a:solidFill>
+              <a:srgbClr val="CCFF00"/>
+            </a:solidFill>
+            <a:prstDash val="solid"/>
+          </a:ln>
+        </p:spPr>
+      </p:sp>
+      <p:sp>
+        <p:nvSpPr>
+          <p:cNvPr id="69" name="tam-label">
+            <a:extLst xmlns:a="http://schemas.openxmlformats.org/drawingml/2006/main">
+              <a:ext uri="{FF2B5EF4-FFF2-40B4-BE49-F238E27FC236}">
+                <a16:creationId xmlns:a16="http://schemas.microsoft.com/office/drawing/2014/main" id="{88B40003-23E9-4C87-A533-8E712CB3BC3D}"/>
+              </a:ext>
+            </a:extLst>
+          </p:cNvPr>
+          <p:cNvSpPr>
+            <a:spLocks xmlns:a="http://schemas.openxmlformats.org/drawingml/2006/main" noGrp="1"/>
+          </p:cNvSpPr>
+          <p:nvPr/>
+        </p:nvSpPr>
+        <p:spPr>
+          <a:xfrm xmlns:a="http://schemas.openxmlformats.org/drawingml/2006/main">
+            <a:off x="1381125" y="3305175"/>
+            <a:ext cx="1143000" cy="171450"/>
+          </a:xfrm>
+          <a:prstGeom xmlns:a="http://schemas.openxmlformats.org/drawingml/2006/main" prst="rect">
+            <a:avLst/>
+          </a:prstGeom>
+          <a:noFill xmlns:a="http://schemas.openxmlformats.org/drawingml/2006/main"/>
+          <a:ln xmlns:a="http://schemas.openxmlformats.org/drawingml/2006/main" w="0">
+            <a:noFill/>
+            <a:prstDash val="solid"/>
+          </a:ln>
+        </p:spPr>
+        <p:txBody>
+          <a:bodyPr xmlns:a="http://schemas.openxmlformats.org/drawingml/2006/main"/>
+          <a:lstStyle xmlns:a="http://schemas.openxmlformats.org/drawingml/2006/main"/>
+          <a:p xmlns:a="http://schemas.openxmlformats.org/drawingml/2006/main">
+            <a:pPr>
+              <a:defRPr sz="1050" b="1">
+                <a:solidFill>
+                  <a:srgbClr val="F3F0E8"/>
+                </a:solidFill>
+              </a:defRPr>
+            </a:pPr>
+            <a:r>
+              <a:rPr sz="1050" b="1">
+                <a:solidFill>
+                  <a:srgbClr val="F3F0E8"/>
+                </a:solidFill>
+              </a:rPr>
+              <a:t>TAM</a:t>
+            </a:r>
+          </a:p>
+        </p:txBody>
+      </p:sp>
+      <p:sp>
+        <p:nvSpPr>
+          <p:cNvPr id="70" name="tam-value">
+            <a:extLst xmlns:a="http://schemas.openxmlformats.org/drawingml/2006/main">
+              <a:ext uri="{FF2B5EF4-FFF2-40B4-BE49-F238E27FC236}">
+                <a16:creationId xmlns:a16="http://schemas.microsoft.com/office/drawing/2014/main" id="{2F46CB14-9A59-423A-9501-A6DF468371BE}"/>
+              </a:ext>
+            </a:extLst>
+          </p:cNvPr>
+          <p:cNvSpPr>
+            <a:spLocks xmlns:a="http://schemas.openxmlformats.org/drawingml/2006/main" noGrp="1"/>
+          </p:cNvSpPr>
+          <p:nvPr/>
+        </p:nvSpPr>
+        <p:spPr>
+          <a:xfrm xmlns:a="http://schemas.openxmlformats.org/drawingml/2006/main">
+            <a:off x="1381125" y="3524250"/>
+            <a:ext cx="1714500" cy="323850"/>
+          </a:xfrm>
+          <a:prstGeom xmlns:a="http://schemas.openxmlformats.org/drawingml/2006/main" prst="rect">
+            <a:avLst/>
+          </a:prstGeom>
+          <a:noFill xmlns:a="http://schemas.openxmlformats.org/drawingml/2006/main"/>
+          <a:ln xmlns:a="http://schemas.openxmlformats.org/drawingml/2006/main" w="0">
+            <a:noFill/>
+            <a:prstDash val="solid"/>
+          </a:ln>
+        </p:spPr>
+        <p:txBody>
+          <a:bodyPr xmlns:a="http://schemas.openxmlformats.org/drawingml/2006/main"/>
+          <a:lstStyle xmlns:a="http://schemas.openxmlformats.org/drawingml/2006/main"/>
+          <a:p xmlns:a="http://schemas.openxmlformats.org/drawingml/2006/main">
+            <a:pPr>
+              <a:defRPr sz="2100" b="1">
+                <a:solidFill>
+                  <a:srgbClr val="CCFF00"/>
+                </a:solidFill>
+              </a:defRPr>
+            </a:pPr>
+            <a:r>
+              <a:rPr sz="2100" b="1">
+                <a:solidFill>
+                  <a:srgbClr val="CCFF00"/>
+                </a:solidFill>
+              </a:rPr>
+              <a:t>$429B</a:t>
+            </a:r>
+          </a:p>
+        </p:txBody>
+      </p:sp>
+      <p:sp>
+        <p:nvSpPr>
+          <p:cNvPr id="71" name="sam-label">
+            <a:extLst xmlns:a="http://schemas.openxmlformats.org/drawingml/2006/main">
+              <a:ext uri="{FF2B5EF4-FFF2-40B4-BE49-F238E27FC236}">
+                <a16:creationId xmlns:a16="http://schemas.microsoft.com/office/drawing/2014/main" id="{C18A713F-9218-453A-AC54-97EC8B210B88}"/>
+              </a:ext>
+            </a:extLst>
+          </p:cNvPr>
+          <p:cNvSpPr>
+            <a:spLocks xmlns:a="http://schemas.openxmlformats.org/drawingml/2006/main" noGrp="1"/>
+          </p:cNvSpPr>
+          <p:nvPr/>
+        </p:nvSpPr>
+        <p:spPr>
+          <a:xfrm xmlns:a="http://schemas.openxmlformats.org/drawingml/2006/main">
+            <a:off x="1924050" y="3848100"/>
+            <a:ext cx="1143000" cy="171450"/>
+          </a:xfrm>
+          <a:prstGeom xmlns:a="http://schemas.openxmlformats.org/drawingml/2006/main" prst="rect">
+            <a:avLst/>
+          </a:prstGeom>
+          <a:noFill xmlns:a="http://schemas.openxmlformats.org/drawingml/2006/main"/>
+          <a:ln xmlns:a="http://schemas.openxmlformats.org/drawingml/2006/main" w="0">
+            <a:noFill/>
+            <a:prstDash val="solid"/>
+          </a:ln>
+        </p:spPr>
+        <p:txBody>
+          <a:bodyPr xmlns:a="http://schemas.openxmlformats.org/drawingml/2006/main"/>
+          <a:lstStyle xmlns:a="http://schemas.openxmlformats.org/drawingml/2006/main"/>
+          <a:p xmlns:a="http://schemas.openxmlformats.org/drawingml/2006/main">
+            <a:pPr>
+              <a:defRPr sz="1050" b="1">
+                <a:solidFill>
+                  <a:srgbClr val="F3F0E8"/>
+                </a:solidFill>
+              </a:defRPr>
+            </a:pPr>
+            <a:r>
+              <a:rPr sz="1050" b="1">
+                <a:solidFill>
+                  <a:srgbClr val="F3F0E8"/>
+                </a:solidFill>
+              </a:rPr>
+              <a:t>SAM</a:t>
+            </a:r>
+          </a:p>
+        </p:txBody>
+      </p:sp>
+      <p:sp>
+        <p:nvSpPr>
+          <p:cNvPr id="72" name="sam-value">
+            <a:extLst xmlns:a="http://schemas.openxmlformats.org/drawingml/2006/main">
+              <a:ext uri="{FF2B5EF4-FFF2-40B4-BE49-F238E27FC236}">
+                <a16:creationId xmlns:a16="http://schemas.microsoft.com/office/drawing/2014/main" id="{4B25513A-8837-4E62-ACBF-DC10412EE55F}"/>
+              </a:ext>
+            </a:extLst>
+          </p:cNvPr>
+          <p:cNvSpPr>
+            <a:spLocks xmlns:a="http://schemas.openxmlformats.org/drawingml/2006/main" noGrp="1"/>
+          </p:cNvSpPr>
+          <p:nvPr/>
+        </p:nvSpPr>
+        <p:spPr>
+          <a:xfrm xmlns:a="http://schemas.openxmlformats.org/drawingml/2006/main">
+            <a:off x="1924050" y="4076700"/>
+            <a:ext cx="1524000" cy="247650"/>
+          </a:xfrm>
+          <a:prstGeom xmlns:a="http://schemas.openxmlformats.org/drawingml/2006/main" prst="rect">
+            <a:avLst/>
+          </a:prstGeom>
+          <a:noFill xmlns:a="http://schemas.openxmlformats.org/drawingml/2006/main"/>
+          <a:ln xmlns:a="http://schemas.openxmlformats.org/drawingml/2006/main" w="0">
+            <a:noFill/>
+            <a:prstDash val="solid"/>
+          </a:ln>
+        </p:spPr>
+        <p:txBody>
+          <a:bodyPr xmlns:a="http://schemas.openxmlformats.org/drawingml/2006/main"/>
+          <a:lstStyle xmlns:a="http://schemas.openxmlformats.org/drawingml/2006/main"/>
+          <a:p xmlns:a="http://schemas.openxmlformats.org/drawingml/2006/main">
+            <a:pPr>
+              <a:defRPr sz="1500" b="1">
+                <a:solidFill>
+                  <a:srgbClr val="CCFF00"/>
+                </a:solidFill>
+              </a:defRPr>
+            </a:pPr>
+            <a:r>
+              <a:rPr sz="1500" b="1">
+                <a:solidFill>
+                  <a:srgbClr val="CCFF00"/>
+                </a:solidFill>
+              </a:rPr>
+              <a:t>$165.2B</a:t>
+            </a:r>
+          </a:p>
+        </p:txBody>
+      </p:sp>
+      <p:sp>
+        <p:nvSpPr>
+          <p:cNvPr id="73" name="som-label">
+            <a:extLst xmlns:a="http://schemas.openxmlformats.org/drawingml/2006/main">
+              <a:ext uri="{FF2B5EF4-FFF2-40B4-BE49-F238E27FC236}">
+                <a16:creationId xmlns:a16="http://schemas.microsoft.com/office/drawing/2014/main" id="{EF2EEC7B-B8F8-4B44-B906-AED0F8558047}"/>
+              </a:ext>
+            </a:extLst>
+          </p:cNvPr>
+          <p:cNvSpPr>
+            <a:spLocks xmlns:a="http://schemas.openxmlformats.org/drawingml/2006/main" noGrp="1"/>
+          </p:cNvSpPr>
+          <p:nvPr/>
+        </p:nvSpPr>
+        <p:spPr>
+          <a:xfrm xmlns:a="http://schemas.openxmlformats.org/drawingml/2006/main">
+            <a:off x="2362200" y="4171950"/>
+            <a:ext cx="762000" cy="171450"/>
+          </a:xfrm>
+          <a:prstGeom xmlns:a="http://schemas.openxmlformats.org/drawingml/2006/main" prst="rect">
+            <a:avLst/>
+          </a:prstGeom>
+          <a:noFill xmlns:a="http://schemas.openxmlformats.org/drawingml/2006/main"/>
+          <a:ln xmlns:a="http://schemas.openxmlformats.org/drawingml/2006/main" w="0">
+            <a:noFill/>
+            <a:prstDash val="solid"/>
+          </a:ln>
+        </p:spPr>
+        <p:txBody>
+          <a:bodyPr xmlns:a="http://schemas.openxmlformats.org/drawingml/2006/main"/>
+          <a:lstStyle xmlns:a="http://schemas.openxmlformats.org/drawingml/2006/main"/>
+          <a:p xmlns:a="http://schemas.openxmlformats.org/drawingml/2006/main">
+            <a:pPr>
+              <a:defRPr sz="975" b="1">
+                <a:solidFill>
+                  <a:srgbClr val="F3F0E8"/>
+                </a:solidFill>
+              </a:defRPr>
+            </a:pPr>
+            <a:r>
+              <a:rPr sz="975" b="1">
+                <a:solidFill>
+                  <a:srgbClr val="F3F0E8"/>
+                </a:solidFill>
+              </a:rPr>
+              <a:t>SOM</a:t>
+            </a:r>
+          </a:p>
+        </p:txBody>
+      </p:sp>
+      <p:sp>
+        <p:nvSpPr>
+          <p:cNvPr id="74" name="som-value">
+            <a:extLst xmlns:a="http://schemas.openxmlformats.org/drawingml/2006/main">
+              <a:ext uri="{FF2B5EF4-FFF2-40B4-BE49-F238E27FC236}">
+                <a16:creationId xmlns:a16="http://schemas.microsoft.com/office/drawing/2014/main" id="{7D2C6529-93C3-450F-8F53-9A66C528C42C}"/>
+              </a:ext>
+            </a:extLst>
+          </p:cNvPr>
+          <p:cNvSpPr>
+            <a:spLocks xmlns:a="http://schemas.openxmlformats.org/drawingml/2006/main" noGrp="1"/>
+          </p:cNvSpPr>
+          <p:nvPr/>
+        </p:nvSpPr>
+        <p:spPr>
+          <a:xfrm xmlns:a="http://schemas.openxmlformats.org/drawingml/2006/main">
+            <a:off x="2352675" y="4400550"/>
+            <a:ext cx="857250" cy="228600"/>
+          </a:xfrm>
+          <a:prstGeom xmlns:a="http://schemas.openxmlformats.org/drawingml/2006/main" prst="rect">
+            <a:avLst/>
+          </a:prstGeom>
+          <a:noFill xmlns:a="http://schemas.openxmlformats.org/drawingml/2006/main"/>
+          <a:ln xmlns:a="http://schemas.openxmlformats.org/drawingml/2006/main" w="0">
+            <a:noFill/>
+            <a:prstDash val="solid"/>
+          </a:ln>
+        </p:spPr>
+        <p:txBody>
+          <a:bodyPr xmlns:a="http://schemas.openxmlformats.org/drawingml/2006/main"/>
+          <a:lstStyle xmlns:a="http://schemas.openxmlformats.org/drawingml/2006/main"/>
+          <a:p xmlns:a="http://schemas.openxmlformats.org/drawingml/2006/main">
+            <a:pPr>
+              <a:defRPr sz="1350" b="1">
+                <a:solidFill>
+                  <a:srgbClr val="CCFF00"/>
+                </a:solidFill>
+              </a:defRPr>
+            </a:pPr>
+            <a:r>
+              <a:rPr sz="1350" b="1">
+                <a:solidFill>
+                  <a:srgbClr val="CCFF00"/>
+                </a:solidFill>
+              </a:rPr>
+              <a:t>$500k</a:t>
+            </a:r>
+          </a:p>
+        </p:txBody>
+      </p:sp>
+      <p:sp>
+        <p:nvSpPr>
+          <p:cNvPr id="75" name="tam-sam-som-divider">
+            <a:extLst xmlns:a="http://schemas.openxmlformats.org/drawingml/2006/main">
+              <a:ext uri="{FF2B5EF4-FFF2-40B4-BE49-F238E27FC236}">
+                <a16:creationId xmlns:a16="http://schemas.microsoft.com/office/drawing/2014/main" id="{06DBEEC6-7C34-45E8-A7E4-47EBD2811F92}"/>
+              </a:ext>
+            </a:extLst>
+          </p:cNvPr>
+          <p:cNvSpPr>
+            <a:spLocks xmlns:a="http://schemas.openxmlformats.org/drawingml/2006/main" noGrp="1"/>
+          </p:cNvSpPr>
+          <p:nvPr/>
+        </p:nvSpPr>
+        <p:spPr>
+          <a:xfrm xmlns:a="http://schemas.openxmlformats.org/drawingml/2006/main">
+            <a:off x="5391150" y="2724150"/>
+            <a:ext cx="9525" cy="3067050"/>
+          </a:xfrm>
+          <a:prstGeom xmlns:a="http://schemas.openxmlformats.org/drawingml/2006/main" prst="rect">
+            <a:avLst/>
+          </a:prstGeom>
+          <a:solidFill xmlns:a="http://schemas.openxmlformats.org/drawingml/2006/main">
+            <a:srgbClr val="25302E"/>
+          </a:solidFill>
+          <a:ln xmlns:a="http://schemas.openxmlformats.org/drawingml/2006/main" w="0">
+            <a:solidFill>
+              <a:srgbClr val="25302E"/>
+            </a:solidFill>
+            <a:prstDash val="solid"/>
+          </a:ln>
+        </p:spPr>
+      </p:sp>
+      <p:sp>
+        <p:nvSpPr>
+          <p:cNvPr id="76" name="tam-legend-label">
+            <a:extLst xmlns:a="http://schemas.openxmlformats.org/drawingml/2006/main">
+              <a:ext uri="{FF2B5EF4-FFF2-40B4-BE49-F238E27FC236}">
+                <a16:creationId xmlns:a16="http://schemas.microsoft.com/office/drawing/2014/main" id="{EE954E91-1528-4149-A6AF-FD5B2A89DF81}"/>
+              </a:ext>
+            </a:extLst>
+          </p:cNvPr>
+          <p:cNvSpPr>
+            <a:spLocks xmlns:a="http://schemas.openxmlformats.org/drawingml/2006/main" noGrp="1"/>
+          </p:cNvSpPr>
+          <p:nvPr/>
+        </p:nvSpPr>
+        <p:spPr>
+          <a:xfrm xmlns:a="http://schemas.openxmlformats.org/drawingml/2006/main">
+            <a:off x="5905500" y="2781300"/>
+            <a:ext cx="1428750" cy="171450"/>
+          </a:xfrm>
+          <a:prstGeom xmlns:a="http://schemas.openxmlformats.org/drawingml/2006/main" prst="rect">
+            <a:avLst/>
+          </a:prstGeom>
+          <a:noFill xmlns:a="http://schemas.openxmlformats.org/drawingml/2006/main"/>
+          <a:ln xmlns:a="http://schemas.openxmlformats.org/drawingml/2006/main" w="0">
+            <a:noFill/>
+            <a:prstDash val="solid"/>
+          </a:ln>
+        </p:spPr>
+        <p:txBody>
+          <a:bodyPr xmlns:a="http://schemas.openxmlformats.org/drawingml/2006/main"/>
+          <a:lstStyle xmlns:a="http://schemas.openxmlformats.org/drawingml/2006/main"/>
+          <a:p xmlns:a="http://schemas.openxmlformats.org/drawingml/2006/main">
+            <a:pPr>
+              <a:defRPr sz="1050" b="1">
+                <a:solidFill>
+                  <a:srgbClr val="F3F0E8"/>
+                </a:solidFill>
+              </a:defRPr>
+            </a:pPr>
+            <a:r>
+              <a:rPr sz="1050" b="1">
+                <a:solidFill>
+                  <a:srgbClr val="F3F0E8"/>
+                </a:solidFill>
+              </a:rPr>
+              <a:t>TAM</a:t>
+            </a:r>
+          </a:p>
+        </p:txBody>
+      </p:sp>
+      <p:sp>
+        <p:nvSpPr>
+          <p:cNvPr id="77" name="tam-legend-value">
+            <a:extLst xmlns:a="http://schemas.openxmlformats.org/drawingml/2006/main">
+              <a:ext uri="{FF2B5EF4-FFF2-40B4-BE49-F238E27FC236}">
+                <a16:creationId xmlns:a16="http://schemas.microsoft.com/office/drawing/2014/main" id="{1FF898FF-7ED1-4AA6-AC52-029735A37BA6}"/>
+              </a:ext>
+            </a:extLst>
+          </p:cNvPr>
+          <p:cNvSpPr>
+            <a:spLocks xmlns:a="http://schemas.openxmlformats.org/drawingml/2006/main" noGrp="1"/>
+          </p:cNvSpPr>
+          <p:nvPr/>
+        </p:nvSpPr>
+        <p:spPr>
+          <a:xfrm xmlns:a="http://schemas.openxmlformats.org/drawingml/2006/main">
+            <a:off x="5905500" y="3009900"/>
+            <a:ext cx="1905000" cy="285750"/>
+          </a:xfrm>
+          <a:prstGeom xmlns:a="http://schemas.openxmlformats.org/drawingml/2006/main" prst="rect">
+            <a:avLst/>
+          </a:prstGeom>
+          <a:noFill xmlns:a="http://schemas.openxmlformats.org/drawingml/2006/main"/>
+          <a:ln xmlns:a="http://schemas.openxmlformats.org/drawingml/2006/main" w="0">
+            <a:noFill/>
+            <a:prstDash val="solid"/>
+          </a:ln>
+        </p:spPr>
+        <p:txBody>
+          <a:bodyPr xmlns:a="http://schemas.openxmlformats.org/drawingml/2006/main"/>
+          <a:lstStyle xmlns:a="http://schemas.openxmlformats.org/drawingml/2006/main"/>
+          <a:p xmlns:a="http://schemas.openxmlformats.org/drawingml/2006/main">
+            <a:pPr>
+              <a:defRPr sz="2100" b="1">
+                <a:solidFill>
+                  <a:srgbClr val="CCFF00"/>
+                </a:solidFill>
+              </a:defRPr>
+            </a:pPr>
+            <a:r>
+              <a:rPr sz="2100" b="1">
+                <a:solidFill>
+                  <a:srgbClr val="CCFF00"/>
+                </a:solidFill>
+              </a:rPr>
+              <a:t>$429B</a:t>
+            </a:r>
+          </a:p>
+        </p:txBody>
+      </p:sp>
+      <p:sp>
+        <p:nvSpPr>
+          <p:cNvPr id="78" name="tam-legend-copy">
+            <a:extLst xmlns:a="http://schemas.openxmlformats.org/drawingml/2006/main">
+              <a:ext uri="{FF2B5EF4-FFF2-40B4-BE49-F238E27FC236}">
+                <a16:creationId xmlns:a16="http://schemas.microsoft.com/office/drawing/2014/main" id="{DD8871B9-7DE8-493E-B38F-5C03934FF78F}"/>
+              </a:ext>
+            </a:extLst>
+          </p:cNvPr>
+          <p:cNvSpPr>
+            <a:spLocks xmlns:a="http://schemas.openxmlformats.org/drawingml/2006/main" noGrp="1"/>
+          </p:cNvSpPr>
+          <p:nvPr/>
+        </p:nvSpPr>
+        <p:spPr>
+          <a:xfrm xmlns:a="http://schemas.openxmlformats.org/drawingml/2006/main">
+            <a:off x="8267700" y="3067050"/>
+            <a:ext cx="2667000" cy="190500"/>
+          </a:xfrm>
+          <a:prstGeom xmlns:a="http://schemas.openxmlformats.org/drawingml/2006/main" prst="rect">
+            <a:avLst/>
+          </a:prstGeom>
+          <a:noFill xmlns:a="http://schemas.openxmlformats.org/drawingml/2006/main"/>
+          <a:ln xmlns:a="http://schemas.openxmlformats.org/drawingml/2006/main" w="0">
+            <a:noFill/>
+            <a:prstDash val="solid"/>
+          </a:ln>
+        </p:spPr>
+        <p:txBody>
+          <a:bodyPr xmlns:a="http://schemas.openxmlformats.org/drawingml/2006/main"/>
+          <a:lstStyle xmlns:a="http://schemas.openxmlformats.org/drawingml/2006/main"/>
+          <a:p xmlns:a="http://schemas.openxmlformats.org/drawingml/2006/main">
+            <a:pPr>
+              <a:defRPr sz="1050" b="0">
+                <a:solidFill>
+                  <a:srgbClr val="F3F0E8"/>
+                </a:solidFill>
+              </a:defRPr>
+            </a:pPr>
+            <a:r>
+              <a:rPr sz="1050" b="0">
+                <a:solidFill>
+                  <a:srgbClr val="F3F0E8"/>
+                </a:solidFill>
+              </a:rPr>
+              <a:t>Global space economy / 2025</a:t>
+            </a:r>
+          </a:p>
+        </p:txBody>
+      </p:sp>
+      <p:sp>
+        <p:nvSpPr>
+          <p:cNvPr id="79" name="tam-legend-rule-1">
+            <a:extLst xmlns:a="http://schemas.openxmlformats.org/drawingml/2006/main">
+              <a:ext uri="{FF2B5EF4-FFF2-40B4-BE49-F238E27FC236}">
+                <a16:creationId xmlns:a16="http://schemas.microsoft.com/office/drawing/2014/main" id="{7DC4FF44-B039-4C4B-AC26-4B0C2222B322}"/>
+              </a:ext>
+            </a:extLst>
+          </p:cNvPr>
+          <p:cNvSpPr>
+            <a:spLocks xmlns:a="http://schemas.openxmlformats.org/drawingml/2006/main" noGrp="1"/>
+          </p:cNvSpPr>
+          <p:nvPr/>
+        </p:nvSpPr>
+        <p:spPr>
+          <a:xfrm xmlns:a="http://schemas.openxmlformats.org/drawingml/2006/main">
+            <a:off x="5905500" y="3429000"/>
+            <a:ext cx="5029200" cy="9525"/>
+          </a:xfrm>
+          <a:prstGeom xmlns:a="http://schemas.openxmlformats.org/drawingml/2006/main" prst="rect">
+            <a:avLst/>
+          </a:prstGeom>
+          <a:solidFill xmlns:a="http://schemas.openxmlformats.org/drawingml/2006/main">
+            <a:srgbClr val="25302E"/>
+          </a:solidFill>
+          <a:ln xmlns:a="http://schemas.openxmlformats.org/drawingml/2006/main" w="0">
+            <a:solidFill>
+              <a:srgbClr val="25302E"/>
+            </a:solidFill>
+            <a:prstDash val="solid"/>
+          </a:ln>
+        </p:spPr>
+      </p:sp>
+      <p:sp>
+        <p:nvSpPr>
+          <p:cNvPr id="80" name="sam-legend-label">
+            <a:extLst xmlns:a="http://schemas.openxmlformats.org/drawingml/2006/main">
+              <a:ext uri="{FF2B5EF4-FFF2-40B4-BE49-F238E27FC236}">
+                <a16:creationId xmlns:a16="http://schemas.microsoft.com/office/drawing/2014/main" id="{669AC8F2-B0DD-487C-BC68-60256E3BF82B}"/>
+              </a:ext>
+            </a:extLst>
+          </p:cNvPr>
+          <p:cNvSpPr>
+            <a:spLocks xmlns:a="http://schemas.openxmlformats.org/drawingml/2006/main" noGrp="1"/>
+          </p:cNvSpPr>
+          <p:nvPr/>
+        </p:nvSpPr>
+        <p:spPr>
+          <a:xfrm xmlns:a="http://schemas.openxmlformats.org/drawingml/2006/main">
+            <a:off x="5905500" y="3638550"/>
+            <a:ext cx="1428750" cy="171450"/>
+          </a:xfrm>
+          <a:prstGeom xmlns:a="http://schemas.openxmlformats.org/drawingml/2006/main" prst="rect">
+            <a:avLst/>
+          </a:prstGeom>
+          <a:noFill xmlns:a="http://schemas.openxmlformats.org/drawingml/2006/main"/>
+          <a:ln xmlns:a="http://schemas.openxmlformats.org/drawingml/2006/main" w="0">
+            <a:noFill/>
+            <a:prstDash val="solid"/>
+          </a:ln>
+        </p:spPr>
+        <p:txBody>
+          <a:bodyPr xmlns:a="http://schemas.openxmlformats.org/drawingml/2006/main"/>
+          <a:lstStyle xmlns:a="http://schemas.openxmlformats.org/drawingml/2006/main"/>
+          <a:p xmlns:a="http://schemas.openxmlformats.org/drawingml/2006/main">
+            <a:pPr>
+              <a:defRPr sz="1050" b="1">
+                <a:solidFill>
+                  <a:srgbClr val="F3F0E8"/>
+                </a:solidFill>
+              </a:defRPr>
+            </a:pPr>
+            <a:r>
+              <a:rPr sz="1050" b="1">
+                <a:solidFill>
+                  <a:srgbClr val="F3F0E8"/>
+                </a:solidFill>
+              </a:rPr>
+              <a:t>SAM</a:t>
+            </a:r>
+          </a:p>
+        </p:txBody>
+      </p:sp>
+      <p:sp>
+        <p:nvSpPr>
+          <p:cNvPr id="81" name="sam-legend-value">
+            <a:extLst xmlns:a="http://schemas.openxmlformats.org/drawingml/2006/main">
+              <a:ext uri="{FF2B5EF4-FFF2-40B4-BE49-F238E27FC236}">
+                <a16:creationId xmlns:a16="http://schemas.microsoft.com/office/drawing/2014/main" id="{1A203243-C2C5-4B4D-B9C0-93D65D3DEF16}"/>
+              </a:ext>
+            </a:extLst>
+          </p:cNvPr>
+          <p:cNvSpPr>
+            <a:spLocks xmlns:a="http://schemas.openxmlformats.org/drawingml/2006/main" noGrp="1"/>
+          </p:cNvSpPr>
+          <p:nvPr/>
+        </p:nvSpPr>
+        <p:spPr>
+          <a:xfrm xmlns:a="http://schemas.openxmlformats.org/drawingml/2006/main">
+            <a:off x="5905500" y="3867150"/>
+            <a:ext cx="1905000" cy="285750"/>
+          </a:xfrm>
+          <a:prstGeom xmlns:a="http://schemas.openxmlformats.org/drawingml/2006/main" prst="rect">
+            <a:avLst/>
+          </a:prstGeom>
+          <a:noFill xmlns:a="http://schemas.openxmlformats.org/drawingml/2006/main"/>
+          <a:ln xmlns:a="http://schemas.openxmlformats.org/drawingml/2006/main" w="0">
+            <a:noFill/>
+            <a:prstDash val="solid"/>
+          </a:ln>
+        </p:spPr>
+        <p:txBody>
+          <a:bodyPr xmlns:a="http://schemas.openxmlformats.org/drawingml/2006/main"/>
+          <a:lstStyle xmlns:a="http://schemas.openxmlformats.org/drawingml/2006/main"/>
+          <a:p xmlns:a="http://schemas.openxmlformats.org/drawingml/2006/main">
+            <a:pPr>
+              <a:defRPr sz="2100" b="1">
+                <a:solidFill>
+                  <a:srgbClr val="CCFF00"/>
+                </a:solidFill>
+              </a:defRPr>
+            </a:pPr>
+            <a:r>
+              <a:rPr sz="2100" b="1">
+                <a:solidFill>
+                  <a:srgbClr val="CCFF00"/>
+                </a:solidFill>
+              </a:rPr>
+              <a:t>$165.2B</a:t>
+            </a:r>
+          </a:p>
+        </p:txBody>
+      </p:sp>
+      <p:sp>
+        <p:nvSpPr>
+          <p:cNvPr id="82" name="sam-legend-copy">
+            <a:extLst xmlns:a="http://schemas.openxmlformats.org/drawingml/2006/main">
+              <a:ext uri="{FF2B5EF4-FFF2-40B4-BE49-F238E27FC236}">
+                <a16:creationId xmlns:a16="http://schemas.microsoft.com/office/drawing/2014/main" id="{B307FABB-4C80-4D39-A5B6-9D773526326A}"/>
+              </a:ext>
+            </a:extLst>
+          </p:cNvPr>
+          <p:cNvSpPr>
+            <a:spLocks xmlns:a="http://schemas.openxmlformats.org/drawingml/2006/main" noGrp="1"/>
+          </p:cNvSpPr>
+          <p:nvPr/>
+        </p:nvSpPr>
+        <p:spPr>
+          <a:xfrm xmlns:a="http://schemas.openxmlformats.org/drawingml/2006/main">
+            <a:off x="8267700" y="3924300"/>
+            <a:ext cx="2667000" cy="323850"/>
+          </a:xfrm>
+          <a:prstGeom xmlns:a="http://schemas.openxmlformats.org/drawingml/2006/main" prst="rect">
+            <a:avLst/>
+          </a:prstGeom>
+          <a:noFill xmlns:a="http://schemas.openxmlformats.org/drawingml/2006/main"/>
+          <a:ln xmlns:a="http://schemas.openxmlformats.org/drawingml/2006/main" w="0">
+            <a:noFill/>
+            <a:prstDash val="solid"/>
+          </a:ln>
+        </p:spPr>
+        <p:txBody>
+          <a:bodyPr xmlns:a="http://schemas.openxmlformats.org/drawingml/2006/main"/>
+          <a:lstStyle xmlns:a="http://schemas.openxmlformats.org/drawingml/2006/main"/>
+          <a:p xmlns:a="http://schemas.openxmlformats.org/drawingml/2006/main">
+            <a:pPr>
+              <a:defRPr sz="1050" b="0">
+                <a:solidFill>
+                  <a:srgbClr val="F3F0E8"/>
+                </a:solidFill>
+              </a:defRPr>
+            </a:pPr>
+            <a:r>
+              <a:rPr sz="1050" b="0">
+                <a:solidFill>
+                  <a:srgbClr val="F3F0E8"/>
+                </a:solidFill>
+              </a:rPr>
+              <a:t>Satellite ground segment + GNSS equipment / 2025</a:t>
+            </a:r>
+          </a:p>
+        </p:txBody>
+      </p:sp>
+      <p:sp>
+        <p:nvSpPr>
+          <p:cNvPr id="83" name="tam-legend-rule-2">
+            <a:extLst xmlns:a="http://schemas.openxmlformats.org/drawingml/2006/main">
+              <a:ext uri="{FF2B5EF4-FFF2-40B4-BE49-F238E27FC236}">
+                <a16:creationId xmlns:a16="http://schemas.microsoft.com/office/drawing/2014/main" id="{9C4D61BB-E356-43F8-97CB-36FE43AB243A}"/>
+              </a:ext>
+            </a:extLst>
+          </p:cNvPr>
+          <p:cNvSpPr>
+            <a:spLocks xmlns:a="http://schemas.openxmlformats.org/drawingml/2006/main" noGrp="1"/>
+          </p:cNvSpPr>
+          <p:nvPr/>
+        </p:nvSpPr>
+        <p:spPr>
+          <a:xfrm xmlns:a="http://schemas.openxmlformats.org/drawingml/2006/main">
+            <a:off x="5905500" y="4362450"/>
+            <a:ext cx="5029200" cy="9525"/>
+          </a:xfrm>
+          <a:prstGeom xmlns:a="http://schemas.openxmlformats.org/drawingml/2006/main" prst="rect">
+            <a:avLst/>
+          </a:prstGeom>
+          <a:solidFill xmlns:a="http://schemas.openxmlformats.org/drawingml/2006/main">
+            <a:srgbClr val="25302E"/>
+          </a:solidFill>
+          <a:ln xmlns:a="http://schemas.openxmlformats.org/drawingml/2006/main" w="0">
+            <a:solidFill>
+              <a:srgbClr val="25302E"/>
+            </a:solidFill>
+            <a:prstDash val="solid"/>
+          </a:ln>
+        </p:spPr>
+      </p:sp>
+      <p:sp>
+        <p:nvSpPr>
+          <p:cNvPr id="84" name="som-legend-label">
+            <a:extLst xmlns:a="http://schemas.openxmlformats.org/drawingml/2006/main">
+              <a:ext uri="{FF2B5EF4-FFF2-40B4-BE49-F238E27FC236}">
+                <a16:creationId xmlns:a16="http://schemas.microsoft.com/office/drawing/2014/main" id="{DB6CBFCB-ED27-4EB0-902F-E39949AAC55E}"/>
+              </a:ext>
+            </a:extLst>
+          </p:cNvPr>
+          <p:cNvSpPr>
+            <a:spLocks xmlns:a="http://schemas.openxmlformats.org/drawingml/2006/main" noGrp="1"/>
+          </p:cNvSpPr>
+          <p:nvPr/>
+        </p:nvSpPr>
+        <p:spPr>
+          <a:xfrm xmlns:a="http://schemas.openxmlformats.org/drawingml/2006/main">
+            <a:off x="5905500" y="4572000"/>
+            <a:ext cx="1428750" cy="171450"/>
+          </a:xfrm>
+          <a:prstGeom xmlns:a="http://schemas.openxmlformats.org/drawingml/2006/main" prst="rect">
+            <a:avLst/>
+          </a:prstGeom>
+          <a:noFill xmlns:a="http://schemas.openxmlformats.org/drawingml/2006/main"/>
+          <a:ln xmlns:a="http://schemas.openxmlformats.org/drawingml/2006/main" w="0">
+            <a:noFill/>
+            <a:prstDash val="solid"/>
+          </a:ln>
+        </p:spPr>
+        <p:txBody>
+          <a:bodyPr xmlns:a="http://schemas.openxmlformats.org/drawingml/2006/main"/>
+          <a:lstStyle xmlns:a="http://schemas.openxmlformats.org/drawingml/2006/main"/>
+          <a:p xmlns:a="http://schemas.openxmlformats.org/drawingml/2006/main">
+            <a:pPr>
+              <a:defRPr sz="1050" b="1">
+                <a:solidFill>
+                  <a:srgbClr val="F3F0E8"/>
+                </a:solidFill>
+              </a:defRPr>
+            </a:pPr>
+            <a:r>
+              <a:rPr sz="1050" b="1">
+                <a:solidFill>
+                  <a:srgbClr val="F3F0E8"/>
+                </a:solidFill>
+              </a:rPr>
+              <a:t>SOM</a:t>
+            </a:r>
+          </a:p>
+        </p:txBody>
+      </p:sp>
+      <p:sp>
+        <p:nvSpPr>
+          <p:cNvPr id="85" name="som-legend-value">
+            <a:extLst xmlns:a="http://schemas.openxmlformats.org/drawingml/2006/main">
+              <a:ext uri="{FF2B5EF4-FFF2-40B4-BE49-F238E27FC236}">
+                <a16:creationId xmlns:a16="http://schemas.microsoft.com/office/drawing/2014/main" id="{97EF1BCF-28CF-4EA9-9812-C48187E63FFE}"/>
+              </a:ext>
+            </a:extLst>
+          </p:cNvPr>
+          <p:cNvSpPr>
+            <a:spLocks xmlns:a="http://schemas.openxmlformats.org/drawingml/2006/main" noGrp="1"/>
+          </p:cNvSpPr>
+          <p:nvPr/>
+        </p:nvSpPr>
+        <p:spPr>
+          <a:xfrm xmlns:a="http://schemas.openxmlformats.org/drawingml/2006/main">
+            <a:off x="5905500" y="4800600"/>
+            <a:ext cx="2190750" cy="285750"/>
+          </a:xfrm>
+          <a:prstGeom xmlns:a="http://schemas.openxmlformats.org/drawingml/2006/main" prst="rect">
+            <a:avLst/>
+          </a:prstGeom>
+          <a:noFill xmlns:a="http://schemas.openxmlformats.org/drawingml/2006/main"/>
+          <a:ln xmlns:a="http://schemas.openxmlformats.org/drawingml/2006/main" w="0">
+            <a:noFill/>
+            <a:prstDash val="solid"/>
+          </a:ln>
+        </p:spPr>
+        <p:txBody>
+          <a:bodyPr xmlns:a="http://schemas.openxmlformats.org/drawingml/2006/main"/>
+          <a:lstStyle xmlns:a="http://schemas.openxmlformats.org/drawingml/2006/main"/>
+          <a:p xmlns:a="http://schemas.openxmlformats.org/drawingml/2006/main">
+            <a:pPr>
+              <a:defRPr sz="2100" b="1">
+                <a:solidFill>
+                  <a:srgbClr val="CCFF00"/>
+                </a:solidFill>
+              </a:defRPr>
+            </a:pPr>
+            <a:r>
+              <a:rPr sz="2100" b="1">
+                <a:solidFill>
+                  <a:srgbClr val="CCFF00"/>
+                </a:solidFill>
+              </a:rPr>
+              <a:t>$500k ARR</a:t>
+            </a:r>
+          </a:p>
+        </p:txBody>
+      </p:sp>
+      <p:sp>
+        <p:nvSpPr>
+          <p:cNvPr id="86" name="som-legend-copy">
+            <a:extLst xmlns:a="http://schemas.openxmlformats.org/drawingml/2006/main">
+              <a:ext uri="{FF2B5EF4-FFF2-40B4-BE49-F238E27FC236}">
+                <a16:creationId xmlns:a16="http://schemas.microsoft.com/office/drawing/2014/main" id="{2D98C380-77D9-4BF5-A65F-49BF4B0CBE56}"/>
+              </a:ext>
+            </a:extLst>
+          </p:cNvPr>
+          <p:cNvSpPr>
+            <a:spLocks xmlns:a="http://schemas.openxmlformats.org/drawingml/2006/main" noGrp="1"/>
+          </p:cNvSpPr>
+          <p:nvPr/>
+        </p:nvSpPr>
+        <p:spPr>
+          <a:xfrm xmlns:a="http://schemas.openxmlformats.org/drawingml/2006/main">
+            <a:off x="8267700" y="4857750"/>
+            <a:ext cx="2667000" cy="190500"/>
+          </a:xfrm>
+          <a:prstGeom xmlns:a="http://schemas.openxmlformats.org/drawingml/2006/main" prst="rect">
+            <a:avLst/>
+          </a:prstGeom>
+          <a:noFill xmlns:a="http://schemas.openxmlformats.org/drawingml/2006/main"/>
+          <a:ln xmlns:a="http://schemas.openxmlformats.org/drawingml/2006/main" w="0">
+            <a:noFill/>
+            <a:prstDash val="solid"/>
+          </a:ln>
+        </p:spPr>
+        <p:txBody>
+          <a:bodyPr xmlns:a="http://schemas.openxmlformats.org/drawingml/2006/main"/>
+          <a:lstStyle xmlns:a="http://schemas.openxmlformats.org/drawingml/2006/main"/>
+          <a:p xmlns:a="http://schemas.openxmlformats.org/drawingml/2006/main">
+            <a:pPr>
+              <a:defRPr sz="1050" b="0">
+                <a:solidFill>
+                  <a:srgbClr val="F3F0E8"/>
+                </a:solidFill>
+              </a:defRPr>
+            </a:pPr>
+            <a:r>
+              <a:rPr sz="1050" b="0">
+                <a:solidFill>
+                  <a:srgbClr val="F3F0E8"/>
+                </a:solidFill>
+              </a:rPr>
+              <a:t>Five fleet accounts × $100k annual platform value</a:t>
+            </a:r>
+          </a:p>
+        </p:txBody>
+      </p:sp>
+      <p:sp>
+        <p:nvSpPr>
+          <p:cNvPr id="87" name="tam-sam-som-caveat">
+            <a:extLst xmlns:a="http://schemas.openxmlformats.org/drawingml/2006/main">
+              <a:ext uri="{FF2B5EF4-FFF2-40B4-BE49-F238E27FC236}">
+                <a16:creationId xmlns:a16="http://schemas.microsoft.com/office/drawing/2014/main" id="{B489445C-C1E5-402F-9672-FCE08486858D}"/>
+              </a:ext>
+            </a:extLst>
+          </p:cNvPr>
+          <p:cNvSpPr>
+            <a:spLocks xmlns:a="http://schemas.openxmlformats.org/drawingml/2006/main" noGrp="1"/>
+          </p:cNvSpPr>
+          <p:nvPr/>
+        </p:nvSpPr>
+        <p:spPr>
+          <a:xfrm xmlns:a="http://schemas.openxmlformats.org/drawingml/2006/main">
+            <a:off x="5905500" y="5257800"/>
+            <a:ext cx="5029200" cy="361950"/>
+          </a:xfrm>
+          <a:prstGeom xmlns:a="http://schemas.openxmlformats.org/drawingml/2006/main" prst="rect">
+            <a:avLst/>
+          </a:prstGeom>
+          <a:noFill xmlns:a="http://schemas.openxmlformats.org/drawingml/2006/main"/>
+          <a:ln xmlns:a="http://schemas.openxmlformats.org/drawingml/2006/main" w="0">
+            <a:noFill/>
+            <a:prstDash val="solid"/>
+          </a:ln>
+        </p:spPr>
+        <p:txBody>
+          <a:bodyPr xmlns:a="http://schemas.openxmlformats.org/drawingml/2006/main"/>
+          <a:lstStyle xmlns:a="http://schemas.openxmlformats.org/drawingml/2006/main"/>
+          <a:p xmlns:a="http://schemas.openxmlformats.org/drawingml/2006/main">
+            <a:pPr>
+              <a:defRPr sz="1125" b="1">
+                <a:solidFill>
+                  <a:srgbClr val="F3F0E8"/>
+                </a:solidFill>
+              </a:defRPr>
+            </a:pPr>
+            <a:r>
+              <a:rPr sz="1125" b="1">
+                <a:solidFill>
+                  <a:srgbClr val="F3F0E8"/>
+                </a:solidFill>
+              </a:rPr>
+              <a:t>TAM / SAM are category context; SOM is an internal revenue target, not market share.</a:t>
+            </a:r>
+          </a:p>
+        </p:txBody>
+      </p:sp>
+      <p:sp>
+        <p:nvSpPr>
+          <p:cNvPr id="88" name="tam-sam-som-source-rail">
+            <a:extLst xmlns:a="http://schemas.openxmlformats.org/drawingml/2006/main">
+              <a:ext uri="{FF2B5EF4-FFF2-40B4-BE49-F238E27FC236}">
+                <a16:creationId xmlns:a16="http://schemas.microsoft.com/office/drawing/2014/main" id="{985EE9CC-AA61-4157-9CA8-DB6BAB5A1492}"/>
+              </a:ext>
+            </a:extLst>
+          </p:cNvPr>
+          <p:cNvSpPr>
+            <a:spLocks xmlns:a="http://schemas.openxmlformats.org/drawingml/2006/main" noGrp="1"/>
+          </p:cNvSpPr>
+          <p:nvPr/>
+        </p:nvSpPr>
+        <p:spPr>
+          <a:xfrm xmlns:a="http://schemas.openxmlformats.org/drawingml/2006/main">
+            <a:off x="5905500" y="5829300"/>
+            <a:ext cx="5334000" cy="171450"/>
+          </a:xfrm>
+          <a:prstGeom xmlns:a="http://schemas.openxmlformats.org/drawingml/2006/main" prst="rect">
+            <a:avLst/>
+          </a:prstGeom>
+          <a:noFill xmlns:a="http://schemas.openxmlformats.org/drawingml/2006/main"/>
+          <a:ln xmlns:a="http://schemas.openxmlformats.org/drawingml/2006/main" w="0">
+            <a:noFill/>
+            <a:prstDash val="solid"/>
+          </a:ln>
+        </p:spPr>
+        <p:txBody>
+          <a:bodyPr xmlns:a="http://schemas.openxmlformats.org/drawingml/2006/main"/>
+          <a:lstStyle xmlns:a="http://schemas.openxmlformats.org/drawingml/2006/main"/>
+          <a:p xmlns:a="http://schemas.openxmlformats.org/drawingml/2006/main">
+            <a:pPr>
               <a:defRPr sz="900" b="0">
                 <a:solidFill>
                   <a:srgbClr val="F3F0E8"/>
@@ -15732,7 +18113,7 @@
         </p:xfrm>
         <a:graphic xmlns:a="http://schemas.openxmlformats.org/drawingml/2006/main">
           <a:graphicData uri="http://schemas.openxmlformats.org/drawingml/2006/chart">
-            <c:chart xmlns:r="http://schemas.openxmlformats.org/officeDocument/2006/relationships" xmlns:c="http://schemas.openxmlformats.org/drawingml/2006/chart" r:id="R1cba6e24a5e14702"/>
+            <c:chart xmlns:r="http://schemas.openxmlformats.org/officeDocument/2006/relationships" xmlns:c="http://schemas.openxmlformats.org/drawingml/2006/chart" r:id="R3d4f65fe5af04bc2"/>
           </a:graphicData>
         </a:graphic>
       </p:graphicFrame>
@@ -16700,14 +19081,14 @@
       </p:grpSpPr>
       <p:pic>
         <p:nvPicPr>
-          <p:cNvPr id="170" name="Image 0"/>
+          <p:cNvPr id="250" name="Image 0"/>
           <p:cNvPicPr>
             <a:picLocks xmlns:a="http://schemas.openxmlformats.org/drawingml/2006/main" noChangeAspect="1"/>
           </p:cNvPicPr>
           <p:nvPr/>
         </p:nvPicPr>
         <p:blipFill>
-          <a:blip xmlns:r="http://schemas.openxmlformats.org/officeDocument/2006/relationships" xmlns:a="http://schemas.openxmlformats.org/drawingml/2006/main" r:embed="Rb53801237ee04c21">
+          <a:blip xmlns:r="http://schemas.openxmlformats.org/officeDocument/2006/relationships" xmlns:a="http://schemas.openxmlformats.org/drawingml/2006/main" r:embed="R0459d3a67fa44fb7">
             <a:alphaModFix amt="96000"/>
           </a:blip>
           <a:stretch xmlns:a="http://schemas.openxmlformats.org/drawingml/2006/main">
@@ -17101,7 +19482,7 @@
       </p:sp>
       <p:graphicFrame>
         <p:nvGraphicFramePr>
-          <p:cNvPr id="178" name="Table 0"/>
+          <p:cNvPr id="258" name="Table 0"/>
           <p:cNvGraphicFramePr/>
           <p:nvPr/>
         </p:nvGraphicFramePr>
@@ -18694,17 +21075,17 @@
       </p:sp>
       <p:pic>
         <p:nvPicPr>
-          <p:cNvPr id="183" name=""/>
+          <p:cNvPr id="263" name=""/>
           <p:cNvPicPr>
             <a:picLocks xmlns:a="http://schemas.openxmlformats.org/drawingml/2006/main" noChangeAspect="1"/>
           </p:cNvPicPr>
           <p:nvPr/>
         </p:nvPicPr>
         <p:blipFill>
-          <a:blip xmlns:r="http://schemas.openxmlformats.org/officeDocument/2006/relationships" xmlns:a="http://schemas.openxmlformats.org/drawingml/2006/main" r:embed="R0776b20f543e4742">
+          <a:blip xmlns:r="http://schemas.openxmlformats.org/officeDocument/2006/relationships" xmlns:a="http://schemas.openxmlformats.org/drawingml/2006/main" r:embed="Rcbe2e47c42194c86">
             <a:extLst>
               <a:ext uri="{96DAC541-7B7A-43D3-8B79-37D633B846F1}">
-                <asvg:svgBlip xmlns:asvg="http://schemas.microsoft.com/office/drawing/2016/SVG/main" r:embed="Rc33f3ff7984240e4"/>
+                <asvg:svgBlip xmlns:asvg="http://schemas.microsoft.com/office/drawing/2016/SVG/main" r:embed="Rd3030c1062d74ae3"/>
               </a:ext>
             </a:extLst>
           </a:blip>
@@ -18722,14 +21103,14 @@
       </p:pic>
       <p:pic>
         <p:nvPicPr>
-          <p:cNvPr id="184" name=""/>
+          <p:cNvPr id="264" name=""/>
           <p:cNvPicPr>
             <a:picLocks xmlns:a="http://schemas.openxmlformats.org/drawingml/2006/main" noChangeAspect="1"/>
           </p:cNvPicPr>
           <p:nvPr/>
         </p:nvPicPr>
         <p:blipFill>
-          <a:blip xmlns:r="http://schemas.openxmlformats.org/officeDocument/2006/relationships" xmlns:a="http://schemas.openxmlformats.org/drawingml/2006/main" r:embed="R7abe034a0ae44c31"/>
+          <a:blip xmlns:r="http://schemas.openxmlformats.org/officeDocument/2006/relationships" xmlns:a="http://schemas.openxmlformats.org/drawingml/2006/main" r:embed="Recedfe1d4da34968"/>
           <a:stretch xmlns:a="http://schemas.openxmlformats.org/drawingml/2006/main"/>
         </p:blipFill>
         <p:spPr>
@@ -18744,17 +21125,17 @@
       </p:pic>
       <p:pic>
         <p:nvPicPr>
-          <p:cNvPr id="185" name=""/>
+          <p:cNvPr id="265" name=""/>
           <p:cNvPicPr>
             <a:picLocks xmlns:a="http://schemas.openxmlformats.org/drawingml/2006/main" noChangeAspect="1"/>
           </p:cNvPicPr>
           <p:nvPr/>
         </p:nvPicPr>
         <p:blipFill>
-          <a:blip xmlns:r="http://schemas.openxmlformats.org/officeDocument/2006/relationships" xmlns:a="http://schemas.openxmlformats.org/drawingml/2006/main" r:embed="R5fea89fc0b494fc9">
+          <a:blip xmlns:r="http://schemas.openxmlformats.org/officeDocument/2006/relationships" xmlns:a="http://schemas.openxmlformats.org/drawingml/2006/main" r:embed="R2ffba623c6984ac7">
             <a:extLst>
               <a:ext uri="{96DAC541-7B7A-43D3-8B79-37D633B846F1}">
-                <asvg:svgBlip xmlns:asvg="http://schemas.microsoft.com/office/drawing/2016/SVG/main" r:embed="R30b22f68a4c44cd4"/>
+                <asvg:svgBlip xmlns:asvg="http://schemas.microsoft.com/office/drawing/2016/SVG/main" r:embed="R64982ff9d19b4359"/>
               </a:ext>
             </a:extLst>
           </a:blip>
@@ -18772,14 +21153,14 @@
       </p:pic>
       <p:pic>
         <p:nvPicPr>
-          <p:cNvPr id="186" name=""/>
+          <p:cNvPr id="266" name=""/>
           <p:cNvPicPr>
             <a:picLocks xmlns:a="http://schemas.openxmlformats.org/drawingml/2006/main" noChangeAspect="1"/>
           </p:cNvPicPr>
           <p:nvPr/>
         </p:nvPicPr>
         <p:blipFill>
-          <a:blip xmlns:r="http://schemas.openxmlformats.org/officeDocument/2006/relationships" xmlns:a="http://schemas.openxmlformats.org/drawingml/2006/main" r:embed="Re5b1838c674f4919"/>
+          <a:blip xmlns:r="http://schemas.openxmlformats.org/officeDocument/2006/relationships" xmlns:a="http://schemas.openxmlformats.org/drawingml/2006/main" r:embed="Rbeb8f487327c43c4"/>
           <a:stretch xmlns:a="http://schemas.openxmlformats.org/drawingml/2006/main"/>
         </p:blipFill>
         <p:spPr>
@@ -18794,17 +21175,17 @@
       </p:pic>
       <p:pic>
         <p:nvPicPr>
-          <p:cNvPr id="187" name=""/>
+          <p:cNvPr id="267" name=""/>
           <p:cNvPicPr>
             <a:picLocks xmlns:a="http://schemas.openxmlformats.org/drawingml/2006/main" noChangeAspect="1"/>
           </p:cNvPicPr>
           <p:nvPr/>
         </p:nvPicPr>
         <p:blipFill>
-          <a:blip xmlns:r="http://schemas.openxmlformats.org/officeDocument/2006/relationships" xmlns:a="http://schemas.openxmlformats.org/drawingml/2006/main" r:embed="Rc13ec89555304165">
+          <a:blip xmlns:r="http://schemas.openxmlformats.org/officeDocument/2006/relationships" xmlns:a="http://schemas.openxmlformats.org/drawingml/2006/main" r:embed="R844cb74294114cf6">
             <a:extLst>
               <a:ext uri="{96DAC541-7B7A-43D3-8B79-37D633B846F1}">
-                <asvg:svgBlip xmlns:asvg="http://schemas.microsoft.com/office/drawing/2016/SVG/main" r:embed="R5568654b6cc34c58"/>
+                <asvg:svgBlip xmlns:asvg="http://schemas.microsoft.com/office/drawing/2016/SVG/main" r:embed="R21ebc349e1de43f0"/>
               </a:ext>
             </a:extLst>
           </a:blip>
@@ -18822,17 +21203,17 @@
       </p:pic>
       <p:pic>
         <p:nvPicPr>
-          <p:cNvPr id="188" name=""/>
+          <p:cNvPr id="268" name=""/>
           <p:cNvPicPr>
             <a:picLocks xmlns:a="http://schemas.openxmlformats.org/drawingml/2006/main" noChangeAspect="1"/>
           </p:cNvPicPr>
           <p:nvPr/>
         </p:nvPicPr>
         <p:blipFill>
-          <a:blip xmlns:r="http://schemas.openxmlformats.org/officeDocument/2006/relationships" xmlns:a="http://schemas.openxmlformats.org/drawingml/2006/main" r:embed="R7abe034a0ae44c31">
+          <a:blip xmlns:r="http://schemas.openxmlformats.org/officeDocument/2006/relationships" xmlns:a="http://schemas.openxmlformats.org/drawingml/2006/main" r:embed="Recedfe1d4da34968">
             <a:extLst>
               <a:ext uri="{96DAC541-7B7A-43D3-8B79-37D633B846F1}">
-                <asvg:svgBlip xmlns:asvg="http://schemas.microsoft.com/office/drawing/2016/SVG/main" r:embed="R190d6d18328e4550"/>
+                <asvg:svgBlip xmlns:asvg="http://schemas.microsoft.com/office/drawing/2016/SVG/main" r:embed="Rbfcd114a136a4b6a"/>
               </a:ext>
             </a:extLst>
           </a:blip>
@@ -18850,17 +21231,17 @@
       </p:pic>
       <p:pic>
         <p:nvPicPr>
-          <p:cNvPr id="189" name=""/>
+          <p:cNvPr id="269" name=""/>
           <p:cNvPicPr>
             <a:picLocks xmlns:a="http://schemas.openxmlformats.org/drawingml/2006/main" noChangeAspect="1"/>
           </p:cNvPicPr>
           <p:nvPr/>
         </p:nvPicPr>
         <p:blipFill>
-          <a:blip xmlns:r="http://schemas.openxmlformats.org/officeDocument/2006/relationships" xmlns:a="http://schemas.openxmlformats.org/drawingml/2006/main" r:embed="Re5b1838c674f4919">
+          <a:blip xmlns:r="http://schemas.openxmlformats.org/officeDocument/2006/relationships" xmlns:a="http://schemas.openxmlformats.org/drawingml/2006/main" r:embed="Rbeb8f487327c43c4">
             <a:extLst>
               <a:ext uri="{96DAC541-7B7A-43D3-8B79-37D633B846F1}">
-                <asvg:svgBlip xmlns:asvg="http://schemas.microsoft.com/office/drawing/2016/SVG/main" r:embed="R576c4f0d0a094e58"/>
+                <asvg:svgBlip xmlns:asvg="http://schemas.microsoft.com/office/drawing/2016/SVG/main" r:embed="Rfdaa533aaeda4696"/>
               </a:ext>
             </a:extLst>
           </a:blip>
@@ -18878,14 +21259,14 @@
       </p:pic>
       <p:pic>
         <p:nvPicPr>
-          <p:cNvPr id="190" name=""/>
+          <p:cNvPr id="270" name=""/>
           <p:cNvPicPr>
             <a:picLocks xmlns:a="http://schemas.openxmlformats.org/drawingml/2006/main" noChangeAspect="1"/>
           </p:cNvPicPr>
           <p:nvPr/>
         </p:nvPicPr>
         <p:blipFill>
-          <a:blip xmlns:r="http://schemas.openxmlformats.org/officeDocument/2006/relationships" xmlns:a="http://schemas.openxmlformats.org/drawingml/2006/main" r:embed="R63d247845a7d4ce5"/>
+          <a:blip xmlns:r="http://schemas.openxmlformats.org/officeDocument/2006/relationships" xmlns:a="http://schemas.openxmlformats.org/drawingml/2006/main" r:embed="R17310f699b5d4438"/>
           <a:stretch xmlns:a="http://schemas.openxmlformats.org/drawingml/2006/main"/>
         </p:blipFill>
         <p:spPr>
@@ -18900,17 +21281,17 @@
       </p:pic>
       <p:pic>
         <p:nvPicPr>
-          <p:cNvPr id="191" name=""/>
+          <p:cNvPr id="271" name=""/>
           <p:cNvPicPr>
             <a:picLocks xmlns:a="http://schemas.openxmlformats.org/drawingml/2006/main" noChangeAspect="1"/>
           </p:cNvPicPr>
           <p:nvPr/>
         </p:nvPicPr>
         <p:blipFill>
-          <a:blip xmlns:r="http://schemas.openxmlformats.org/officeDocument/2006/relationships" xmlns:a="http://schemas.openxmlformats.org/drawingml/2006/main" r:embed="R63d247845a7d4ce5">
+          <a:blip xmlns:r="http://schemas.openxmlformats.org/officeDocument/2006/relationships" xmlns:a="http://schemas.openxmlformats.org/drawingml/2006/main" r:embed="R17310f699b5d4438">
             <a:extLst>
               <a:ext uri="{96DAC541-7B7A-43D3-8B79-37D633B846F1}">
-                <asvg:svgBlip xmlns:asvg="http://schemas.microsoft.com/office/drawing/2016/SVG/main" r:embed="R87133008fd124b08"/>
+                <asvg:svgBlip xmlns:asvg="http://schemas.microsoft.com/office/drawing/2016/SVG/main" r:embed="R4ec4e0fc22a942e8"/>
               </a:ext>
             </a:extLst>
           </a:blip>
@@ -18928,14 +21309,14 @@
       </p:pic>
       <p:pic>
         <p:nvPicPr>
-          <p:cNvPr id="192" name=""/>
+          <p:cNvPr id="272" name=""/>
           <p:cNvPicPr>
             <a:picLocks xmlns:a="http://schemas.openxmlformats.org/drawingml/2006/main" noChangeAspect="1"/>
           </p:cNvPicPr>
           <p:nvPr/>
         </p:nvPicPr>
         <p:blipFill>
-          <a:blip xmlns:r="http://schemas.openxmlformats.org/officeDocument/2006/relationships" xmlns:a="http://schemas.openxmlformats.org/drawingml/2006/main" r:embed="Rff4bfddabe2948bf"/>
+          <a:blip xmlns:r="http://schemas.openxmlformats.org/officeDocument/2006/relationships" xmlns:a="http://schemas.openxmlformats.org/drawingml/2006/main" r:embed="Rd0676fa751554e3d"/>
           <a:stretch xmlns:a="http://schemas.openxmlformats.org/drawingml/2006/main"/>
         </p:blipFill>
         <p:spPr>
@@ -18950,17 +21331,17 @@
       </p:pic>
       <p:pic>
         <p:nvPicPr>
-          <p:cNvPr id="193" name=""/>
+          <p:cNvPr id="273" name=""/>
           <p:cNvPicPr>
             <a:picLocks xmlns:a="http://schemas.openxmlformats.org/drawingml/2006/main" noChangeAspect="1"/>
           </p:cNvPicPr>
           <p:nvPr/>
         </p:nvPicPr>
         <p:blipFill>
-          <a:blip xmlns:r="http://schemas.openxmlformats.org/officeDocument/2006/relationships" xmlns:a="http://schemas.openxmlformats.org/drawingml/2006/main" r:embed="R0549595bbc404870">
+          <a:blip xmlns:r="http://schemas.openxmlformats.org/officeDocument/2006/relationships" xmlns:a="http://schemas.openxmlformats.org/drawingml/2006/main" r:embed="Rd0676fa751554e3d">
             <a:extLst>
               <a:ext uri="{96DAC541-7B7A-43D3-8B79-37D633B846F1}">
-                <asvg:svgBlip xmlns:asvg="http://schemas.microsoft.com/office/drawing/2016/SVG/main" r:embed="R31ec40d79ef5480a"/>
+                <asvg:svgBlip xmlns:asvg="http://schemas.microsoft.com/office/drawing/2016/SVG/main" r:embed="Reb4d3da1acc545d7"/>
               </a:ext>
             </a:extLst>
           </a:blip>
@@ -18978,17 +21359,17 @@
       </p:pic>
       <p:pic>
         <p:nvPicPr>
-          <p:cNvPr id="194" name=""/>
+          <p:cNvPr id="274" name=""/>
           <p:cNvPicPr>
             <a:picLocks xmlns:a="http://schemas.openxmlformats.org/drawingml/2006/main" noChangeAspect="1"/>
           </p:cNvPicPr>
           <p:nvPr/>
         </p:nvPicPr>
         <p:blipFill>
-          <a:blip xmlns:r="http://schemas.openxmlformats.org/officeDocument/2006/relationships" xmlns:a="http://schemas.openxmlformats.org/drawingml/2006/main" r:embed="Rff4bfddabe2948bf">
+          <a:blip xmlns:r="http://schemas.openxmlformats.org/officeDocument/2006/relationships" xmlns:a="http://schemas.openxmlformats.org/drawingml/2006/main" r:embed="R14b365d2cf444d8d">
             <a:extLst>
               <a:ext uri="{96DAC541-7B7A-43D3-8B79-37D633B846F1}">
-                <asvg:svgBlip xmlns:asvg="http://schemas.microsoft.com/office/drawing/2016/SVG/main" r:embed="R240c99bd645d41b4"/>
+                <asvg:svgBlip xmlns:asvg="http://schemas.microsoft.com/office/drawing/2016/SVG/main" r:embed="R4982098a30e546df"/>
               </a:ext>
             </a:extLst>
           </a:blip>
@@ -19006,17 +21387,17 @@
       </p:pic>
       <p:pic>
         <p:nvPicPr>
-          <p:cNvPr id="195" name=""/>
+          <p:cNvPr id="275" name=""/>
           <p:cNvPicPr>
             <a:picLocks xmlns:a="http://schemas.openxmlformats.org/drawingml/2006/main" noChangeAspect="1"/>
           </p:cNvPicPr>
           <p:nvPr/>
         </p:nvPicPr>
         <p:blipFill>
-          <a:blip xmlns:r="http://schemas.openxmlformats.org/officeDocument/2006/relationships" xmlns:a="http://schemas.openxmlformats.org/drawingml/2006/main" r:embed="R7bbdd64a1eb24847">
+          <a:blip xmlns:r="http://schemas.openxmlformats.org/officeDocument/2006/relationships" xmlns:a="http://schemas.openxmlformats.org/drawingml/2006/main" r:embed="R0dbe28f6459c4d98">
             <a:extLst>
               <a:ext uri="{96DAC541-7B7A-43D3-8B79-37D633B846F1}">
-                <asvg:svgBlip xmlns:asvg="http://schemas.microsoft.com/office/drawing/2016/SVG/main" r:embed="R331f8f6c46b849fc"/>
+                <asvg:svgBlip xmlns:asvg="http://schemas.microsoft.com/office/drawing/2016/SVG/main" r:embed="R58a075af0a344b82"/>
               </a:ext>
             </a:extLst>
           </a:blip>
@@ -19034,14 +21415,14 @@
       </p:pic>
       <p:pic>
         <p:nvPicPr>
-          <p:cNvPr id="196" name=""/>
+          <p:cNvPr id="276" name=""/>
           <p:cNvPicPr>
             <a:picLocks xmlns:a="http://schemas.openxmlformats.org/drawingml/2006/main" noChangeAspect="1"/>
           </p:cNvPicPr>
           <p:nvPr/>
         </p:nvPicPr>
         <p:blipFill>
-          <a:blip xmlns:r="http://schemas.openxmlformats.org/officeDocument/2006/relationships" xmlns:a="http://schemas.openxmlformats.org/drawingml/2006/main" r:embed="Re0d130edf1e04fbc"/>
+          <a:blip xmlns:r="http://schemas.openxmlformats.org/officeDocument/2006/relationships" xmlns:a="http://schemas.openxmlformats.org/drawingml/2006/main" r:embed="Rdcc81b4250654980"/>
           <a:stretch xmlns:a="http://schemas.openxmlformats.org/drawingml/2006/main"/>
         </p:blipFill>
         <p:spPr>
@@ -19056,17 +21437,17 @@
       </p:pic>
       <p:pic>
         <p:nvPicPr>
-          <p:cNvPr id="197" name=""/>
+          <p:cNvPr id="277" name=""/>
           <p:cNvPicPr>
             <a:picLocks xmlns:a="http://schemas.openxmlformats.org/drawingml/2006/main" noChangeAspect="1"/>
           </p:cNvPicPr>
           <p:nvPr/>
         </p:nvPicPr>
         <p:blipFill>
-          <a:blip xmlns:r="http://schemas.openxmlformats.org/officeDocument/2006/relationships" xmlns:a="http://schemas.openxmlformats.org/drawingml/2006/main" r:embed="R7e8f96aed66642da">
+          <a:blip xmlns:r="http://schemas.openxmlformats.org/officeDocument/2006/relationships" xmlns:a="http://schemas.openxmlformats.org/drawingml/2006/main" r:embed="Rdcc81b4250654980">
             <a:extLst>
               <a:ext uri="{96DAC541-7B7A-43D3-8B79-37D633B846F1}">
-                <asvg:svgBlip xmlns:asvg="http://schemas.microsoft.com/office/drawing/2016/SVG/main" r:embed="R758ce5a2cffe46d3"/>
+                <asvg:svgBlip xmlns:asvg="http://schemas.microsoft.com/office/drawing/2016/SVG/main" r:embed="R187756525976432a"/>
               </a:ext>
             </a:extLst>
           </a:blip>
@@ -19084,14 +21465,14 @@
       </p:pic>
       <p:pic>
         <p:nvPicPr>
-          <p:cNvPr id="198" name=""/>
+          <p:cNvPr id="278" name=""/>
           <p:cNvPicPr>
             <a:picLocks xmlns:a="http://schemas.openxmlformats.org/drawingml/2006/main" noChangeAspect="1"/>
           </p:cNvPicPr>
           <p:nvPr/>
         </p:nvPicPr>
         <p:blipFill>
-          <a:blip xmlns:r="http://schemas.openxmlformats.org/officeDocument/2006/relationships" xmlns:a="http://schemas.openxmlformats.org/drawingml/2006/main" r:embed="R35ab0097f2754c04"/>
+          <a:blip xmlns:r="http://schemas.openxmlformats.org/officeDocument/2006/relationships" xmlns:a="http://schemas.openxmlformats.org/drawingml/2006/main" r:embed="R3cf464c1fbc64dec"/>
           <a:stretch xmlns:a="http://schemas.openxmlformats.org/drawingml/2006/main"/>
         </p:blipFill>
         <p:spPr>
@@ -19106,17 +21487,17 @@
       </p:pic>
       <p:pic>
         <p:nvPicPr>
-          <p:cNvPr id="199" name=""/>
+          <p:cNvPr id="279" name=""/>
           <p:cNvPicPr>
             <a:picLocks xmlns:a="http://schemas.openxmlformats.org/drawingml/2006/main" noChangeAspect="1"/>
           </p:cNvPicPr>
           <p:nvPr/>
         </p:nvPicPr>
         <p:blipFill>
-          <a:blip xmlns:r="http://schemas.openxmlformats.org/officeDocument/2006/relationships" xmlns:a="http://schemas.openxmlformats.org/drawingml/2006/main" r:embed="Re0d130edf1e04fbc">
+          <a:blip xmlns:r="http://schemas.openxmlformats.org/officeDocument/2006/relationships" xmlns:a="http://schemas.openxmlformats.org/drawingml/2006/main" r:embed="R3cf464c1fbc64dec">
             <a:extLst>
               <a:ext uri="{96DAC541-7B7A-43D3-8B79-37D633B846F1}">
-                <asvg:svgBlip xmlns:asvg="http://schemas.microsoft.com/office/drawing/2016/SVG/main" r:embed="Rb98ad6df331c48b5"/>
+                <asvg:svgBlip xmlns:asvg="http://schemas.microsoft.com/office/drawing/2016/SVG/main" r:embed="Rb0c18d8d216a4348"/>
               </a:ext>
             </a:extLst>
           </a:blip>
@@ -19134,17 +21515,17 @@
       </p:pic>
       <p:pic>
         <p:nvPicPr>
-          <p:cNvPr id="200" name=""/>
+          <p:cNvPr id="280" name=""/>
           <p:cNvPicPr>
             <a:picLocks xmlns:a="http://schemas.openxmlformats.org/drawingml/2006/main" noChangeAspect="1"/>
           </p:cNvPicPr>
           <p:nvPr/>
         </p:nvPicPr>
         <p:blipFill>
-          <a:blip xmlns:r="http://schemas.openxmlformats.org/officeDocument/2006/relationships" xmlns:a="http://schemas.openxmlformats.org/drawingml/2006/main" r:embed="R382d413e1d1b4407">
+          <a:blip xmlns:r="http://schemas.openxmlformats.org/officeDocument/2006/relationships" xmlns:a="http://schemas.openxmlformats.org/drawingml/2006/main" r:embed="R6938a1400e9a4df7">
             <a:extLst>
               <a:ext uri="{96DAC541-7B7A-43D3-8B79-37D633B846F1}">
-                <asvg:svgBlip xmlns:asvg="http://schemas.microsoft.com/office/drawing/2016/SVG/main" r:embed="R86290dcffd0a4549"/>
+                <asvg:svgBlip xmlns:asvg="http://schemas.microsoft.com/office/drawing/2016/SVG/main" r:embed="R846458a980c240b7"/>
               </a:ext>
             </a:extLst>
           </a:blip>
@@ -19160,12 +21541,168 @@
           </a:prstGeom>
         </p:spPr>
       </p:pic>
-      <p:sp>
-        <p:nvSpPr>
-          <p:cNvPr id="148" name="competitor-table-cover">
-            <a:extLst xmlns:a="http://schemas.openxmlformats.org/drawingml/2006/main">
-              <a:ext uri="{FF2B5EF4-FFF2-40B4-BE49-F238E27FC236}">
-                <a16:creationId xmlns:a16="http://schemas.microsoft.com/office/drawing/2014/main" id="{A6DDA8A9-11D4-4AF2-8DAE-851C13BE5EB7}"/>
+      <p:pic>
+        <p:nvPicPr>
+          <p:cNvPr id="281" name=""/>
+          <p:cNvPicPr>
+            <a:picLocks xmlns:a="http://schemas.openxmlformats.org/drawingml/2006/main" noChangeAspect="1"/>
+          </p:cNvPicPr>
+          <p:nvPr/>
+        </p:nvPicPr>
+        <p:blipFill>
+          <a:blip xmlns:r="http://schemas.openxmlformats.org/officeDocument/2006/relationships" xmlns:a="http://schemas.openxmlformats.org/drawingml/2006/main" r:embed="Rb6aa8419ea41466a">
+            <a:extLst>
+              <a:ext uri="{96DAC541-7B7A-43D3-8B79-37D633B846F1}">
+                <asvg:svgBlip xmlns:asvg="http://schemas.microsoft.com/office/drawing/2016/SVG/main" r:embed="R43b50f847c1a4109"/>
+              </a:ext>
+            </a:extLst>
+          </a:blip>
+          <a:stretch xmlns:a="http://schemas.openxmlformats.org/drawingml/2006/main"/>
+        </p:blipFill>
+        <p:spPr>
+          <a:xfrm xmlns:a="http://schemas.openxmlformats.org/drawingml/2006/main">
+            <a:off x="1790700" y="3286125"/>
+            <a:ext cx="1162050" cy="209550"/>
+          </a:xfrm>
+          <a:prstGeom xmlns:a="http://schemas.openxmlformats.org/drawingml/2006/main" prst="rect">
+            <a:avLst/>
+          </a:prstGeom>
+        </p:spPr>
+      </p:pic>
+      <p:pic>
+        <p:nvPicPr>
+          <p:cNvPr id="282" name=""/>
+          <p:cNvPicPr>
+            <a:picLocks xmlns:a="http://schemas.openxmlformats.org/drawingml/2006/main" noChangeAspect="1"/>
+          </p:cNvPicPr>
+          <p:nvPr/>
+        </p:nvPicPr>
+        <p:blipFill>
+          <a:blip xmlns:r="http://schemas.openxmlformats.org/officeDocument/2006/relationships" xmlns:a="http://schemas.openxmlformats.org/drawingml/2006/main" r:embed="R25e3b9c574a44455"/>
+          <a:stretch xmlns:a="http://schemas.openxmlformats.org/drawingml/2006/main"/>
+        </p:blipFill>
+        <p:spPr>
+          <a:xfrm xmlns:a="http://schemas.openxmlformats.org/drawingml/2006/main">
+            <a:off x="3536871" y="4238625"/>
+            <a:ext cx="908208" cy="209550"/>
+          </a:xfrm>
+          <a:prstGeom xmlns:a="http://schemas.openxmlformats.org/drawingml/2006/main" prst="rect">
+            <a:avLst/>
+          </a:prstGeom>
+        </p:spPr>
+      </p:pic>
+      <p:pic>
+        <p:nvPicPr>
+          <p:cNvPr id="283" name=""/>
+          <p:cNvPicPr>
+            <a:picLocks xmlns:a="http://schemas.openxmlformats.org/drawingml/2006/main" noChangeAspect="1"/>
+          </p:cNvPicPr>
+          <p:nvPr/>
+        </p:nvPicPr>
+        <p:blipFill>
+          <a:blip xmlns:r="http://schemas.openxmlformats.org/officeDocument/2006/relationships" xmlns:a="http://schemas.openxmlformats.org/drawingml/2006/main" r:embed="R25e3b9c574a44455">
+            <a:extLst>
+              <a:ext uri="{96DAC541-7B7A-43D3-8B79-37D633B846F1}">
+                <asvg:svgBlip xmlns:asvg="http://schemas.microsoft.com/office/drawing/2016/SVG/main" r:embed="Rcea6293c49764241"/>
+              </a:ext>
+            </a:extLst>
+          </a:blip>
+          <a:stretch xmlns:a="http://schemas.openxmlformats.org/drawingml/2006/main"/>
+        </p:blipFill>
+        <p:spPr>
+          <a:xfrm xmlns:a="http://schemas.openxmlformats.org/drawingml/2006/main">
+            <a:off x="3219450" y="2886075"/>
+            <a:ext cx="1162050" cy="209550"/>
+          </a:xfrm>
+          <a:prstGeom xmlns:a="http://schemas.openxmlformats.org/drawingml/2006/main" prst="rect">
+            <a:avLst/>
+          </a:prstGeom>
+        </p:spPr>
+      </p:pic>
+      <p:pic>
+        <p:nvPicPr>
+          <p:cNvPr id="284" name=""/>
+          <p:cNvPicPr>
+            <a:picLocks xmlns:a="http://schemas.openxmlformats.org/drawingml/2006/main" noChangeAspect="1"/>
+          </p:cNvPicPr>
+          <p:nvPr/>
+        </p:nvPicPr>
+        <p:blipFill>
+          <a:blip xmlns:r="http://schemas.openxmlformats.org/officeDocument/2006/relationships" xmlns:a="http://schemas.openxmlformats.org/drawingml/2006/main" r:embed="R6c3c52e64d1f4ab5"/>
+          <a:stretch xmlns:a="http://schemas.openxmlformats.org/drawingml/2006/main"/>
+        </p:blipFill>
+        <p:spPr>
+          <a:xfrm xmlns:a="http://schemas.openxmlformats.org/drawingml/2006/main">
+            <a:off x="4678781" y="4238625"/>
+            <a:ext cx="1005639" cy="209550"/>
+          </a:xfrm>
+          <a:prstGeom xmlns:a="http://schemas.openxmlformats.org/drawingml/2006/main" prst="rect">
+            <a:avLst/>
+          </a:prstGeom>
+        </p:spPr>
+      </p:pic>
+      <p:pic>
+        <p:nvPicPr>
+          <p:cNvPr id="285" name=""/>
+          <p:cNvPicPr>
+            <a:picLocks xmlns:a="http://schemas.openxmlformats.org/drawingml/2006/main" noChangeAspect="1"/>
+          </p:cNvPicPr>
+          <p:nvPr/>
+        </p:nvPicPr>
+        <p:blipFill>
+          <a:blip xmlns:r="http://schemas.openxmlformats.org/officeDocument/2006/relationships" xmlns:a="http://schemas.openxmlformats.org/drawingml/2006/main" r:embed="R6c3c52e64d1f4ab5">
+            <a:extLst>
+              <a:ext uri="{96DAC541-7B7A-43D3-8B79-37D633B846F1}">
+                <asvg:svgBlip xmlns:asvg="http://schemas.microsoft.com/office/drawing/2016/SVG/main" r:embed="R32b9a982e63048b6"/>
+              </a:ext>
+            </a:extLst>
+          </a:blip>
+          <a:stretch xmlns:a="http://schemas.openxmlformats.org/drawingml/2006/main"/>
+        </p:blipFill>
+        <p:spPr>
+          <a:xfrm xmlns:a="http://schemas.openxmlformats.org/drawingml/2006/main">
+            <a:off x="7410450" y="2886075"/>
+            <a:ext cx="1162050" cy="209550"/>
+          </a:xfrm>
+          <a:prstGeom xmlns:a="http://schemas.openxmlformats.org/drawingml/2006/main" prst="rect">
+            <a:avLst/>
+          </a:prstGeom>
+        </p:spPr>
+      </p:pic>
+      <p:pic>
+        <p:nvPicPr>
+          <p:cNvPr id="286" name=""/>
+          <p:cNvPicPr>
+            <a:picLocks xmlns:a="http://schemas.openxmlformats.org/drawingml/2006/main" noChangeAspect="1"/>
+          </p:cNvPicPr>
+          <p:nvPr/>
+        </p:nvPicPr>
+        <p:blipFill>
+          <a:blip xmlns:r="http://schemas.openxmlformats.org/officeDocument/2006/relationships" xmlns:a="http://schemas.openxmlformats.org/drawingml/2006/main" r:embed="R178243e0ee104e55">
+            <a:extLst>
+              <a:ext uri="{96DAC541-7B7A-43D3-8B79-37D633B846F1}">
+                <asvg:svgBlip xmlns:asvg="http://schemas.microsoft.com/office/drawing/2016/SVG/main" r:embed="R8e1b310978964ec4"/>
+              </a:ext>
+            </a:extLst>
+          </a:blip>
+          <a:stretch xmlns:a="http://schemas.openxmlformats.org/drawingml/2006/main"/>
+        </p:blipFill>
+        <p:spPr>
+          <a:xfrm xmlns:a="http://schemas.openxmlformats.org/drawingml/2006/main">
+            <a:off x="8696325" y="4238625"/>
+            <a:ext cx="1162050" cy="209550"/>
+          </a:xfrm>
+          <a:prstGeom xmlns:a="http://schemas.openxmlformats.org/drawingml/2006/main" prst="rect">
+            <a:avLst/>
+          </a:prstGeom>
+        </p:spPr>
+      </p:pic>
+      <p:sp>
+        <p:nvSpPr>
+          <p:cNvPr id="196" name="competitor-table-cover">
+            <a:extLst xmlns:a="http://schemas.openxmlformats.org/drawingml/2006/main">
+              <a:ext uri="{FF2B5EF4-FFF2-40B4-BE49-F238E27FC236}">
+                <a16:creationId xmlns:a16="http://schemas.microsoft.com/office/drawing/2014/main" id="{7B71F5B7-1081-43B4-8697-83DB90245091}"/>
               </a:ext>
             </a:extLst>
           </p:cNvPr>
@@ -19195,10 +21732,10 @@
       </p:sp>
       <p:sp>
         <p:nvSpPr>
-          <p:cNvPr id="149" name="competitor-matrix-frame">
-            <a:extLst xmlns:a="http://schemas.openxmlformats.org/drawingml/2006/main">
-              <a:ext uri="{FF2B5EF4-FFF2-40B4-BE49-F238E27FC236}">
-                <a16:creationId xmlns:a16="http://schemas.microsoft.com/office/drawing/2014/main" id="{7DA3309E-5ECF-46FF-919A-C0ED3D02F2CA}"/>
+          <p:cNvPr id="197" name="competitor-matrix-frame">
+            <a:extLst xmlns:a="http://schemas.openxmlformats.org/drawingml/2006/main">
+              <a:ext uri="{FF2B5EF4-FFF2-40B4-BE49-F238E27FC236}">
+                <a16:creationId xmlns:a16="http://schemas.microsoft.com/office/drawing/2014/main" id="{3CD87437-A97A-43A2-AFB1-8D2CE86C96E0}"/>
               </a:ext>
             </a:extLst>
           </p:cNvPr>
@@ -19228,10 +21765,10 @@
       </p:sp>
       <p:sp>
         <p:nvSpPr>
-          <p:cNvPr id="150" name="competitor-matrix-axis-y">
-            <a:extLst xmlns:a="http://schemas.openxmlformats.org/drawingml/2006/main">
-              <a:ext uri="{FF2B5EF4-FFF2-40B4-BE49-F238E27FC236}">
-                <a16:creationId xmlns:a16="http://schemas.microsoft.com/office/drawing/2014/main" id="{4D38BA08-5E50-4DB4-985A-F1CC205FF6D6}"/>
+          <p:cNvPr id="198" name="competitor-matrix-axis-y">
+            <a:extLst xmlns:a="http://schemas.openxmlformats.org/drawingml/2006/main">
+              <a:ext uri="{FF2B5EF4-FFF2-40B4-BE49-F238E27FC236}">
+                <a16:creationId xmlns:a16="http://schemas.microsoft.com/office/drawing/2014/main" id="{91782250-7E22-404F-A997-FC4D3C4FCE8F}"/>
               </a:ext>
             </a:extLst>
           </p:cNvPr>
@@ -19261,10 +21798,10 @@
       </p:sp>
       <p:sp>
         <p:nvSpPr>
-          <p:cNvPr id="151" name="competitor-matrix-axis-x">
-            <a:extLst xmlns:a="http://schemas.openxmlformats.org/drawingml/2006/main">
-              <a:ext uri="{FF2B5EF4-FFF2-40B4-BE49-F238E27FC236}">
-                <a16:creationId xmlns:a16="http://schemas.microsoft.com/office/drawing/2014/main" id="{3E70E8F1-7C82-40EA-A20F-B883A711A892}"/>
+          <p:cNvPr id="199" name="competitor-matrix-axis-x">
+            <a:extLst xmlns:a="http://schemas.openxmlformats.org/drawingml/2006/main">
+              <a:ext uri="{FF2B5EF4-FFF2-40B4-BE49-F238E27FC236}">
+                <a16:creationId xmlns:a16="http://schemas.microsoft.com/office/drawing/2014/main" id="{CF4DD817-6381-4653-AFFD-99078A630AD5}"/>
               </a:ext>
             </a:extLst>
           </p:cNvPr>
@@ -19294,10 +21831,10 @@
       </p:sp>
       <p:sp>
         <p:nvSpPr>
-          <p:cNvPr id="152" name="matrix-axis-left">
-            <a:extLst xmlns:a="http://schemas.openxmlformats.org/drawingml/2006/main">
-              <a:ext uri="{FF2B5EF4-FFF2-40B4-BE49-F238E27FC236}">
-                <a16:creationId xmlns:a16="http://schemas.microsoft.com/office/drawing/2014/main" id="{8B14241F-A806-4B3D-B3C4-C88C8A9C7710}"/>
+          <p:cNvPr id="200" name="matrix-axis-left">
+            <a:extLst xmlns:a="http://schemas.openxmlformats.org/drawingml/2006/main">
+              <a:ext uri="{FF2B5EF4-FFF2-40B4-BE49-F238E27FC236}">
+                <a16:creationId xmlns:a16="http://schemas.microsoft.com/office/drawing/2014/main" id="{77C27F64-C945-4ED8-A1EB-250A76596189}"/>
               </a:ext>
             </a:extLst>
           </p:cNvPr>
@@ -19325,6 +21862,7 @@
           <a:lstStyle xmlns:a="http://schemas.openxmlformats.org/drawingml/2006/main"/>
           <a:p xmlns:a="http://schemas.openxmlformats.org/drawingml/2006/main">
             <a:pPr>
+              <a:buNone/>
               <a:defRPr sz="900" b="1">
                 <a:solidFill>
                   <a:srgbClr val="F3F0E8"/>
@@ -19344,10 +21882,10 @@
       </p:sp>
       <p:sp>
         <p:nvSpPr>
-          <p:cNvPr id="153" name="matrix-axis-top">
-            <a:extLst xmlns:a="http://schemas.openxmlformats.org/drawingml/2006/main">
-              <a:ext uri="{FF2B5EF4-FFF2-40B4-BE49-F238E27FC236}">
-                <a16:creationId xmlns:a16="http://schemas.microsoft.com/office/drawing/2014/main" id="{AE3D845C-B10D-4AA1-A693-9D1C0DD09904}"/>
+          <p:cNvPr id="201" name="matrix-axis-top">
+            <a:extLst xmlns:a="http://schemas.openxmlformats.org/drawingml/2006/main">
+              <a:ext uri="{FF2B5EF4-FFF2-40B4-BE49-F238E27FC236}">
+                <a16:creationId xmlns:a16="http://schemas.microsoft.com/office/drawing/2014/main" id="{BF998FCF-3FF0-4FA4-8D13-EC0E616A1B8B}"/>
               </a:ext>
             </a:extLst>
           </p:cNvPr>
@@ -19375,6 +21913,7 @@
           <a:lstStyle xmlns:a="http://schemas.openxmlformats.org/drawingml/2006/main"/>
           <a:p xmlns:a="http://schemas.openxmlformats.org/drawingml/2006/main">
             <a:pPr>
+              <a:buNone/>
               <a:defRPr sz="900" b="1">
                 <a:solidFill>
                   <a:srgbClr val="F3F0E8"/>
@@ -19394,10 +21933,10 @@
       </p:sp>
       <p:sp>
         <p:nvSpPr>
-          <p:cNvPr id="154" name="matrix-axis-right">
-            <a:extLst xmlns:a="http://schemas.openxmlformats.org/drawingml/2006/main">
-              <a:ext uri="{FF2B5EF4-FFF2-40B4-BE49-F238E27FC236}">
-                <a16:creationId xmlns:a16="http://schemas.microsoft.com/office/drawing/2014/main" id="{96CD57B4-3885-436E-AE0E-53AB7F14AC75}"/>
+          <p:cNvPr id="202" name="matrix-axis-right">
+            <a:extLst xmlns:a="http://schemas.openxmlformats.org/drawingml/2006/main">
+              <a:ext uri="{FF2B5EF4-FFF2-40B4-BE49-F238E27FC236}">
+                <a16:creationId xmlns:a16="http://schemas.microsoft.com/office/drawing/2014/main" id="{6E44C19A-B04E-4414-B7A7-B9596418E2D0}"/>
               </a:ext>
             </a:extLst>
           </p:cNvPr>
@@ -19425,6 +21964,7 @@
           <a:lstStyle xmlns:a="http://schemas.openxmlformats.org/drawingml/2006/main"/>
           <a:p xmlns:a="http://schemas.openxmlformats.org/drawingml/2006/main">
             <a:pPr>
+              <a:buNone/>
               <a:defRPr sz="900" b="1">
                 <a:solidFill>
                   <a:srgbClr val="F3F0E8"/>
@@ -19444,10 +21984,10 @@
       </p:sp>
       <p:sp>
         <p:nvSpPr>
-          <p:cNvPr id="155" name="matrix-axis-bottom">
-            <a:extLst xmlns:a="http://schemas.openxmlformats.org/drawingml/2006/main">
-              <a:ext uri="{FF2B5EF4-FFF2-40B4-BE49-F238E27FC236}">
-                <a16:creationId xmlns:a16="http://schemas.microsoft.com/office/drawing/2014/main" id="{BF24AC04-9E34-4AEB-9E47-647A8365536A}"/>
+          <p:cNvPr id="203" name="matrix-axis-bottom">
+            <a:extLst xmlns:a="http://schemas.openxmlformats.org/drawingml/2006/main">
+              <a:ext uri="{FF2B5EF4-FFF2-40B4-BE49-F238E27FC236}">
+                <a16:creationId xmlns:a16="http://schemas.microsoft.com/office/drawing/2014/main" id="{1FBB797E-BA2D-47A5-AEFE-6EA73428CE5C}"/>
               </a:ext>
             </a:extLst>
           </p:cNvPr>
@@ -19475,6 +22015,7 @@
           <a:lstStyle xmlns:a="http://schemas.openxmlformats.org/drawingml/2006/main"/>
           <a:p xmlns:a="http://schemas.openxmlformats.org/drawingml/2006/main">
             <a:pPr>
+              <a:buNone/>
               <a:defRPr sz="900" b="1">
                 <a:solidFill>
                   <a:srgbClr val="F3F0E8"/>
@@ -19494,26 +22035,26 @@
       </p:sp>
       <p:sp>
         <p:nvSpPr>
-          <p:cNvPr id="156" name="matrix-pill-Yamcs mission control">
-            <a:extLst xmlns:a="http://schemas.openxmlformats.org/drawingml/2006/main">
-              <a:ext uri="{FF2B5EF4-FFF2-40B4-BE49-F238E27FC236}">
-                <a16:creationId xmlns:a16="http://schemas.microsoft.com/office/drawing/2014/main" id="{B0F1D138-4311-47A2-BEA4-7C2F9D6C773D}"/>
-              </a:ext>
-            </a:extLst>
-          </p:cNvPr>
-          <p:cNvSpPr>
-            <a:spLocks xmlns:a="http://schemas.openxmlformats.org/drawingml/2006/main" noGrp="1"/>
-          </p:cNvSpPr>
-          <p:nvPr/>
-        </p:nvSpPr>
-        <p:spPr>
-          <a:xfrm xmlns:a="http://schemas.openxmlformats.org/drawingml/2006/main">
-            <a:off x="1714500" y="3257550"/>
-            <a:ext cx="1314450" cy="266700"/>
+          <p:cNvPr id="204" name="matrix-pill-Yamcs mission control">
+            <a:extLst xmlns:a="http://schemas.openxmlformats.org/drawingml/2006/main">
+              <a:ext uri="{FF2B5EF4-FFF2-40B4-BE49-F238E27FC236}">
+                <a16:creationId xmlns:a16="http://schemas.microsoft.com/office/drawing/2014/main" id="{3C648652-5600-4EAC-863A-90E21CDFB5C2}"/>
+              </a:ext>
+            </a:extLst>
+          </p:cNvPr>
+          <p:cNvSpPr>
+            <a:spLocks xmlns:a="http://schemas.openxmlformats.org/drawingml/2006/main" noGrp="1"/>
+          </p:cNvSpPr>
+          <p:nvPr/>
+        </p:nvSpPr>
+        <p:spPr>
+          <a:xfrm xmlns:a="http://schemas.openxmlformats.org/drawingml/2006/main">
+            <a:off x="1619250" y="3257550"/>
+            <a:ext cx="1619250" cy="400050"/>
           </a:xfrm>
           <a:prstGeom xmlns:a="http://schemas.openxmlformats.org/drawingml/2006/main" prst="roundRect">
             <a:avLst>
-              <a:gd name="adj" fmla="val 28571"/>
+              <a:gd name="adj" fmla="val 19048"/>
             </a:avLst>
           </a:prstGeom>
           <a:solidFill xmlns:a="http://schemas.openxmlformats.org/drawingml/2006/main">
@@ -19529,26 +22070,20 @@
       </p:sp>
       <p:pic>
         <p:nvPicPr>
-          <p:cNvPr id="210" name=""/>
+          <p:cNvPr id="296" name=""/>
           <p:cNvPicPr>
             <a:picLocks xmlns:a="http://schemas.openxmlformats.org/drawingml/2006/main" noChangeAspect="1"/>
           </p:cNvPicPr>
           <p:nvPr/>
         </p:nvPicPr>
         <p:blipFill>
-          <a:blip xmlns:r="http://schemas.openxmlformats.org/officeDocument/2006/relationships" xmlns:a="http://schemas.openxmlformats.org/drawingml/2006/main" r:embed="R148430c425144272">
-            <a:extLst>
-              <a:ext uri="{96DAC541-7B7A-43D3-8B79-37D633B846F1}">
-                <asvg:svgBlip xmlns:asvg="http://schemas.microsoft.com/office/drawing/2016/SVG/main" r:embed="R23a92413bb074af2"/>
-              </a:ext>
-            </a:extLst>
-          </a:blip>
+          <a:blip xmlns:r="http://schemas.openxmlformats.org/officeDocument/2006/relationships" xmlns:a="http://schemas.openxmlformats.org/drawingml/2006/main" r:embed="R956b87fb44334dbf"/>
           <a:stretch xmlns:a="http://schemas.openxmlformats.org/drawingml/2006/main"/>
         </p:blipFill>
         <p:spPr>
           <a:xfrm xmlns:a="http://schemas.openxmlformats.org/drawingml/2006/main">
-            <a:off x="1790700" y="3286125"/>
-            <a:ext cx="1162050" cy="209550"/>
+            <a:off x="2085975" y="3314700"/>
+            <a:ext cx="685800" cy="285750"/>
           </a:xfrm>
           <a:prstGeom xmlns:a="http://schemas.openxmlformats.org/drawingml/2006/main" prst="rect">
             <a:avLst/>
@@ -19557,26 +22092,26 @@
       </p:pic>
       <p:sp>
         <p:nvSpPr>
-          <p:cNvPr id="158" name="matrix-pill-OpenC3 COSMOS">
-            <a:extLst xmlns:a="http://schemas.openxmlformats.org/drawingml/2006/main">
-              <a:ext uri="{FF2B5EF4-FFF2-40B4-BE49-F238E27FC236}">
-                <a16:creationId xmlns:a16="http://schemas.microsoft.com/office/drawing/2014/main" id="{0422F581-6916-40AE-903A-58BC91841FBD}"/>
-              </a:ext>
-            </a:extLst>
-          </p:cNvPr>
-          <p:cNvSpPr>
-            <a:spLocks xmlns:a="http://schemas.openxmlformats.org/drawingml/2006/main" noGrp="1"/>
-          </p:cNvSpPr>
-          <p:nvPr/>
-        </p:nvSpPr>
-        <p:spPr>
-          <a:xfrm xmlns:a="http://schemas.openxmlformats.org/drawingml/2006/main">
-            <a:off x="3333750" y="4210050"/>
-            <a:ext cx="1314450" cy="266700"/>
+          <p:cNvPr id="206" name="matrix-pill-OpenC3 COSMOS">
+            <a:extLst xmlns:a="http://schemas.openxmlformats.org/drawingml/2006/main">
+              <a:ext uri="{FF2B5EF4-FFF2-40B4-BE49-F238E27FC236}">
+                <a16:creationId xmlns:a16="http://schemas.microsoft.com/office/drawing/2014/main" id="{289BB2E7-7B10-4612-BB3B-4D0CA654F55F}"/>
+              </a:ext>
+            </a:extLst>
+          </p:cNvPr>
+          <p:cNvSpPr>
+            <a:spLocks xmlns:a="http://schemas.openxmlformats.org/drawingml/2006/main" noGrp="1"/>
+          </p:cNvSpPr>
+          <p:nvPr/>
+        </p:nvSpPr>
+        <p:spPr>
+          <a:xfrm xmlns:a="http://schemas.openxmlformats.org/drawingml/2006/main">
+            <a:off x="2857500" y="4210050"/>
+            <a:ext cx="1619250" cy="400050"/>
           </a:xfrm>
           <a:prstGeom xmlns:a="http://schemas.openxmlformats.org/drawingml/2006/main" prst="roundRect">
             <a:avLst>
-              <a:gd name="adj" fmla="val 28571"/>
+              <a:gd name="adj" fmla="val 19048"/>
             </a:avLst>
           </a:prstGeom>
           <a:solidFill xmlns:a="http://schemas.openxmlformats.org/drawingml/2006/main">
@@ -19592,20 +22127,20 @@
       </p:sp>
       <p:pic>
         <p:nvPicPr>
-          <p:cNvPr id="212" name=""/>
+          <p:cNvPr id="298" name=""/>
           <p:cNvPicPr>
             <a:picLocks xmlns:a="http://schemas.openxmlformats.org/drawingml/2006/main" noChangeAspect="1"/>
           </p:cNvPicPr>
           <p:nvPr/>
         </p:nvPicPr>
         <p:blipFill>
-          <a:blip xmlns:r="http://schemas.openxmlformats.org/officeDocument/2006/relationships" xmlns:a="http://schemas.openxmlformats.org/drawingml/2006/main" r:embed="Rcfc621e1ac8e4016"/>
+          <a:blip xmlns:r="http://schemas.openxmlformats.org/officeDocument/2006/relationships" xmlns:a="http://schemas.openxmlformats.org/drawingml/2006/main" r:embed="R9145db3977f44cfa"/>
           <a:stretch xmlns:a="http://schemas.openxmlformats.org/drawingml/2006/main"/>
         </p:blipFill>
         <p:spPr>
           <a:xfrm xmlns:a="http://schemas.openxmlformats.org/drawingml/2006/main">
-            <a:off x="3536871" y="4238625"/>
-            <a:ext cx="908208" cy="209550"/>
+            <a:off x="3047426" y="4267200"/>
+            <a:ext cx="1239398" cy="285750"/>
           </a:xfrm>
           <a:prstGeom xmlns:a="http://schemas.openxmlformats.org/drawingml/2006/main" prst="rect">
             <a:avLst/>
@@ -19614,26 +22149,26 @@
       </p:pic>
       <p:sp>
         <p:nvSpPr>
-          <p:cNvPr id="160" name="matrix-pill-Slingshot Portal">
-            <a:extLst xmlns:a="http://schemas.openxmlformats.org/drawingml/2006/main">
-              <a:ext uri="{FF2B5EF4-FFF2-40B4-BE49-F238E27FC236}">
-                <a16:creationId xmlns:a16="http://schemas.microsoft.com/office/drawing/2014/main" id="{7C931D35-F614-4B24-9282-B0187061E679}"/>
-              </a:ext>
-            </a:extLst>
-          </p:cNvPr>
-          <p:cNvSpPr>
-            <a:spLocks xmlns:a="http://schemas.openxmlformats.org/drawingml/2006/main" noGrp="1"/>
-          </p:cNvSpPr>
-          <p:nvPr/>
-        </p:nvSpPr>
-        <p:spPr>
-          <a:xfrm xmlns:a="http://schemas.openxmlformats.org/drawingml/2006/main">
-            <a:off x="3143250" y="2857500"/>
-            <a:ext cx="1314450" cy="266700"/>
+          <p:cNvPr id="208" name="matrix-pill-Slingshot Portal">
+            <a:extLst xmlns:a="http://schemas.openxmlformats.org/drawingml/2006/main">
+              <a:ext uri="{FF2B5EF4-FFF2-40B4-BE49-F238E27FC236}">
+                <a16:creationId xmlns:a16="http://schemas.microsoft.com/office/drawing/2014/main" id="{16ADDABC-DC77-4DF1-8230-370A9CE1D73E}"/>
+              </a:ext>
+            </a:extLst>
+          </p:cNvPr>
+          <p:cNvSpPr>
+            <a:spLocks xmlns:a="http://schemas.openxmlformats.org/drawingml/2006/main" noGrp="1"/>
+          </p:cNvSpPr>
+          <p:nvPr/>
+        </p:nvSpPr>
+        <p:spPr>
+          <a:xfrm xmlns:a="http://schemas.openxmlformats.org/drawingml/2006/main">
+            <a:off x="2857500" y="2781300"/>
+            <a:ext cx="1619250" cy="400050"/>
           </a:xfrm>
           <a:prstGeom xmlns:a="http://schemas.openxmlformats.org/drawingml/2006/main" prst="roundRect">
             <a:avLst>
-              <a:gd name="adj" fmla="val 28571"/>
+              <a:gd name="adj" fmla="val 19048"/>
             </a:avLst>
           </a:prstGeom>
           <a:solidFill xmlns:a="http://schemas.openxmlformats.org/drawingml/2006/main">
@@ -19649,26 +22184,20 @@
       </p:sp>
       <p:pic>
         <p:nvPicPr>
-          <p:cNvPr id="214" name=""/>
+          <p:cNvPr id="300" name=""/>
           <p:cNvPicPr>
             <a:picLocks xmlns:a="http://schemas.openxmlformats.org/drawingml/2006/main" noChangeAspect="1"/>
           </p:cNvPicPr>
           <p:nvPr/>
         </p:nvPicPr>
         <p:blipFill>
-          <a:blip xmlns:r="http://schemas.openxmlformats.org/officeDocument/2006/relationships" xmlns:a="http://schemas.openxmlformats.org/drawingml/2006/main" r:embed="R44bfb2a5913e4b09">
-            <a:extLst>
-              <a:ext uri="{96DAC541-7B7A-43D3-8B79-37D633B846F1}">
-                <asvg:svgBlip xmlns:asvg="http://schemas.microsoft.com/office/drawing/2016/SVG/main" r:embed="R5fb0328a4a764f6d"/>
-              </a:ext>
-            </a:extLst>
-          </a:blip>
+          <a:blip xmlns:r="http://schemas.openxmlformats.org/officeDocument/2006/relationships" xmlns:a="http://schemas.openxmlformats.org/drawingml/2006/main" r:embed="Ra2c6554b34d342ca"/>
           <a:stretch xmlns:a="http://schemas.openxmlformats.org/drawingml/2006/main"/>
         </p:blipFill>
         <p:spPr>
           <a:xfrm xmlns:a="http://schemas.openxmlformats.org/drawingml/2006/main">
-            <a:off x="3219450" y="2886075"/>
-            <a:ext cx="1162050" cy="209550"/>
+            <a:off x="3081305" y="2838450"/>
+            <a:ext cx="1171640" cy="285750"/>
           </a:xfrm>
           <a:prstGeom xmlns:a="http://schemas.openxmlformats.org/drawingml/2006/main" prst="rect">
             <a:avLst/>
@@ -19677,26 +22206,26 @@
       </p:pic>
       <p:sp>
         <p:nvSpPr>
-          <p:cNvPr id="162" name="matrix-pill-AIKO orbital_OLIVER">
-            <a:extLst xmlns:a="http://schemas.openxmlformats.org/drawingml/2006/main">
-              <a:ext uri="{FF2B5EF4-FFF2-40B4-BE49-F238E27FC236}">
-                <a16:creationId xmlns:a16="http://schemas.microsoft.com/office/drawing/2014/main" id="{B1353E97-178F-4922-9505-20FF0C13D529}"/>
-              </a:ext>
-            </a:extLst>
-          </p:cNvPr>
-          <p:cNvSpPr>
-            <a:spLocks xmlns:a="http://schemas.openxmlformats.org/drawingml/2006/main" noGrp="1"/>
-          </p:cNvSpPr>
-          <p:nvPr/>
-        </p:nvSpPr>
-        <p:spPr>
-          <a:xfrm xmlns:a="http://schemas.openxmlformats.org/drawingml/2006/main">
-            <a:off x="4524375" y="4210050"/>
-            <a:ext cx="1314450" cy="266700"/>
+          <p:cNvPr id="210" name="matrix-pill-AIKO orbital_OLIVER">
+            <a:extLst xmlns:a="http://schemas.openxmlformats.org/drawingml/2006/main">
+              <a:ext uri="{FF2B5EF4-FFF2-40B4-BE49-F238E27FC236}">
+                <a16:creationId xmlns:a16="http://schemas.microsoft.com/office/drawing/2014/main" id="{89A8AB5E-4A8F-4FEB-8D27-3D708BCD4C27}"/>
+              </a:ext>
+            </a:extLst>
+          </p:cNvPr>
+          <p:cNvSpPr>
+            <a:spLocks xmlns:a="http://schemas.openxmlformats.org/drawingml/2006/main" noGrp="1"/>
+          </p:cNvSpPr>
+          <p:nvPr/>
+        </p:nvSpPr>
+        <p:spPr>
+          <a:xfrm xmlns:a="http://schemas.openxmlformats.org/drawingml/2006/main">
+            <a:off x="4667250" y="4210050"/>
+            <a:ext cx="1619250" cy="400050"/>
           </a:xfrm>
           <a:prstGeom xmlns:a="http://schemas.openxmlformats.org/drawingml/2006/main" prst="roundRect">
             <a:avLst>
-              <a:gd name="adj" fmla="val 28571"/>
+              <a:gd name="adj" fmla="val 19048"/>
             </a:avLst>
           </a:prstGeom>
           <a:solidFill xmlns:a="http://schemas.openxmlformats.org/drawingml/2006/main">
@@ -19712,20 +22241,20 @@
       </p:sp>
       <p:pic>
         <p:nvPicPr>
-          <p:cNvPr id="216" name=""/>
+          <p:cNvPr id="302" name=""/>
           <p:cNvPicPr>
             <a:picLocks xmlns:a="http://schemas.openxmlformats.org/drawingml/2006/main" noChangeAspect="1"/>
           </p:cNvPicPr>
           <p:nvPr/>
         </p:nvPicPr>
         <p:blipFill>
-          <a:blip xmlns:r="http://schemas.openxmlformats.org/officeDocument/2006/relationships" xmlns:a="http://schemas.openxmlformats.org/drawingml/2006/main" r:embed="R3a07ae1dc22c4d8e"/>
+          <a:blip xmlns:r="http://schemas.openxmlformats.org/officeDocument/2006/relationships" xmlns:a="http://schemas.openxmlformats.org/drawingml/2006/main" r:embed="R63a6a890d1114d60"/>
           <a:stretch xmlns:a="http://schemas.openxmlformats.org/drawingml/2006/main"/>
         </p:blipFill>
         <p:spPr>
           <a:xfrm xmlns:a="http://schemas.openxmlformats.org/drawingml/2006/main">
-            <a:off x="4678781" y="4238625"/>
-            <a:ext cx="1005639" cy="209550"/>
+            <a:off x="4791075" y="4267200"/>
+            <a:ext cx="1371600" cy="285750"/>
           </a:xfrm>
           <a:prstGeom xmlns:a="http://schemas.openxmlformats.org/drawingml/2006/main" prst="rect">
             <a:avLst/>
@@ -19734,26 +22263,26 @@
       </p:pic>
       <p:sp>
         <p:nvSpPr>
-          <p:cNvPr id="164" name="matrix-pill-Arize AI observability">
-            <a:extLst xmlns:a="http://schemas.openxmlformats.org/drawingml/2006/main">
-              <a:ext uri="{FF2B5EF4-FFF2-40B4-BE49-F238E27FC236}">
-                <a16:creationId xmlns:a16="http://schemas.microsoft.com/office/drawing/2014/main" id="{42B908AD-54FA-4633-A168-EDE682E83FA7}"/>
-              </a:ext>
-            </a:extLst>
-          </p:cNvPr>
-          <p:cNvSpPr>
-            <a:spLocks xmlns:a="http://schemas.openxmlformats.org/drawingml/2006/main" noGrp="1"/>
-          </p:cNvSpPr>
-          <p:nvPr/>
-        </p:nvSpPr>
-        <p:spPr>
-          <a:xfrm xmlns:a="http://schemas.openxmlformats.org/drawingml/2006/main">
-            <a:off x="7334250" y="2857500"/>
-            <a:ext cx="1314450" cy="266700"/>
+          <p:cNvPr id="212" name="matrix-pill-Arize AI observability">
+            <a:extLst xmlns:a="http://schemas.openxmlformats.org/drawingml/2006/main">
+              <a:ext uri="{FF2B5EF4-FFF2-40B4-BE49-F238E27FC236}">
+                <a16:creationId xmlns:a16="http://schemas.microsoft.com/office/drawing/2014/main" id="{02D4F407-8847-4FC0-B8FD-1008E999A4E9}"/>
+              </a:ext>
+            </a:extLst>
+          </p:cNvPr>
+          <p:cNvSpPr>
+            <a:spLocks xmlns:a="http://schemas.openxmlformats.org/drawingml/2006/main" noGrp="1"/>
+          </p:cNvSpPr>
+          <p:nvPr/>
+        </p:nvSpPr>
+        <p:spPr>
+          <a:xfrm xmlns:a="http://schemas.openxmlformats.org/drawingml/2006/main">
+            <a:off x="7429500" y="2781300"/>
+            <a:ext cx="1619250" cy="400050"/>
           </a:xfrm>
           <a:prstGeom xmlns:a="http://schemas.openxmlformats.org/drawingml/2006/main" prst="roundRect">
             <a:avLst>
-              <a:gd name="adj" fmla="val 28571"/>
+              <a:gd name="adj" fmla="val 19048"/>
             </a:avLst>
           </a:prstGeom>
           <a:solidFill xmlns:a="http://schemas.openxmlformats.org/drawingml/2006/main">
@@ -19769,26 +22298,20 @@
       </p:sp>
       <p:pic>
         <p:nvPicPr>
-          <p:cNvPr id="218" name=""/>
+          <p:cNvPr id="304" name=""/>
           <p:cNvPicPr>
             <a:picLocks xmlns:a="http://schemas.openxmlformats.org/drawingml/2006/main" noChangeAspect="1"/>
           </p:cNvPicPr>
           <p:nvPr/>
         </p:nvPicPr>
         <p:blipFill>
-          <a:blip xmlns:r="http://schemas.openxmlformats.org/officeDocument/2006/relationships" xmlns:a="http://schemas.openxmlformats.org/drawingml/2006/main" r:embed="R3898d83d24f04e06">
-            <a:extLst>
-              <a:ext uri="{96DAC541-7B7A-43D3-8B79-37D633B846F1}">
-                <asvg:svgBlip xmlns:asvg="http://schemas.microsoft.com/office/drawing/2016/SVG/main" r:embed="Rb00b9e2072344f8f"/>
-              </a:ext>
-            </a:extLst>
-          </a:blip>
+          <a:blip xmlns:r="http://schemas.openxmlformats.org/officeDocument/2006/relationships" xmlns:a="http://schemas.openxmlformats.org/drawingml/2006/main" r:embed="R49dd7f6b2a5e4d59"/>
           <a:stretch xmlns:a="http://schemas.openxmlformats.org/drawingml/2006/main"/>
         </p:blipFill>
         <p:spPr>
           <a:xfrm xmlns:a="http://schemas.openxmlformats.org/drawingml/2006/main">
-            <a:off x="7410450" y="2886075"/>
-            <a:ext cx="1162050" cy="209550"/>
+            <a:off x="7705567" y="2838450"/>
+            <a:ext cx="1067116" cy="285750"/>
           </a:xfrm>
           <a:prstGeom xmlns:a="http://schemas.openxmlformats.org/drawingml/2006/main" prst="rect">
             <a:avLst/>
@@ -19797,26 +22320,26 @@
       </p:pic>
       <p:sp>
         <p:nvSpPr>
-          <p:cNvPr id="166" name="matrix-pill-Fiddler AI observability">
-            <a:extLst xmlns:a="http://schemas.openxmlformats.org/drawingml/2006/main">
-              <a:ext uri="{FF2B5EF4-FFF2-40B4-BE49-F238E27FC236}">
-                <a16:creationId xmlns:a16="http://schemas.microsoft.com/office/drawing/2014/main" id="{AD8BC388-2321-4588-BBE7-4407F5F13A19}"/>
-              </a:ext>
-            </a:extLst>
-          </p:cNvPr>
-          <p:cNvSpPr>
-            <a:spLocks xmlns:a="http://schemas.openxmlformats.org/drawingml/2006/main" noGrp="1"/>
-          </p:cNvSpPr>
-          <p:nvPr/>
-        </p:nvSpPr>
-        <p:spPr>
-          <a:xfrm xmlns:a="http://schemas.openxmlformats.org/drawingml/2006/main">
-            <a:off x="8620125" y="4210050"/>
-            <a:ext cx="1314450" cy="266700"/>
+          <p:cNvPr id="214" name="matrix-pill-Fiddler AI observability">
+            <a:extLst xmlns:a="http://schemas.openxmlformats.org/drawingml/2006/main">
+              <a:ext uri="{FF2B5EF4-FFF2-40B4-BE49-F238E27FC236}">
+                <a16:creationId xmlns:a16="http://schemas.microsoft.com/office/drawing/2014/main" id="{CE441D4B-5FEC-45DB-895D-BC52223EF148}"/>
+              </a:ext>
+            </a:extLst>
+          </p:cNvPr>
+          <p:cNvSpPr>
+            <a:spLocks xmlns:a="http://schemas.openxmlformats.org/drawingml/2006/main" noGrp="1"/>
+          </p:cNvSpPr>
+          <p:nvPr/>
+        </p:nvSpPr>
+        <p:spPr>
+          <a:xfrm xmlns:a="http://schemas.openxmlformats.org/drawingml/2006/main">
+            <a:off x="8572500" y="4210050"/>
+            <a:ext cx="1619250" cy="400050"/>
           </a:xfrm>
           <a:prstGeom xmlns:a="http://schemas.openxmlformats.org/drawingml/2006/main" prst="roundRect">
             <a:avLst>
-              <a:gd name="adj" fmla="val 28571"/>
+              <a:gd name="adj" fmla="val 19048"/>
             </a:avLst>
           </a:prstGeom>
           <a:solidFill xmlns:a="http://schemas.openxmlformats.org/drawingml/2006/main">
@@ -19832,26 +22355,20 @@
       </p:sp>
       <p:pic>
         <p:nvPicPr>
-          <p:cNvPr id="220" name=""/>
+          <p:cNvPr id="306" name=""/>
           <p:cNvPicPr>
             <a:picLocks xmlns:a="http://schemas.openxmlformats.org/drawingml/2006/main" noChangeAspect="1"/>
           </p:cNvPicPr>
           <p:nvPr/>
         </p:nvPicPr>
         <p:blipFill>
-          <a:blip xmlns:r="http://schemas.openxmlformats.org/officeDocument/2006/relationships" xmlns:a="http://schemas.openxmlformats.org/drawingml/2006/main" r:embed="R41f7f497f1de41e5">
-            <a:extLst>
-              <a:ext uri="{96DAC541-7B7A-43D3-8B79-37D633B846F1}">
-                <asvg:svgBlip xmlns:asvg="http://schemas.microsoft.com/office/drawing/2016/SVG/main" r:embed="R3d95acc39681453f"/>
-              </a:ext>
-            </a:extLst>
-          </a:blip>
+          <a:blip xmlns:r="http://schemas.openxmlformats.org/officeDocument/2006/relationships" xmlns:a="http://schemas.openxmlformats.org/drawingml/2006/main" r:embed="R25d4095b80fd483d"/>
           <a:stretch xmlns:a="http://schemas.openxmlformats.org/drawingml/2006/main"/>
         </p:blipFill>
         <p:spPr>
           <a:xfrm xmlns:a="http://schemas.openxmlformats.org/drawingml/2006/main">
-            <a:off x="8696325" y="4238625"/>
-            <a:ext cx="1162050" cy="209550"/>
+            <a:off x="8743974" y="4267200"/>
+            <a:ext cx="1276303" cy="285750"/>
           </a:xfrm>
           <a:prstGeom xmlns:a="http://schemas.openxmlformats.org/drawingml/2006/main" prst="rect">
             <a:avLst/>
@@ -19860,26 +22377,26 @@
       </p:pic>
       <p:sp>
         <p:nvSpPr>
-          <p:cNvPr id="168" name="matrix-gauss-pill">
-            <a:extLst xmlns:a="http://schemas.openxmlformats.org/drawingml/2006/main">
-              <a:ext uri="{FF2B5EF4-FFF2-40B4-BE49-F238E27FC236}">
-                <a16:creationId xmlns:a16="http://schemas.microsoft.com/office/drawing/2014/main" id="{61AFE92C-4B92-4FA4-BE93-3388CA534657}"/>
-              </a:ext>
-            </a:extLst>
-          </p:cNvPr>
-          <p:cNvSpPr>
-            <a:spLocks xmlns:a="http://schemas.openxmlformats.org/drawingml/2006/main" noGrp="1"/>
-          </p:cNvSpPr>
-          <p:nvPr/>
-        </p:nvSpPr>
-        <p:spPr>
-          <a:xfrm xmlns:a="http://schemas.openxmlformats.org/drawingml/2006/main">
-            <a:off x="8620125" y="3124200"/>
-            <a:ext cx="1428750" cy="361950"/>
+          <p:cNvPr id="216" name="matrix-gauss-pill">
+            <a:extLst xmlns:a="http://schemas.openxmlformats.org/drawingml/2006/main">
+              <a:ext uri="{FF2B5EF4-FFF2-40B4-BE49-F238E27FC236}">
+                <a16:creationId xmlns:a16="http://schemas.microsoft.com/office/drawing/2014/main" id="{E7873DC8-8B48-4072-947A-60A7BEFC4140}"/>
+              </a:ext>
+            </a:extLst>
+          </p:cNvPr>
+          <p:cNvSpPr>
+            <a:spLocks xmlns:a="http://schemas.openxmlformats.org/drawingml/2006/main" noGrp="1"/>
+          </p:cNvSpPr>
+          <p:nvPr/>
+        </p:nvSpPr>
+        <p:spPr>
+          <a:xfrm xmlns:a="http://schemas.openxmlformats.org/drawingml/2006/main">
+            <a:off x="8572500" y="3257550"/>
+            <a:ext cx="1619250" cy="400050"/>
           </a:xfrm>
           <a:prstGeom xmlns:a="http://schemas.openxmlformats.org/drawingml/2006/main" prst="roundRect">
             <a:avLst>
-              <a:gd name="adj" fmla="val 21053"/>
+              <a:gd name="adj" fmla="val 19048"/>
             </a:avLst>
           </a:prstGeom>
           <a:solidFill xmlns:a="http://schemas.openxmlformats.org/drawingml/2006/main">
@@ -19895,22 +22412,22 @@
       </p:sp>
       <p:sp>
         <p:nvSpPr>
-          <p:cNvPr id="169" name="matrix-gauss-label">
-            <a:extLst xmlns:a="http://schemas.openxmlformats.org/drawingml/2006/main">
-              <a:ext uri="{FF2B5EF4-FFF2-40B4-BE49-F238E27FC236}">
-                <a16:creationId xmlns:a16="http://schemas.microsoft.com/office/drawing/2014/main" id="{ABB03417-D04A-40F2-B9BE-BF34426C1D8B}"/>
-              </a:ext>
-            </a:extLst>
-          </p:cNvPr>
-          <p:cNvSpPr>
-            <a:spLocks xmlns:a="http://schemas.openxmlformats.org/drawingml/2006/main" noGrp="1"/>
-          </p:cNvSpPr>
-          <p:nvPr/>
-        </p:nvSpPr>
-        <p:spPr>
-          <a:xfrm xmlns:a="http://schemas.openxmlformats.org/drawingml/2006/main">
-            <a:off x="8810625" y="3200400"/>
-            <a:ext cx="1047750" cy="190500"/>
+          <p:cNvPr id="217" name="matrix-gauss-label">
+            <a:extLst xmlns:a="http://schemas.openxmlformats.org/drawingml/2006/main">
+              <a:ext uri="{FF2B5EF4-FFF2-40B4-BE49-F238E27FC236}">
+                <a16:creationId xmlns:a16="http://schemas.microsoft.com/office/drawing/2014/main" id="{002E9A79-4AB2-4219-9EF3-38EBFCED1C45}"/>
+              </a:ext>
+            </a:extLst>
+          </p:cNvPr>
+          <p:cNvSpPr>
+            <a:spLocks xmlns:a="http://schemas.openxmlformats.org/drawingml/2006/main" noGrp="1"/>
+          </p:cNvSpPr>
+          <p:nvPr/>
+        </p:nvSpPr>
+        <p:spPr>
+          <a:xfrm xmlns:a="http://schemas.openxmlformats.org/drawingml/2006/main">
+            <a:off x="8810625" y="3343275"/>
+            <a:ext cx="1143000" cy="190500"/>
           </a:xfrm>
           <a:prstGeom xmlns:a="http://schemas.openxmlformats.org/drawingml/2006/main" prst="rect">
             <a:avLst/>
@@ -19926,6 +22443,7 @@
           <a:lstStyle xmlns:a="http://schemas.openxmlformats.org/drawingml/2006/main"/>
           <a:p xmlns:a="http://schemas.openxmlformats.org/drawingml/2006/main">
             <a:pPr>
+              <a:buNone/>
               <a:defRPr sz="1350" b="1">
                 <a:solidFill>
                   <a:srgbClr val="CCFF00"/>
@@ -19981,7 +22499,7 @@
           <p:nvPr/>
         </p:nvPicPr>
         <p:blipFill>
-          <a:blip xmlns:r="http://schemas.openxmlformats.org/officeDocument/2006/relationships" xmlns:a="http://schemas.openxmlformats.org/drawingml/2006/main" r:embed="R48b290182cf94c3f">
+          <a:blip xmlns:r="http://schemas.openxmlformats.org/officeDocument/2006/relationships" xmlns:a="http://schemas.openxmlformats.org/drawingml/2006/main" r:embed="Rdead1da6bf614064">
             <a:alphaModFix amt="96000"/>
           </a:blip>
           <a:stretch xmlns:a="http://schemas.openxmlformats.org/drawingml/2006/main">

</xml_diff>

<commit_message>
Align deck to Malaysia criteria
</commit_message>
<xml_diff>
--- a/reports/presentation/Gauss_Aurora_Investor_Deck_pptxgenjs.pptx
+++ b/reports/presentation/Gauss_Aurora_Investor_Deck_pptxgenjs.pptx
@@ -2,23 +2,23 @@
 <file path=ppt/presentation.xml><?xml version="1.0" encoding="utf-8"?>
 <p:presentation xmlns:p="http://schemas.openxmlformats.org/presentationml/2006/main">
   <p:sldMasterIdLst>
-    <p:sldMasterId xmlns:r="http://schemas.openxmlformats.org/officeDocument/2006/relationships" id="2147483648" r:id="R1d14971925304943"/>
+    <p:sldMasterId xmlns:r="http://schemas.openxmlformats.org/officeDocument/2006/relationships" id="2147483648" r:id="Rb6b89e5f35f042a8"/>
   </p:sldMasterIdLst>
   <p:notesMasterIdLst>
-    <p:notesMasterId xmlns:r="http://schemas.openxmlformats.org/officeDocument/2006/relationships" r:id="Re90b6ae77aa74e6c"/>
+    <p:notesMasterId xmlns:r="http://schemas.openxmlformats.org/officeDocument/2006/relationships" r:id="R631121548f634e58"/>
   </p:notesMasterIdLst>
   <p:sldIdLst>
-    <p:sldId xmlns:r="http://schemas.openxmlformats.org/officeDocument/2006/relationships" id="256" r:id="Rf4a651d384de45c0"/>
-    <p:sldId xmlns:r="http://schemas.openxmlformats.org/officeDocument/2006/relationships" id="257" r:id="R6a266c18ccb6433f"/>
-    <p:sldId xmlns:r="http://schemas.openxmlformats.org/officeDocument/2006/relationships" id="258" r:id="Rcceb9fa622b440df"/>
-    <p:sldId xmlns:r="http://schemas.openxmlformats.org/officeDocument/2006/relationships" id="259" r:id="R29015f9600c74673"/>
-    <p:sldId xmlns:r="http://schemas.openxmlformats.org/officeDocument/2006/relationships" id="260" r:id="R8f60aeb5c5c54d1f"/>
-    <p:sldId xmlns:r="http://schemas.openxmlformats.org/officeDocument/2006/relationships" id="261" r:id="Rd3b0d68de7704dec"/>
-    <p:sldId xmlns:r="http://schemas.openxmlformats.org/officeDocument/2006/relationships" id="262" r:id="R4cc4e2b8aa454f86"/>
-    <p:sldId xmlns:r="http://schemas.openxmlformats.org/officeDocument/2006/relationships" id="263" r:id="R07c80e33ffd14e87"/>
-    <p:sldId xmlns:r="http://schemas.openxmlformats.org/officeDocument/2006/relationships" id="264" r:id="R5727c358055f4286"/>
-    <p:sldId xmlns:r="http://schemas.openxmlformats.org/officeDocument/2006/relationships" id="265" r:id="R03147c1171ed4062"/>
-    <p:sldId xmlns:r="http://schemas.openxmlformats.org/officeDocument/2006/relationships" id="266" r:id="R51afe130ea1641c0"/>
+    <p:sldId xmlns:r="http://schemas.openxmlformats.org/officeDocument/2006/relationships" id="256" r:id="Rc2a836aa18f243c8"/>
+    <p:sldId xmlns:r="http://schemas.openxmlformats.org/officeDocument/2006/relationships" id="257" r:id="R48df2ee38d5b4d9a"/>
+    <p:sldId xmlns:r="http://schemas.openxmlformats.org/officeDocument/2006/relationships" id="258" r:id="Rf0cce12c19ac4ca1"/>
+    <p:sldId xmlns:r="http://schemas.openxmlformats.org/officeDocument/2006/relationships" id="259" r:id="Rb89ee2f7a1bf4579"/>
+    <p:sldId xmlns:r="http://schemas.openxmlformats.org/officeDocument/2006/relationships" id="260" r:id="R2f168ac0b1c749c5"/>
+    <p:sldId xmlns:r="http://schemas.openxmlformats.org/officeDocument/2006/relationships" id="261" r:id="Rfb06b9cb31f1434f"/>
+    <p:sldId xmlns:r="http://schemas.openxmlformats.org/officeDocument/2006/relationships" id="262" r:id="Rdd2cc8ed9c0543f1"/>
+    <p:sldId xmlns:r="http://schemas.openxmlformats.org/officeDocument/2006/relationships" id="263" r:id="R5640c51fa33a435d"/>
+    <p:sldId xmlns:r="http://schemas.openxmlformats.org/officeDocument/2006/relationships" id="264" r:id="Rb47ccb90006a4158"/>
+    <p:sldId xmlns:r="http://schemas.openxmlformats.org/officeDocument/2006/relationships" id="265" r:id="R0c27a33260954444"/>
+    <p:sldId xmlns:r="http://schemas.openxmlformats.org/officeDocument/2006/relationships" id="266" r:id="R0b5bee59ff184ad1"/>
   </p:sldIdLst>
   <p:sldSz cx="12192000" cy="6858000"/>
   <p:notesSz cx="6858000" cy="9144000"/>
@@ -599,11 +599,31 @@
           <a:lstStyle xmlns:a="http://schemas.openxmlformats.org/drawingml/2006/main"/>
           <a:p xmlns:a="http://schemas.openxmlformats.org/drawingml/2006/main">
             <a:r>
-              <a:t>Close on the proof point: five paid fleet accounts and a repeatable evidence contract. Funding allocation is an internal planning scenario.
-[Sources]
-- Repo: development/memory/DECISIONS.md, D-110 (2026-08-19)
-- Repo: config/product-packages.json and config/product-packages.schema.json
-- User-provided: Gauss_Aurora_Pitch_Deck_v1.pptx</a:t>
+              <a:t>The ask is $1.5M. Purpose: fund a 6–12 month ground-first programme covering product and integrations, security/compliance, go-to-market/design partners, and runway. The commercial return is a planning case of five paid ground/integration accounts producing $500k ARR; no signed pipeline is claimed.</a:t>
+            </a:r>
+            <a:endParaRPr/>
+          </a:p>
+          <a:p xmlns:a="http://schemas.openxmlformats.org/drawingml/2006/main">
+            <a:r>
+              <a:t/>
+            </a:r>
+            <a:endParaRPr/>
+          </a:p>
+          <a:p xmlns:a="http://schemas.openxmlformats.org/drawingml/2006/main">
+            <a:r>
+              <a:t>[Sources]</a:t>
+            </a:r>
+            <a:endParaRPr/>
+          </a:p>
+          <a:p xmlns:a="http://schemas.openxmlformats.org/drawingml/2006/main">
+            <a:r>
+              <a:t>- Internal Gauss business memo: docs/BUSINESS_MEMO_GAUSS_GROUND_FIRST_2026-08-21.md</a:t>
+            </a:r>
+            <a:endParaRPr/>
+          </a:p>
+          <a:p xmlns:a="http://schemas.openxmlformats.org/drawingml/2006/main">
+            <a:r>
+              <a:t>- Internal Gauss decision log: development/memory/DECISIONS.md (D-110, D-124, D-127)</a:t>
             </a:r>
             <a:endParaRPr/>
           </a:p>
@@ -674,7 +694,7 @@
           <a:lstStyle xmlns:a="http://schemas.openxmlformats.org/drawingml/2006/main"/>
           <a:p xmlns:a="http://schemas.openxmlformats.org/drawingml/2006/main">
             <a:r>
-              <a:t>This is an internal readiness scorecard for the current investor deck, not an eligibility determination. The next diligence unlocks are founder credibility, customer proof, explicit readiness evidence, and IP defensibility.</a:t>
+              <a:t>Project duration is framed as a 6–12 month ground-first programme. The first 90 days follow the repository operating plan: evidence and conversion, paid pilot readiness, then commercial proof. Flight-candidate and federated bridge work are expansion gates, not current claims, and require a named mission, target processor, partner and hardware evidence.</a:t>
             </a:r>
             <a:endParaRPr/>
           </a:p>
@@ -692,31 +712,19 @@
           </a:p>
           <a:p xmlns:a="http://schemas.openxmlformats.org/drawingml/2006/main">
             <a:r>
-              <a:t>- User-provided Gauss_Aurora_Pitch_Deck_v1.pptx</a:t>
+              <a:t>- Internal Gauss business memo: docs/BUSINESS_MEMO_GAUSS_GROUND_FIRST_2026-08-21.md</a:t>
             </a:r>
             <a:endParaRPr/>
           </a:p>
           <a:p xmlns:a="http://schemas.openxmlformats.org/drawingml/2006/main">
             <a:r>
-              <a:t>- Internal Gauss repository planning model and product notes</a:t>
+              <a:t>- Internal Gauss decision log: development/memory/DECISIONS.md (D-110, D-124, D-127)</a:t>
             </a:r>
             <a:endParaRPr/>
           </a:p>
           <a:p xmlns:a="http://schemas.openxmlformats.org/drawingml/2006/main">
             <a:r>
-              <a:t>- https://www.starcloud.com/</a:t>
-            </a:r>
-            <a:endParaRPr/>
-          </a:p>
-          <a:p xmlns:a="http://schemas.openxmlformats.org/drawingml/2006/main">
-            <a:r>
-              <a:t>- https://investors.rocketlabcorp.com/</a:t>
-            </a:r>
-            <a:endParaRPr/>
-          </a:p>
-          <a:p xmlns:a="http://schemas.openxmlformats.org/drawingml/2006/main">
-            <a:r>
-              <a:t>- https://www.relativityspace.com/about</a:t>
+              <a:t>- Internal target catalog: config/mission-targets.json</a:t>
             </a:r>
             <a:endParaRPr/>
           </a:p>
@@ -1264,7 +1272,7 @@
           <a:lstStyle xmlns:a="http://schemas.openxmlformats.org/drawingml/2006/main"/>
           <a:p xmlns:a="http://schemas.openxmlformats.org/drawingml/2006/main">
             <a:r>
-              <a:t>Pricing remains a starting hypothesis for customer validation. The $500k ARR path is five $100k annual fleet accounts; pilots, implementation, and NRE are not ARR.</a:t>
+              <a:t>Commercial return is an internal planning scenario, not signed pipeline: five paid ground/integration accounts can establish $500k ARR. The first off-takers are mission-data, ground-segment and systems-integration teams with continuity, telemetry-quality or anomaly-review problems. Planning prices remain subject to customer discovery.</a:t>
             </a:r>
             <a:endParaRPr/>
           </a:p>
@@ -1282,7 +1290,19 @@
           </a:p>
           <a:p xmlns:a="http://schemas.openxmlformats.org/drawingml/2006/main">
             <a:r>
-              <a:t>- Internal Gauss model: development/memory/DECISIONS.md (D-110, D-124, D-126)</a:t>
+              <a:t>- Internal Gauss business memo: docs/BUSINESS_MEMO_GAUSS_GROUND_FIRST_2026-08-21.md</a:t>
+            </a:r>
+            <a:endParaRPr/>
+          </a:p>
+          <a:p xmlns:a="http://schemas.openxmlformats.org/drawingml/2006/main">
+            <a:r>
+              <a:t>- Internal Gauss decision log: development/memory/DECISIONS.md (D-110, D-124, D-126, D-127)</a:t>
+            </a:r>
+            <a:endParaRPr/>
+          </a:p>
+          <a:p xmlns:a="http://schemas.openxmlformats.org/drawingml/2006/main">
+            <a:r>
+              <a:t>- Internal target catalog: config/mission-targets.json</a:t>
             </a:r>
             <a:endParaRPr/>
           </a:p>
@@ -1699,8 +1719,8 @@
   </p:cSld>
   <p:clrMap bg1="lt1" tx1="dk1" bg2="lt2" tx2="dk2" accent1="accent1" accent2="accent2" accent3="accent3" accent4="accent4" accent5="accent5" accent6="accent6" hlink="hlink" folHlink="folHlink"/>
   <p:sldLayoutIdLst>
-    <p:sldLayoutId xmlns:r="http://schemas.openxmlformats.org/officeDocument/2006/relationships" id="2147483649" r:id="R57b7332e1ff54166"/>
-    <p:sldLayoutId xmlns:r="http://schemas.openxmlformats.org/officeDocument/2006/relationships" id="2147483650" r:id="R282420eb1c9a47e4"/>
+    <p:sldLayoutId xmlns:r="http://schemas.openxmlformats.org/officeDocument/2006/relationships" id="2147483649" r:id="R3be761711cd14fb2"/>
+    <p:sldLayoutId xmlns:r="http://schemas.openxmlformats.org/officeDocument/2006/relationships" id="2147483650" r:id="R8ea7d5d1cd5f4836"/>
   </p:sldLayoutIdLst>
   <p:hf sldNum="0" hdr="0" ftr="0" dt="0"/>
   <p:txStyles>
@@ -2729,7 +2749,7 @@
           <p:nvPr/>
         </p:nvPicPr>
         <p:blipFill>
-          <a:blip xmlns:r="http://schemas.openxmlformats.org/officeDocument/2006/relationships" xmlns:a="http://schemas.openxmlformats.org/drawingml/2006/main" r:embed="Ra47d0a27a0b0415a"/>
+          <a:blip xmlns:r="http://schemas.openxmlformats.org/officeDocument/2006/relationships" xmlns:a="http://schemas.openxmlformats.org/drawingml/2006/main" r:embed="Re7b070048a3445d8"/>
           <a:srcRect xmlns:a="http://schemas.openxmlformats.org/drawingml/2006/main" l="0" t="4999" r="0" b="4999"/>
           <a:stretch xmlns:a="http://schemas.openxmlformats.org/drawingml/2006/main">
             <a:fillRect l="0" t="0" r="0" b="0"/>
@@ -3448,7 +3468,7 @@
           <p:nvPr/>
         </p:nvPicPr>
         <p:blipFill>
-          <a:blip xmlns:r="http://schemas.openxmlformats.org/officeDocument/2006/relationships" xmlns:a="http://schemas.openxmlformats.org/drawingml/2006/main" r:embed="Rf7382b6716e14bd2"/>
+          <a:blip xmlns:r="http://schemas.openxmlformats.org/officeDocument/2006/relationships" xmlns:a="http://schemas.openxmlformats.org/drawingml/2006/main" r:embed="Re4d18b7f556b41af"/>
           <a:stretch xmlns:a="http://schemas.openxmlformats.org/drawingml/2006/main">
             <a:fillRect l="0" t="0" r="0" b="0"/>
           </a:stretch>
@@ -3604,7 +3624,7 @@
         </p:spPr>
         <p:txBody>
           <a:bodyPr xmlns:a="http://schemas.openxmlformats.org/drawingml/2006/main" wrap="square" lIns="0" tIns="0" rIns="0" bIns="0" anchor="ctr">
-            <a:normAutofit fontScale="67826"/>
+            <a:normAutofit fontScale="91202"/>
           </a:bodyPr>
           <a:lstStyle xmlns:a="http://schemas.openxmlformats.org/drawingml/2006/main"/>
           <a:p xmlns:a="http://schemas.openxmlformats.org/drawingml/2006/main">
@@ -3613,14 +3633,14 @@
                 <a:spcPct val="100000"/>
               </a:lnSpc>
               <a:buNone/>
-              <a:defRPr>
-                <a:solidFill>
-                  <a:srgbClr val="F3F0E8"/>
-                </a:solidFill>
-              </a:defRPr>
-            </a:pPr>
-            <a:r>
-              <a:rPr sz="2300" b="1">
+              <a:defRPr sz="1800" b="1">
+                <a:solidFill>
+                  <a:srgbClr val="F3F0E8"/>
+                </a:solidFill>
+              </a:defRPr>
+            </a:pPr>
+            <a:r>
+              <a:rPr sz="1800" b="1">
                 <a:solidFill>
                   <a:srgbClr val="F3F0E8"/>
                 </a:solidFill>
@@ -3628,7 +3648,7 @@
                 <a:ea typeface="Inter"/>
                 <a:cs typeface="Inter"/>
               </a:rPr>
-              <a:t>to make mission-data assurance a repeatable commercial category.</a:t>
+              <a:t>to fund a 6–12 month ground-first programme to paid pilots.</a:t>
             </a:r>
             <a:endParaRPr sz="2300"/>
           </a:p>
@@ -3660,7 +3680,7 @@
         </p:spPr>
         <p:txBody>
           <a:bodyPr xmlns:a="http://schemas.openxmlformats.org/drawingml/2006/main" wrap="square" lIns="0" tIns="0" rIns="0" bIns="0" anchor="ctr">
-            <a:normAutofit fontScale="82439"/>
+            <a:normAutofit fontScale="90989"/>
           </a:bodyPr>
           <a:lstStyle xmlns:a="http://schemas.openxmlformats.org/drawingml/2006/main"/>
           <a:p xmlns:a="http://schemas.openxmlformats.org/drawingml/2006/main">
@@ -3684,7 +3704,7 @@
                 <a:ea typeface="JetBrains Mono"/>
                 <a:cs typeface="JetBrains Mono"/>
               </a:rPr>
-              <a:t>USE OF FUNDS  /  $1.5M INTERNAL PLAN</a:t>
+              <a:t>PURPOSE  /  USE OF FUNDS  /  $1.5M</a:t>
             </a:r>
             <a:endParaRPr sz="800"/>
           </a:p>
@@ -4540,7 +4560,7 @@
         </p:spPr>
         <p:txBody>
           <a:bodyPr xmlns:a="http://schemas.openxmlformats.org/drawingml/2006/main" wrap="square" lIns="0" tIns="0" rIns="0" bIns="0" anchor="ctr">
-            <a:normAutofit fontScale="100000"/>
+            <a:normAutofit fontScale="91429"/>
           </a:bodyPr>
           <a:lstStyle xmlns:a="http://schemas.openxmlformats.org/drawingml/2006/main"/>
           <a:p xmlns:a="http://schemas.openxmlformats.org/drawingml/2006/main">
@@ -4549,14 +4569,14 @@
                 <a:spcPct val="100000"/>
               </a:lnSpc>
               <a:buNone/>
-              <a:defRPr>
-                <a:solidFill>
-                  <a:srgbClr val="F3F0E8"/>
-                </a:solidFill>
-              </a:defRPr>
-            </a:pPr>
-            <a:r>
-              <a:rPr sz="800" b="1">
+              <a:defRPr sz="1050" b="1">
+                <a:solidFill>
+                  <a:srgbClr val="F3F0E8"/>
+                </a:solidFill>
+              </a:defRPr>
+            </a:pPr>
+            <a:r>
+              <a:rPr sz="1050" b="1">
                 <a:solidFill>
                   <a:srgbClr val="F3F0E8"/>
                 </a:solidFill>
@@ -4564,7 +4584,7 @@
                 <a:ea typeface="JetBrains Mono"/>
                 <a:cs typeface="JetBrains Mono"/>
               </a:rPr>
-              <a:t>THE PROOF POINT</a:t>
+              <a:t>COMMERCIAL RETURN</a:t>
             </a:r>
             <a:endParaRPr sz="800"/>
           </a:p>
@@ -4596,7 +4616,7 @@
         </p:spPr>
         <p:txBody>
           <a:bodyPr xmlns:a="http://schemas.openxmlformats.org/drawingml/2006/main" wrap="square" lIns="0" tIns="0" rIns="0" bIns="0" anchor="ctr">
-            <a:normAutofit fontScale="69677"/>
+            <a:normAutofit fontScale="100000"/>
           </a:bodyPr>
           <a:lstStyle xmlns:a="http://schemas.openxmlformats.org/drawingml/2006/main"/>
           <a:p xmlns:a="http://schemas.openxmlformats.org/drawingml/2006/main">
@@ -4605,14 +4625,14 @@
                 <a:spcPct val="100000"/>
               </a:lnSpc>
               <a:buNone/>
-              <a:defRPr>
-                <a:solidFill>
-                  <a:srgbClr val="F3F0E8"/>
-                </a:solidFill>
-              </a:defRPr>
-            </a:pPr>
-            <a:r>
-              <a:rPr sz="3100" b="1">
+              <a:defRPr sz="2100" b="1">
+                <a:solidFill>
+                  <a:srgbClr val="F3F0E8"/>
+                </a:solidFill>
+              </a:defRPr>
+            </a:pPr>
+            <a:r>
+              <a:rPr sz="2100" b="1">
                 <a:solidFill>
                   <a:srgbClr val="F3F0E8"/>
                 </a:solidFill>
@@ -4620,7 +4640,7 @@
                 <a:ea typeface="Inter"/>
                 <a:cs typeface="Inter"/>
               </a:rPr>
-              <a:t>5 fleet</a:t>
+              <a:t>5 paid</a:t>
             </a:r>
             <a:endParaRPr sz="3100"/>
           </a:p>
@@ -4630,14 +4650,14 @@
                 <a:spcPct val="100000"/>
               </a:lnSpc>
               <a:buNone/>
-              <a:defRPr>
-                <a:solidFill>
-                  <a:srgbClr val="F3F0E8"/>
-                </a:solidFill>
-              </a:defRPr>
-            </a:pPr>
-            <a:r>
-              <a:rPr sz="3100" b="1">
+              <a:defRPr sz="2100" b="1">
+                <a:solidFill>
+                  <a:srgbClr val="F3F0E8"/>
+                </a:solidFill>
+              </a:defRPr>
+            </a:pPr>
+            <a:r>
+              <a:rPr sz="2100" b="1">
                 <a:solidFill>
                   <a:srgbClr val="F3F0E8"/>
                 </a:solidFill>
@@ -4828,14 +4848,14 @@
                 <a:spcPct val="100000"/>
               </a:lnSpc>
               <a:buNone/>
-              <a:defRPr>
-                <a:solidFill>
-                  <a:srgbClr val="F3F0E8"/>
-                </a:solidFill>
-              </a:defRPr>
-            </a:pPr>
-            <a:r>
-              <a:rPr sz="1000">
+              <a:defRPr sz="1050">
+                <a:solidFill>
+                  <a:srgbClr val="F3F0E8"/>
+                </a:solidFill>
+              </a:defRPr>
+            </a:pPr>
+            <a:r>
+              <a:rPr sz="1050">
                 <a:solidFill>
                   <a:srgbClr val="F3F0E8"/>
                 </a:solidFill>
@@ -4843,7 +4863,7 @@
                 <a:ea typeface="IBM Plex Sans"/>
                 <a:cs typeface="IBM Plex Sans"/>
               </a:rPr>
-              <a:t>Gauss gives space operators a safer path from data abundance to trusted action.</a:t>
+              <a:t>Return case: five paid ground / integration accounts → $500k ARR.</a:t>
             </a:r>
             <a:endParaRPr sz="1000"/>
           </a:p>
@@ -4941,14 +4961,14 @@
       </p:grpSpPr>
       <p:pic>
         <p:nvPicPr>
-          <p:cNvPr id="28" name="Image 0"/>
+          <p:cNvPr id="50" name="Image 0"/>
           <p:cNvPicPr>
             <a:picLocks xmlns:a="http://schemas.openxmlformats.org/drawingml/2006/main" noChangeAspect="1"/>
           </p:cNvPicPr>
           <p:nvPr/>
         </p:nvPicPr>
         <p:blipFill>
-          <a:blip xmlns:r="http://schemas.openxmlformats.org/officeDocument/2006/relationships" xmlns:a="http://schemas.openxmlformats.org/drawingml/2006/main" r:embed="Rc0ed1de5f05d43d1">
+          <a:blip xmlns:r="http://schemas.openxmlformats.org/officeDocument/2006/relationships" xmlns:a="http://schemas.openxmlformats.org/drawingml/2006/main" r:embed="R6389500a4022421e">
             <a:alphaModFix amt="96000"/>
           </a:blip>
           <a:stretch xmlns:a="http://schemas.openxmlformats.org/drawingml/2006/main">
@@ -5115,14 +5135,14 @@
                 <a:spcPct val="100000"/>
               </a:lnSpc>
               <a:buNone/>
-              <a:defRPr>
-                <a:solidFill>
-                  <a:srgbClr val="F3F0E8"/>
-                </a:solidFill>
-              </a:defRPr>
-            </a:pPr>
-            <a:r>
-              <a:rPr sz="800" b="1">
+              <a:defRPr sz="1050" b="1">
+                <a:solidFill>
+                  <a:srgbClr val="F3F0E8"/>
+                </a:solidFill>
+              </a:defRPr>
+            </a:pPr>
+            <a:r>
+              <a:rPr sz="1050" b="1">
                 <a:solidFill>
                   <a:srgbClr val="F3F0E8"/>
                 </a:solidFill>
@@ -5130,7 +5150,7 @@
                 <a:ea typeface="JetBrains Mono"/>
                 <a:cs typeface="JetBrains Mono"/>
               </a:rPr>
-              <a:t>READINESS</a:t>
+              <a:t>PROGRAMME</a:t>
             </a:r>
             <a:endParaRPr sz="800"/>
           </a:p>
@@ -5278,7 +5298,7 @@
                 <a:ea typeface="Inter"/>
                 <a:cs typeface="Inter"/>
               </a:rPr>
-              <a:t>Investor-ready story; diligence-ready evidence is next.</a:t>
+              <a:t>Six to twelve months to commercial proof.</a:t>
             </a:r>
             <a:endParaRPr sz="2800"/>
           </a:p>
@@ -5334,7 +5354,7 @@
                 <a:ea typeface="IBM Plex Sans"/>
                 <a:cs typeface="IBM Plex Sans"/>
               </a:rPr>
-              <a:t>A practical readiness scorecard for a space-software raise.</a:t>
+              <a:t>Ground-first milestones; flight and IOD remain evidence-gated.</a:t>
             </a:r>
             <a:endParaRPr sz="1500"/>
           </a:p>
@@ -5342,7 +5362,7 @@
       </p:sp>
       <p:graphicFrame>
         <p:nvGraphicFramePr>
-          <p:cNvPr id="36" name="Table 0"/>
+          <p:cNvPr id="58" name="Table 0"/>
           <p:cNvGraphicFramePr/>
           <p:nvPr/>
         </p:nvGraphicFramePr>
@@ -6933,6 +6953,920 @@
           </a:p>
         </p:txBody>
       </p:sp>
+      <p:sp>
+        <p:nvSpPr>
+          <p:cNvPr id="28" name="programme-cover">
+            <a:extLst xmlns:a="http://schemas.openxmlformats.org/drawingml/2006/main">
+              <a:ext uri="{FF2B5EF4-FFF2-40B4-BE49-F238E27FC236}">
+                <a16:creationId xmlns:a16="http://schemas.microsoft.com/office/drawing/2014/main" id="{B26E19C1-4BE6-43B7-818D-083F5F5F6ABD}"/>
+              </a:ext>
+            </a:extLst>
+          </p:cNvPr>
+          <p:cNvSpPr>
+            <a:spLocks xmlns:a="http://schemas.openxmlformats.org/drawingml/2006/main" noGrp="1"/>
+          </p:cNvSpPr>
+          <p:nvPr/>
+        </p:nvSpPr>
+        <p:spPr>
+          <a:xfrm xmlns:a="http://schemas.openxmlformats.org/drawingml/2006/main">
+            <a:off x="685800" y="2095500"/>
+            <a:ext cx="10817352" cy="3905250"/>
+          </a:xfrm>
+          <a:prstGeom xmlns:a="http://schemas.openxmlformats.org/drawingml/2006/main" prst="rect">
+            <a:avLst/>
+          </a:prstGeom>
+          <a:solidFill xmlns:a="http://schemas.openxmlformats.org/drawingml/2006/main">
+            <a:srgbClr val="050505"/>
+          </a:solidFill>
+          <a:ln xmlns:a="http://schemas.openxmlformats.org/drawingml/2006/main" w="0">
+            <a:solidFill>
+              <a:srgbClr val="050505"/>
+            </a:solidFill>
+            <a:prstDash val="solid"/>
+          </a:ln>
+        </p:spPr>
+      </p:sp>
+      <p:sp>
+        <p:nvSpPr>
+          <p:cNvPr id="29" name="programme-duration-label">
+            <a:extLst xmlns:a="http://schemas.openxmlformats.org/drawingml/2006/main">
+              <a:ext uri="{FF2B5EF4-FFF2-40B4-BE49-F238E27FC236}">
+                <a16:creationId xmlns:a16="http://schemas.microsoft.com/office/drawing/2014/main" id="{0AA88DCA-97FA-4179-AD7A-1B9F2A96A054}"/>
+              </a:ext>
+            </a:extLst>
+          </p:cNvPr>
+          <p:cNvSpPr>
+            <a:spLocks xmlns:a="http://schemas.openxmlformats.org/drawingml/2006/main" noGrp="1"/>
+          </p:cNvSpPr>
+          <p:nvPr/>
+        </p:nvSpPr>
+        <p:spPr>
+          <a:xfrm xmlns:a="http://schemas.openxmlformats.org/drawingml/2006/main">
+            <a:off x="876300" y="2305050"/>
+            <a:ext cx="2095500" cy="171450"/>
+          </a:xfrm>
+          <a:prstGeom xmlns:a="http://schemas.openxmlformats.org/drawingml/2006/main" prst="rect">
+            <a:avLst/>
+          </a:prstGeom>
+          <a:noFill xmlns:a="http://schemas.openxmlformats.org/drawingml/2006/main"/>
+          <a:ln xmlns:a="http://schemas.openxmlformats.org/drawingml/2006/main" w="0">
+            <a:noFill/>
+            <a:prstDash val="solid"/>
+          </a:ln>
+        </p:spPr>
+        <p:txBody>
+          <a:bodyPr xmlns:a="http://schemas.openxmlformats.org/drawingml/2006/main"/>
+          <a:lstStyle xmlns:a="http://schemas.openxmlformats.org/drawingml/2006/main"/>
+          <a:p xmlns:a="http://schemas.openxmlformats.org/drawingml/2006/main">
+            <a:pPr>
+              <a:buNone/>
+              <a:defRPr sz="1050" b="1">
+                <a:solidFill>
+                  <a:srgbClr val="F3F0E8"/>
+                </a:solidFill>
+              </a:defRPr>
+            </a:pPr>
+            <a:r>
+              <a:rPr sz="1050" b="1">
+                <a:solidFill>
+                  <a:srgbClr val="F3F0E8"/>
+                </a:solidFill>
+              </a:rPr>
+              <a:t>PROJECT DURATION</a:t>
+            </a:r>
+          </a:p>
+        </p:txBody>
+      </p:sp>
+      <p:sp>
+        <p:nvSpPr>
+          <p:cNvPr id="30" name="programme-duration-value">
+            <a:extLst xmlns:a="http://schemas.openxmlformats.org/drawingml/2006/main">
+              <a:ext uri="{FF2B5EF4-FFF2-40B4-BE49-F238E27FC236}">
+                <a16:creationId xmlns:a16="http://schemas.microsoft.com/office/drawing/2014/main" id="{6B2D23AA-058F-479E-B0CE-1FA281C1DFC5}"/>
+              </a:ext>
+            </a:extLst>
+          </p:cNvPr>
+          <p:cNvSpPr>
+            <a:spLocks xmlns:a="http://schemas.openxmlformats.org/drawingml/2006/main" noGrp="1"/>
+          </p:cNvSpPr>
+          <p:nvPr/>
+        </p:nvSpPr>
+        <p:spPr>
+          <a:xfrm xmlns:a="http://schemas.openxmlformats.org/drawingml/2006/main">
+            <a:off x="3143250" y="2266950"/>
+            <a:ext cx="2571750" cy="266700"/>
+          </a:xfrm>
+          <a:prstGeom xmlns:a="http://schemas.openxmlformats.org/drawingml/2006/main" prst="rect">
+            <a:avLst/>
+          </a:prstGeom>
+          <a:noFill xmlns:a="http://schemas.openxmlformats.org/drawingml/2006/main"/>
+          <a:ln xmlns:a="http://schemas.openxmlformats.org/drawingml/2006/main" w="0">
+            <a:noFill/>
+            <a:prstDash val="solid"/>
+          </a:ln>
+        </p:spPr>
+        <p:txBody>
+          <a:bodyPr xmlns:a="http://schemas.openxmlformats.org/drawingml/2006/main"/>
+          <a:lstStyle xmlns:a="http://schemas.openxmlformats.org/drawingml/2006/main"/>
+          <a:p xmlns:a="http://schemas.openxmlformats.org/drawingml/2006/main">
+            <a:pPr>
+              <a:buNone/>
+              <a:defRPr sz="1650" b="1">
+                <a:solidFill>
+                  <a:srgbClr val="CCFF00"/>
+                </a:solidFill>
+              </a:defRPr>
+            </a:pPr>
+            <a:r>
+              <a:rPr sz="1650" b="1">
+                <a:solidFill>
+                  <a:srgbClr val="CCFF00"/>
+                </a:solidFill>
+              </a:rPr>
+              <a:t>6–12 MONTHS</a:t>
+            </a:r>
+          </a:p>
+        </p:txBody>
+      </p:sp>
+      <p:sp>
+        <p:nvSpPr>
+          <p:cNvPr id="31" name="programme-timeline">
+            <a:extLst xmlns:a="http://schemas.openxmlformats.org/drawingml/2006/main">
+              <a:ext uri="{FF2B5EF4-FFF2-40B4-BE49-F238E27FC236}">
+                <a16:creationId xmlns:a16="http://schemas.microsoft.com/office/drawing/2014/main" id="{D00BD1E0-722F-4937-B77D-75DFA2307F56}"/>
+              </a:ext>
+            </a:extLst>
+          </p:cNvPr>
+          <p:cNvSpPr>
+            <a:spLocks xmlns:a="http://schemas.openxmlformats.org/drawingml/2006/main" noGrp="1"/>
+          </p:cNvSpPr>
+          <p:nvPr/>
+        </p:nvSpPr>
+        <p:spPr>
+          <a:xfrm xmlns:a="http://schemas.openxmlformats.org/drawingml/2006/main">
+            <a:off x="1562100" y="3124200"/>
+            <a:ext cx="8610600" cy="19050"/>
+          </a:xfrm>
+          <a:prstGeom xmlns:a="http://schemas.openxmlformats.org/drawingml/2006/main" prst="rect">
+            <a:avLst/>
+          </a:prstGeom>
+          <a:solidFill xmlns:a="http://schemas.openxmlformats.org/drawingml/2006/main">
+            <a:srgbClr val="25302E"/>
+          </a:solidFill>
+          <a:ln xmlns:a="http://schemas.openxmlformats.org/drawingml/2006/main" w="0">
+            <a:solidFill>
+              <a:srgbClr val="25302E"/>
+            </a:solidFill>
+            <a:prstDash val="solid"/>
+          </a:ln>
+        </p:spPr>
+      </p:sp>
+      <p:sp>
+        <p:nvSpPr>
+          <p:cNvPr id="32" name="programme-node-1">
+            <a:extLst xmlns:a="http://schemas.openxmlformats.org/drawingml/2006/main">
+              <a:ext uri="{FF2B5EF4-FFF2-40B4-BE49-F238E27FC236}">
+                <a16:creationId xmlns:a16="http://schemas.microsoft.com/office/drawing/2014/main" id="{218BAB5E-B612-42A1-9947-3F11130310CC}"/>
+              </a:ext>
+            </a:extLst>
+          </p:cNvPr>
+          <p:cNvSpPr>
+            <a:spLocks xmlns:a="http://schemas.openxmlformats.org/drawingml/2006/main" noGrp="1"/>
+          </p:cNvSpPr>
+          <p:nvPr/>
+        </p:nvSpPr>
+        <p:spPr>
+          <a:xfrm xmlns:a="http://schemas.openxmlformats.org/drawingml/2006/main">
+            <a:off x="1905000" y="3028950"/>
+            <a:ext cx="209550" cy="209550"/>
+          </a:xfrm>
+          <a:prstGeom xmlns:a="http://schemas.openxmlformats.org/drawingml/2006/main" prst="ellipse">
+            <a:avLst/>
+          </a:prstGeom>
+          <a:solidFill xmlns:a="http://schemas.openxmlformats.org/drawingml/2006/main">
+            <a:srgbClr val="CCFF00"/>
+          </a:solidFill>
+          <a:ln xmlns:a="http://schemas.openxmlformats.org/drawingml/2006/main" w="9525">
+            <a:solidFill>
+              <a:srgbClr val="CCFF00"/>
+            </a:solidFill>
+            <a:prstDash val="solid"/>
+          </a:ln>
+        </p:spPr>
+      </p:sp>
+      <p:sp>
+        <p:nvSpPr>
+          <p:cNvPr id="33" name="programme-node-2">
+            <a:extLst xmlns:a="http://schemas.openxmlformats.org/drawingml/2006/main">
+              <a:ext uri="{FF2B5EF4-FFF2-40B4-BE49-F238E27FC236}">
+                <a16:creationId xmlns:a16="http://schemas.microsoft.com/office/drawing/2014/main" id="{3F11DBFD-40E0-4412-994A-5F51D9C209CE}"/>
+              </a:ext>
+            </a:extLst>
+          </p:cNvPr>
+          <p:cNvSpPr>
+            <a:spLocks xmlns:a="http://schemas.openxmlformats.org/drawingml/2006/main" noGrp="1"/>
+          </p:cNvSpPr>
+          <p:nvPr/>
+        </p:nvSpPr>
+        <p:spPr>
+          <a:xfrm xmlns:a="http://schemas.openxmlformats.org/drawingml/2006/main">
+            <a:off x="5810250" y="3028950"/>
+            <a:ext cx="209550" cy="209550"/>
+          </a:xfrm>
+          <a:prstGeom xmlns:a="http://schemas.openxmlformats.org/drawingml/2006/main" prst="ellipse">
+            <a:avLst/>
+          </a:prstGeom>
+          <a:solidFill xmlns:a="http://schemas.openxmlformats.org/drawingml/2006/main">
+            <a:srgbClr val="CCFF00"/>
+          </a:solidFill>
+          <a:ln xmlns:a="http://schemas.openxmlformats.org/drawingml/2006/main" w="9525">
+            <a:solidFill>
+              <a:srgbClr val="CCFF00"/>
+            </a:solidFill>
+            <a:prstDash val="solid"/>
+          </a:ln>
+        </p:spPr>
+      </p:sp>
+      <p:sp>
+        <p:nvSpPr>
+          <p:cNvPr id="34" name="programme-node-3">
+            <a:extLst xmlns:a="http://schemas.openxmlformats.org/drawingml/2006/main">
+              <a:ext uri="{FF2B5EF4-FFF2-40B4-BE49-F238E27FC236}">
+                <a16:creationId xmlns:a16="http://schemas.microsoft.com/office/drawing/2014/main" id="{833812B2-0ED7-452B-8D9F-A9E2D69CD8CD}"/>
+              </a:ext>
+            </a:extLst>
+          </p:cNvPr>
+          <p:cNvSpPr>
+            <a:spLocks xmlns:a="http://schemas.openxmlformats.org/drawingml/2006/main" noGrp="1"/>
+          </p:cNvSpPr>
+          <p:nvPr/>
+        </p:nvSpPr>
+        <p:spPr>
+          <a:xfrm xmlns:a="http://schemas.openxmlformats.org/drawingml/2006/main">
+            <a:off x="9715500" y="3028950"/>
+            <a:ext cx="209550" cy="209550"/>
+          </a:xfrm>
+          <a:prstGeom xmlns:a="http://schemas.openxmlformats.org/drawingml/2006/main" prst="ellipse">
+            <a:avLst/>
+          </a:prstGeom>
+          <a:solidFill xmlns:a="http://schemas.openxmlformats.org/drawingml/2006/main">
+            <a:srgbClr val="CCFF00"/>
+          </a:solidFill>
+          <a:ln xmlns:a="http://schemas.openxmlformats.org/drawingml/2006/main" w="9525">
+            <a:solidFill>
+              <a:srgbClr val="CCFF00"/>
+            </a:solidFill>
+            <a:prstDash val="solid"/>
+          </a:ln>
+        </p:spPr>
+      </p:sp>
+      <p:sp>
+        <p:nvSpPr>
+          <p:cNvPr id="35" name="programme-step-1">
+            <a:extLst xmlns:a="http://schemas.openxmlformats.org/drawingml/2006/main">
+              <a:ext uri="{FF2B5EF4-FFF2-40B4-BE49-F238E27FC236}">
+                <a16:creationId xmlns:a16="http://schemas.microsoft.com/office/drawing/2014/main" id="{F12E2EE4-1EEC-451C-8318-6F21B55E5D65}"/>
+              </a:ext>
+            </a:extLst>
+          </p:cNvPr>
+          <p:cNvSpPr>
+            <a:spLocks xmlns:a="http://schemas.openxmlformats.org/drawingml/2006/main" noGrp="1"/>
+          </p:cNvSpPr>
+          <p:nvPr/>
+        </p:nvSpPr>
+        <p:spPr>
+          <a:xfrm xmlns:a="http://schemas.openxmlformats.org/drawingml/2006/main">
+            <a:off x="876300" y="2647950"/>
+            <a:ext cx="2857500" cy="171450"/>
+          </a:xfrm>
+          <a:prstGeom xmlns:a="http://schemas.openxmlformats.org/drawingml/2006/main" prst="rect">
+            <a:avLst/>
+          </a:prstGeom>
+          <a:noFill xmlns:a="http://schemas.openxmlformats.org/drawingml/2006/main"/>
+          <a:ln xmlns:a="http://schemas.openxmlformats.org/drawingml/2006/main" w="0">
+            <a:noFill/>
+            <a:prstDash val="solid"/>
+          </a:ln>
+        </p:spPr>
+        <p:txBody>
+          <a:bodyPr xmlns:a="http://schemas.openxmlformats.org/drawingml/2006/main"/>
+          <a:lstStyle xmlns:a="http://schemas.openxmlformats.org/drawingml/2006/main"/>
+          <a:p xmlns:a="http://schemas.openxmlformats.org/drawingml/2006/main">
+            <a:pPr>
+              <a:buNone/>
+              <a:defRPr sz="1050" b="1">
+                <a:solidFill>
+                  <a:srgbClr val="CCFF00"/>
+                </a:solidFill>
+              </a:defRPr>
+            </a:pPr>
+            <a:r>
+              <a:rPr sz="1050" b="1">
+                <a:solidFill>
+                  <a:srgbClr val="CCFF00"/>
+                </a:solidFill>
+              </a:rPr>
+              <a:t>01  /  DAYS 0–30</a:t>
+            </a:r>
+          </a:p>
+        </p:txBody>
+      </p:sp>
+      <p:sp>
+        <p:nvSpPr>
+          <p:cNvPr id="36" name="programme-title-1">
+            <a:extLst xmlns:a="http://schemas.openxmlformats.org/drawingml/2006/main">
+              <a:ext uri="{FF2B5EF4-FFF2-40B4-BE49-F238E27FC236}">
+                <a16:creationId xmlns:a16="http://schemas.microsoft.com/office/drawing/2014/main" id="{E53378A8-8FC5-4899-AC41-AC6846498CBB}"/>
+              </a:ext>
+            </a:extLst>
+          </p:cNvPr>
+          <p:cNvSpPr>
+            <a:spLocks xmlns:a="http://schemas.openxmlformats.org/drawingml/2006/main" noGrp="1"/>
+          </p:cNvSpPr>
+          <p:nvPr/>
+        </p:nvSpPr>
+        <p:spPr>
+          <a:xfrm xmlns:a="http://schemas.openxmlformats.org/drawingml/2006/main">
+            <a:off x="876300" y="3476625"/>
+            <a:ext cx="2857500" cy="266700"/>
+          </a:xfrm>
+          <a:prstGeom xmlns:a="http://schemas.openxmlformats.org/drawingml/2006/main" prst="rect">
+            <a:avLst/>
+          </a:prstGeom>
+          <a:noFill xmlns:a="http://schemas.openxmlformats.org/drawingml/2006/main"/>
+          <a:ln xmlns:a="http://schemas.openxmlformats.org/drawingml/2006/main" w="0">
+            <a:noFill/>
+            <a:prstDash val="solid"/>
+          </a:ln>
+        </p:spPr>
+        <p:txBody>
+          <a:bodyPr xmlns:a="http://schemas.openxmlformats.org/drawingml/2006/main"/>
+          <a:lstStyle xmlns:a="http://schemas.openxmlformats.org/drawingml/2006/main"/>
+          <a:p xmlns:a="http://schemas.openxmlformats.org/drawingml/2006/main">
+            <a:pPr>
+              <a:buNone/>
+              <a:defRPr sz="1500" b="1">
+                <a:solidFill>
+                  <a:srgbClr val="F3F0E8"/>
+                </a:solidFill>
+              </a:defRPr>
+            </a:pPr>
+            <a:r>
+              <a:rPr sz="1500" b="1">
+                <a:solidFill>
+                  <a:srgbClr val="F3F0E8"/>
+                </a:solidFill>
+              </a:rPr>
+              <a:t>Evidence + conversion</a:t>
+            </a:r>
+          </a:p>
+        </p:txBody>
+      </p:sp>
+      <p:sp>
+        <p:nvSpPr>
+          <p:cNvPr id="37" name="programme-body-1">
+            <a:extLst xmlns:a="http://schemas.openxmlformats.org/drawingml/2006/main">
+              <a:ext uri="{FF2B5EF4-FFF2-40B4-BE49-F238E27FC236}">
+                <a16:creationId xmlns:a16="http://schemas.microsoft.com/office/drawing/2014/main" id="{553F96E7-33D7-4965-9A47-EB0CBEBD3B61}"/>
+              </a:ext>
+            </a:extLst>
+          </p:cNvPr>
+          <p:cNvSpPr>
+            <a:spLocks xmlns:a="http://schemas.openxmlformats.org/drawingml/2006/main" noGrp="1"/>
+          </p:cNvSpPr>
+          <p:nvPr/>
+        </p:nvSpPr>
+        <p:spPr>
+          <a:xfrm xmlns:a="http://schemas.openxmlformats.org/drawingml/2006/main">
+            <a:off x="876300" y="3857625"/>
+            <a:ext cx="2857500" cy="685800"/>
+          </a:xfrm>
+          <a:prstGeom xmlns:a="http://schemas.openxmlformats.org/drawingml/2006/main" prst="rect">
+            <a:avLst/>
+          </a:prstGeom>
+          <a:noFill xmlns:a="http://schemas.openxmlformats.org/drawingml/2006/main"/>
+          <a:ln xmlns:a="http://schemas.openxmlformats.org/drawingml/2006/main" w="0">
+            <a:noFill/>
+            <a:prstDash val="solid"/>
+          </a:ln>
+        </p:spPr>
+        <p:txBody>
+          <a:bodyPr xmlns:a="http://schemas.openxmlformats.org/drawingml/2006/main"/>
+          <a:lstStyle xmlns:a="http://schemas.openxmlformats.org/drawingml/2006/main"/>
+          <a:p xmlns:a="http://schemas.openxmlformats.org/drawingml/2006/main">
+            <a:pPr>
+              <a:buNone/>
+              <a:defRPr sz="1050" b="0">
+                <a:solidFill>
+                  <a:srgbClr val="F3F0E8"/>
+                </a:solidFill>
+              </a:defRPr>
+            </a:pPr>
+            <a:r>
+              <a:rPr sz="1050" b="0">
+                <a:solidFill>
+                  <a:srgbClr val="F3F0E8"/>
+                </a:solidFill>
+              </a:rPr>
+              <a:t>Radiation-resilience pack, ESA BIC framing, and scoped partner work with mission-control / Yamcs and SSA data.</a:t>
+            </a:r>
+          </a:p>
+        </p:txBody>
+      </p:sp>
+      <p:sp>
+        <p:nvSpPr>
+          <p:cNvPr id="38" name="programme-step-2">
+            <a:extLst xmlns:a="http://schemas.openxmlformats.org/drawingml/2006/main">
+              <a:ext uri="{FF2B5EF4-FFF2-40B4-BE49-F238E27FC236}">
+                <a16:creationId xmlns:a16="http://schemas.microsoft.com/office/drawing/2014/main" id="{9FFAFD0B-396D-42F2-895D-D76A0A16858A}"/>
+              </a:ext>
+            </a:extLst>
+          </p:cNvPr>
+          <p:cNvSpPr>
+            <a:spLocks xmlns:a="http://schemas.openxmlformats.org/drawingml/2006/main" noGrp="1"/>
+          </p:cNvSpPr>
+          <p:nvPr/>
+        </p:nvSpPr>
+        <p:spPr>
+          <a:xfrm xmlns:a="http://schemas.openxmlformats.org/drawingml/2006/main">
+            <a:off x="4543425" y="2647950"/>
+            <a:ext cx="2857500" cy="171450"/>
+          </a:xfrm>
+          <a:prstGeom xmlns:a="http://schemas.openxmlformats.org/drawingml/2006/main" prst="rect">
+            <a:avLst/>
+          </a:prstGeom>
+          <a:noFill xmlns:a="http://schemas.openxmlformats.org/drawingml/2006/main"/>
+          <a:ln xmlns:a="http://schemas.openxmlformats.org/drawingml/2006/main" w="0">
+            <a:noFill/>
+            <a:prstDash val="solid"/>
+          </a:ln>
+        </p:spPr>
+        <p:txBody>
+          <a:bodyPr xmlns:a="http://schemas.openxmlformats.org/drawingml/2006/main"/>
+          <a:lstStyle xmlns:a="http://schemas.openxmlformats.org/drawingml/2006/main"/>
+          <a:p xmlns:a="http://schemas.openxmlformats.org/drawingml/2006/main">
+            <a:pPr>
+              <a:buNone/>
+              <a:defRPr sz="1050" b="1">
+                <a:solidFill>
+                  <a:srgbClr val="CCFF00"/>
+                </a:solidFill>
+              </a:defRPr>
+            </a:pPr>
+            <a:r>
+              <a:rPr sz="1050" b="1">
+                <a:solidFill>
+                  <a:srgbClr val="CCFF00"/>
+                </a:solidFill>
+              </a:rPr>
+              <a:t>02  /  DAYS 31–60</a:t>
+            </a:r>
+          </a:p>
+        </p:txBody>
+      </p:sp>
+      <p:sp>
+        <p:nvSpPr>
+          <p:cNvPr id="39" name="programme-title-2">
+            <a:extLst xmlns:a="http://schemas.openxmlformats.org/drawingml/2006/main">
+              <a:ext uri="{FF2B5EF4-FFF2-40B4-BE49-F238E27FC236}">
+                <a16:creationId xmlns:a16="http://schemas.microsoft.com/office/drawing/2014/main" id="{6AEB2C5A-F278-4C58-BA37-0FD136084B33}"/>
+              </a:ext>
+            </a:extLst>
+          </p:cNvPr>
+          <p:cNvSpPr>
+            <a:spLocks xmlns:a="http://schemas.openxmlformats.org/drawingml/2006/main" noGrp="1"/>
+          </p:cNvSpPr>
+          <p:nvPr/>
+        </p:nvSpPr>
+        <p:spPr>
+          <a:xfrm xmlns:a="http://schemas.openxmlformats.org/drawingml/2006/main">
+            <a:off x="4543425" y="3476625"/>
+            <a:ext cx="2857500" cy="266700"/>
+          </a:xfrm>
+          <a:prstGeom xmlns:a="http://schemas.openxmlformats.org/drawingml/2006/main" prst="rect">
+            <a:avLst/>
+          </a:prstGeom>
+          <a:noFill xmlns:a="http://schemas.openxmlformats.org/drawingml/2006/main"/>
+          <a:ln xmlns:a="http://schemas.openxmlformats.org/drawingml/2006/main" w="0">
+            <a:noFill/>
+            <a:prstDash val="solid"/>
+          </a:ln>
+        </p:spPr>
+        <p:txBody>
+          <a:bodyPr xmlns:a="http://schemas.openxmlformats.org/drawingml/2006/main"/>
+          <a:lstStyle xmlns:a="http://schemas.openxmlformats.org/drawingml/2006/main"/>
+          <a:p xmlns:a="http://schemas.openxmlformats.org/drawingml/2006/main">
+            <a:pPr>
+              <a:buNone/>
+              <a:defRPr sz="1500" b="1">
+                <a:solidFill>
+                  <a:srgbClr val="F3F0E8"/>
+                </a:solidFill>
+              </a:defRPr>
+            </a:pPr>
+            <a:r>
+              <a:rPr sz="1500" b="1">
+                <a:solidFill>
+                  <a:srgbClr val="F3F0E8"/>
+                </a:solidFill>
+              </a:rPr>
+              <a:t>Paid pilot readiness</a:t>
+            </a:r>
+          </a:p>
+        </p:txBody>
+      </p:sp>
+      <p:sp>
+        <p:nvSpPr>
+          <p:cNvPr id="40" name="programme-body-2">
+            <a:extLst xmlns:a="http://schemas.openxmlformats.org/drawingml/2006/main">
+              <a:ext uri="{FF2B5EF4-FFF2-40B4-BE49-F238E27FC236}">
+                <a16:creationId xmlns:a16="http://schemas.microsoft.com/office/drawing/2014/main" id="{AD80D1DB-FDC5-481F-AAA5-5890A4E134C4}"/>
+              </a:ext>
+            </a:extLst>
+          </p:cNvPr>
+          <p:cNvSpPr>
+            <a:spLocks xmlns:a="http://schemas.openxmlformats.org/drawingml/2006/main" noGrp="1"/>
+          </p:cNvSpPr>
+          <p:nvPr/>
+        </p:nvSpPr>
+        <p:spPr>
+          <a:xfrm xmlns:a="http://schemas.openxmlformats.org/drawingml/2006/main">
+            <a:off x="4543425" y="3857625"/>
+            <a:ext cx="2857500" cy="685800"/>
+          </a:xfrm>
+          <a:prstGeom xmlns:a="http://schemas.openxmlformats.org/drawingml/2006/main" prst="rect">
+            <a:avLst/>
+          </a:prstGeom>
+          <a:noFill xmlns:a="http://schemas.openxmlformats.org/drawingml/2006/main"/>
+          <a:ln xmlns:a="http://schemas.openxmlformats.org/drawingml/2006/main" w="0">
+            <a:noFill/>
+            <a:prstDash val="solid"/>
+          </a:ln>
+        </p:spPr>
+        <p:txBody>
+          <a:bodyPr xmlns:a="http://schemas.openxmlformats.org/drawingml/2006/main"/>
+          <a:lstStyle xmlns:a="http://schemas.openxmlformats.org/drawingml/2006/main"/>
+          <a:p xmlns:a="http://schemas.openxmlformats.org/drawingml/2006/main">
+            <a:pPr>
+              <a:buNone/>
+              <a:defRPr sz="1050" b="0">
+                <a:solidFill>
+                  <a:srgbClr val="F3F0E8"/>
+                </a:solidFill>
+              </a:defRPr>
+            </a:pPr>
+            <a:r>
+              <a:rPr sz="1050" b="0">
+                <a:solidFill>
+                  <a:srgbClr val="F3F0E8"/>
+                </a:solidFill>
+              </a:rPr>
+              <a:t>Replay review, bounded data integration, target-compute benchmark, and security / data-residency pack.</a:t>
+            </a:r>
+          </a:p>
+        </p:txBody>
+      </p:sp>
+      <p:sp>
+        <p:nvSpPr>
+          <p:cNvPr id="41" name="programme-step-3">
+            <a:extLst xmlns:a="http://schemas.openxmlformats.org/drawingml/2006/main">
+              <a:ext uri="{FF2B5EF4-FFF2-40B4-BE49-F238E27FC236}">
+                <a16:creationId xmlns:a16="http://schemas.microsoft.com/office/drawing/2014/main" id="{CC94F305-FAEA-44AB-B95F-AD33F9692A6C}"/>
+              </a:ext>
+            </a:extLst>
+          </p:cNvPr>
+          <p:cNvSpPr>
+            <a:spLocks xmlns:a="http://schemas.openxmlformats.org/drawingml/2006/main" noGrp="1"/>
+          </p:cNvSpPr>
+          <p:nvPr/>
+        </p:nvSpPr>
+        <p:spPr>
+          <a:xfrm xmlns:a="http://schemas.openxmlformats.org/drawingml/2006/main">
+            <a:off x="8210550" y="2647950"/>
+            <a:ext cx="2857500" cy="171450"/>
+          </a:xfrm>
+          <a:prstGeom xmlns:a="http://schemas.openxmlformats.org/drawingml/2006/main" prst="rect">
+            <a:avLst/>
+          </a:prstGeom>
+          <a:noFill xmlns:a="http://schemas.openxmlformats.org/drawingml/2006/main"/>
+          <a:ln xmlns:a="http://schemas.openxmlformats.org/drawingml/2006/main" w="0">
+            <a:noFill/>
+            <a:prstDash val="solid"/>
+          </a:ln>
+        </p:spPr>
+        <p:txBody>
+          <a:bodyPr xmlns:a="http://schemas.openxmlformats.org/drawingml/2006/main"/>
+          <a:lstStyle xmlns:a="http://schemas.openxmlformats.org/drawingml/2006/main"/>
+          <a:p xmlns:a="http://schemas.openxmlformats.org/drawingml/2006/main">
+            <a:pPr>
+              <a:buNone/>
+              <a:defRPr sz="1050" b="1">
+                <a:solidFill>
+                  <a:srgbClr val="CCFF00"/>
+                </a:solidFill>
+              </a:defRPr>
+            </a:pPr>
+            <a:r>
+              <a:rPr sz="1050" b="1">
+                <a:solidFill>
+                  <a:srgbClr val="CCFF00"/>
+                </a:solidFill>
+              </a:rPr>
+              <a:t>03  /  DAYS 61–90</a:t>
+            </a:r>
+          </a:p>
+        </p:txBody>
+      </p:sp>
+      <p:sp>
+        <p:nvSpPr>
+          <p:cNvPr id="42" name="programme-title-3">
+            <a:extLst xmlns:a="http://schemas.openxmlformats.org/drawingml/2006/main">
+              <a:ext uri="{FF2B5EF4-FFF2-40B4-BE49-F238E27FC236}">
+                <a16:creationId xmlns:a16="http://schemas.microsoft.com/office/drawing/2014/main" id="{1B57BC3D-BC87-492A-90E1-CA7DA6597C56}"/>
+              </a:ext>
+            </a:extLst>
+          </p:cNvPr>
+          <p:cNvSpPr>
+            <a:spLocks xmlns:a="http://schemas.openxmlformats.org/drawingml/2006/main" noGrp="1"/>
+          </p:cNvSpPr>
+          <p:nvPr/>
+        </p:nvSpPr>
+        <p:spPr>
+          <a:xfrm xmlns:a="http://schemas.openxmlformats.org/drawingml/2006/main">
+            <a:off x="8210550" y="3476625"/>
+            <a:ext cx="2857500" cy="266700"/>
+          </a:xfrm>
+          <a:prstGeom xmlns:a="http://schemas.openxmlformats.org/drawingml/2006/main" prst="rect">
+            <a:avLst/>
+          </a:prstGeom>
+          <a:noFill xmlns:a="http://schemas.openxmlformats.org/drawingml/2006/main"/>
+          <a:ln xmlns:a="http://schemas.openxmlformats.org/drawingml/2006/main" w="0">
+            <a:noFill/>
+            <a:prstDash val="solid"/>
+          </a:ln>
+        </p:spPr>
+        <p:txBody>
+          <a:bodyPr xmlns:a="http://schemas.openxmlformats.org/drawingml/2006/main"/>
+          <a:lstStyle xmlns:a="http://schemas.openxmlformats.org/drawingml/2006/main"/>
+          <a:p xmlns:a="http://schemas.openxmlformats.org/drawingml/2006/main">
+            <a:pPr>
+              <a:buNone/>
+              <a:defRPr sz="1500" b="1">
+                <a:solidFill>
+                  <a:srgbClr val="F3F0E8"/>
+                </a:solidFill>
+              </a:defRPr>
+            </a:pPr>
+            <a:r>
+              <a:rPr sz="1500" b="1">
+                <a:solidFill>
+                  <a:srgbClr val="F3F0E8"/>
+                </a:solidFill>
+              </a:rPr>
+              <a:t>Commercial proof</a:t>
+            </a:r>
+          </a:p>
+        </p:txBody>
+      </p:sp>
+      <p:sp>
+        <p:nvSpPr>
+          <p:cNvPr id="43" name="programme-body-3">
+            <a:extLst xmlns:a="http://schemas.openxmlformats.org/drawingml/2006/main">
+              <a:ext uri="{FF2B5EF4-FFF2-40B4-BE49-F238E27FC236}">
+                <a16:creationId xmlns:a16="http://schemas.microsoft.com/office/drawing/2014/main" id="{9C732FA4-8043-4FA3-B33A-DE352E983205}"/>
+              </a:ext>
+            </a:extLst>
+          </p:cNvPr>
+          <p:cNvSpPr>
+            <a:spLocks xmlns:a="http://schemas.openxmlformats.org/drawingml/2006/main" noGrp="1"/>
+          </p:cNvSpPr>
+          <p:nvPr/>
+        </p:nvSpPr>
+        <p:spPr>
+          <a:xfrm xmlns:a="http://schemas.openxmlformats.org/drawingml/2006/main">
+            <a:off x="8210550" y="3857625"/>
+            <a:ext cx="2857500" cy="685800"/>
+          </a:xfrm>
+          <a:prstGeom xmlns:a="http://schemas.openxmlformats.org/drawingml/2006/main" prst="rect">
+            <a:avLst/>
+          </a:prstGeom>
+          <a:noFill xmlns:a="http://schemas.openxmlformats.org/drawingml/2006/main"/>
+          <a:ln xmlns:a="http://schemas.openxmlformats.org/drawingml/2006/main" w="0">
+            <a:noFill/>
+            <a:prstDash val="solid"/>
+          </a:ln>
+        </p:spPr>
+        <p:txBody>
+          <a:bodyPr xmlns:a="http://schemas.openxmlformats.org/drawingml/2006/main"/>
+          <a:lstStyle xmlns:a="http://schemas.openxmlformats.org/drawingml/2006/main"/>
+          <a:p xmlns:a="http://schemas.openxmlformats.org/drawingml/2006/main">
+            <a:pPr>
+              <a:buNone/>
+              <a:defRPr sz="1050" b="0">
+                <a:solidFill>
+                  <a:srgbClr val="F3F0E8"/>
+                </a:solidFill>
+              </a:defRPr>
+            </a:pPr>
+            <a:r>
+              <a:rPr sz="1050" b="0">
+                <a:solidFill>
+                  <a:srgbClr val="F3F0E8"/>
+                </a:solidFill>
+              </a:rPr>
+              <a:t>Two design partners, one paid ground or integration pilot, and validated price / acceptance criteria.</a:t>
+            </a:r>
+          </a:p>
+        </p:txBody>
+      </p:sp>
+      <p:sp>
+        <p:nvSpPr>
+          <p:cNvPr id="44" name="programme-expansion-gate">
+            <a:extLst xmlns:a="http://schemas.openxmlformats.org/drawingml/2006/main">
+              <a:ext uri="{FF2B5EF4-FFF2-40B4-BE49-F238E27FC236}">
+                <a16:creationId xmlns:a16="http://schemas.microsoft.com/office/drawing/2014/main" id="{1D1E55C8-B644-4474-A00C-8CCAA91F1EEA}"/>
+              </a:ext>
+            </a:extLst>
+          </p:cNvPr>
+          <p:cNvSpPr>
+            <a:spLocks xmlns:a="http://schemas.openxmlformats.org/drawingml/2006/main" noGrp="1"/>
+          </p:cNvSpPr>
+          <p:nvPr/>
+        </p:nvSpPr>
+        <p:spPr>
+          <a:xfrm xmlns:a="http://schemas.openxmlformats.org/drawingml/2006/main">
+            <a:off x="876300" y="5048250"/>
+            <a:ext cx="10058400" cy="533400"/>
+          </a:xfrm>
+          <a:prstGeom xmlns:a="http://schemas.openxmlformats.org/drawingml/2006/main" prst="roundRect">
+            <a:avLst>
+              <a:gd name="adj" fmla="val 14286"/>
+            </a:avLst>
+          </a:prstGeom>
+          <a:solidFill xmlns:a="http://schemas.openxmlformats.org/drawingml/2006/main">
+            <a:srgbClr val="0D1010"/>
+          </a:solidFill>
+          <a:ln xmlns:a="http://schemas.openxmlformats.org/drawingml/2006/main" w="9525">
+            <a:solidFill>
+              <a:srgbClr val="25302E"/>
+            </a:solidFill>
+            <a:prstDash val="solid"/>
+          </a:ln>
+        </p:spPr>
+      </p:sp>
+      <p:sp>
+        <p:nvSpPr>
+          <p:cNvPr id="45" name="programme-gate-label">
+            <a:extLst xmlns:a="http://schemas.openxmlformats.org/drawingml/2006/main">
+              <a:ext uri="{FF2B5EF4-FFF2-40B4-BE49-F238E27FC236}">
+                <a16:creationId xmlns:a16="http://schemas.microsoft.com/office/drawing/2014/main" id="{DF33AF5A-C2E9-4095-90B8-B4A7A54216EB}"/>
+              </a:ext>
+            </a:extLst>
+          </p:cNvPr>
+          <p:cNvSpPr>
+            <a:spLocks xmlns:a="http://schemas.openxmlformats.org/drawingml/2006/main" noGrp="1"/>
+          </p:cNvSpPr>
+          <p:nvPr/>
+        </p:nvSpPr>
+        <p:spPr>
+          <a:xfrm xmlns:a="http://schemas.openxmlformats.org/drawingml/2006/main">
+            <a:off x="1104900" y="5219700"/>
+            <a:ext cx="2000250" cy="171450"/>
+          </a:xfrm>
+          <a:prstGeom xmlns:a="http://schemas.openxmlformats.org/drawingml/2006/main" prst="rect">
+            <a:avLst/>
+          </a:prstGeom>
+          <a:noFill xmlns:a="http://schemas.openxmlformats.org/drawingml/2006/main"/>
+          <a:ln xmlns:a="http://schemas.openxmlformats.org/drawingml/2006/main" w="0">
+            <a:noFill/>
+            <a:prstDash val="solid"/>
+          </a:ln>
+        </p:spPr>
+        <p:txBody>
+          <a:bodyPr xmlns:a="http://schemas.openxmlformats.org/drawingml/2006/main"/>
+          <a:lstStyle xmlns:a="http://schemas.openxmlformats.org/drawingml/2006/main"/>
+          <a:p xmlns:a="http://schemas.openxmlformats.org/drawingml/2006/main">
+            <a:pPr>
+              <a:buNone/>
+              <a:defRPr sz="1050" b="1">
+                <a:solidFill>
+                  <a:srgbClr val="CCFF00"/>
+                </a:solidFill>
+              </a:defRPr>
+            </a:pPr>
+            <a:r>
+              <a:rPr sz="1050" b="1">
+                <a:solidFill>
+                  <a:srgbClr val="CCFF00"/>
+                </a:solidFill>
+              </a:rPr>
+              <a:t>GATE TO EXPANSION</a:t>
+            </a:r>
+          </a:p>
+        </p:txBody>
+      </p:sp>
+      <p:sp>
+        <p:nvSpPr>
+          <p:cNvPr id="46" name="programme-gate-copy">
+            <a:extLst xmlns:a="http://schemas.openxmlformats.org/drawingml/2006/main">
+              <a:ext uri="{FF2B5EF4-FFF2-40B4-BE49-F238E27FC236}">
+                <a16:creationId xmlns:a16="http://schemas.microsoft.com/office/drawing/2014/main" id="{F915B4ED-5D2E-4E99-9088-9BC30F477F28}"/>
+              </a:ext>
+            </a:extLst>
+          </p:cNvPr>
+          <p:cNvSpPr>
+            <a:spLocks xmlns:a="http://schemas.openxmlformats.org/drawingml/2006/main" noGrp="1"/>
+          </p:cNvSpPr>
+          <p:nvPr/>
+        </p:nvSpPr>
+        <p:spPr>
+          <a:xfrm xmlns:a="http://schemas.openxmlformats.org/drawingml/2006/main">
+            <a:off x="3333750" y="5181600"/>
+            <a:ext cx="7239000" cy="266700"/>
+          </a:xfrm>
+          <a:prstGeom xmlns:a="http://schemas.openxmlformats.org/drawingml/2006/main" prst="rect">
+            <a:avLst/>
+          </a:prstGeom>
+          <a:noFill xmlns:a="http://schemas.openxmlformats.org/drawingml/2006/main"/>
+          <a:ln xmlns:a="http://schemas.openxmlformats.org/drawingml/2006/main" w="0">
+            <a:noFill/>
+            <a:prstDash val="solid"/>
+          </a:ln>
+        </p:spPr>
+        <p:txBody>
+          <a:bodyPr xmlns:a="http://schemas.openxmlformats.org/drawingml/2006/main"/>
+          <a:lstStyle xmlns:a="http://schemas.openxmlformats.org/drawingml/2006/main"/>
+          <a:p xmlns:a="http://schemas.openxmlformats.org/drawingml/2006/main">
+            <a:pPr>
+              <a:buNone/>
+              <a:defRPr sz="1050" b="0">
+                <a:solidFill>
+                  <a:srgbClr val="F3F0E8"/>
+                </a:solidFill>
+              </a:defRPr>
+            </a:pPr>
+            <a:r>
+              <a:rPr sz="1050" b="0">
+                <a:solidFill>
+                  <a:srgbClr val="F3F0E8"/>
+                </a:solidFill>
+              </a:rPr>
+              <a:t>Flight Candidate Adapter / Federated Bridge Node only after named mission, target processor, partner and hardware evidence.</a:t>
+            </a:r>
+          </a:p>
+        </p:txBody>
+      </p:sp>
+      <p:sp>
+        <p:nvSpPr>
+          <p:cNvPr id="47" name="programme-source-rail">
+            <a:extLst xmlns:a="http://schemas.openxmlformats.org/drawingml/2006/main">
+              <a:ext uri="{FF2B5EF4-FFF2-40B4-BE49-F238E27FC236}">
+                <a16:creationId xmlns:a16="http://schemas.microsoft.com/office/drawing/2014/main" id="{3C186ABE-ADBF-4A36-9BB6-53B5C67BAC99}"/>
+              </a:ext>
+            </a:extLst>
+          </p:cNvPr>
+          <p:cNvSpPr>
+            <a:spLocks xmlns:a="http://schemas.openxmlformats.org/drawingml/2006/main" noGrp="1"/>
+          </p:cNvSpPr>
+          <p:nvPr/>
+        </p:nvSpPr>
+        <p:spPr>
+          <a:xfrm xmlns:a="http://schemas.openxmlformats.org/drawingml/2006/main">
+            <a:off x="876300" y="5791200"/>
+            <a:ext cx="10058400" cy="171450"/>
+          </a:xfrm>
+          <a:prstGeom xmlns:a="http://schemas.openxmlformats.org/drawingml/2006/main" prst="rect">
+            <a:avLst/>
+          </a:prstGeom>
+          <a:noFill xmlns:a="http://schemas.openxmlformats.org/drawingml/2006/main"/>
+          <a:ln xmlns:a="http://schemas.openxmlformats.org/drawingml/2006/main" w="0">
+            <a:noFill/>
+            <a:prstDash val="solid"/>
+          </a:ln>
+        </p:spPr>
+        <p:txBody>
+          <a:bodyPr xmlns:a="http://schemas.openxmlformats.org/drawingml/2006/main"/>
+          <a:lstStyle xmlns:a="http://schemas.openxmlformats.org/drawingml/2006/main"/>
+          <a:p xmlns:a="http://schemas.openxmlformats.org/drawingml/2006/main">
+            <a:pPr>
+              <a:buNone/>
+              <a:defRPr sz="900" b="0">
+                <a:solidFill>
+                  <a:srgbClr val="F3F0E8"/>
+                </a:solidFill>
+              </a:defRPr>
+            </a:pPr>
+            <a:r>
+              <a:rPr sz="900" b="0">
+                <a:solidFill>
+                  <a:srgbClr val="F3F0E8"/>
+                </a:solidFill>
+              </a:rPr>
+              <a:t>Plan follows the repository ground-first commercial memo; expansion claims remain explicitly gated.</a:t>
+            </a:r>
+          </a:p>
+        </p:txBody>
+      </p:sp>
     </p:spTree>
     <p:extLst>
       <p:ext uri="{BB962C8B-B14F-4D97-AF65-F5344CB8AC3E}">
@@ -7287,7 +8221,7 @@
           <p:nvPr/>
         </p:nvPicPr>
         <p:blipFill>
-          <a:blip xmlns:r="http://schemas.openxmlformats.org/officeDocument/2006/relationships" xmlns:a="http://schemas.openxmlformats.org/drawingml/2006/main" r:embed="Rcbf83da15120492d"/>
+          <a:blip xmlns:r="http://schemas.openxmlformats.org/officeDocument/2006/relationships" xmlns:a="http://schemas.openxmlformats.org/drawingml/2006/main" r:embed="R7228f170a9c549b2"/>
           <a:srcRect xmlns:a="http://schemas.openxmlformats.org/drawingml/2006/main" l="9091" t="0" r="9091" b="0"/>
           <a:stretch xmlns:a="http://schemas.openxmlformats.org/drawingml/2006/main">
             <a:fillRect l="0" t="0" r="0" b="0"/>
@@ -8416,7 +9350,7 @@
           <p:nvPr/>
         </p:nvPicPr>
         <p:blipFill>
-          <a:blip xmlns:r="http://schemas.openxmlformats.org/officeDocument/2006/relationships" xmlns:a="http://schemas.openxmlformats.org/drawingml/2006/main" r:embed="R0b5a7079fdb547d2"/>
+          <a:blip xmlns:r="http://schemas.openxmlformats.org/officeDocument/2006/relationships" xmlns:a="http://schemas.openxmlformats.org/drawingml/2006/main" r:embed="R92174d41ce7c416b"/>
           <a:srcRect xmlns:a="http://schemas.openxmlformats.org/drawingml/2006/main" l="2676" t="0" r="2676" b="0"/>
           <a:stretch xmlns:a="http://schemas.openxmlformats.org/drawingml/2006/main">
             <a:fillRect l="0" t="0" r="0" b="0"/>
@@ -11124,7 +12058,7 @@
           <p:nvPr/>
         </p:nvPicPr>
         <p:blipFill>
-          <a:blip xmlns:r="http://schemas.openxmlformats.org/officeDocument/2006/relationships" xmlns:a="http://schemas.openxmlformats.org/drawingml/2006/main" r:embed="R6a2edd2ae9bf416a">
+          <a:blip xmlns:r="http://schemas.openxmlformats.org/officeDocument/2006/relationships" xmlns:a="http://schemas.openxmlformats.org/drawingml/2006/main" r:embed="Rde50a615cd084caa">
             <a:alphaModFix amt="96000"/>
           </a:blip>
           <a:stretch xmlns:a="http://schemas.openxmlformats.org/drawingml/2006/main">
@@ -13655,14 +14589,14 @@
       </p:grpSpPr>
       <p:pic>
         <p:nvPicPr>
-          <p:cNvPr id="89" name="Image 0"/>
+          <p:cNvPr id="90" name="Image 0"/>
           <p:cNvPicPr>
             <a:picLocks xmlns:a="http://schemas.openxmlformats.org/drawingml/2006/main" noChangeAspect="1"/>
           </p:cNvPicPr>
           <p:nvPr/>
         </p:nvPicPr>
         <p:blipFill>
-          <a:blip xmlns:r="http://schemas.openxmlformats.org/officeDocument/2006/relationships" xmlns:a="http://schemas.openxmlformats.org/drawingml/2006/main" r:embed="Ra34a72f9ec104ac4">
+          <a:blip xmlns:r="http://schemas.openxmlformats.org/officeDocument/2006/relationships" xmlns:a="http://schemas.openxmlformats.org/drawingml/2006/main" r:embed="R4baafe3570304564">
             <a:alphaModFix amt="96000"/>
           </a:blip>
           <a:stretch xmlns:a="http://schemas.openxmlformats.org/drawingml/2006/main">
@@ -16529,6 +17463,7 @@
           <a:lstStyle xmlns:a="http://schemas.openxmlformats.org/drawingml/2006/main"/>
           <a:p xmlns:a="http://schemas.openxmlformats.org/drawingml/2006/main">
             <a:pPr>
+              <a:buNone/>
               <a:defRPr sz="1050" b="1">
                 <a:solidFill>
                   <a:srgbClr val="F3F0E8"/>
@@ -16579,6 +17514,7 @@
           <a:lstStyle xmlns:a="http://schemas.openxmlformats.org/drawingml/2006/main"/>
           <a:p xmlns:a="http://schemas.openxmlformats.org/drawingml/2006/main">
             <a:pPr>
+              <a:buNone/>
               <a:defRPr sz="900" b="0">
                 <a:solidFill>
                   <a:srgbClr val="F3F0E8"/>
@@ -16728,6 +17664,7 @@
           <a:lstStyle xmlns:a="http://schemas.openxmlformats.org/drawingml/2006/main"/>
           <a:p xmlns:a="http://schemas.openxmlformats.org/drawingml/2006/main">
             <a:pPr>
+              <a:buNone/>
               <a:defRPr sz="1050" b="1">
                 <a:solidFill>
                   <a:srgbClr val="F3F0E8"/>
@@ -16778,6 +17715,7 @@
           <a:lstStyle xmlns:a="http://schemas.openxmlformats.org/drawingml/2006/main"/>
           <a:p xmlns:a="http://schemas.openxmlformats.org/drawingml/2006/main">
             <a:pPr>
+              <a:buNone/>
               <a:defRPr sz="2100" b="1">
                 <a:solidFill>
                   <a:srgbClr val="CCFF00"/>
@@ -16828,6 +17766,7 @@
           <a:lstStyle xmlns:a="http://schemas.openxmlformats.org/drawingml/2006/main"/>
           <a:p xmlns:a="http://schemas.openxmlformats.org/drawingml/2006/main">
             <a:pPr>
+              <a:buNone/>
               <a:defRPr sz="1050" b="1">
                 <a:solidFill>
                   <a:srgbClr val="F3F0E8"/>
@@ -16878,6 +17817,7 @@
           <a:lstStyle xmlns:a="http://schemas.openxmlformats.org/drawingml/2006/main"/>
           <a:p xmlns:a="http://schemas.openxmlformats.org/drawingml/2006/main">
             <a:pPr>
+              <a:buNone/>
               <a:defRPr sz="1500" b="1">
                 <a:solidFill>
                   <a:srgbClr val="CCFF00"/>
@@ -16928,6 +17868,7 @@
           <a:lstStyle xmlns:a="http://schemas.openxmlformats.org/drawingml/2006/main"/>
           <a:p xmlns:a="http://schemas.openxmlformats.org/drawingml/2006/main">
             <a:pPr>
+              <a:buNone/>
               <a:defRPr sz="975" b="1">
                 <a:solidFill>
                   <a:srgbClr val="F3F0E8"/>
@@ -16978,6 +17919,7 @@
           <a:lstStyle xmlns:a="http://schemas.openxmlformats.org/drawingml/2006/main"/>
           <a:p xmlns:a="http://schemas.openxmlformats.org/drawingml/2006/main">
             <a:pPr>
+              <a:buNone/>
               <a:defRPr sz="1350" b="1">
                 <a:solidFill>
                   <a:srgbClr val="CCFF00"/>
@@ -17061,6 +18003,7 @@
           <a:lstStyle xmlns:a="http://schemas.openxmlformats.org/drawingml/2006/main"/>
           <a:p xmlns:a="http://schemas.openxmlformats.org/drawingml/2006/main">
             <a:pPr>
+              <a:buNone/>
               <a:defRPr sz="1050" b="1">
                 <a:solidFill>
                   <a:srgbClr val="F3F0E8"/>
@@ -17111,6 +18054,7 @@
           <a:lstStyle xmlns:a="http://schemas.openxmlformats.org/drawingml/2006/main"/>
           <a:p xmlns:a="http://schemas.openxmlformats.org/drawingml/2006/main">
             <a:pPr>
+              <a:buNone/>
               <a:defRPr sz="2100" b="1">
                 <a:solidFill>
                   <a:srgbClr val="CCFF00"/>
@@ -17161,6 +18105,7 @@
           <a:lstStyle xmlns:a="http://schemas.openxmlformats.org/drawingml/2006/main"/>
           <a:p xmlns:a="http://schemas.openxmlformats.org/drawingml/2006/main">
             <a:pPr>
+              <a:buNone/>
               <a:defRPr sz="1050" b="0">
                 <a:solidFill>
                   <a:srgbClr val="F3F0E8"/>
@@ -17244,6 +18189,7 @@
           <a:lstStyle xmlns:a="http://schemas.openxmlformats.org/drawingml/2006/main"/>
           <a:p xmlns:a="http://schemas.openxmlformats.org/drawingml/2006/main">
             <a:pPr>
+              <a:buNone/>
               <a:defRPr sz="1050" b="1">
                 <a:solidFill>
                   <a:srgbClr val="F3F0E8"/>
@@ -17294,6 +18240,7 @@
           <a:lstStyle xmlns:a="http://schemas.openxmlformats.org/drawingml/2006/main"/>
           <a:p xmlns:a="http://schemas.openxmlformats.org/drawingml/2006/main">
             <a:pPr>
+              <a:buNone/>
               <a:defRPr sz="2100" b="1">
                 <a:solidFill>
                   <a:srgbClr val="CCFF00"/>
@@ -17344,6 +18291,7 @@
           <a:lstStyle xmlns:a="http://schemas.openxmlformats.org/drawingml/2006/main"/>
           <a:p xmlns:a="http://schemas.openxmlformats.org/drawingml/2006/main">
             <a:pPr>
+              <a:buNone/>
               <a:defRPr sz="1050" b="0">
                 <a:solidFill>
                   <a:srgbClr val="F3F0E8"/>
@@ -17427,6 +18375,7 @@
           <a:lstStyle xmlns:a="http://schemas.openxmlformats.org/drawingml/2006/main"/>
           <a:p xmlns:a="http://schemas.openxmlformats.org/drawingml/2006/main">
             <a:pPr>
+              <a:buNone/>
               <a:defRPr sz="1050" b="1">
                 <a:solidFill>
                   <a:srgbClr val="F3F0E8"/>
@@ -17477,6 +18426,7 @@
           <a:lstStyle xmlns:a="http://schemas.openxmlformats.org/drawingml/2006/main"/>
           <a:p xmlns:a="http://schemas.openxmlformats.org/drawingml/2006/main">
             <a:pPr>
+              <a:buNone/>
               <a:defRPr sz="2100" b="1">
                 <a:solidFill>
                   <a:srgbClr val="CCFF00"/>
@@ -17527,6 +18477,7 @@
           <a:lstStyle xmlns:a="http://schemas.openxmlformats.org/drawingml/2006/main"/>
           <a:p xmlns:a="http://schemas.openxmlformats.org/drawingml/2006/main">
             <a:pPr>
+              <a:buNone/>
               <a:defRPr sz="1050" b="0">
                 <a:solidFill>
                   <a:srgbClr val="F3F0E8"/>
@@ -17577,6 +18528,7 @@
           <a:lstStyle xmlns:a="http://schemas.openxmlformats.org/drawingml/2006/main"/>
           <a:p xmlns:a="http://schemas.openxmlformats.org/drawingml/2006/main">
             <a:pPr>
+              <a:buNone/>
               <a:defRPr sz="1125" b="1">
                 <a:solidFill>
                   <a:srgbClr val="F3F0E8"/>
@@ -17627,6 +18579,7 @@
           <a:lstStyle xmlns:a="http://schemas.openxmlformats.org/drawingml/2006/main"/>
           <a:p xmlns:a="http://schemas.openxmlformats.org/drawingml/2006/main">
             <a:pPr>
+              <a:buNone/>
               <a:defRPr sz="900" b="0">
                 <a:solidFill>
                   <a:srgbClr val="F3F0E8"/>
@@ -17914,20 +18867,20 @@
               <a:buNone/>
               <a:defRPr sz="3150" b="1">
                 <a:solidFill>
-                  <a:srgbClr val="F3F0E8"/>
+                  <a:srgbClr val="CCFF00"/>
                 </a:solidFill>
               </a:defRPr>
             </a:pPr>
             <a:r>
               <a:rPr sz="3150" b="1">
                 <a:solidFill>
-                  <a:srgbClr val="F3F0E8"/>
+                  <a:srgbClr val="CCFF00"/>
                 </a:solidFill>
                 <a:latin typeface="Inter"/>
                 <a:ea typeface="Inter"/>
                 <a:cs typeface="Inter"/>
               </a:rPr>
-              <a:t>06</a:t>
+              <a:t>$500k ARR</a:t>
             </a:r>
             <a:endParaRPr sz="2800"/>
           </a:p>
@@ -17983,7 +18936,7 @@
                 <a:ea typeface="IBM Plex Sans"/>
                 <a:cs typeface="IBM Plex Sans"/>
               </a:rPr>
-              <a:t>Platform revenue compounds by fleet; services and flight work stay outside ARR.</a:t>
+              <a:t>Five paid ground / integration accounts can establish the first recurring revenue base.</a:t>
             </a:r>
             <a:endParaRPr sz="1500"/>
           </a:p>
@@ -18024,14 +18977,14 @@
                 <a:spcPct val="100000"/>
               </a:lnSpc>
               <a:buNone/>
-              <a:defRPr>
-                <a:solidFill>
-                  <a:srgbClr val="F3F0E8"/>
-                </a:solidFill>
-              </a:defRPr>
-            </a:pPr>
-            <a:r>
-              <a:rPr sz="800" b="1">
+              <a:defRPr sz="1050" b="1">
+                <a:solidFill>
+                  <a:srgbClr val="F3F0E8"/>
+                </a:solidFill>
+              </a:defRPr>
+            </a:pPr>
+            <a:r>
+              <a:rPr sz="1050" b="1">
                 <a:solidFill>
                   <a:srgbClr val="F3F0E8"/>
                 </a:solidFill>
@@ -18039,7 +18992,7 @@
                 <a:ea typeface="JetBrains Mono"/>
                 <a:cs typeface="JetBrains Mono"/>
               </a:rPr>
-              <a:t>REVENUE STACK</a:t>
+              <a:t>RETURN + OFF-TAKERS</a:t>
             </a:r>
             <a:endParaRPr sz="800"/>
           </a:p>
@@ -18113,7 +19066,7 @@
         </p:xfrm>
         <a:graphic xmlns:a="http://schemas.openxmlformats.org/drawingml/2006/main">
           <a:graphicData uri="http://schemas.openxmlformats.org/drawingml/2006/chart">
-            <c:chart xmlns:r="http://schemas.openxmlformats.org/officeDocument/2006/relationships" xmlns:c="http://schemas.openxmlformats.org/drawingml/2006/chart" r:id="R3d4f65fe5af04bc2"/>
+            <c:chart xmlns:r="http://schemas.openxmlformats.org/officeDocument/2006/relationships" xmlns:c="http://schemas.openxmlformats.org/drawingml/2006/chart" r:id="R59333eb8a6b44bba"/>
           </a:graphicData>
         </a:graphic>
       </p:graphicFrame>
@@ -18143,7 +19096,7 @@
         </p:spPr>
         <p:txBody>
           <a:bodyPr xmlns:a="http://schemas.openxmlformats.org/drawingml/2006/main" wrap="square" lIns="0" tIns="0" rIns="0" bIns="0" anchor="ctr">
-            <a:normAutofit fontScale="100000"/>
+            <a:normAutofit fontScale="60000"/>
           </a:bodyPr>
           <a:lstStyle xmlns:a="http://schemas.openxmlformats.org/drawingml/2006/main"/>
           <a:p xmlns:a="http://schemas.openxmlformats.org/drawingml/2006/main">
@@ -18152,14 +19105,14 @@
                 <a:spcPct val="100000"/>
               </a:lnSpc>
               <a:buNone/>
-              <a:defRPr>
-                <a:solidFill>
-                  <a:srgbClr val="F3F0E8"/>
-                </a:solidFill>
-              </a:defRPr>
-            </a:pPr>
-            <a:r>
-              <a:rPr sz="800">
+              <a:defRPr sz="900">
+                <a:solidFill>
+                  <a:srgbClr val="F3F0E8"/>
+                </a:solidFill>
+              </a:defRPr>
+            </a:pPr>
+            <a:r>
+              <a:rPr sz="900">
                 <a:solidFill>
                   <a:srgbClr val="F3F0E8"/>
                 </a:solidFill>
@@ -18167,7 +19120,32 @@
                 <a:ea typeface="JetBrains Mono"/>
                 <a:cs typeface="JetBrains Mono"/>
               </a:rPr>
-              <a:t>$k ARR / annualized contract value</a:t>
+              <a:t>OFF-TAKERS: mission-control  •  ground-segment  •  systems integrators</a:t>
+            </a:r>
+            <a:endParaRPr sz="800"/>
+          </a:p>
+          <a:p xmlns:a="http://schemas.openxmlformats.org/drawingml/2006/main">
+            <a:pPr marL="0" indent="0" algn="l">
+              <a:lnSpc>
+                <a:spcPct val="100000"/>
+              </a:lnSpc>
+              <a:buNone/>
+              <a:defRPr sz="900">
+                <a:solidFill>
+                  <a:srgbClr val="F3F0E8"/>
+                </a:solidFill>
+              </a:defRPr>
+            </a:pPr>
+            <a:r>
+              <a:rPr sz="900">
+                <a:solidFill>
+                  <a:srgbClr val="F3F0E8"/>
+                </a:solidFill>
+                <a:latin typeface="JetBrains Mono"/>
+                <a:ea typeface="JetBrains Mono"/>
+                <a:cs typeface="JetBrains Mono"/>
+              </a:rPr>
+              <a:t>Planning case; not signed pipeline.</a:t>
             </a:r>
             <a:endParaRPr sz="800"/>
           </a:p>
@@ -19088,7 +20066,7 @@
           <p:nvPr/>
         </p:nvPicPr>
         <p:blipFill>
-          <a:blip xmlns:r="http://schemas.openxmlformats.org/officeDocument/2006/relationships" xmlns:a="http://schemas.openxmlformats.org/drawingml/2006/main" r:embed="R0459d3a67fa44fb7">
+          <a:blip xmlns:r="http://schemas.openxmlformats.org/officeDocument/2006/relationships" xmlns:a="http://schemas.openxmlformats.org/drawingml/2006/main" r:embed="Ra92002365a2a48b6">
             <a:alphaModFix amt="96000"/>
           </a:blip>
           <a:stretch xmlns:a="http://schemas.openxmlformats.org/drawingml/2006/main">
@@ -21082,10 +22060,10 @@
           <p:nvPr/>
         </p:nvPicPr>
         <p:blipFill>
-          <a:blip xmlns:r="http://schemas.openxmlformats.org/officeDocument/2006/relationships" xmlns:a="http://schemas.openxmlformats.org/drawingml/2006/main" r:embed="Rcbe2e47c42194c86">
+          <a:blip xmlns:r="http://schemas.openxmlformats.org/officeDocument/2006/relationships" xmlns:a="http://schemas.openxmlformats.org/drawingml/2006/main" r:embed="R1ad26c5d9a6341e4">
             <a:extLst>
               <a:ext uri="{96DAC541-7B7A-43D3-8B79-37D633B846F1}">
-                <asvg:svgBlip xmlns:asvg="http://schemas.microsoft.com/office/drawing/2016/SVG/main" r:embed="Rd3030c1062d74ae3"/>
+                <asvg:svgBlip xmlns:asvg="http://schemas.microsoft.com/office/drawing/2016/SVG/main" r:embed="R9224cd77207549ca"/>
               </a:ext>
             </a:extLst>
           </a:blip>
@@ -21110,7 +22088,7 @@
           <p:nvPr/>
         </p:nvPicPr>
         <p:blipFill>
-          <a:blip xmlns:r="http://schemas.openxmlformats.org/officeDocument/2006/relationships" xmlns:a="http://schemas.openxmlformats.org/drawingml/2006/main" r:embed="Recedfe1d4da34968"/>
+          <a:blip xmlns:r="http://schemas.openxmlformats.org/officeDocument/2006/relationships" xmlns:a="http://schemas.openxmlformats.org/drawingml/2006/main" r:embed="Rebdaf05e8b564eb1"/>
           <a:stretch xmlns:a="http://schemas.openxmlformats.org/drawingml/2006/main"/>
         </p:blipFill>
         <p:spPr>
@@ -21132,10 +22110,10 @@
           <p:nvPr/>
         </p:nvPicPr>
         <p:blipFill>
-          <a:blip xmlns:r="http://schemas.openxmlformats.org/officeDocument/2006/relationships" xmlns:a="http://schemas.openxmlformats.org/drawingml/2006/main" r:embed="R2ffba623c6984ac7">
+          <a:blip xmlns:r="http://schemas.openxmlformats.org/officeDocument/2006/relationships" xmlns:a="http://schemas.openxmlformats.org/drawingml/2006/main" r:embed="R5bc3d8f25eba448c">
             <a:extLst>
               <a:ext uri="{96DAC541-7B7A-43D3-8B79-37D633B846F1}">
-                <asvg:svgBlip xmlns:asvg="http://schemas.microsoft.com/office/drawing/2016/SVG/main" r:embed="R64982ff9d19b4359"/>
+                <asvg:svgBlip xmlns:asvg="http://schemas.microsoft.com/office/drawing/2016/SVG/main" r:embed="R456a058017b74eec"/>
               </a:ext>
             </a:extLst>
           </a:blip>
@@ -21160,7 +22138,7 @@
           <p:nvPr/>
         </p:nvPicPr>
         <p:blipFill>
-          <a:blip xmlns:r="http://schemas.openxmlformats.org/officeDocument/2006/relationships" xmlns:a="http://schemas.openxmlformats.org/drawingml/2006/main" r:embed="Rbeb8f487327c43c4"/>
+          <a:blip xmlns:r="http://schemas.openxmlformats.org/officeDocument/2006/relationships" xmlns:a="http://schemas.openxmlformats.org/drawingml/2006/main" r:embed="Rcd9785bd26054010"/>
           <a:stretch xmlns:a="http://schemas.openxmlformats.org/drawingml/2006/main"/>
         </p:blipFill>
         <p:spPr>
@@ -21182,10 +22160,10 @@
           <p:nvPr/>
         </p:nvPicPr>
         <p:blipFill>
-          <a:blip xmlns:r="http://schemas.openxmlformats.org/officeDocument/2006/relationships" xmlns:a="http://schemas.openxmlformats.org/drawingml/2006/main" r:embed="R844cb74294114cf6">
+          <a:blip xmlns:r="http://schemas.openxmlformats.org/officeDocument/2006/relationships" xmlns:a="http://schemas.openxmlformats.org/drawingml/2006/main" r:embed="R021a95392fa848e6">
             <a:extLst>
               <a:ext uri="{96DAC541-7B7A-43D3-8B79-37D633B846F1}">
-                <asvg:svgBlip xmlns:asvg="http://schemas.microsoft.com/office/drawing/2016/SVG/main" r:embed="R21ebc349e1de43f0"/>
+                <asvg:svgBlip xmlns:asvg="http://schemas.microsoft.com/office/drawing/2016/SVG/main" r:embed="Rcb1ea9f75e6b4508"/>
               </a:ext>
             </a:extLst>
           </a:blip>
@@ -21210,10 +22188,10 @@
           <p:nvPr/>
         </p:nvPicPr>
         <p:blipFill>
-          <a:blip xmlns:r="http://schemas.openxmlformats.org/officeDocument/2006/relationships" xmlns:a="http://schemas.openxmlformats.org/drawingml/2006/main" r:embed="Recedfe1d4da34968">
+          <a:blip xmlns:r="http://schemas.openxmlformats.org/officeDocument/2006/relationships" xmlns:a="http://schemas.openxmlformats.org/drawingml/2006/main" r:embed="Rebdaf05e8b564eb1">
             <a:extLst>
               <a:ext uri="{96DAC541-7B7A-43D3-8B79-37D633B846F1}">
-                <asvg:svgBlip xmlns:asvg="http://schemas.microsoft.com/office/drawing/2016/SVG/main" r:embed="Rbfcd114a136a4b6a"/>
+                <asvg:svgBlip xmlns:asvg="http://schemas.microsoft.com/office/drawing/2016/SVG/main" r:embed="Raad2f42d402b4907"/>
               </a:ext>
             </a:extLst>
           </a:blip>
@@ -21238,10 +22216,10 @@
           <p:nvPr/>
         </p:nvPicPr>
         <p:blipFill>
-          <a:blip xmlns:r="http://schemas.openxmlformats.org/officeDocument/2006/relationships" xmlns:a="http://schemas.openxmlformats.org/drawingml/2006/main" r:embed="Rbeb8f487327c43c4">
+          <a:blip xmlns:r="http://schemas.openxmlformats.org/officeDocument/2006/relationships" xmlns:a="http://schemas.openxmlformats.org/drawingml/2006/main" r:embed="Rcd9785bd26054010">
             <a:extLst>
               <a:ext uri="{96DAC541-7B7A-43D3-8B79-37D633B846F1}">
-                <asvg:svgBlip xmlns:asvg="http://schemas.microsoft.com/office/drawing/2016/SVG/main" r:embed="Rfdaa533aaeda4696"/>
+                <asvg:svgBlip xmlns:asvg="http://schemas.microsoft.com/office/drawing/2016/SVG/main" r:embed="R6bb7e10180df45e7"/>
               </a:ext>
             </a:extLst>
           </a:blip>
@@ -21266,7 +22244,7 @@
           <p:nvPr/>
         </p:nvPicPr>
         <p:blipFill>
-          <a:blip xmlns:r="http://schemas.openxmlformats.org/officeDocument/2006/relationships" xmlns:a="http://schemas.openxmlformats.org/drawingml/2006/main" r:embed="R17310f699b5d4438"/>
+          <a:blip xmlns:r="http://schemas.openxmlformats.org/officeDocument/2006/relationships" xmlns:a="http://schemas.openxmlformats.org/drawingml/2006/main" r:embed="Rab17bc85b2be447f"/>
           <a:stretch xmlns:a="http://schemas.openxmlformats.org/drawingml/2006/main"/>
         </p:blipFill>
         <p:spPr>
@@ -21288,10 +22266,10 @@
           <p:nvPr/>
         </p:nvPicPr>
         <p:blipFill>
-          <a:blip xmlns:r="http://schemas.openxmlformats.org/officeDocument/2006/relationships" xmlns:a="http://schemas.openxmlformats.org/drawingml/2006/main" r:embed="R17310f699b5d4438">
+          <a:blip xmlns:r="http://schemas.openxmlformats.org/officeDocument/2006/relationships" xmlns:a="http://schemas.openxmlformats.org/drawingml/2006/main" r:embed="Rab17bc85b2be447f">
             <a:extLst>
               <a:ext uri="{96DAC541-7B7A-43D3-8B79-37D633B846F1}">
-                <asvg:svgBlip xmlns:asvg="http://schemas.microsoft.com/office/drawing/2016/SVG/main" r:embed="R4ec4e0fc22a942e8"/>
+                <asvg:svgBlip xmlns:asvg="http://schemas.microsoft.com/office/drawing/2016/SVG/main" r:embed="R0262aa8bf7ae4e10"/>
               </a:ext>
             </a:extLst>
           </a:blip>
@@ -21316,7 +22294,7 @@
           <p:nvPr/>
         </p:nvPicPr>
         <p:blipFill>
-          <a:blip xmlns:r="http://schemas.openxmlformats.org/officeDocument/2006/relationships" xmlns:a="http://schemas.openxmlformats.org/drawingml/2006/main" r:embed="Rd0676fa751554e3d"/>
+          <a:blip xmlns:r="http://schemas.openxmlformats.org/officeDocument/2006/relationships" xmlns:a="http://schemas.openxmlformats.org/drawingml/2006/main" r:embed="Rf7eb9e38aa654188"/>
           <a:stretch xmlns:a="http://schemas.openxmlformats.org/drawingml/2006/main"/>
         </p:blipFill>
         <p:spPr>
@@ -21338,10 +22316,10 @@
           <p:nvPr/>
         </p:nvPicPr>
         <p:blipFill>
-          <a:blip xmlns:r="http://schemas.openxmlformats.org/officeDocument/2006/relationships" xmlns:a="http://schemas.openxmlformats.org/drawingml/2006/main" r:embed="Rd0676fa751554e3d">
+          <a:blip xmlns:r="http://schemas.openxmlformats.org/officeDocument/2006/relationships" xmlns:a="http://schemas.openxmlformats.org/drawingml/2006/main" r:embed="Rf7eb9e38aa654188">
             <a:extLst>
               <a:ext uri="{96DAC541-7B7A-43D3-8B79-37D633B846F1}">
-                <asvg:svgBlip xmlns:asvg="http://schemas.microsoft.com/office/drawing/2016/SVG/main" r:embed="Reb4d3da1acc545d7"/>
+                <asvg:svgBlip xmlns:asvg="http://schemas.microsoft.com/office/drawing/2016/SVG/main" r:embed="R7e83a6e623804f2f"/>
               </a:ext>
             </a:extLst>
           </a:blip>
@@ -21366,10 +22344,10 @@
           <p:nvPr/>
         </p:nvPicPr>
         <p:blipFill>
-          <a:blip xmlns:r="http://schemas.openxmlformats.org/officeDocument/2006/relationships" xmlns:a="http://schemas.openxmlformats.org/drawingml/2006/main" r:embed="R14b365d2cf444d8d">
+          <a:blip xmlns:r="http://schemas.openxmlformats.org/officeDocument/2006/relationships" xmlns:a="http://schemas.openxmlformats.org/drawingml/2006/main" r:embed="Rf91c26f344c3426d">
             <a:extLst>
               <a:ext uri="{96DAC541-7B7A-43D3-8B79-37D633B846F1}">
-                <asvg:svgBlip xmlns:asvg="http://schemas.microsoft.com/office/drawing/2016/SVG/main" r:embed="R4982098a30e546df"/>
+                <asvg:svgBlip xmlns:asvg="http://schemas.microsoft.com/office/drawing/2016/SVG/main" r:embed="Rc574c069d05f4d24"/>
               </a:ext>
             </a:extLst>
           </a:blip>
@@ -21394,10 +22372,10 @@
           <p:nvPr/>
         </p:nvPicPr>
         <p:blipFill>
-          <a:blip xmlns:r="http://schemas.openxmlformats.org/officeDocument/2006/relationships" xmlns:a="http://schemas.openxmlformats.org/drawingml/2006/main" r:embed="R0dbe28f6459c4d98">
+          <a:blip xmlns:r="http://schemas.openxmlformats.org/officeDocument/2006/relationships" xmlns:a="http://schemas.openxmlformats.org/drawingml/2006/main" r:embed="R023a4da59c3b44df">
             <a:extLst>
               <a:ext uri="{96DAC541-7B7A-43D3-8B79-37D633B846F1}">
-                <asvg:svgBlip xmlns:asvg="http://schemas.microsoft.com/office/drawing/2016/SVG/main" r:embed="R58a075af0a344b82"/>
+                <asvg:svgBlip xmlns:asvg="http://schemas.microsoft.com/office/drawing/2016/SVG/main" r:embed="R605b8b7dc6514fcf"/>
               </a:ext>
             </a:extLst>
           </a:blip>
@@ -21422,7 +22400,7 @@
           <p:nvPr/>
         </p:nvPicPr>
         <p:blipFill>
-          <a:blip xmlns:r="http://schemas.openxmlformats.org/officeDocument/2006/relationships" xmlns:a="http://schemas.openxmlformats.org/drawingml/2006/main" r:embed="Rdcc81b4250654980"/>
+          <a:blip xmlns:r="http://schemas.openxmlformats.org/officeDocument/2006/relationships" xmlns:a="http://schemas.openxmlformats.org/drawingml/2006/main" r:embed="R8eb44ef50215408e"/>
           <a:stretch xmlns:a="http://schemas.openxmlformats.org/drawingml/2006/main"/>
         </p:blipFill>
         <p:spPr>
@@ -21444,10 +22422,10 @@
           <p:nvPr/>
         </p:nvPicPr>
         <p:blipFill>
-          <a:blip xmlns:r="http://schemas.openxmlformats.org/officeDocument/2006/relationships" xmlns:a="http://schemas.openxmlformats.org/drawingml/2006/main" r:embed="Rdcc81b4250654980">
+          <a:blip xmlns:r="http://schemas.openxmlformats.org/officeDocument/2006/relationships" xmlns:a="http://schemas.openxmlformats.org/drawingml/2006/main" r:embed="R8eb44ef50215408e">
             <a:extLst>
               <a:ext uri="{96DAC541-7B7A-43D3-8B79-37D633B846F1}">
-                <asvg:svgBlip xmlns:asvg="http://schemas.microsoft.com/office/drawing/2016/SVG/main" r:embed="R187756525976432a"/>
+                <asvg:svgBlip xmlns:asvg="http://schemas.microsoft.com/office/drawing/2016/SVG/main" r:embed="R97d4ac630fec4a8e"/>
               </a:ext>
             </a:extLst>
           </a:blip>
@@ -21472,7 +22450,7 @@
           <p:nvPr/>
         </p:nvPicPr>
         <p:blipFill>
-          <a:blip xmlns:r="http://schemas.openxmlformats.org/officeDocument/2006/relationships" xmlns:a="http://schemas.openxmlformats.org/drawingml/2006/main" r:embed="R3cf464c1fbc64dec"/>
+          <a:blip xmlns:r="http://schemas.openxmlformats.org/officeDocument/2006/relationships" xmlns:a="http://schemas.openxmlformats.org/drawingml/2006/main" r:embed="Ra98ef0780eff47dd"/>
           <a:stretch xmlns:a="http://schemas.openxmlformats.org/drawingml/2006/main"/>
         </p:blipFill>
         <p:spPr>
@@ -21494,10 +22472,10 @@
           <p:nvPr/>
         </p:nvPicPr>
         <p:blipFill>
-          <a:blip xmlns:r="http://schemas.openxmlformats.org/officeDocument/2006/relationships" xmlns:a="http://schemas.openxmlformats.org/drawingml/2006/main" r:embed="R3cf464c1fbc64dec">
+          <a:blip xmlns:r="http://schemas.openxmlformats.org/officeDocument/2006/relationships" xmlns:a="http://schemas.openxmlformats.org/drawingml/2006/main" r:embed="Ra98ef0780eff47dd">
             <a:extLst>
               <a:ext uri="{96DAC541-7B7A-43D3-8B79-37D633B846F1}">
-                <asvg:svgBlip xmlns:asvg="http://schemas.microsoft.com/office/drawing/2016/SVG/main" r:embed="Rb0c18d8d216a4348"/>
+                <asvg:svgBlip xmlns:asvg="http://schemas.microsoft.com/office/drawing/2016/SVG/main" r:embed="R00b049adb24c464d"/>
               </a:ext>
             </a:extLst>
           </a:blip>
@@ -21522,10 +22500,10 @@
           <p:nvPr/>
         </p:nvPicPr>
         <p:blipFill>
-          <a:blip xmlns:r="http://schemas.openxmlformats.org/officeDocument/2006/relationships" xmlns:a="http://schemas.openxmlformats.org/drawingml/2006/main" r:embed="R6938a1400e9a4df7">
+          <a:blip xmlns:r="http://schemas.openxmlformats.org/officeDocument/2006/relationships" xmlns:a="http://schemas.openxmlformats.org/drawingml/2006/main" r:embed="R0734a0a83a59495b">
             <a:extLst>
               <a:ext uri="{96DAC541-7B7A-43D3-8B79-37D633B846F1}">
-                <asvg:svgBlip xmlns:asvg="http://schemas.microsoft.com/office/drawing/2016/SVG/main" r:embed="R846458a980c240b7"/>
+                <asvg:svgBlip xmlns:asvg="http://schemas.microsoft.com/office/drawing/2016/SVG/main" r:embed="R0795dc343c4d4dce"/>
               </a:ext>
             </a:extLst>
           </a:blip>
@@ -21550,10 +22528,10 @@
           <p:nvPr/>
         </p:nvPicPr>
         <p:blipFill>
-          <a:blip xmlns:r="http://schemas.openxmlformats.org/officeDocument/2006/relationships" xmlns:a="http://schemas.openxmlformats.org/drawingml/2006/main" r:embed="Rb6aa8419ea41466a">
+          <a:blip xmlns:r="http://schemas.openxmlformats.org/officeDocument/2006/relationships" xmlns:a="http://schemas.openxmlformats.org/drawingml/2006/main" r:embed="R94eaefaa299b4b9b">
             <a:extLst>
               <a:ext uri="{96DAC541-7B7A-43D3-8B79-37D633B846F1}">
-                <asvg:svgBlip xmlns:asvg="http://schemas.microsoft.com/office/drawing/2016/SVG/main" r:embed="R43b50f847c1a4109"/>
+                <asvg:svgBlip xmlns:asvg="http://schemas.microsoft.com/office/drawing/2016/SVG/main" r:embed="R9f29a5c721f546c4"/>
               </a:ext>
             </a:extLst>
           </a:blip>
@@ -21578,7 +22556,7 @@
           <p:nvPr/>
         </p:nvPicPr>
         <p:blipFill>
-          <a:blip xmlns:r="http://schemas.openxmlformats.org/officeDocument/2006/relationships" xmlns:a="http://schemas.openxmlformats.org/drawingml/2006/main" r:embed="R25e3b9c574a44455"/>
+          <a:blip xmlns:r="http://schemas.openxmlformats.org/officeDocument/2006/relationships" xmlns:a="http://schemas.openxmlformats.org/drawingml/2006/main" r:embed="R8f44c3db6ce04ec8"/>
           <a:stretch xmlns:a="http://schemas.openxmlformats.org/drawingml/2006/main"/>
         </p:blipFill>
         <p:spPr>
@@ -21600,10 +22578,10 @@
           <p:nvPr/>
         </p:nvPicPr>
         <p:blipFill>
-          <a:blip xmlns:r="http://schemas.openxmlformats.org/officeDocument/2006/relationships" xmlns:a="http://schemas.openxmlformats.org/drawingml/2006/main" r:embed="R25e3b9c574a44455">
+          <a:blip xmlns:r="http://schemas.openxmlformats.org/officeDocument/2006/relationships" xmlns:a="http://schemas.openxmlformats.org/drawingml/2006/main" r:embed="R8f44c3db6ce04ec8">
             <a:extLst>
               <a:ext uri="{96DAC541-7B7A-43D3-8B79-37D633B846F1}">
-                <asvg:svgBlip xmlns:asvg="http://schemas.microsoft.com/office/drawing/2016/SVG/main" r:embed="Rcea6293c49764241"/>
+                <asvg:svgBlip xmlns:asvg="http://schemas.microsoft.com/office/drawing/2016/SVG/main" r:embed="Re12d21012e75439d"/>
               </a:ext>
             </a:extLst>
           </a:blip>
@@ -21628,7 +22606,7 @@
           <p:nvPr/>
         </p:nvPicPr>
         <p:blipFill>
-          <a:blip xmlns:r="http://schemas.openxmlformats.org/officeDocument/2006/relationships" xmlns:a="http://schemas.openxmlformats.org/drawingml/2006/main" r:embed="R6c3c52e64d1f4ab5"/>
+          <a:blip xmlns:r="http://schemas.openxmlformats.org/officeDocument/2006/relationships" xmlns:a="http://schemas.openxmlformats.org/drawingml/2006/main" r:embed="Rb09e17e3cdcf4d91"/>
           <a:stretch xmlns:a="http://schemas.openxmlformats.org/drawingml/2006/main"/>
         </p:blipFill>
         <p:spPr>
@@ -21650,10 +22628,10 @@
           <p:nvPr/>
         </p:nvPicPr>
         <p:blipFill>
-          <a:blip xmlns:r="http://schemas.openxmlformats.org/officeDocument/2006/relationships" xmlns:a="http://schemas.openxmlformats.org/drawingml/2006/main" r:embed="R6c3c52e64d1f4ab5">
+          <a:blip xmlns:r="http://schemas.openxmlformats.org/officeDocument/2006/relationships" xmlns:a="http://schemas.openxmlformats.org/drawingml/2006/main" r:embed="Rb09e17e3cdcf4d91">
             <a:extLst>
               <a:ext uri="{96DAC541-7B7A-43D3-8B79-37D633B846F1}">
-                <asvg:svgBlip xmlns:asvg="http://schemas.microsoft.com/office/drawing/2016/SVG/main" r:embed="R32b9a982e63048b6"/>
+                <asvg:svgBlip xmlns:asvg="http://schemas.microsoft.com/office/drawing/2016/SVG/main" r:embed="R7c014326f22c4686"/>
               </a:ext>
             </a:extLst>
           </a:blip>
@@ -21678,10 +22656,10 @@
           <p:nvPr/>
         </p:nvPicPr>
         <p:blipFill>
-          <a:blip xmlns:r="http://schemas.openxmlformats.org/officeDocument/2006/relationships" xmlns:a="http://schemas.openxmlformats.org/drawingml/2006/main" r:embed="R178243e0ee104e55">
+          <a:blip xmlns:r="http://schemas.openxmlformats.org/officeDocument/2006/relationships" xmlns:a="http://schemas.openxmlformats.org/drawingml/2006/main" r:embed="Rf57ae2c91f7e4eaf">
             <a:extLst>
               <a:ext uri="{96DAC541-7B7A-43D3-8B79-37D633B846F1}">
-                <asvg:svgBlip xmlns:asvg="http://schemas.microsoft.com/office/drawing/2016/SVG/main" r:embed="R8e1b310978964ec4"/>
+                <asvg:svgBlip xmlns:asvg="http://schemas.microsoft.com/office/drawing/2016/SVG/main" r:embed="Rfc44bff6ed2b492e"/>
               </a:ext>
             </a:extLst>
           </a:blip>
@@ -22077,7 +23055,7 @@
           <p:nvPr/>
         </p:nvPicPr>
         <p:blipFill>
-          <a:blip xmlns:r="http://schemas.openxmlformats.org/officeDocument/2006/relationships" xmlns:a="http://schemas.openxmlformats.org/drawingml/2006/main" r:embed="R956b87fb44334dbf"/>
+          <a:blip xmlns:r="http://schemas.openxmlformats.org/officeDocument/2006/relationships" xmlns:a="http://schemas.openxmlformats.org/drawingml/2006/main" r:embed="R1609c926854b47d1"/>
           <a:stretch xmlns:a="http://schemas.openxmlformats.org/drawingml/2006/main"/>
         </p:blipFill>
         <p:spPr>
@@ -22134,7 +23112,7 @@
           <p:nvPr/>
         </p:nvPicPr>
         <p:blipFill>
-          <a:blip xmlns:r="http://schemas.openxmlformats.org/officeDocument/2006/relationships" xmlns:a="http://schemas.openxmlformats.org/drawingml/2006/main" r:embed="R9145db3977f44cfa"/>
+          <a:blip xmlns:r="http://schemas.openxmlformats.org/officeDocument/2006/relationships" xmlns:a="http://schemas.openxmlformats.org/drawingml/2006/main" r:embed="R89d210e2d9b14c78"/>
           <a:stretch xmlns:a="http://schemas.openxmlformats.org/drawingml/2006/main"/>
         </p:blipFill>
         <p:spPr>
@@ -22191,7 +23169,7 @@
           <p:nvPr/>
         </p:nvPicPr>
         <p:blipFill>
-          <a:blip xmlns:r="http://schemas.openxmlformats.org/officeDocument/2006/relationships" xmlns:a="http://schemas.openxmlformats.org/drawingml/2006/main" r:embed="Ra2c6554b34d342ca"/>
+          <a:blip xmlns:r="http://schemas.openxmlformats.org/officeDocument/2006/relationships" xmlns:a="http://schemas.openxmlformats.org/drawingml/2006/main" r:embed="Re7ce67b17f36417e"/>
           <a:stretch xmlns:a="http://schemas.openxmlformats.org/drawingml/2006/main"/>
         </p:blipFill>
         <p:spPr>
@@ -22248,7 +23226,7 @@
           <p:nvPr/>
         </p:nvPicPr>
         <p:blipFill>
-          <a:blip xmlns:r="http://schemas.openxmlformats.org/officeDocument/2006/relationships" xmlns:a="http://schemas.openxmlformats.org/drawingml/2006/main" r:embed="R63a6a890d1114d60"/>
+          <a:blip xmlns:r="http://schemas.openxmlformats.org/officeDocument/2006/relationships" xmlns:a="http://schemas.openxmlformats.org/drawingml/2006/main" r:embed="R10fd4bfebac043f5"/>
           <a:stretch xmlns:a="http://schemas.openxmlformats.org/drawingml/2006/main"/>
         </p:blipFill>
         <p:spPr>
@@ -22305,7 +23283,7 @@
           <p:nvPr/>
         </p:nvPicPr>
         <p:blipFill>
-          <a:blip xmlns:r="http://schemas.openxmlformats.org/officeDocument/2006/relationships" xmlns:a="http://schemas.openxmlformats.org/drawingml/2006/main" r:embed="R49dd7f6b2a5e4d59"/>
+          <a:blip xmlns:r="http://schemas.openxmlformats.org/officeDocument/2006/relationships" xmlns:a="http://schemas.openxmlformats.org/drawingml/2006/main" r:embed="Rc6076f242b824c91"/>
           <a:stretch xmlns:a="http://schemas.openxmlformats.org/drawingml/2006/main"/>
         </p:blipFill>
         <p:spPr>
@@ -22362,7 +23340,7 @@
           <p:nvPr/>
         </p:nvPicPr>
         <p:blipFill>
-          <a:blip xmlns:r="http://schemas.openxmlformats.org/officeDocument/2006/relationships" xmlns:a="http://schemas.openxmlformats.org/drawingml/2006/main" r:embed="R25d4095b80fd483d"/>
+          <a:blip xmlns:r="http://schemas.openxmlformats.org/officeDocument/2006/relationships" xmlns:a="http://schemas.openxmlformats.org/drawingml/2006/main" r:embed="Rce87d06a77b5484c"/>
           <a:stretch xmlns:a="http://schemas.openxmlformats.org/drawingml/2006/main"/>
         </p:blipFill>
         <p:spPr>
@@ -22499,7 +23477,7 @@
           <p:nvPr/>
         </p:nvPicPr>
         <p:blipFill>
-          <a:blip xmlns:r="http://schemas.openxmlformats.org/officeDocument/2006/relationships" xmlns:a="http://schemas.openxmlformats.org/drawingml/2006/main" r:embed="Rdead1da6bf614064">
+          <a:blip xmlns:r="http://schemas.openxmlformats.org/officeDocument/2006/relationships" xmlns:a="http://schemas.openxmlformats.org/drawingml/2006/main" r:embed="R6885221264bc44a8">
             <a:alphaModFix amt="96000"/>
           </a:blip>
           <a:stretch xmlns:a="http://schemas.openxmlformats.org/drawingml/2006/main">

</xml_diff>

<commit_message>
Tighten deck spacing and alignment
</commit_message>
<xml_diff>
--- a/reports/presentation/Gauss_Aurora_Investor_Deck_pptxgenjs.pptx
+++ b/reports/presentation/Gauss_Aurora_Investor_Deck_pptxgenjs.pptx
@@ -2,23 +2,23 @@
 <file path=ppt/presentation.xml><?xml version="1.0" encoding="utf-8"?>
 <p:presentation xmlns:p="http://schemas.openxmlformats.org/presentationml/2006/main">
   <p:sldMasterIdLst>
-    <p:sldMasterId xmlns:r="http://schemas.openxmlformats.org/officeDocument/2006/relationships" id="2147483648" r:id="Rb6b89e5f35f042a8"/>
+    <p:sldMasterId xmlns:r="http://schemas.openxmlformats.org/officeDocument/2006/relationships" id="2147483648" r:id="R6bb361dec8f348e5"/>
   </p:sldMasterIdLst>
   <p:notesMasterIdLst>
-    <p:notesMasterId xmlns:r="http://schemas.openxmlformats.org/officeDocument/2006/relationships" r:id="R631121548f634e58"/>
+    <p:notesMasterId xmlns:r="http://schemas.openxmlformats.org/officeDocument/2006/relationships" r:id="R1322bb4a336c4462"/>
   </p:notesMasterIdLst>
   <p:sldIdLst>
-    <p:sldId xmlns:r="http://schemas.openxmlformats.org/officeDocument/2006/relationships" id="256" r:id="Rc2a836aa18f243c8"/>
-    <p:sldId xmlns:r="http://schemas.openxmlformats.org/officeDocument/2006/relationships" id="257" r:id="R48df2ee38d5b4d9a"/>
-    <p:sldId xmlns:r="http://schemas.openxmlformats.org/officeDocument/2006/relationships" id="258" r:id="Rf0cce12c19ac4ca1"/>
-    <p:sldId xmlns:r="http://schemas.openxmlformats.org/officeDocument/2006/relationships" id="259" r:id="Rb89ee2f7a1bf4579"/>
-    <p:sldId xmlns:r="http://schemas.openxmlformats.org/officeDocument/2006/relationships" id="260" r:id="R2f168ac0b1c749c5"/>
-    <p:sldId xmlns:r="http://schemas.openxmlformats.org/officeDocument/2006/relationships" id="261" r:id="Rfb06b9cb31f1434f"/>
-    <p:sldId xmlns:r="http://schemas.openxmlformats.org/officeDocument/2006/relationships" id="262" r:id="Rdd2cc8ed9c0543f1"/>
-    <p:sldId xmlns:r="http://schemas.openxmlformats.org/officeDocument/2006/relationships" id="263" r:id="R5640c51fa33a435d"/>
-    <p:sldId xmlns:r="http://schemas.openxmlformats.org/officeDocument/2006/relationships" id="264" r:id="Rb47ccb90006a4158"/>
-    <p:sldId xmlns:r="http://schemas.openxmlformats.org/officeDocument/2006/relationships" id="265" r:id="R0c27a33260954444"/>
-    <p:sldId xmlns:r="http://schemas.openxmlformats.org/officeDocument/2006/relationships" id="266" r:id="R0b5bee59ff184ad1"/>
+    <p:sldId xmlns:r="http://schemas.openxmlformats.org/officeDocument/2006/relationships" id="256" r:id="R306abda21794449e"/>
+    <p:sldId xmlns:r="http://schemas.openxmlformats.org/officeDocument/2006/relationships" id="257" r:id="R1e732858117848ef"/>
+    <p:sldId xmlns:r="http://schemas.openxmlformats.org/officeDocument/2006/relationships" id="258" r:id="Re837efe40fab4fbf"/>
+    <p:sldId xmlns:r="http://schemas.openxmlformats.org/officeDocument/2006/relationships" id="259" r:id="R3ab192cfc73d4479"/>
+    <p:sldId xmlns:r="http://schemas.openxmlformats.org/officeDocument/2006/relationships" id="260" r:id="Rb4e32b80f162410b"/>
+    <p:sldId xmlns:r="http://schemas.openxmlformats.org/officeDocument/2006/relationships" id="261" r:id="Rcc81e98d22c74f80"/>
+    <p:sldId xmlns:r="http://schemas.openxmlformats.org/officeDocument/2006/relationships" id="262" r:id="Rd79710785c834c8c"/>
+    <p:sldId xmlns:r="http://schemas.openxmlformats.org/officeDocument/2006/relationships" id="263" r:id="R626a9276e90b4afd"/>
+    <p:sldId xmlns:r="http://schemas.openxmlformats.org/officeDocument/2006/relationships" id="264" r:id="R9709c6761c1747d4"/>
+    <p:sldId xmlns:r="http://schemas.openxmlformats.org/officeDocument/2006/relationships" id="265" r:id="R2cdad82d465e4318"/>
+    <p:sldId xmlns:r="http://schemas.openxmlformats.org/officeDocument/2006/relationships" id="266" r:id="R86e2cd2033b34bfc"/>
   </p:sldIdLst>
   <p:sldSz cx="12192000" cy="6858000"/>
   <p:notesSz cx="6858000" cy="9144000"/>
@@ -1719,8 +1719,8 @@
   </p:cSld>
   <p:clrMap bg1="lt1" tx1="dk1" bg2="lt2" tx2="dk2" accent1="accent1" accent2="accent2" accent3="accent3" accent4="accent4" accent5="accent5" accent6="accent6" hlink="hlink" folHlink="folHlink"/>
   <p:sldLayoutIdLst>
-    <p:sldLayoutId xmlns:r="http://schemas.openxmlformats.org/officeDocument/2006/relationships" id="2147483649" r:id="R3be761711cd14fb2"/>
-    <p:sldLayoutId xmlns:r="http://schemas.openxmlformats.org/officeDocument/2006/relationships" id="2147483650" r:id="R8ea7d5d1cd5f4836"/>
+    <p:sldLayoutId xmlns:r="http://schemas.openxmlformats.org/officeDocument/2006/relationships" id="2147483649" r:id="Rabdfc21eaf4b42ed"/>
+    <p:sldLayoutId xmlns:r="http://schemas.openxmlformats.org/officeDocument/2006/relationships" id="2147483650" r:id="R0b4596ca3f394de3"/>
   </p:sldLayoutIdLst>
   <p:hf sldNum="0" hdr="0" ftr="0" dt="0"/>
   <p:txStyles>
@@ -2749,7 +2749,7 @@
           <p:nvPr/>
         </p:nvPicPr>
         <p:blipFill>
-          <a:blip xmlns:r="http://schemas.openxmlformats.org/officeDocument/2006/relationships" xmlns:a="http://schemas.openxmlformats.org/drawingml/2006/main" r:embed="Re7b070048a3445d8"/>
+          <a:blip xmlns:r="http://schemas.openxmlformats.org/officeDocument/2006/relationships" xmlns:a="http://schemas.openxmlformats.org/drawingml/2006/main" r:embed="Rd6bc098402c64622"/>
           <a:srcRect xmlns:a="http://schemas.openxmlformats.org/drawingml/2006/main" l="0" t="4999" r="0" b="4999"/>
           <a:stretch xmlns:a="http://schemas.openxmlformats.org/drawingml/2006/main">
             <a:fillRect l="0" t="0" r="0" b="0"/>
@@ -3468,7 +3468,7 @@
           <p:nvPr/>
         </p:nvPicPr>
         <p:blipFill>
-          <a:blip xmlns:r="http://schemas.openxmlformats.org/officeDocument/2006/relationships" xmlns:a="http://schemas.openxmlformats.org/drawingml/2006/main" r:embed="Re4d18b7f556b41af"/>
+          <a:blip xmlns:r="http://schemas.openxmlformats.org/officeDocument/2006/relationships" xmlns:a="http://schemas.openxmlformats.org/drawingml/2006/main" r:embed="R05ace83cc9f94580"/>
           <a:stretch xmlns:a="http://schemas.openxmlformats.org/drawingml/2006/main">
             <a:fillRect l="0" t="0" r="0" b="0"/>
           </a:stretch>
@@ -3671,7 +3671,7 @@
         <p:spPr>
           <a:xfrm xmlns:a="http://schemas.openxmlformats.org/drawingml/2006/main">
             <a:off x="749808" y="3493008"/>
-            <a:ext cx="2194560" cy="146304"/>
+            <a:ext cx="2476500" cy="171450"/>
           </a:xfrm>
           <a:prstGeom xmlns:a="http://schemas.openxmlformats.org/drawingml/2006/main" prst="rect">
             <a:avLst/>
@@ -3680,7 +3680,7 @@
         </p:spPr>
         <p:txBody>
           <a:bodyPr xmlns:a="http://schemas.openxmlformats.org/drawingml/2006/main" wrap="square" lIns="0" tIns="0" rIns="0" bIns="0" anchor="ctr">
-            <a:normAutofit fontScale="90989"/>
+            <a:normAutofit fontScale="100000"/>
           </a:bodyPr>
           <a:lstStyle xmlns:a="http://schemas.openxmlformats.org/drawingml/2006/main"/>
           <a:p xmlns:a="http://schemas.openxmlformats.org/drawingml/2006/main">
@@ -3704,7 +3704,7 @@
                 <a:ea typeface="JetBrains Mono"/>
                 <a:cs typeface="JetBrains Mono"/>
               </a:rPr>
-              <a:t>PURPOSE  /  USE OF FUNDS  /  $1.5M</a:t>
+              <a:t>PURPOSE / USE OF FUNDS</a:t>
             </a:r>
             <a:endParaRPr sz="800"/>
           </a:p>
@@ -4968,7 +4968,7 @@
           <p:nvPr/>
         </p:nvPicPr>
         <p:blipFill>
-          <a:blip xmlns:r="http://schemas.openxmlformats.org/officeDocument/2006/relationships" xmlns:a="http://schemas.openxmlformats.org/drawingml/2006/main" r:embed="R6389500a4022421e">
+          <a:blip xmlns:r="http://schemas.openxmlformats.org/officeDocument/2006/relationships" xmlns:a="http://schemas.openxmlformats.org/drawingml/2006/main" r:embed="R73ed4b20b8fe4d74">
             <a:alphaModFix amt="96000"/>
           </a:blip>
           <a:stretch xmlns:a="http://schemas.openxmlformats.org/drawingml/2006/main">
@@ -8221,7 +8221,7 @@
           <p:nvPr/>
         </p:nvPicPr>
         <p:blipFill>
-          <a:blip xmlns:r="http://schemas.openxmlformats.org/officeDocument/2006/relationships" xmlns:a="http://schemas.openxmlformats.org/drawingml/2006/main" r:embed="R7228f170a9c549b2"/>
+          <a:blip xmlns:r="http://schemas.openxmlformats.org/officeDocument/2006/relationships" xmlns:a="http://schemas.openxmlformats.org/drawingml/2006/main" r:embed="R73f497fba5da4ea5"/>
           <a:srcRect xmlns:a="http://schemas.openxmlformats.org/drawingml/2006/main" l="9091" t="0" r="9091" b="0"/>
           <a:stretch xmlns:a="http://schemas.openxmlformats.org/drawingml/2006/main">
             <a:fillRect l="0" t="0" r="0" b="0"/>
@@ -9350,7 +9350,7 @@
           <p:nvPr/>
         </p:nvPicPr>
         <p:blipFill>
-          <a:blip xmlns:r="http://schemas.openxmlformats.org/officeDocument/2006/relationships" xmlns:a="http://schemas.openxmlformats.org/drawingml/2006/main" r:embed="R92174d41ce7c416b"/>
+          <a:blip xmlns:r="http://schemas.openxmlformats.org/officeDocument/2006/relationships" xmlns:a="http://schemas.openxmlformats.org/drawingml/2006/main" r:embed="R6659f67dd304456e"/>
           <a:srcRect xmlns:a="http://schemas.openxmlformats.org/drawingml/2006/main" l="2676" t="0" r="2676" b="0"/>
           <a:stretch xmlns:a="http://schemas.openxmlformats.org/drawingml/2006/main">
             <a:fillRect l="0" t="0" r="0" b="0"/>
@@ -12058,7 +12058,7 @@
           <p:nvPr/>
         </p:nvPicPr>
         <p:blipFill>
-          <a:blip xmlns:r="http://schemas.openxmlformats.org/officeDocument/2006/relationships" xmlns:a="http://schemas.openxmlformats.org/drawingml/2006/main" r:embed="Rde50a615cd084caa">
+          <a:blip xmlns:r="http://schemas.openxmlformats.org/officeDocument/2006/relationships" xmlns:a="http://schemas.openxmlformats.org/drawingml/2006/main" r:embed="Rb5160c1fdcb94eb9">
             <a:alphaModFix amt="96000"/>
           </a:blip>
           <a:stretch xmlns:a="http://schemas.openxmlformats.org/drawingml/2006/main">
@@ -14596,7 +14596,7 @@
           <p:nvPr/>
         </p:nvPicPr>
         <p:blipFill>
-          <a:blip xmlns:r="http://schemas.openxmlformats.org/officeDocument/2006/relationships" xmlns:a="http://schemas.openxmlformats.org/drawingml/2006/main" r:embed="R4baafe3570304564">
+          <a:blip xmlns:r="http://schemas.openxmlformats.org/officeDocument/2006/relationships" xmlns:a="http://schemas.openxmlformats.org/drawingml/2006/main" r:embed="Ra5a0ff9a24a54ff5">
             <a:alphaModFix amt="96000"/>
           </a:blip>
           <a:stretch xmlns:a="http://schemas.openxmlformats.org/drawingml/2006/main">
@@ -19066,7 +19066,7 @@
         </p:xfrm>
         <a:graphic xmlns:a="http://schemas.openxmlformats.org/drawingml/2006/main">
           <a:graphicData uri="http://schemas.openxmlformats.org/drawingml/2006/chart">
-            <c:chart xmlns:r="http://schemas.openxmlformats.org/officeDocument/2006/relationships" xmlns:c="http://schemas.openxmlformats.org/drawingml/2006/chart" r:id="R59333eb8a6b44bba"/>
+            <c:chart xmlns:r="http://schemas.openxmlformats.org/officeDocument/2006/relationships" xmlns:c="http://schemas.openxmlformats.org/drawingml/2006/chart" r:id="R8c5da4d089104b49"/>
           </a:graphicData>
         </a:graphic>
       </p:graphicFrame>
@@ -19086,8 +19086,8 @@
         </p:nvSpPr>
         <p:spPr>
           <a:xfrm xmlns:a="http://schemas.openxmlformats.org/drawingml/2006/main">
-            <a:off x="685800" y="5257800"/>
-            <a:ext cx="2926080" cy="164592"/>
+            <a:off x="685800" y="5219700"/>
+            <a:ext cx="5334000" cy="438150"/>
           </a:xfrm>
           <a:prstGeom xmlns:a="http://schemas.openxmlformats.org/drawingml/2006/main" prst="rect">
             <a:avLst/>
@@ -19096,7 +19096,7 @@
         </p:spPr>
         <p:txBody>
           <a:bodyPr xmlns:a="http://schemas.openxmlformats.org/drawingml/2006/main" wrap="square" lIns="0" tIns="0" rIns="0" bIns="0" anchor="ctr">
-            <a:normAutofit fontScale="60000"/>
+            <a:normAutofit fontScale="98291"/>
           </a:bodyPr>
           <a:lstStyle xmlns:a="http://schemas.openxmlformats.org/drawingml/2006/main"/>
           <a:p xmlns:a="http://schemas.openxmlformats.org/drawingml/2006/main">
@@ -19105,14 +19105,14 @@
                 <a:spcPct val="100000"/>
               </a:lnSpc>
               <a:buNone/>
-              <a:defRPr sz="900">
-                <a:solidFill>
-                  <a:srgbClr val="F3F0E8"/>
-                </a:solidFill>
-              </a:defRPr>
-            </a:pPr>
-            <a:r>
-              <a:rPr sz="900">
+              <a:defRPr sz="975">
+                <a:solidFill>
+                  <a:srgbClr val="F3F0E8"/>
+                </a:solidFill>
+              </a:defRPr>
+            </a:pPr>
+            <a:r>
+              <a:rPr sz="975">
                 <a:solidFill>
                   <a:srgbClr val="F3F0E8"/>
                 </a:solidFill>
@@ -19120,7 +19120,7 @@
                 <a:ea typeface="JetBrains Mono"/>
                 <a:cs typeface="JetBrains Mono"/>
               </a:rPr>
-              <a:t>OFF-TAKERS: mission-control  •  ground-segment  •  systems integrators</a:t>
+              <a:t>OFF-TAKERS / BUYERS</a:t>
             </a:r>
             <a:endParaRPr sz="800"/>
           </a:p>
@@ -19130,14 +19130,39 @@
                 <a:spcPct val="100000"/>
               </a:lnSpc>
               <a:buNone/>
-              <a:defRPr sz="900">
-                <a:solidFill>
-                  <a:srgbClr val="F3F0E8"/>
-                </a:solidFill>
-              </a:defRPr>
-            </a:pPr>
-            <a:r>
-              <a:rPr sz="900">
+              <a:defRPr sz="975">
+                <a:solidFill>
+                  <a:srgbClr val="F3F0E8"/>
+                </a:solidFill>
+              </a:defRPr>
+            </a:pPr>
+            <a:r>
+              <a:rPr sz="975">
+                <a:solidFill>
+                  <a:srgbClr val="F3F0E8"/>
+                </a:solidFill>
+                <a:latin typeface="JetBrains Mono"/>
+                <a:ea typeface="JetBrains Mono"/>
+                <a:cs typeface="JetBrains Mono"/>
+              </a:rPr>
+              <a:t>Mission-control  •  ground-segment  •  systems integrators</a:t>
+            </a:r>
+            <a:endParaRPr sz="800"/>
+          </a:p>
+          <a:p xmlns:a="http://schemas.openxmlformats.org/drawingml/2006/main">
+            <a:pPr marL="0" indent="0" algn="l">
+              <a:lnSpc>
+                <a:spcPct val="100000"/>
+              </a:lnSpc>
+              <a:buNone/>
+              <a:defRPr sz="975">
+                <a:solidFill>
+                  <a:srgbClr val="F3F0E8"/>
+                </a:solidFill>
+              </a:defRPr>
+            </a:pPr>
+            <a:r>
+              <a:rPr sz="975">
                 <a:solidFill>
                   <a:srgbClr val="F3F0E8"/>
                 </a:solidFill>
@@ -20066,7 +20091,7 @@
           <p:nvPr/>
         </p:nvPicPr>
         <p:blipFill>
-          <a:blip xmlns:r="http://schemas.openxmlformats.org/officeDocument/2006/relationships" xmlns:a="http://schemas.openxmlformats.org/drawingml/2006/main" r:embed="Ra92002365a2a48b6">
+          <a:blip xmlns:r="http://schemas.openxmlformats.org/officeDocument/2006/relationships" xmlns:a="http://schemas.openxmlformats.org/drawingml/2006/main" r:embed="R339c3eeef229422c">
             <a:alphaModFix amt="96000"/>
           </a:blip>
           <a:stretch xmlns:a="http://schemas.openxmlformats.org/drawingml/2006/main">
@@ -22060,10 +22085,10 @@
           <p:nvPr/>
         </p:nvPicPr>
         <p:blipFill>
-          <a:blip xmlns:r="http://schemas.openxmlformats.org/officeDocument/2006/relationships" xmlns:a="http://schemas.openxmlformats.org/drawingml/2006/main" r:embed="R1ad26c5d9a6341e4">
+          <a:blip xmlns:r="http://schemas.openxmlformats.org/officeDocument/2006/relationships" xmlns:a="http://schemas.openxmlformats.org/drawingml/2006/main" r:embed="Rf2ba903478c5472e">
             <a:extLst>
               <a:ext uri="{96DAC541-7B7A-43D3-8B79-37D633B846F1}">
-                <asvg:svgBlip xmlns:asvg="http://schemas.microsoft.com/office/drawing/2016/SVG/main" r:embed="R9224cd77207549ca"/>
+                <asvg:svgBlip xmlns:asvg="http://schemas.microsoft.com/office/drawing/2016/SVG/main" r:embed="Rba58d16ea1774463"/>
               </a:ext>
             </a:extLst>
           </a:blip>
@@ -22088,7 +22113,7 @@
           <p:nvPr/>
         </p:nvPicPr>
         <p:blipFill>
-          <a:blip xmlns:r="http://schemas.openxmlformats.org/officeDocument/2006/relationships" xmlns:a="http://schemas.openxmlformats.org/drawingml/2006/main" r:embed="Rebdaf05e8b564eb1"/>
+          <a:blip xmlns:r="http://schemas.openxmlformats.org/officeDocument/2006/relationships" xmlns:a="http://schemas.openxmlformats.org/drawingml/2006/main" r:embed="Rd1423343c5304349"/>
           <a:stretch xmlns:a="http://schemas.openxmlformats.org/drawingml/2006/main"/>
         </p:blipFill>
         <p:spPr>
@@ -22110,10 +22135,10 @@
           <p:nvPr/>
         </p:nvPicPr>
         <p:blipFill>
-          <a:blip xmlns:r="http://schemas.openxmlformats.org/officeDocument/2006/relationships" xmlns:a="http://schemas.openxmlformats.org/drawingml/2006/main" r:embed="R5bc3d8f25eba448c">
+          <a:blip xmlns:r="http://schemas.openxmlformats.org/officeDocument/2006/relationships" xmlns:a="http://schemas.openxmlformats.org/drawingml/2006/main" r:embed="R5ee6030043d547a3">
             <a:extLst>
               <a:ext uri="{96DAC541-7B7A-43D3-8B79-37D633B846F1}">
-                <asvg:svgBlip xmlns:asvg="http://schemas.microsoft.com/office/drawing/2016/SVG/main" r:embed="R456a058017b74eec"/>
+                <asvg:svgBlip xmlns:asvg="http://schemas.microsoft.com/office/drawing/2016/SVG/main" r:embed="Rf3f9b9a81c73464b"/>
               </a:ext>
             </a:extLst>
           </a:blip>
@@ -22138,7 +22163,7 @@
           <p:nvPr/>
         </p:nvPicPr>
         <p:blipFill>
-          <a:blip xmlns:r="http://schemas.openxmlformats.org/officeDocument/2006/relationships" xmlns:a="http://schemas.openxmlformats.org/drawingml/2006/main" r:embed="Rcd9785bd26054010"/>
+          <a:blip xmlns:r="http://schemas.openxmlformats.org/officeDocument/2006/relationships" xmlns:a="http://schemas.openxmlformats.org/drawingml/2006/main" r:embed="R6d6085715d124ce4"/>
           <a:stretch xmlns:a="http://schemas.openxmlformats.org/drawingml/2006/main"/>
         </p:blipFill>
         <p:spPr>
@@ -22160,10 +22185,10 @@
           <p:nvPr/>
         </p:nvPicPr>
         <p:blipFill>
-          <a:blip xmlns:r="http://schemas.openxmlformats.org/officeDocument/2006/relationships" xmlns:a="http://schemas.openxmlformats.org/drawingml/2006/main" r:embed="R021a95392fa848e6">
+          <a:blip xmlns:r="http://schemas.openxmlformats.org/officeDocument/2006/relationships" xmlns:a="http://schemas.openxmlformats.org/drawingml/2006/main" r:embed="Rf4624f90231d410a">
             <a:extLst>
               <a:ext uri="{96DAC541-7B7A-43D3-8B79-37D633B846F1}">
-                <asvg:svgBlip xmlns:asvg="http://schemas.microsoft.com/office/drawing/2016/SVG/main" r:embed="Rcb1ea9f75e6b4508"/>
+                <asvg:svgBlip xmlns:asvg="http://schemas.microsoft.com/office/drawing/2016/SVG/main" r:embed="Rc1e1beab0fff47f6"/>
               </a:ext>
             </a:extLst>
           </a:blip>
@@ -22188,10 +22213,10 @@
           <p:nvPr/>
         </p:nvPicPr>
         <p:blipFill>
-          <a:blip xmlns:r="http://schemas.openxmlformats.org/officeDocument/2006/relationships" xmlns:a="http://schemas.openxmlformats.org/drawingml/2006/main" r:embed="Rebdaf05e8b564eb1">
+          <a:blip xmlns:r="http://schemas.openxmlformats.org/officeDocument/2006/relationships" xmlns:a="http://schemas.openxmlformats.org/drawingml/2006/main" r:embed="Rd1423343c5304349">
             <a:extLst>
               <a:ext uri="{96DAC541-7B7A-43D3-8B79-37D633B846F1}">
-                <asvg:svgBlip xmlns:asvg="http://schemas.microsoft.com/office/drawing/2016/SVG/main" r:embed="Raad2f42d402b4907"/>
+                <asvg:svgBlip xmlns:asvg="http://schemas.microsoft.com/office/drawing/2016/SVG/main" r:embed="Rd45191fdd9974420"/>
               </a:ext>
             </a:extLst>
           </a:blip>
@@ -22216,10 +22241,10 @@
           <p:nvPr/>
         </p:nvPicPr>
         <p:blipFill>
-          <a:blip xmlns:r="http://schemas.openxmlformats.org/officeDocument/2006/relationships" xmlns:a="http://schemas.openxmlformats.org/drawingml/2006/main" r:embed="Rcd9785bd26054010">
+          <a:blip xmlns:r="http://schemas.openxmlformats.org/officeDocument/2006/relationships" xmlns:a="http://schemas.openxmlformats.org/drawingml/2006/main" r:embed="R6d6085715d124ce4">
             <a:extLst>
               <a:ext uri="{96DAC541-7B7A-43D3-8B79-37D633B846F1}">
-                <asvg:svgBlip xmlns:asvg="http://schemas.microsoft.com/office/drawing/2016/SVG/main" r:embed="R6bb7e10180df45e7"/>
+                <asvg:svgBlip xmlns:asvg="http://schemas.microsoft.com/office/drawing/2016/SVG/main" r:embed="Rea95ec43cf514868"/>
               </a:ext>
             </a:extLst>
           </a:blip>
@@ -22244,7 +22269,7 @@
           <p:nvPr/>
         </p:nvPicPr>
         <p:blipFill>
-          <a:blip xmlns:r="http://schemas.openxmlformats.org/officeDocument/2006/relationships" xmlns:a="http://schemas.openxmlformats.org/drawingml/2006/main" r:embed="Rab17bc85b2be447f"/>
+          <a:blip xmlns:r="http://schemas.openxmlformats.org/officeDocument/2006/relationships" xmlns:a="http://schemas.openxmlformats.org/drawingml/2006/main" r:embed="R62073c2357c249ec"/>
           <a:stretch xmlns:a="http://schemas.openxmlformats.org/drawingml/2006/main"/>
         </p:blipFill>
         <p:spPr>
@@ -22266,10 +22291,10 @@
           <p:nvPr/>
         </p:nvPicPr>
         <p:blipFill>
-          <a:blip xmlns:r="http://schemas.openxmlformats.org/officeDocument/2006/relationships" xmlns:a="http://schemas.openxmlformats.org/drawingml/2006/main" r:embed="Rab17bc85b2be447f">
+          <a:blip xmlns:r="http://schemas.openxmlformats.org/officeDocument/2006/relationships" xmlns:a="http://schemas.openxmlformats.org/drawingml/2006/main" r:embed="R62073c2357c249ec">
             <a:extLst>
               <a:ext uri="{96DAC541-7B7A-43D3-8B79-37D633B846F1}">
-                <asvg:svgBlip xmlns:asvg="http://schemas.microsoft.com/office/drawing/2016/SVG/main" r:embed="R0262aa8bf7ae4e10"/>
+                <asvg:svgBlip xmlns:asvg="http://schemas.microsoft.com/office/drawing/2016/SVG/main" r:embed="Re455688a557d4601"/>
               </a:ext>
             </a:extLst>
           </a:blip>
@@ -22294,7 +22319,7 @@
           <p:nvPr/>
         </p:nvPicPr>
         <p:blipFill>
-          <a:blip xmlns:r="http://schemas.openxmlformats.org/officeDocument/2006/relationships" xmlns:a="http://schemas.openxmlformats.org/drawingml/2006/main" r:embed="Rf7eb9e38aa654188"/>
+          <a:blip xmlns:r="http://schemas.openxmlformats.org/officeDocument/2006/relationships" xmlns:a="http://schemas.openxmlformats.org/drawingml/2006/main" r:embed="R94a875fdb3984cfc"/>
           <a:stretch xmlns:a="http://schemas.openxmlformats.org/drawingml/2006/main"/>
         </p:blipFill>
         <p:spPr>
@@ -22316,10 +22341,10 @@
           <p:nvPr/>
         </p:nvPicPr>
         <p:blipFill>
-          <a:blip xmlns:r="http://schemas.openxmlformats.org/officeDocument/2006/relationships" xmlns:a="http://schemas.openxmlformats.org/drawingml/2006/main" r:embed="Rf7eb9e38aa654188">
+          <a:blip xmlns:r="http://schemas.openxmlformats.org/officeDocument/2006/relationships" xmlns:a="http://schemas.openxmlformats.org/drawingml/2006/main" r:embed="R94a875fdb3984cfc">
             <a:extLst>
               <a:ext uri="{96DAC541-7B7A-43D3-8B79-37D633B846F1}">
-                <asvg:svgBlip xmlns:asvg="http://schemas.microsoft.com/office/drawing/2016/SVG/main" r:embed="R7e83a6e623804f2f"/>
+                <asvg:svgBlip xmlns:asvg="http://schemas.microsoft.com/office/drawing/2016/SVG/main" r:embed="Ra42465a5b0c54c9d"/>
               </a:ext>
             </a:extLst>
           </a:blip>
@@ -22344,10 +22369,10 @@
           <p:nvPr/>
         </p:nvPicPr>
         <p:blipFill>
-          <a:blip xmlns:r="http://schemas.openxmlformats.org/officeDocument/2006/relationships" xmlns:a="http://schemas.openxmlformats.org/drawingml/2006/main" r:embed="Rf91c26f344c3426d">
+          <a:blip xmlns:r="http://schemas.openxmlformats.org/officeDocument/2006/relationships" xmlns:a="http://schemas.openxmlformats.org/drawingml/2006/main" r:embed="R6164e2dbcabe4324">
             <a:extLst>
               <a:ext uri="{96DAC541-7B7A-43D3-8B79-37D633B846F1}">
-                <asvg:svgBlip xmlns:asvg="http://schemas.microsoft.com/office/drawing/2016/SVG/main" r:embed="Rc574c069d05f4d24"/>
+                <asvg:svgBlip xmlns:asvg="http://schemas.microsoft.com/office/drawing/2016/SVG/main" r:embed="Recd2f08108854f17"/>
               </a:ext>
             </a:extLst>
           </a:blip>
@@ -22372,10 +22397,10 @@
           <p:nvPr/>
         </p:nvPicPr>
         <p:blipFill>
-          <a:blip xmlns:r="http://schemas.openxmlformats.org/officeDocument/2006/relationships" xmlns:a="http://schemas.openxmlformats.org/drawingml/2006/main" r:embed="R023a4da59c3b44df">
+          <a:blip xmlns:r="http://schemas.openxmlformats.org/officeDocument/2006/relationships" xmlns:a="http://schemas.openxmlformats.org/drawingml/2006/main" r:embed="R8b3bef48a2604198">
             <a:extLst>
               <a:ext uri="{96DAC541-7B7A-43D3-8B79-37D633B846F1}">
-                <asvg:svgBlip xmlns:asvg="http://schemas.microsoft.com/office/drawing/2016/SVG/main" r:embed="R605b8b7dc6514fcf"/>
+                <asvg:svgBlip xmlns:asvg="http://schemas.microsoft.com/office/drawing/2016/SVG/main" r:embed="R9d3cdf1515f44cad"/>
               </a:ext>
             </a:extLst>
           </a:blip>
@@ -22400,7 +22425,7 @@
           <p:nvPr/>
         </p:nvPicPr>
         <p:blipFill>
-          <a:blip xmlns:r="http://schemas.openxmlformats.org/officeDocument/2006/relationships" xmlns:a="http://schemas.openxmlformats.org/drawingml/2006/main" r:embed="R8eb44ef50215408e"/>
+          <a:blip xmlns:r="http://schemas.openxmlformats.org/officeDocument/2006/relationships" xmlns:a="http://schemas.openxmlformats.org/drawingml/2006/main" r:embed="R7eb5497e8b3e4e4e"/>
           <a:stretch xmlns:a="http://schemas.openxmlformats.org/drawingml/2006/main"/>
         </p:blipFill>
         <p:spPr>
@@ -22422,10 +22447,10 @@
           <p:nvPr/>
         </p:nvPicPr>
         <p:blipFill>
-          <a:blip xmlns:r="http://schemas.openxmlformats.org/officeDocument/2006/relationships" xmlns:a="http://schemas.openxmlformats.org/drawingml/2006/main" r:embed="R8eb44ef50215408e">
+          <a:blip xmlns:r="http://schemas.openxmlformats.org/officeDocument/2006/relationships" xmlns:a="http://schemas.openxmlformats.org/drawingml/2006/main" r:embed="R7eb5497e8b3e4e4e">
             <a:extLst>
               <a:ext uri="{96DAC541-7B7A-43D3-8B79-37D633B846F1}">
-                <asvg:svgBlip xmlns:asvg="http://schemas.microsoft.com/office/drawing/2016/SVG/main" r:embed="R97d4ac630fec4a8e"/>
+                <asvg:svgBlip xmlns:asvg="http://schemas.microsoft.com/office/drawing/2016/SVG/main" r:embed="Rf176870716c147c3"/>
               </a:ext>
             </a:extLst>
           </a:blip>
@@ -22450,7 +22475,7 @@
           <p:nvPr/>
         </p:nvPicPr>
         <p:blipFill>
-          <a:blip xmlns:r="http://schemas.openxmlformats.org/officeDocument/2006/relationships" xmlns:a="http://schemas.openxmlformats.org/drawingml/2006/main" r:embed="Ra98ef0780eff47dd"/>
+          <a:blip xmlns:r="http://schemas.openxmlformats.org/officeDocument/2006/relationships" xmlns:a="http://schemas.openxmlformats.org/drawingml/2006/main" r:embed="R15eec424364645a6"/>
           <a:stretch xmlns:a="http://schemas.openxmlformats.org/drawingml/2006/main"/>
         </p:blipFill>
         <p:spPr>
@@ -22472,10 +22497,10 @@
           <p:nvPr/>
         </p:nvPicPr>
         <p:blipFill>
-          <a:blip xmlns:r="http://schemas.openxmlformats.org/officeDocument/2006/relationships" xmlns:a="http://schemas.openxmlformats.org/drawingml/2006/main" r:embed="Ra98ef0780eff47dd">
+          <a:blip xmlns:r="http://schemas.openxmlformats.org/officeDocument/2006/relationships" xmlns:a="http://schemas.openxmlformats.org/drawingml/2006/main" r:embed="R15eec424364645a6">
             <a:extLst>
               <a:ext uri="{96DAC541-7B7A-43D3-8B79-37D633B846F1}">
-                <asvg:svgBlip xmlns:asvg="http://schemas.microsoft.com/office/drawing/2016/SVG/main" r:embed="R00b049adb24c464d"/>
+                <asvg:svgBlip xmlns:asvg="http://schemas.microsoft.com/office/drawing/2016/SVG/main" r:embed="R5bf4d8da0b0a4b90"/>
               </a:ext>
             </a:extLst>
           </a:blip>
@@ -22500,10 +22525,10 @@
           <p:nvPr/>
         </p:nvPicPr>
         <p:blipFill>
-          <a:blip xmlns:r="http://schemas.openxmlformats.org/officeDocument/2006/relationships" xmlns:a="http://schemas.openxmlformats.org/drawingml/2006/main" r:embed="R0734a0a83a59495b">
+          <a:blip xmlns:r="http://schemas.openxmlformats.org/officeDocument/2006/relationships" xmlns:a="http://schemas.openxmlformats.org/drawingml/2006/main" r:embed="R2c5fd5d91ca64439">
             <a:extLst>
               <a:ext uri="{96DAC541-7B7A-43D3-8B79-37D633B846F1}">
-                <asvg:svgBlip xmlns:asvg="http://schemas.microsoft.com/office/drawing/2016/SVG/main" r:embed="R0795dc343c4d4dce"/>
+                <asvg:svgBlip xmlns:asvg="http://schemas.microsoft.com/office/drawing/2016/SVG/main" r:embed="R866020a9d988415b"/>
               </a:ext>
             </a:extLst>
           </a:blip>
@@ -22528,10 +22553,10 @@
           <p:nvPr/>
         </p:nvPicPr>
         <p:blipFill>
-          <a:blip xmlns:r="http://schemas.openxmlformats.org/officeDocument/2006/relationships" xmlns:a="http://schemas.openxmlformats.org/drawingml/2006/main" r:embed="R94eaefaa299b4b9b">
+          <a:blip xmlns:r="http://schemas.openxmlformats.org/officeDocument/2006/relationships" xmlns:a="http://schemas.openxmlformats.org/drawingml/2006/main" r:embed="Rf1ccff44b4c04ca3">
             <a:extLst>
               <a:ext uri="{96DAC541-7B7A-43D3-8B79-37D633B846F1}">
-                <asvg:svgBlip xmlns:asvg="http://schemas.microsoft.com/office/drawing/2016/SVG/main" r:embed="R9f29a5c721f546c4"/>
+                <asvg:svgBlip xmlns:asvg="http://schemas.microsoft.com/office/drawing/2016/SVG/main" r:embed="R995ec702e037452f"/>
               </a:ext>
             </a:extLst>
           </a:blip>
@@ -22556,7 +22581,7 @@
           <p:nvPr/>
         </p:nvPicPr>
         <p:blipFill>
-          <a:blip xmlns:r="http://schemas.openxmlformats.org/officeDocument/2006/relationships" xmlns:a="http://schemas.openxmlformats.org/drawingml/2006/main" r:embed="R8f44c3db6ce04ec8"/>
+          <a:blip xmlns:r="http://schemas.openxmlformats.org/officeDocument/2006/relationships" xmlns:a="http://schemas.openxmlformats.org/drawingml/2006/main" r:embed="R2840d4cbaae54f0c"/>
           <a:stretch xmlns:a="http://schemas.openxmlformats.org/drawingml/2006/main"/>
         </p:blipFill>
         <p:spPr>
@@ -22578,10 +22603,10 @@
           <p:nvPr/>
         </p:nvPicPr>
         <p:blipFill>
-          <a:blip xmlns:r="http://schemas.openxmlformats.org/officeDocument/2006/relationships" xmlns:a="http://schemas.openxmlformats.org/drawingml/2006/main" r:embed="R8f44c3db6ce04ec8">
+          <a:blip xmlns:r="http://schemas.openxmlformats.org/officeDocument/2006/relationships" xmlns:a="http://schemas.openxmlformats.org/drawingml/2006/main" r:embed="R2840d4cbaae54f0c">
             <a:extLst>
               <a:ext uri="{96DAC541-7B7A-43D3-8B79-37D633B846F1}">
-                <asvg:svgBlip xmlns:asvg="http://schemas.microsoft.com/office/drawing/2016/SVG/main" r:embed="Re12d21012e75439d"/>
+                <asvg:svgBlip xmlns:asvg="http://schemas.microsoft.com/office/drawing/2016/SVG/main" r:embed="Rf780c7c2eef94b4c"/>
               </a:ext>
             </a:extLst>
           </a:blip>
@@ -22606,7 +22631,7 @@
           <p:nvPr/>
         </p:nvPicPr>
         <p:blipFill>
-          <a:blip xmlns:r="http://schemas.openxmlformats.org/officeDocument/2006/relationships" xmlns:a="http://schemas.openxmlformats.org/drawingml/2006/main" r:embed="Rb09e17e3cdcf4d91"/>
+          <a:blip xmlns:r="http://schemas.openxmlformats.org/officeDocument/2006/relationships" xmlns:a="http://schemas.openxmlformats.org/drawingml/2006/main" r:embed="R1df3bd82946c4714"/>
           <a:stretch xmlns:a="http://schemas.openxmlformats.org/drawingml/2006/main"/>
         </p:blipFill>
         <p:spPr>
@@ -22628,10 +22653,10 @@
           <p:nvPr/>
         </p:nvPicPr>
         <p:blipFill>
-          <a:blip xmlns:r="http://schemas.openxmlformats.org/officeDocument/2006/relationships" xmlns:a="http://schemas.openxmlformats.org/drawingml/2006/main" r:embed="Rb09e17e3cdcf4d91">
+          <a:blip xmlns:r="http://schemas.openxmlformats.org/officeDocument/2006/relationships" xmlns:a="http://schemas.openxmlformats.org/drawingml/2006/main" r:embed="R1df3bd82946c4714">
             <a:extLst>
               <a:ext uri="{96DAC541-7B7A-43D3-8B79-37D633B846F1}">
-                <asvg:svgBlip xmlns:asvg="http://schemas.microsoft.com/office/drawing/2016/SVG/main" r:embed="R7c014326f22c4686"/>
+                <asvg:svgBlip xmlns:asvg="http://schemas.microsoft.com/office/drawing/2016/SVG/main" r:embed="R7925896b658540b7"/>
               </a:ext>
             </a:extLst>
           </a:blip>
@@ -22656,10 +22681,10 @@
           <p:nvPr/>
         </p:nvPicPr>
         <p:blipFill>
-          <a:blip xmlns:r="http://schemas.openxmlformats.org/officeDocument/2006/relationships" xmlns:a="http://schemas.openxmlformats.org/drawingml/2006/main" r:embed="Rf57ae2c91f7e4eaf">
+          <a:blip xmlns:r="http://schemas.openxmlformats.org/officeDocument/2006/relationships" xmlns:a="http://schemas.openxmlformats.org/drawingml/2006/main" r:embed="R818136ebdb5543c3">
             <a:extLst>
               <a:ext uri="{96DAC541-7B7A-43D3-8B79-37D633B846F1}">
-                <asvg:svgBlip xmlns:asvg="http://schemas.microsoft.com/office/drawing/2016/SVG/main" r:embed="Rfc44bff6ed2b492e"/>
+                <asvg:svgBlip xmlns:asvg="http://schemas.microsoft.com/office/drawing/2016/SVG/main" r:embed="Rf0dd5506d1774119"/>
               </a:ext>
             </a:extLst>
           </a:blip>
@@ -23055,7 +23080,7 @@
           <p:nvPr/>
         </p:nvPicPr>
         <p:blipFill>
-          <a:blip xmlns:r="http://schemas.openxmlformats.org/officeDocument/2006/relationships" xmlns:a="http://schemas.openxmlformats.org/drawingml/2006/main" r:embed="R1609c926854b47d1"/>
+          <a:blip xmlns:r="http://schemas.openxmlformats.org/officeDocument/2006/relationships" xmlns:a="http://schemas.openxmlformats.org/drawingml/2006/main" r:embed="Rd1c700b876b44f38"/>
           <a:stretch xmlns:a="http://schemas.openxmlformats.org/drawingml/2006/main"/>
         </p:blipFill>
         <p:spPr>
@@ -23112,7 +23137,7 @@
           <p:nvPr/>
         </p:nvPicPr>
         <p:blipFill>
-          <a:blip xmlns:r="http://schemas.openxmlformats.org/officeDocument/2006/relationships" xmlns:a="http://schemas.openxmlformats.org/drawingml/2006/main" r:embed="R89d210e2d9b14c78"/>
+          <a:blip xmlns:r="http://schemas.openxmlformats.org/officeDocument/2006/relationships" xmlns:a="http://schemas.openxmlformats.org/drawingml/2006/main" r:embed="R1594712a06464b47"/>
           <a:stretch xmlns:a="http://schemas.openxmlformats.org/drawingml/2006/main"/>
         </p:blipFill>
         <p:spPr>
@@ -23169,7 +23194,7 @@
           <p:nvPr/>
         </p:nvPicPr>
         <p:blipFill>
-          <a:blip xmlns:r="http://schemas.openxmlformats.org/officeDocument/2006/relationships" xmlns:a="http://schemas.openxmlformats.org/drawingml/2006/main" r:embed="Re7ce67b17f36417e"/>
+          <a:blip xmlns:r="http://schemas.openxmlformats.org/officeDocument/2006/relationships" xmlns:a="http://schemas.openxmlformats.org/drawingml/2006/main" r:embed="Ref31aedf889c4411"/>
           <a:stretch xmlns:a="http://schemas.openxmlformats.org/drawingml/2006/main"/>
         </p:blipFill>
         <p:spPr>
@@ -23226,7 +23251,7 @@
           <p:nvPr/>
         </p:nvPicPr>
         <p:blipFill>
-          <a:blip xmlns:r="http://schemas.openxmlformats.org/officeDocument/2006/relationships" xmlns:a="http://schemas.openxmlformats.org/drawingml/2006/main" r:embed="R10fd4bfebac043f5"/>
+          <a:blip xmlns:r="http://schemas.openxmlformats.org/officeDocument/2006/relationships" xmlns:a="http://schemas.openxmlformats.org/drawingml/2006/main" r:embed="R6b01f7fd66d64342"/>
           <a:stretch xmlns:a="http://schemas.openxmlformats.org/drawingml/2006/main"/>
         </p:blipFill>
         <p:spPr>
@@ -23283,7 +23308,7 @@
           <p:nvPr/>
         </p:nvPicPr>
         <p:blipFill>
-          <a:blip xmlns:r="http://schemas.openxmlformats.org/officeDocument/2006/relationships" xmlns:a="http://schemas.openxmlformats.org/drawingml/2006/main" r:embed="Rc6076f242b824c91"/>
+          <a:blip xmlns:r="http://schemas.openxmlformats.org/officeDocument/2006/relationships" xmlns:a="http://schemas.openxmlformats.org/drawingml/2006/main" r:embed="R750cd183aae9405c"/>
           <a:stretch xmlns:a="http://schemas.openxmlformats.org/drawingml/2006/main"/>
         </p:blipFill>
         <p:spPr>
@@ -23340,7 +23365,7 @@
           <p:nvPr/>
         </p:nvPicPr>
         <p:blipFill>
-          <a:blip xmlns:r="http://schemas.openxmlformats.org/officeDocument/2006/relationships" xmlns:a="http://schemas.openxmlformats.org/drawingml/2006/main" r:embed="Rce87d06a77b5484c"/>
+          <a:blip xmlns:r="http://schemas.openxmlformats.org/officeDocument/2006/relationships" xmlns:a="http://schemas.openxmlformats.org/drawingml/2006/main" r:embed="R1752dfa5919942c5"/>
           <a:stretch xmlns:a="http://schemas.openxmlformats.org/drawingml/2006/main"/>
         </p:blipFill>
         <p:spPr>
@@ -23477,7 +23502,7 @@
           <p:nvPr/>
         </p:nvPicPr>
         <p:blipFill>
-          <a:blip xmlns:r="http://schemas.openxmlformats.org/officeDocument/2006/relationships" xmlns:a="http://schemas.openxmlformats.org/drawingml/2006/main" r:embed="R6885221264bc44a8">
+          <a:blip xmlns:r="http://schemas.openxmlformats.org/officeDocument/2006/relationships" xmlns:a="http://schemas.openxmlformats.org/drawingml/2006/main" r:embed="R3e25a1fb9883496d">
             <a:alphaModFix amt="96000"/>
           </a:blip>
           <a:stretch xmlns:a="http://schemas.openxmlformats.org/drawingml/2006/main">

</xml_diff>